<commit_message>
deck: callout count matches the title (ten processors)
</commit_message>
<xml_diff>
--- a/docs/sgm-results.pptx
+++ b/docs/sgm-results.pptx
@@ -5081,7 +5081,7 @@
                 </a:solidFill>
                 <a:latin typeface="Calibri"/>
               </a:rPr>
-              <a:t>9 / 4 / 3 / 1</a:t>
+              <a:t>10 / 4 / 3 / 1</a:t>
             </a:r>
           </a:p>
         </p:txBody>
@@ -5116,7 +5116,7 @@
                 </a:solidFill>
                 <a:latin typeface="Calibri"/>
               </a:rPr>
-              <a:t>targets / vendors / programming models</a:t>
+              <a:t>processors / vendors / programming models</a:t>
             </a:r>
           </a:p>
           <a:p>

</xml_diff>

<commit_message>
results table: a DRAM bandwidth column, because this workload is moving data
The README table and deck slide 1 gain "DRAM GB/s (achieved / ceiling)". At
1080p D=64 the aggregation phase streams 1.46 GB per frame -- the summed cost
volume is 265 MB touched four times -- so bandwidth is the explanatory
variable for most of the ranking, and it belongs beside the throughput it
explains: across a 7.9x spread in GPU bandwidth, utilisation stays in a
42-58% band.

The footnote carries the provenance split per LAW 1: ceilings are MEASURED
(streaming-copy probe, tools/gpu_bandwidth.cu); achieved figures are DERIVED
(the kernel's exact modelled byte count over the measured phase time), not
DRAM counters. The Hexagon pair is the qualcomm session's own probe and
model. CPU and Mali cells are blank -- not instrumented, not zero -- because
an empty cell beats an estimate.
</commit_message>
<xml_diff>
--- a/docs/sgm-results.pptx
+++ b/docs/sgm-results.pptx
@@ -3190,12 +3190,13 @@
                 <a:tableStyleId>{5C22544A-7EE6-4342-B048-85BDC9FD1C3A}</a:tableStyleId>
               </a:tblPr>
               <a:tblGrid>
-                <a:gridCol w="3200400"/>
+                <a:gridCol w="3017520"/>
+                <a:gridCol w="822960"/>
+                <a:gridCol w="1554480"/>
                 <a:gridCol w="1005840"/>
-                <a:gridCol w="1554480"/>
                 <a:gridCol w="1371600"/>
-                <a:gridCol w="1737360"/>
-                <a:gridCol w="2194560"/>
+                <a:gridCol w="1463040"/>
+                <a:gridCol w="1828800"/>
               </a:tblGrid>
               <a:tr h="246888">
                 <a:tc>
@@ -3314,7 +3315,7 @@
                             <a:srgbClr val="FFFFFF"/>
                           </a:solidFill>
                         </a:rPr>
-                        <a:t>vs scalar reference</a:t>
+                        <a:t>DRAM GB/s *</a:t>
                       </a:r>
                     </a:p>
                   </a:txBody>
@@ -3324,6 +3325,27 @@
                     </a:solidFill>
                   </a:tcPr>
                 </a:tc>
+                <a:tc>
+                  <a:txBody>
+                    <a:bodyPr/>
+                    <a:lstStyle/>
+                    <a:p>
+                      <a:r>
+                        <a:rPr sz="1100" b="1">
+                          <a:solidFill>
+                            <a:srgbClr val="FFFFFF"/>
+                          </a:solidFill>
+                        </a:rPr>
+                        <a:t>vs scalar reference</a:t>
+                      </a:r>
+                    </a:p>
+                  </a:txBody>
+                  <a:tcPr>
+                    <a:solidFill>
+                      <a:srgbClr val="202124"/>
+                    </a:solidFill>
+                  </a:tcPr>
+                </a:tc>
               </a:tr>
               <a:tr h="246888">
                 <a:tc>
@@ -3422,6 +3444,23 @@
                             <a:srgbClr val="202124"/>
                           </a:solidFill>
                         </a:rPr>
+                        <a:t>587 / 1,385</a:t>
+                      </a:r>
+                    </a:p>
+                  </a:txBody>
+                  <a:tcPr/>
+                </a:tc>
+                <a:tc>
+                  <a:txBody>
+                    <a:bodyPr/>
+                    <a:lstStyle/>
+                    <a:p>
+                      <a:r>
+                        <a:rPr sz="1100" b="0">
+                          <a:solidFill>
+                            <a:srgbClr val="202124"/>
+                          </a:solidFill>
+                        </a:rPr>
                         <a:t>2,655x faster</a:t>
                       </a:r>
                     </a:p>
@@ -3526,6 +3565,23 @@
                             <a:srgbClr val="202124"/>
                           </a:solidFill>
                         </a:rPr>
+                        <a:t>—</a:t>
+                      </a:r>
+                    </a:p>
+                  </a:txBody>
+                  <a:tcPr/>
+                </a:tc>
+                <a:tc>
+                  <a:txBody>
+                    <a:bodyPr/>
+                    <a:lstStyle/>
+                    <a:p>
+                      <a:r>
+                        <a:rPr sz="1100" b="0">
+                          <a:solidFill>
+                            <a:srgbClr val="202124"/>
+                          </a:solidFill>
+                        </a:rPr>
                         <a:t>throughput only</a:t>
                       </a:r>
                     </a:p>
@@ -3630,6 +3686,23 @@
                             <a:srgbClr val="202124"/>
                           </a:solidFill>
                         </a:rPr>
+                        <a:t>145 / 249</a:t>
+                      </a:r>
+                    </a:p>
+                  </a:txBody>
+                  <a:tcPr/>
+                </a:tc>
+                <a:tc>
+                  <a:txBody>
+                    <a:bodyPr/>
+                    <a:lstStyle/>
+                    <a:p>
+                      <a:r>
+                        <a:rPr sz="1100" b="0">
+                          <a:solidFill>
+                            <a:srgbClr val="202124"/>
+                          </a:solidFill>
+                        </a:rPr>
                         <a:t>697x faster</a:t>
                       </a:r>
                     </a:p>
@@ -3734,6 +3807,23 @@
                             <a:srgbClr val="202124"/>
                           </a:solidFill>
                         </a:rPr>
+                        <a:t>87 / 175</a:t>
+                      </a:r>
+                    </a:p>
+                  </a:txBody>
+                  <a:tcPr/>
+                </a:tc>
+                <a:tc>
+                  <a:txBody>
+                    <a:bodyPr/>
+                    <a:lstStyle/>
+                    <a:p>
+                      <a:r>
+                        <a:rPr sz="1100" b="0">
+                          <a:solidFill>
+                            <a:srgbClr val="202124"/>
+                          </a:solidFill>
+                        </a:rPr>
                         <a:t>395x faster</a:t>
                       </a:r>
                     </a:p>
@@ -3838,6 +3928,23 @@
                             <a:srgbClr val="202124"/>
                           </a:solidFill>
                         </a:rPr>
+                        <a:t>—</a:t>
+                      </a:r>
+                    </a:p>
+                  </a:txBody>
+                  <a:tcPr/>
+                </a:tc>
+                <a:tc>
+                  <a:txBody>
+                    <a:bodyPr/>
+                    <a:lstStyle/>
+                    <a:p>
+                      <a:r>
+                        <a:rPr sz="1100" b="0">
+                          <a:solidFill>
+                            <a:srgbClr val="202124"/>
+                          </a:solidFill>
+                        </a:rPr>
                         <a:t>178x faster</a:t>
                       </a:r>
                     </a:p>
@@ -3942,6 +4049,23 @@
                             <a:srgbClr val="202124"/>
                           </a:solidFill>
                         </a:rPr>
+                        <a:t>—</a:t>
+                      </a:r>
+                    </a:p>
+                  </a:txBody>
+                  <a:tcPr/>
+                </a:tc>
+                <a:tc>
+                  <a:txBody>
+                    <a:bodyPr/>
+                    <a:lstStyle/>
+                    <a:p>
+                      <a:r>
+                        <a:rPr sz="1100" b="0">
+                          <a:solidFill>
+                            <a:srgbClr val="202124"/>
+                          </a:solidFill>
+                        </a:rPr>
                         <a:t>throughput only</a:t>
                       </a:r>
                     </a:p>
@@ -4046,6 +4170,23 @@
                             <a:srgbClr val="202124"/>
                           </a:solidFill>
                         </a:rPr>
+                        <a:t>—</a:t>
+                      </a:r>
+                    </a:p>
+                  </a:txBody>
+                  <a:tcPr/>
+                </a:tc>
+                <a:tc>
+                  <a:txBody>
+                    <a:bodyPr/>
+                    <a:lstStyle/>
+                    <a:p>
+                      <a:r>
+                        <a:rPr sz="1100" b="0">
+                          <a:solidFill>
+                            <a:srgbClr val="202124"/>
+                          </a:solidFill>
+                        </a:rPr>
                         <a:t>94x faster</a:t>
                       </a:r>
                     </a:p>
@@ -4150,6 +4291,23 @@
                             <a:srgbClr val="202124"/>
                           </a:solidFill>
                         </a:rPr>
+                        <a:t>6.8 / 28</a:t>
+                      </a:r>
+                    </a:p>
+                  </a:txBody>
+                  <a:tcPr/>
+                </a:tc>
+                <a:tc>
+                  <a:txBody>
+                    <a:bodyPr/>
+                    <a:lstStyle/>
+                    <a:p>
+                      <a:r>
+                        <a:rPr sz="1100" b="0">
+                          <a:solidFill>
+                            <a:srgbClr val="202124"/>
+                          </a:solidFill>
+                        </a:rPr>
                         <a:t>62x faster</a:t>
                       </a:r>
                     </a:p>
@@ -4254,6 +4412,23 @@
                             <a:srgbClr val="202124"/>
                           </a:solidFill>
                         </a:rPr>
+                        <a:t>—</a:t>
+                      </a:r>
+                    </a:p>
+                  </a:txBody>
+                  <a:tcPr/>
+                </a:tc>
+                <a:tc>
+                  <a:txBody>
+                    <a:bodyPr/>
+                    <a:lstStyle/>
+                    <a:p>
+                      <a:r>
+                        <a:rPr sz="1100" b="0">
+                          <a:solidFill>
+                            <a:srgbClr val="202124"/>
+                          </a:solidFill>
+                        </a:rPr>
                         <a:t>36x faster</a:t>
                       </a:r>
                     </a:p>
@@ -4358,6 +4533,23 @@
                             <a:srgbClr val="202124"/>
                           </a:solidFill>
                         </a:rPr>
+                        <a:t>—</a:t>
+                      </a:r>
+                    </a:p>
+                  </a:txBody>
+                  <a:tcPr/>
+                </a:tc>
+                <a:tc>
+                  <a:txBody>
+                    <a:bodyPr/>
+                    <a:lstStyle/>
+                    <a:p>
+                      <a:r>
+                        <a:rPr sz="1100" b="0">
+                          <a:solidFill>
+                            <a:srgbClr val="202124"/>
+                          </a:solidFill>
+                        </a:rPr>
                         <a:t>29x faster</a:t>
                       </a:r>
                     </a:p>
@@ -4462,6 +4654,23 @@
                             <a:srgbClr val="202124"/>
                           </a:solidFill>
                         </a:rPr>
+                        <a:t>—</a:t>
+                      </a:r>
+                    </a:p>
+                  </a:txBody>
+                  <a:tcPr/>
+                </a:tc>
+                <a:tc>
+                  <a:txBody>
+                    <a:bodyPr/>
+                    <a:lstStyle/>
+                    <a:p>
+                      <a:r>
+                        <a:rPr sz="1100" b="0">
+                          <a:solidFill>
+                            <a:srgbClr val="202124"/>
+                          </a:solidFill>
+                        </a:rPr>
                         <a:t>27x faster</a:t>
                       </a:r>
                     </a:p>
@@ -4566,6 +4775,23 @@
                             <a:srgbClr val="202124"/>
                           </a:solidFill>
                         </a:rPr>
+                        <a:t>—</a:t>
+                      </a:r>
+                    </a:p>
+                  </a:txBody>
+                  <a:tcPr/>
+                </a:tc>
+                <a:tc>
+                  <a:txBody>
+                    <a:bodyPr/>
+                    <a:lstStyle/>
+                    <a:p>
+                      <a:r>
+                        <a:rPr sz="1100" b="0">
+                          <a:solidFill>
+                            <a:srgbClr val="202124"/>
+                          </a:solidFill>
+                        </a:rPr>
                         <a:t>27x faster</a:t>
                       </a:r>
                     </a:p>
@@ -4670,6 +4896,23 @@
                             <a:srgbClr val="202124"/>
                           </a:solidFill>
                         </a:rPr>
+                        <a:t>—</a:t>
+                      </a:r>
+                    </a:p>
+                  </a:txBody>
+                  <a:tcPr/>
+                </a:tc>
+                <a:tc>
+                  <a:txBody>
+                    <a:bodyPr/>
+                    <a:lstStyle/>
+                    <a:p>
+                      <a:r>
+                        <a:rPr sz="1100" b="0">
+                          <a:solidFill>
+                            <a:srgbClr val="202124"/>
+                          </a:solidFill>
+                        </a:rPr>
                         <a:t>6x faster</a:t>
                       </a:r>
                     </a:p>
@@ -4774,6 +5017,23 @@
                             <a:srgbClr val="202124"/>
                           </a:solidFill>
                         </a:rPr>
+                        <a:t>—</a:t>
+                      </a:r>
+                    </a:p>
+                  </a:txBody>
+                  <a:tcPr/>
+                </a:tc>
+                <a:tc>
+                  <a:txBody>
+                    <a:bodyPr/>
+                    <a:lstStyle/>
+                    <a:p>
+                      <a:r>
+                        <a:rPr sz="1100" b="0">
+                          <a:solidFill>
+                            <a:srgbClr val="202124"/>
+                          </a:solidFill>
+                        </a:rPr>
                         <a:t>5x faster</a:t>
                       </a:r>
                     </a:p>
@@ -4862,6 +5122,23 @@
                           </a:solidFill>
                         </a:rPr>
                         <a:t>14</a:t>
+                      </a:r>
+                    </a:p>
+                  </a:txBody>
+                  <a:tcPr/>
+                </a:tc>
+                <a:tc>
+                  <a:txBody>
+                    <a:bodyPr/>
+                    <a:lstStyle/>
+                    <a:p>
+                      <a:r>
+                        <a:rPr sz="1100" b="0">
+                          <a:solidFill>
+                            <a:srgbClr val="202124"/>
+                          </a:solidFill>
+                        </a:rPr>
+                        <a:t>—</a:t>
                       </a:r>
                     </a:p>
                   </a:txBody>
@@ -5162,7 +5439,7 @@
                 </a:solidFill>
                 <a:latin typeface="Calibri"/>
               </a:rPr>
-              <a:t>MDE/s = W x H x D / runtime.  Valid for comparing implementations at a FIXED configuration; it is the wrong unit for CHOOSING one, because the optics fix D.</a:t>
+              <a:t>* DRAM GB/s = achieved (DERIVED: modelled bytes / measured phase time) / ceiling (MEASURED, streaming-copy probe). Aggregation streams 1.46 GB/frame at 1080p D=64. Blank = not instrumented. MDE/s = W x H x D / runtime — right for comparing implementations, wrong for choosing a configuration.</a:t>
             </a:r>
           </a:p>
         </p:txBody>

</xml_diff>

<commit_message>
Final pass: Configuration B gets its figure and its slide
- docs/results_b.png (scripts/make_chart_b.py): the complete Config B roster
  as a chart, same style as the primary figure -- MDE/s work convention with
  ms and fps in the annotations, every bar bit-exact to bcb9cb0bd6f49799.
  Referenced from the Config B section of the README.
- deck: a Configuration B slide (chart + the matched-tier verdict), 15 slides.
- README header: the honest unit count -- eleven processing units (five GPUs,
  three CPU classes, a DSP, two fixed-function stereo engines), four silicon
  vendors.
</commit_message>
<xml_diff>
--- a/docs/sgm-results.pptx
+++ b/docs/sgm-results.pptx
@@ -19,6 +19,7 @@
     <p:sldId id="267" r:id="rId18"/>
     <p:sldId id="268" r:id="rId19"/>
     <p:sldId id="269" r:id="rId20"/>
+    <p:sldId id="270" r:id="rId21"/>
   </p:sldIdLst>
   <p:sldSz cx="12191695" cy="6858000" type="screen4x3"/>
   <p:notesSz cx="6858000" cy="9144000"/>
@@ -6988,6 +6989,188 @@
                 <a:latin typeface="Calibri"/>
               </a:rPr>
               <a:t>Real imagery is a better ACCEPTANCE test, not just a more realistic one: 14,417 pixels have a tied minimum here against 20 on the synthetic scene, so the hash-critical tie-break rule is pinned 720x harder.</a:t>
+            </a:r>
+          </a:p>
+        </p:txBody>
+      </p:sp>
+    </p:spTree>
+  </p:cSld>
+  <p:clrMapOvr>
+    <a:masterClrMapping/>
+  </p:clrMapOvr>
+</p:sld>
+</file>
+
+<file path=ppt/slides/slide15.xml><?xml version="1.0" encoding="utf-8"?>
+<p:sld xmlns:a="http://schemas.openxmlformats.org/drawingml/2006/main" xmlns:p="http://schemas.openxmlformats.org/presentationml/2006/main" xmlns:r="http://schemas.openxmlformats.org/officeDocument/2006/relationships">
+  <p:cSld>
+    <p:spTree>
+      <p:nvGrpSpPr>
+        <p:cNvPr id="1" name=""/>
+        <p:cNvGrpSpPr/>
+        <p:nvPr/>
+      </p:nvGrpSpPr>
+      <p:grpSpPr/>
+      <p:sp>
+        <p:nvSpPr>
+          <p:cNvPr id="2" name="TextBox 1"/>
+          <p:cNvSpPr txBox="1"/>
+          <p:nvPr/>
+        </p:nvSpPr>
+        <p:spPr>
+          <a:xfrm>
+            <a:off x="548640" y="320040"/>
+            <a:ext cx="10972800" cy="640080"/>
+          </a:xfrm>
+          <a:prstGeom prst="rect">
+            <a:avLst/>
+          </a:prstGeom>
+          <a:noFill/>
+        </p:spPr>
+        <p:txBody>
+          <a:bodyPr wrap="square">
+            <a:spAutoFit/>
+          </a:bodyPr>
+          <a:lstStyle/>
+          <a:p>
+            <a:pPr algn="l"/>
+            <a:r>
+              <a:rPr sz="3000" b="1">
+                <a:solidFill>
+                  <a:srgbClr val="202124"/>
+                </a:solidFill>
+                <a:latin typeface="Calibri"/>
+              </a:rPr>
+              <a:t>Configuration B: multi-scale, 8-path</a:t>
+            </a:r>
+          </a:p>
+        </p:txBody>
+      </p:sp>
+      <p:sp>
+        <p:nvSpPr>
+          <p:cNvPr id="3" name="TextBox 2"/>
+          <p:cNvSpPr txBox="1"/>
+          <p:nvPr/>
+        </p:nvSpPr>
+        <p:spPr>
+          <a:xfrm>
+            <a:off x="548640" y="914400"/>
+            <a:ext cx="11155680" cy="365760"/>
+          </a:xfrm>
+          <a:prstGeom prst="rect">
+            <a:avLst/>
+          </a:prstGeom>
+          <a:noFill/>
+        </p:spPr>
+        <p:txBody>
+          <a:bodyPr wrap="square">
+            <a:spAutoFit/>
+          </a:bodyPr>
+          <a:lstStyle/>
+          <a:p>
+            <a:pPr algn="l"/>
+            <a:r>
+              <a:rPr sz="1200" b="0">
+                <a:solidFill>
+                  <a:srgbClr val="5F6368"/>
+                </a:solidFill>
+                <a:latin typeface="Calibri"/>
+              </a:rPr>
+              <a:t>1920x800 in, 960x400 out - two FULL 64-disparity scales with data costs averaged (multi-scale fusion, not coarse-to-fine), census 9x7 on SobelX, 8 paths with direction-weighted P1 (40/20/10), P2=200 saturating.</a:t>
+            </a:r>
+          </a:p>
+        </p:txBody>
+      </p:sp>
+      <p:pic>
+        <p:nvPicPr>
+          <p:cNvPr id="4" name="Picture 3" descr="results_b.png"/>
+          <p:cNvPicPr>
+            <a:picLocks noChangeAspect="1"/>
+          </p:cNvPicPr>
+          <p:nvPr/>
+        </p:nvPicPr>
+        <p:blipFill>
+          <a:blip r:embed="rId2"/>
+          <a:stretch>
+            <a:fillRect/>
+          </a:stretch>
+        </p:blipFill>
+        <p:spPr>
+          <a:xfrm>
+            <a:off x="1234440" y="1417320"/>
+            <a:ext cx="7034084" cy="4526280"/>
+          </a:xfrm>
+          <a:prstGeom prst="rect">
+            <a:avLst/>
+          </a:prstGeom>
+        </p:spPr>
+      </p:pic>
+      <p:sp>
+        <p:nvSpPr>
+          <p:cNvPr id="5" name="TextBox 4"/>
+          <p:cNvSpPr txBox="1"/>
+          <p:nvPr/>
+        </p:nvSpPr>
+        <p:spPr>
+          <a:xfrm>
+            <a:off x="548640" y="6035040"/>
+            <a:ext cx="11155680" cy="731520"/>
+          </a:xfrm>
+          <a:prstGeom prst="rect">
+            <a:avLst/>
+          </a:prstGeom>
+          <a:noFill/>
+        </p:spPr>
+        <p:txBody>
+          <a:bodyPr wrap="square">
+            <a:spAutoFit/>
+          </a:bodyPr>
+          <a:lstStyle/>
+          <a:p>
+            <a:pPr algn="l"/>
+            <a:r>
+              <a:rPr sz="1200" b="0">
+                <a:solidFill>
+                  <a:srgbClr val="202124"/>
+                </a:solidFill>
+                <a:latin typeface="Calibri"/>
+              </a:rPr>
+              <a:t>Same roster, same acceptance model: every row bit-exact to golden bcb9cb0bd6f49799, same implementation tiers as Configuration A (tuned CUDA / OpenCL / NEON+OpenMP / HVX, scalar oracle as the floor). At matched tiers it ranks like Configuration A - the CPU cluster leads one NSP ~1.3x on both; per engine, one NSP beats one A78C core 1.60x.</a:t>
+            </a:r>
+          </a:p>
+        </p:txBody>
+      </p:sp>
+      <p:sp>
+        <p:nvSpPr>
+          <p:cNvPr id="6" name="TextBox 5"/>
+          <p:cNvSpPr txBox="1"/>
+          <p:nvPr/>
+        </p:nvSpPr>
+        <p:spPr>
+          <a:xfrm>
+            <a:off x="548640" y="6510528"/>
+            <a:ext cx="11155680" cy="365760"/>
+          </a:xfrm>
+          <a:prstGeom prst="rect">
+            <a:avLst/>
+          </a:prstGeom>
+          <a:noFill/>
+        </p:spPr>
+        <p:txBody>
+          <a:bodyPr wrap="square">
+            <a:spAutoFit/>
+          </a:bodyPr>
+          <a:lstStyle/>
+          <a:p>
+            <a:pPr algn="l"/>
+            <a:r>
+              <a:rPr sz="1100" b="0">
+                <a:solidFill>
+                  <a:srgbClr val="5F6368"/>
+                </a:solidFill>
+                <a:latin typeface="Calibri"/>
+              </a:rPr>
+              <a:t>MDE/s is the work-performed convention - both scales count: (0.384 + 1.536) Mpx x 64 / time. The OFA engines cannot run this configuration (no 8-path, weighted-P1 or two-scale controls).</a:t>
             </a:r>
           </a:p>
         </p:txBody>

</xml_diff>

<commit_message>
deck: fix Configuration B slide text collision
The verdict paragraph wrapped onto the convention footnote and the footnote's
second line clipped the slide edge (caught by rendering the slide, not by the
generator succeeding). Verdict to 11pt at y=6.5, footnote shortened to one
line at 10pt.
</commit_message>
<xml_diff>
--- a/docs/sgm-results.pptx
+++ b/docs/sgm-results.pptx
@@ -7113,8 +7113,8 @@
         </p:nvSpPr>
         <p:spPr>
           <a:xfrm>
-            <a:off x="548640" y="6035040"/>
-            <a:ext cx="11155680" cy="731520"/>
+            <a:off x="548640" y="5943600"/>
+            <a:ext cx="11155680" cy="640080"/>
           </a:xfrm>
           <a:prstGeom prst="rect">
             <a:avLst/>
@@ -7129,7 +7129,7 @@
           <a:p>
             <a:pPr algn="l"/>
             <a:r>
-              <a:rPr sz="1200" b="0">
+              <a:rPr sz="1100" b="0">
                 <a:solidFill>
                   <a:srgbClr val="202124"/>
                 </a:solidFill>
@@ -7148,8 +7148,8 @@
         </p:nvSpPr>
         <p:spPr>
           <a:xfrm>
-            <a:off x="548640" y="6510528"/>
-            <a:ext cx="11155680" cy="365760"/>
+            <a:off x="548640" y="6565392"/>
+            <a:ext cx="11155680" cy="274320"/>
           </a:xfrm>
           <a:prstGeom prst="rect">
             <a:avLst/>
@@ -7164,13 +7164,13 @@
           <a:p>
             <a:pPr algn="l"/>
             <a:r>
-              <a:rPr sz="1100" b="0">
+              <a:rPr sz="1000" b="0">
                 <a:solidFill>
                   <a:srgbClr val="5F6368"/>
                 </a:solidFill>
                 <a:latin typeface="Calibri"/>
               </a:rPr>
-              <a:t>MDE/s is the work-performed convention - both scales count: (0.384 + 1.536) Mpx x 64 / time. The OFA engines cannot run this configuration (no 8-path, weighted-P1 or two-scale controls).</a:t>
+              <a:t>MDE/s is the work-performed convention - both scales count. The OFA engines cannot run this configuration (no 8-path, weighted-P1 or two-scale controls).</a:t>
             </a:r>
           </a:p>
         </p:txBody>

</xml_diff>

<commit_message>
deck: full per-unit complement for Configuration B (25 slides)
Every Configuration B target gets the same treatment the primary
configuration's units get -- the work-convention arithmetic that produced its
number, then what the measurement means: the generic 8-direction CUDA path
kernel, the A78C tier-artifact correction, the NSP's chain-band diagonals and
the argmin-key lesson, the saturating NEON step, and the oracle's pinned
choices. Deck reads A summary / A units / real imagery / B chart / B units.
</commit_message>
<xml_diff>
--- a/docs/sgm-results.pptx
+++ b/docs/sgm-results.pptx
@@ -20,6 +20,16 @@
     <p:sldId id="268" r:id="rId19"/>
     <p:sldId id="269" r:id="rId20"/>
     <p:sldId id="270" r:id="rId21"/>
+    <p:sldId id="271" r:id="rId22"/>
+    <p:sldId id="272" r:id="rId23"/>
+    <p:sldId id="273" r:id="rId24"/>
+    <p:sldId id="274" r:id="rId25"/>
+    <p:sldId id="275" r:id="rId26"/>
+    <p:sldId id="276" r:id="rId27"/>
+    <p:sldId id="277" r:id="rId28"/>
+    <p:sldId id="278" r:id="rId29"/>
+    <p:sldId id="279" r:id="rId30"/>
+    <p:sldId id="280" r:id="rId31"/>
   </p:sldIdLst>
   <p:sldSz cx="12191695" cy="6858000" type="screen4x3"/>
   <p:notesSz cx="6858000" cy="9144000"/>
@@ -7183,6 +7193,1386 @@
 </p:sld>
 </file>
 
+<file path=ppt/slides/slide16.xml><?xml version="1.0" encoding="utf-8"?>
+<p:sld xmlns:a="http://schemas.openxmlformats.org/drawingml/2006/main" xmlns:p="http://schemas.openxmlformats.org/presentationml/2006/main" xmlns:r="http://schemas.openxmlformats.org/officeDocument/2006/relationships">
+  <p:cSld>
+    <p:spTree>
+      <p:nvGrpSpPr>
+        <p:cNvPr id="1" name=""/>
+        <p:cNvGrpSpPr/>
+        <p:nvPr/>
+      </p:nvGrpSpPr>
+      <p:grpSpPr/>
+      <p:sp>
+        <p:nvSpPr>
+          <p:cNvPr id="2" name="TextBox 1"/>
+          <p:cNvSpPr txBox="1"/>
+          <p:nvPr/>
+        </p:nvSpPr>
+        <p:spPr>
+          <a:xfrm>
+            <a:off x="548640" y="320040"/>
+            <a:ext cx="10058400" cy="640080"/>
+          </a:xfrm>
+          <a:prstGeom prst="rect">
+            <a:avLst/>
+          </a:prstGeom>
+          <a:noFill/>
+        </p:spPr>
+        <p:txBody>
+          <a:bodyPr wrap="square">
+            <a:spAutoFit/>
+          </a:bodyPr>
+          <a:lstStyle/>
+          <a:p>
+            <a:pPr algn="l"/>
+            <a:r>
+              <a:rPr sz="3200" b="1">
+                <a:solidFill>
+                  <a:srgbClr val="4C8BF5"/>
+                </a:solidFill>
+                <a:latin typeface="Calibri"/>
+              </a:rPr>
+              <a:t>NVIDIA RTX 5090</a:t>
+            </a:r>
+          </a:p>
+        </p:txBody>
+      </p:sp>
+      <p:sp>
+        <p:nvSpPr>
+          <p:cNvPr id="3" name="TextBox 2"/>
+          <p:cNvSpPr txBox="1"/>
+          <p:nvPr/>
+        </p:nvSpPr>
+        <p:spPr>
+          <a:xfrm>
+            <a:off x="9509760" y="457200"/>
+            <a:ext cx="2194560" cy="365760"/>
+          </a:xfrm>
+          <a:prstGeom prst="rect">
+            <a:avLst/>
+          </a:prstGeom>
+          <a:noFill/>
+        </p:spPr>
+        <p:txBody>
+          <a:bodyPr wrap="square">
+            <a:spAutoFit/>
+          </a:bodyPr>
+          <a:lstStyle/>
+          <a:p>
+            <a:pPr algn="l"/>
+            <a:r>
+              <a:rPr sz="1200" b="1">
+                <a:solidFill>
+                  <a:srgbClr val="5F6368"/>
+                </a:solidFill>
+                <a:latin typeface="Calibri"/>
+              </a:rPr>
+              <a:t>CONFIGURATION B</a:t>
+            </a:r>
+          </a:p>
+        </p:txBody>
+      </p:sp>
+      <p:sp>
+        <p:nvSpPr>
+          <p:cNvPr id="4" name="TextBox 3"/>
+          <p:cNvSpPr txBox="1"/>
+          <p:nvPr/>
+        </p:nvSpPr>
+        <p:spPr>
+          <a:xfrm>
+            <a:off x="548640" y="914400"/>
+            <a:ext cx="10881360" cy="365760"/>
+          </a:xfrm>
+          <a:prstGeom prst="rect">
+            <a:avLst/>
+          </a:prstGeom>
+          <a:noFill/>
+        </p:spPr>
+        <p:txBody>
+          <a:bodyPr wrap="square">
+            <a:spAutoFit/>
+          </a:bodyPr>
+          <a:lstStyle/>
+          <a:p>
+            <a:pPr algn="l"/>
+            <a:r>
+              <a:rPr sz="1300" b="0">
+                <a:solidFill>
+                  <a:srgbClr val="5F6368"/>
+                </a:solidFill>
+                <a:latin typeface="Calibri"/>
+              </a:rPr>
+              <a:t>CUDA, tuned  |  second independent run: 9.59 ms (shared, unlocked card)</a:t>
+            </a:r>
+          </a:p>
+        </p:txBody>
+      </p:sp>
+      <p:sp>
+        <p:nvSpPr>
+          <p:cNvPr id="5" name="TextBox 4"/>
+          <p:cNvSpPr txBox="1"/>
+          <p:nvPr/>
+        </p:nvSpPr>
+        <p:spPr>
+          <a:xfrm>
+            <a:off x="548640" y="1554480"/>
+            <a:ext cx="10515600" cy="365760"/>
+          </a:xfrm>
+          <a:prstGeom prst="rect">
+            <a:avLst/>
+          </a:prstGeom>
+          <a:noFill/>
+        </p:spPr>
+        <p:txBody>
+          <a:bodyPr wrap="square">
+            <a:spAutoFit/>
+          </a:bodyPr>
+          <a:lstStyle/>
+          <a:p>
+            <a:pPr algn="l"/>
+            <a:r>
+              <a:rPr sz="1600" b="1">
+                <a:solidFill>
+                  <a:srgbClr val="202124"/>
+                </a:solidFill>
+                <a:latin typeface="Calibri"/>
+              </a:rPr>
+              <a:t>The calculation (work-performed convention)</a:t>
+            </a:r>
+          </a:p>
+        </p:txBody>
+      </p:sp>
+      <p:sp>
+        <p:nvSpPr>
+          <p:cNvPr id="6" name="TextBox 5"/>
+          <p:cNvSpPr txBox="1"/>
+          <p:nvPr/>
+        </p:nvSpPr>
+        <p:spPr>
+          <a:xfrm>
+            <a:off x="548640" y="1965960"/>
+            <a:ext cx="10881360" cy="1554480"/>
+          </a:xfrm>
+          <a:prstGeom prst="rect">
+            <a:avLst/>
+          </a:prstGeom>
+          <a:noFill/>
+        </p:spPr>
+        <p:txBody>
+          <a:bodyPr wrap="square">
+            <a:spAutoFit/>
+          </a:bodyPr>
+          <a:lstStyle/>
+          <a:p>
+            <a:pPr algn="l"/>
+            <a:r>
+              <a:rPr sz="1400" b="0">
+                <a:solidFill>
+                  <a:srgbClr val="202124"/>
+                </a:solidFill>
+                <a:latin typeface="Consolas"/>
+              </a:rPr>
+              <a:t>MDE/s  =  (0.384 + 1.536) Mpx x 64 / runtime      (both full-search scales count)
+        =  122,880,000 disparity estimations / 0.00906 s
+        =  13,563 million disparity estimations per second
+frame rate  =  1000 / 9.06  =  110.38 fps   (960x400 disparity map out)</a:t>
+            </a:r>
+          </a:p>
+        </p:txBody>
+      </p:sp>
+      <p:sp>
+        <p:nvSpPr>
+          <p:cNvPr id="7" name="TextBox 6"/>
+          <p:cNvSpPr txBox="1"/>
+          <p:nvPr/>
+        </p:nvSpPr>
+        <p:spPr>
+          <a:xfrm>
+            <a:off x="548640" y="3657600"/>
+            <a:ext cx="10515600" cy="365760"/>
+          </a:xfrm>
+          <a:prstGeom prst="rect">
+            <a:avLst/>
+          </a:prstGeom>
+          <a:noFill/>
+        </p:spPr>
+        <p:txBody>
+          <a:bodyPr wrap="square">
+            <a:spAutoFit/>
+          </a:bodyPr>
+          <a:lstStyle/>
+          <a:p>
+            <a:pPr algn="l"/>
+            <a:r>
+              <a:rPr sz="1600" b="1">
+                <a:solidFill>
+                  <a:srgbClr val="202124"/>
+                </a:solidFill>
+                <a:latin typeface="Calibri"/>
+              </a:rPr>
+              <a:t>What the measurement means</a:t>
+            </a:r>
+          </a:p>
+        </p:txBody>
+      </p:sp>
+      <p:sp>
+        <p:nvSpPr>
+          <p:cNvPr id="8" name="TextBox 7"/>
+          <p:cNvSpPr txBox="1"/>
+          <p:nvPr/>
+        </p:nvSpPr>
+        <p:spPr>
+          <a:xfrm>
+            <a:off x="548640" y="4023360"/>
+            <a:ext cx="10881360" cy="2286000"/>
+          </a:xfrm>
+          <a:prstGeom prst="rect">
+            <a:avLst/>
+          </a:prstGeom>
+          <a:noFill/>
+        </p:spPr>
+        <p:txBody>
+          <a:bodyPr wrap="square">
+            <a:spAutoFit/>
+          </a:bodyPr>
+          <a:lstStyle/>
+          <a:p>
+            <a:pPr algn="l"/>
+            <a:r>
+              <a:rPr sz="1300" b="0">
+                <a:solidFill>
+                  <a:srgbClr val="202124"/>
+                </a:solidFill>
+                <a:latin typeface="Calibri"/>
+              </a:rPr>
+              <a:t>The fastest Configuration B target: 110 fps of two-scale, 8-path, weighted-P1</a:t>
+            </a:r>
+          </a:p>
+          <a:p>
+            <a:r>
+              <a:rPr sz="1300">
+                <a:solidFill>
+                  <a:srgbClr val="202124"/>
+                </a:solidFill>
+                <a:latin typeface="Calibri"/>
+              </a:rPr>
+              <a:t>SGM on a workload designed for a fixed-function embedded block.</a:t>
+            </a:r>
+          </a:p>
+          <a:p>
+            <a:r>
+              <a:rPr sz="1300">
+                <a:solidFill>
+                  <a:srgbClr val="202124"/>
+                </a:solidFill>
+                <a:latin typeface="Calibri"/>
+              </a:rPr>
+              <a:t>The port is a GENERIC path kernel: one warp owns one path line in any of the 8</a:t>
+            </a:r>
+          </a:p>
+          <a:p>
+            <a:r>
+              <a:rPr sz="1300">
+                <a:solidFill>
+                  <a:srgbClr val="202124"/>
+                </a:solidFill>
+                <a:latin typeface="Calibri"/>
+              </a:rPr>
+              <a:t>directions, line start derived from the direction pair, P1 passed per launch</a:t>
+            </a:r>
+          </a:p>
+          <a:p>
+            <a:r>
+              <a:rPr sz="1300">
+                <a:solidFill>
+                  <a:srgbClr val="202124"/>
+                </a:solidFill>
+                <a:latin typeface="Calibri"/>
+              </a:rPr>
+              <a:t>so the direction weighting costs nothing. Bit-exact on the first full run.</a:t>
+            </a:r>
+          </a:p>
+          <a:p>
+            <a:r>
+              <a:rPr sz="1300">
+                <a:solidFill>
+                  <a:srgbClr val="202124"/>
+                </a:solidFill>
+                <a:latin typeface="Calibri"/>
+              </a:rPr>
+              <a:t>It lacks the primary kernel's path-pairing pass, so this row is the</a:t>
+            </a:r>
+          </a:p>
+          <a:p>
+            <a:r>
+              <a:rPr sz="1300">
+                <a:solidFill>
+                  <a:srgbClr val="202124"/>
+                </a:solidFill>
+                <a:latin typeface="Calibri"/>
+              </a:rPr>
+              <a:t>conservative side of what the card can do.</a:t>
+            </a:r>
+          </a:p>
+        </p:txBody>
+      </p:sp>
+      <p:sp>
+        <p:nvSpPr>
+          <p:cNvPr id="9" name="TextBox 8"/>
+          <p:cNvSpPr txBox="1"/>
+          <p:nvPr/>
+        </p:nvSpPr>
+        <p:spPr>
+          <a:xfrm>
+            <a:off x="548640" y="6446520"/>
+            <a:ext cx="10881360" cy="365760"/>
+          </a:xfrm>
+          <a:prstGeom prst="rect">
+            <a:avLst/>
+          </a:prstGeom>
+          <a:noFill/>
+        </p:spPr>
+        <p:txBody>
+          <a:bodyPr wrap="square">
+            <a:spAutoFit/>
+          </a:bodyPr>
+          <a:lstStyle/>
+          <a:p>
+            <a:pPr algn="l"/>
+            <a:r>
+              <a:rPr sz="1100" b="0">
+                <a:solidFill>
+                  <a:srgbClr val="5F6368"/>
+                </a:solidFill>
+                <a:latin typeface="Calibri"/>
+              </a:rPr>
+              <a:t>MEASURED -- median of the timed frames, bit-exact to golden bcb9cb0bd6f49799 in the same run.</a:t>
+            </a:r>
+          </a:p>
+        </p:txBody>
+      </p:sp>
+    </p:spTree>
+  </p:cSld>
+  <p:clrMapOvr>
+    <a:masterClrMapping/>
+  </p:clrMapOvr>
+</p:sld>
+</file>
+
+<file path=ppt/slides/slide17.xml><?xml version="1.0" encoding="utf-8"?>
+<p:sld xmlns:a="http://schemas.openxmlformats.org/drawingml/2006/main" xmlns:p="http://schemas.openxmlformats.org/presentationml/2006/main" xmlns:r="http://schemas.openxmlformats.org/officeDocument/2006/relationships">
+  <p:cSld>
+    <p:spTree>
+      <p:nvGrpSpPr>
+        <p:cNvPr id="1" name=""/>
+        <p:cNvGrpSpPr/>
+        <p:nvPr/>
+      </p:nvGrpSpPr>
+      <p:grpSpPr/>
+      <p:sp>
+        <p:nvSpPr>
+          <p:cNvPr id="2" name="TextBox 1"/>
+          <p:cNvSpPr txBox="1"/>
+          <p:nvPr/>
+        </p:nvSpPr>
+        <p:spPr>
+          <a:xfrm>
+            <a:off x="548640" y="320040"/>
+            <a:ext cx="10058400" cy="640080"/>
+          </a:xfrm>
+          <a:prstGeom prst="rect">
+            <a:avLst/>
+          </a:prstGeom>
+          <a:noFill/>
+        </p:spPr>
+        <p:txBody>
+          <a:bodyPr wrap="square">
+            <a:spAutoFit/>
+          </a:bodyPr>
+          <a:lstStyle/>
+          <a:p>
+            <a:pPr algn="l"/>
+            <a:r>
+              <a:rPr sz="3200" b="1">
+                <a:solidFill>
+                  <a:srgbClr val="4C8BF5"/>
+                </a:solidFill>
+                <a:latin typeface="Calibri"/>
+              </a:rPr>
+              <a:t>NVIDIA Thor</a:t>
+            </a:r>
+          </a:p>
+        </p:txBody>
+      </p:sp>
+      <p:sp>
+        <p:nvSpPr>
+          <p:cNvPr id="3" name="TextBox 2"/>
+          <p:cNvSpPr txBox="1"/>
+          <p:nvPr/>
+        </p:nvSpPr>
+        <p:spPr>
+          <a:xfrm>
+            <a:off x="9509760" y="457200"/>
+            <a:ext cx="2194560" cy="365760"/>
+          </a:xfrm>
+          <a:prstGeom prst="rect">
+            <a:avLst/>
+          </a:prstGeom>
+          <a:noFill/>
+        </p:spPr>
+        <p:txBody>
+          <a:bodyPr wrap="square">
+            <a:spAutoFit/>
+          </a:bodyPr>
+          <a:lstStyle/>
+          <a:p>
+            <a:pPr algn="l"/>
+            <a:r>
+              <a:rPr sz="1200" b="1">
+                <a:solidFill>
+                  <a:srgbClr val="5F6368"/>
+                </a:solidFill>
+                <a:latin typeface="Calibri"/>
+              </a:rPr>
+              <a:t>CONFIGURATION B</a:t>
+            </a:r>
+          </a:p>
+        </p:txBody>
+      </p:sp>
+      <p:sp>
+        <p:nvSpPr>
+          <p:cNvPr id="4" name="TextBox 3"/>
+          <p:cNvSpPr txBox="1"/>
+          <p:nvPr/>
+        </p:nvSpPr>
+        <p:spPr>
+          <a:xfrm>
+            <a:off x="548640" y="914400"/>
+            <a:ext cx="10881360" cy="365760"/>
+          </a:xfrm>
+          <a:prstGeom prst="rect">
+            <a:avLst/>
+          </a:prstGeom>
+          <a:noFill/>
+        </p:spPr>
+        <p:txBody>
+          <a:bodyPr wrap="square">
+            <a:spAutoFit/>
+          </a:bodyPr>
+          <a:lstStyle/>
+          <a:p>
+            <a:pPr algn="l"/>
+            <a:r>
+              <a:rPr sz="1300" b="0">
+                <a:solidFill>
+                  <a:srgbClr val="5F6368"/>
+                </a:solidFill>
+                <a:latin typeface="Calibri"/>
+              </a:rPr>
+              <a:t>CUDA, same kernel, sm_110</a:t>
+            </a:r>
+          </a:p>
+        </p:txBody>
+      </p:sp>
+      <p:sp>
+        <p:nvSpPr>
+          <p:cNvPr id="5" name="TextBox 4"/>
+          <p:cNvSpPr txBox="1"/>
+          <p:nvPr/>
+        </p:nvSpPr>
+        <p:spPr>
+          <a:xfrm>
+            <a:off x="548640" y="1554480"/>
+            <a:ext cx="10515600" cy="365760"/>
+          </a:xfrm>
+          <a:prstGeom prst="rect">
+            <a:avLst/>
+          </a:prstGeom>
+          <a:noFill/>
+        </p:spPr>
+        <p:txBody>
+          <a:bodyPr wrap="square">
+            <a:spAutoFit/>
+          </a:bodyPr>
+          <a:lstStyle/>
+          <a:p>
+            <a:pPr algn="l"/>
+            <a:r>
+              <a:rPr sz="1600" b="1">
+                <a:solidFill>
+                  <a:srgbClr val="202124"/>
+                </a:solidFill>
+                <a:latin typeface="Calibri"/>
+              </a:rPr>
+              <a:t>The calculation (work-performed convention)</a:t>
+            </a:r>
+          </a:p>
+        </p:txBody>
+      </p:sp>
+      <p:sp>
+        <p:nvSpPr>
+          <p:cNvPr id="6" name="TextBox 5"/>
+          <p:cNvSpPr txBox="1"/>
+          <p:nvPr/>
+        </p:nvSpPr>
+        <p:spPr>
+          <a:xfrm>
+            <a:off x="548640" y="1965960"/>
+            <a:ext cx="10881360" cy="1554480"/>
+          </a:xfrm>
+          <a:prstGeom prst="rect">
+            <a:avLst/>
+          </a:prstGeom>
+          <a:noFill/>
+        </p:spPr>
+        <p:txBody>
+          <a:bodyPr wrap="square">
+            <a:spAutoFit/>
+          </a:bodyPr>
+          <a:lstStyle/>
+          <a:p>
+            <a:pPr algn="l"/>
+            <a:r>
+              <a:rPr sz="1400" b="0">
+                <a:solidFill>
+                  <a:srgbClr val="202124"/>
+                </a:solidFill>
+                <a:latin typeface="Consolas"/>
+              </a:rPr>
+              <a:t>MDE/s  =  (0.384 + 1.536) Mpx x 64 / runtime      (both full-search scales count)
+        =  122,880,000 disparity estimations / 0.04510 s
+        =  2,725 million disparity estimations per second
+frame rate  =  1000 / 45.10  =  22.17 fps   (960x400 disparity map out)</a:t>
+            </a:r>
+          </a:p>
+        </p:txBody>
+      </p:sp>
+      <p:sp>
+        <p:nvSpPr>
+          <p:cNvPr id="7" name="TextBox 6"/>
+          <p:cNvSpPr txBox="1"/>
+          <p:nvPr/>
+        </p:nvSpPr>
+        <p:spPr>
+          <a:xfrm>
+            <a:off x="548640" y="3657600"/>
+            <a:ext cx="10515600" cy="365760"/>
+          </a:xfrm>
+          <a:prstGeom prst="rect">
+            <a:avLst/>
+          </a:prstGeom>
+          <a:noFill/>
+        </p:spPr>
+        <p:txBody>
+          <a:bodyPr wrap="square">
+            <a:spAutoFit/>
+          </a:bodyPr>
+          <a:lstStyle/>
+          <a:p>
+            <a:pPr algn="l"/>
+            <a:r>
+              <a:rPr sz="1600" b="1">
+                <a:solidFill>
+                  <a:srgbClr val="202124"/>
+                </a:solidFill>
+                <a:latin typeface="Calibri"/>
+              </a:rPr>
+              <a:t>What the measurement means</a:t>
+            </a:r>
+          </a:p>
+        </p:txBody>
+      </p:sp>
+      <p:sp>
+        <p:nvSpPr>
+          <p:cNvPr id="8" name="TextBox 7"/>
+          <p:cNvSpPr txBox="1"/>
+          <p:nvPr/>
+        </p:nvSpPr>
+        <p:spPr>
+          <a:xfrm>
+            <a:off x="548640" y="4023360"/>
+            <a:ext cx="10881360" cy="2286000"/>
+          </a:xfrm>
+          <a:prstGeom prst="rect">
+            <a:avLst/>
+          </a:prstGeom>
+          <a:noFill/>
+        </p:spPr>
+        <p:txBody>
+          <a:bodyPr wrap="square">
+            <a:spAutoFit/>
+          </a:bodyPr>
+          <a:lstStyle/>
+          <a:p>
+            <a:pPr algn="l"/>
+            <a:r>
+              <a:rPr sz="1300" b="0">
+                <a:solidFill>
+                  <a:srgbClr val="202124"/>
+                </a:solidFill>
+                <a:latin typeface="Calibri"/>
+              </a:rPr>
+              <a:t>22 fps embedded. Same generic 8-direction kernel as the 5090, bit-exact.</a:t>
+            </a:r>
+          </a:p>
+          <a:p>
+            <a:r>
+              <a:rPr sz="1300">
+                <a:solidFill>
+                  <a:srgbClr val="202124"/>
+                </a:solidFill>
+                <a:latin typeface="Calibri"/>
+              </a:rPr>
+              <a:t>The gap to the 5090 (5.0x) is close to the bandwidth ratio of the parts,</a:t>
+            </a:r>
+          </a:p>
+          <a:p>
+            <a:r>
+              <a:rPr sz="1300">
+                <a:solidFill>
+                  <a:srgbClr val="202124"/>
+                </a:solidFill>
+                <a:latin typeface="Calibri"/>
+              </a:rPr>
+              <a:t>consistent with the Configuration A finding that tuned SGM converges on</a:t>
+            </a:r>
+          </a:p>
+          <a:p>
+            <a:r>
+              <a:rPr sz="1300">
+                <a:solidFill>
+                  <a:srgbClr val="202124"/>
+                </a:solidFill>
+                <a:latin typeface="Calibri"/>
+              </a:rPr>
+              <a:t>memory traffic once the arithmetic is done.</a:t>
+            </a:r>
+          </a:p>
+        </p:txBody>
+      </p:sp>
+      <p:sp>
+        <p:nvSpPr>
+          <p:cNvPr id="9" name="TextBox 8"/>
+          <p:cNvSpPr txBox="1"/>
+          <p:nvPr/>
+        </p:nvSpPr>
+        <p:spPr>
+          <a:xfrm>
+            <a:off x="548640" y="6446520"/>
+            <a:ext cx="10881360" cy="365760"/>
+          </a:xfrm>
+          <a:prstGeom prst="rect">
+            <a:avLst/>
+          </a:prstGeom>
+          <a:noFill/>
+        </p:spPr>
+        <p:txBody>
+          <a:bodyPr wrap="square">
+            <a:spAutoFit/>
+          </a:bodyPr>
+          <a:lstStyle/>
+          <a:p>
+            <a:pPr algn="l"/>
+            <a:r>
+              <a:rPr sz="1100" b="0">
+                <a:solidFill>
+                  <a:srgbClr val="5F6368"/>
+                </a:solidFill>
+                <a:latin typeface="Calibri"/>
+              </a:rPr>
+              <a:t>MEASURED -- median of the timed frames, bit-exact to golden bcb9cb0bd6f49799 in the same run.</a:t>
+            </a:r>
+          </a:p>
+        </p:txBody>
+      </p:sp>
+    </p:spTree>
+  </p:cSld>
+  <p:clrMapOvr>
+    <a:masterClrMapping/>
+  </p:clrMapOvr>
+</p:sld>
+</file>
+
+<file path=ppt/slides/slide18.xml><?xml version="1.0" encoding="utf-8"?>
+<p:sld xmlns:a="http://schemas.openxmlformats.org/drawingml/2006/main" xmlns:p="http://schemas.openxmlformats.org/presentationml/2006/main" xmlns:r="http://schemas.openxmlformats.org/officeDocument/2006/relationships">
+  <p:cSld>
+    <p:spTree>
+      <p:nvGrpSpPr>
+        <p:cNvPr id="1" name=""/>
+        <p:cNvGrpSpPr/>
+        <p:nvPr/>
+      </p:nvGrpSpPr>
+      <p:grpSpPr/>
+      <p:sp>
+        <p:nvSpPr>
+          <p:cNvPr id="2" name="TextBox 1"/>
+          <p:cNvSpPr txBox="1"/>
+          <p:nvPr/>
+        </p:nvSpPr>
+        <p:spPr>
+          <a:xfrm>
+            <a:off x="548640" y="320040"/>
+            <a:ext cx="10058400" cy="640080"/>
+          </a:xfrm>
+          <a:prstGeom prst="rect">
+            <a:avLst/>
+          </a:prstGeom>
+          <a:noFill/>
+        </p:spPr>
+        <p:txBody>
+          <a:bodyPr wrap="square">
+            <a:spAutoFit/>
+          </a:bodyPr>
+          <a:lstStyle/>
+          <a:p>
+            <a:pPr algn="l"/>
+            <a:r>
+              <a:rPr sz="3200" b="1">
+                <a:solidFill>
+                  <a:srgbClr val="4C8BF5"/>
+                </a:solidFill>
+                <a:latin typeface="Calibri"/>
+              </a:rPr>
+              <a:t>NVIDIA Orin AGX</a:t>
+            </a:r>
+          </a:p>
+        </p:txBody>
+      </p:sp>
+      <p:sp>
+        <p:nvSpPr>
+          <p:cNvPr id="3" name="TextBox 2"/>
+          <p:cNvSpPr txBox="1"/>
+          <p:nvPr/>
+        </p:nvSpPr>
+        <p:spPr>
+          <a:xfrm>
+            <a:off x="9509760" y="457200"/>
+            <a:ext cx="2194560" cy="365760"/>
+          </a:xfrm>
+          <a:prstGeom prst="rect">
+            <a:avLst/>
+          </a:prstGeom>
+          <a:noFill/>
+        </p:spPr>
+        <p:txBody>
+          <a:bodyPr wrap="square">
+            <a:spAutoFit/>
+          </a:bodyPr>
+          <a:lstStyle/>
+          <a:p>
+            <a:pPr algn="l"/>
+            <a:r>
+              <a:rPr sz="1200" b="1">
+                <a:solidFill>
+                  <a:srgbClr val="5F6368"/>
+                </a:solidFill>
+                <a:latin typeface="Calibri"/>
+              </a:rPr>
+              <a:t>CONFIGURATION B</a:t>
+            </a:r>
+          </a:p>
+        </p:txBody>
+      </p:sp>
+      <p:sp>
+        <p:nvSpPr>
+          <p:cNvPr id="4" name="TextBox 3"/>
+          <p:cNvSpPr txBox="1"/>
+          <p:nvPr/>
+        </p:nvSpPr>
+        <p:spPr>
+          <a:xfrm>
+            <a:off x="548640" y="914400"/>
+            <a:ext cx="10881360" cy="365760"/>
+          </a:xfrm>
+          <a:prstGeom prst="rect">
+            <a:avLst/>
+          </a:prstGeom>
+          <a:noFill/>
+        </p:spPr>
+        <p:txBody>
+          <a:bodyPr wrap="square">
+            <a:spAutoFit/>
+          </a:bodyPr>
+          <a:lstStyle/>
+          <a:p>
+            <a:pPr algn="l"/>
+            <a:r>
+              <a:rPr sz="1300" b="0">
+                <a:solidFill>
+                  <a:srgbClr val="5F6368"/>
+                </a:solidFill>
+                <a:latin typeface="Calibri"/>
+              </a:rPr>
+              <a:t>CUDA, same kernel, sm_87</a:t>
+            </a:r>
+          </a:p>
+        </p:txBody>
+      </p:sp>
+      <p:sp>
+        <p:nvSpPr>
+          <p:cNvPr id="5" name="TextBox 4"/>
+          <p:cNvSpPr txBox="1"/>
+          <p:nvPr/>
+        </p:nvSpPr>
+        <p:spPr>
+          <a:xfrm>
+            <a:off x="548640" y="1554480"/>
+            <a:ext cx="10515600" cy="365760"/>
+          </a:xfrm>
+          <a:prstGeom prst="rect">
+            <a:avLst/>
+          </a:prstGeom>
+          <a:noFill/>
+        </p:spPr>
+        <p:txBody>
+          <a:bodyPr wrap="square">
+            <a:spAutoFit/>
+          </a:bodyPr>
+          <a:lstStyle/>
+          <a:p>
+            <a:pPr algn="l"/>
+            <a:r>
+              <a:rPr sz="1600" b="1">
+                <a:solidFill>
+                  <a:srgbClr val="202124"/>
+                </a:solidFill>
+                <a:latin typeface="Calibri"/>
+              </a:rPr>
+              <a:t>The calculation (work-performed convention)</a:t>
+            </a:r>
+          </a:p>
+        </p:txBody>
+      </p:sp>
+      <p:sp>
+        <p:nvSpPr>
+          <p:cNvPr id="6" name="TextBox 5"/>
+          <p:cNvSpPr txBox="1"/>
+          <p:nvPr/>
+        </p:nvSpPr>
+        <p:spPr>
+          <a:xfrm>
+            <a:off x="548640" y="1965960"/>
+            <a:ext cx="10881360" cy="1554480"/>
+          </a:xfrm>
+          <a:prstGeom prst="rect">
+            <a:avLst/>
+          </a:prstGeom>
+          <a:noFill/>
+        </p:spPr>
+        <p:txBody>
+          <a:bodyPr wrap="square">
+            <a:spAutoFit/>
+          </a:bodyPr>
+          <a:lstStyle/>
+          <a:p>
+            <a:pPr algn="l"/>
+            <a:r>
+              <a:rPr sz="1400" b="0">
+                <a:solidFill>
+                  <a:srgbClr val="202124"/>
+                </a:solidFill>
+                <a:latin typeface="Consolas"/>
+              </a:rPr>
+              <a:t>MDE/s  =  (0.384 + 1.536) Mpx x 64 / runtime      (both full-search scales count)
+        =  122,880,000 disparity estimations / 0.07280 s
+        =  1,688 million disparity estimations per second
+frame rate  =  1000 / 72.80  =  13.74 fps   (960x400 disparity map out)</a:t>
+            </a:r>
+          </a:p>
+        </p:txBody>
+      </p:sp>
+      <p:sp>
+        <p:nvSpPr>
+          <p:cNvPr id="7" name="TextBox 6"/>
+          <p:cNvSpPr txBox="1"/>
+          <p:nvPr/>
+        </p:nvSpPr>
+        <p:spPr>
+          <a:xfrm>
+            <a:off x="548640" y="3657600"/>
+            <a:ext cx="10515600" cy="365760"/>
+          </a:xfrm>
+          <a:prstGeom prst="rect">
+            <a:avLst/>
+          </a:prstGeom>
+          <a:noFill/>
+        </p:spPr>
+        <p:txBody>
+          <a:bodyPr wrap="square">
+            <a:spAutoFit/>
+          </a:bodyPr>
+          <a:lstStyle/>
+          <a:p>
+            <a:pPr algn="l"/>
+            <a:r>
+              <a:rPr sz="1600" b="1">
+                <a:solidFill>
+                  <a:srgbClr val="202124"/>
+                </a:solidFill>
+                <a:latin typeface="Calibri"/>
+              </a:rPr>
+              <a:t>What the measurement means</a:t>
+            </a:r>
+          </a:p>
+        </p:txBody>
+      </p:sp>
+      <p:sp>
+        <p:nvSpPr>
+          <p:cNvPr id="8" name="TextBox 7"/>
+          <p:cNvSpPr txBox="1"/>
+          <p:nvPr/>
+        </p:nvSpPr>
+        <p:spPr>
+          <a:xfrm>
+            <a:off x="548640" y="4023360"/>
+            <a:ext cx="10881360" cy="2286000"/>
+          </a:xfrm>
+          <a:prstGeom prst="rect">
+            <a:avLst/>
+          </a:prstGeom>
+          <a:noFill/>
+        </p:spPr>
+        <p:txBody>
+          <a:bodyPr wrap="square">
+            <a:spAutoFit/>
+          </a:bodyPr>
+          <a:lstStyle/>
+          <a:p>
+            <a:pPr algn="l"/>
+            <a:r>
+              <a:rPr sz="1300" b="0">
+                <a:solidFill>
+                  <a:srgbClr val="202124"/>
+                </a:solidFill>
+                <a:latin typeface="Calibri"/>
+              </a:rPr>
+              <a:t>14 fps on the previous embedded generation, bit-exact, no per-part tuning.</a:t>
+            </a:r>
+          </a:p>
+        </p:txBody>
+      </p:sp>
+      <p:sp>
+        <p:nvSpPr>
+          <p:cNvPr id="9" name="TextBox 8"/>
+          <p:cNvSpPr txBox="1"/>
+          <p:nvPr/>
+        </p:nvSpPr>
+        <p:spPr>
+          <a:xfrm>
+            <a:off x="548640" y="6446520"/>
+            <a:ext cx="10881360" cy="365760"/>
+          </a:xfrm>
+          <a:prstGeom prst="rect">
+            <a:avLst/>
+          </a:prstGeom>
+          <a:noFill/>
+        </p:spPr>
+        <p:txBody>
+          <a:bodyPr wrap="square">
+            <a:spAutoFit/>
+          </a:bodyPr>
+          <a:lstStyle/>
+          <a:p>
+            <a:pPr algn="l"/>
+            <a:r>
+              <a:rPr sz="1100" b="0">
+                <a:solidFill>
+                  <a:srgbClr val="5F6368"/>
+                </a:solidFill>
+                <a:latin typeface="Calibri"/>
+              </a:rPr>
+              <a:t>MEASURED -- median of the timed frames, bit-exact to golden bcb9cb0bd6f49799 in the same run.</a:t>
+            </a:r>
+          </a:p>
+        </p:txBody>
+      </p:sp>
+    </p:spTree>
+  </p:cSld>
+  <p:clrMapOvr>
+    <a:masterClrMapping/>
+  </p:clrMapOvr>
+</p:sld>
+</file>
+
+<file path=ppt/slides/slide19.xml><?xml version="1.0" encoding="utf-8"?>
+<p:sld xmlns:a="http://schemas.openxmlformats.org/drawingml/2006/main" xmlns:p="http://schemas.openxmlformats.org/presentationml/2006/main" xmlns:r="http://schemas.openxmlformats.org/officeDocument/2006/relationships">
+  <p:cSld>
+    <p:spTree>
+      <p:nvGrpSpPr>
+        <p:cNvPr id="1" name=""/>
+        <p:cNvGrpSpPr/>
+        <p:nvPr/>
+      </p:nvGrpSpPr>
+      <p:grpSpPr/>
+      <p:sp>
+        <p:nvSpPr>
+          <p:cNvPr id="2" name="TextBox 1"/>
+          <p:cNvSpPr txBox="1"/>
+          <p:nvPr/>
+        </p:nvSpPr>
+        <p:spPr>
+          <a:xfrm>
+            <a:off x="548640" y="320040"/>
+            <a:ext cx="10058400" cy="640080"/>
+          </a:xfrm>
+          <a:prstGeom prst="rect">
+            <a:avLst/>
+          </a:prstGeom>
+          <a:noFill/>
+        </p:spPr>
+        <p:txBody>
+          <a:bodyPr wrap="square">
+            <a:spAutoFit/>
+          </a:bodyPr>
+          <a:lstStyle/>
+          <a:p>
+            <a:pPr algn="l"/>
+            <a:r>
+              <a:rPr sz="3200" b="1">
+                <a:solidFill>
+                  <a:srgbClr val="E8710A"/>
+                </a:solidFill>
+                <a:latin typeface="Calibri"/>
+              </a:rPr>
+              <a:t>Cortex-A78C x8 (6 threads)</a:t>
+            </a:r>
+          </a:p>
+        </p:txBody>
+      </p:sp>
+      <p:sp>
+        <p:nvSpPr>
+          <p:cNvPr id="3" name="TextBox 2"/>
+          <p:cNvSpPr txBox="1"/>
+          <p:nvPr/>
+        </p:nvSpPr>
+        <p:spPr>
+          <a:xfrm>
+            <a:off x="9509760" y="457200"/>
+            <a:ext cx="2194560" cy="365760"/>
+          </a:xfrm>
+          <a:prstGeom prst="rect">
+            <a:avLst/>
+          </a:prstGeom>
+          <a:noFill/>
+        </p:spPr>
+        <p:txBody>
+          <a:bodyPr wrap="square">
+            <a:spAutoFit/>
+          </a:bodyPr>
+          <a:lstStyle/>
+          <a:p>
+            <a:pPr algn="l"/>
+            <a:r>
+              <a:rPr sz="1200" b="1">
+                <a:solidFill>
+                  <a:srgbClr val="5F6368"/>
+                </a:solidFill>
+                <a:latin typeface="Calibri"/>
+              </a:rPr>
+              <a:t>CONFIGURATION B</a:t>
+            </a:r>
+          </a:p>
+        </p:txBody>
+      </p:sp>
+      <p:sp>
+        <p:nvSpPr>
+          <p:cNvPr id="4" name="TextBox 3"/>
+          <p:cNvSpPr txBox="1"/>
+          <p:nvPr/>
+        </p:nvSpPr>
+        <p:spPr>
+          <a:xfrm>
+            <a:off x="548640" y="914400"/>
+            <a:ext cx="10881360" cy="365760"/>
+          </a:xfrm>
+          <a:prstGeom prst="rect">
+            <a:avLst/>
+          </a:prstGeom>
+          <a:noFill/>
+        </p:spPr>
+        <p:txBody>
+          <a:bodyPr wrap="square">
+            <a:spAutoFit/>
+          </a:bodyPr>
+          <a:lstStyle/>
+          <a:p>
+            <a:pPr algn="l"/>
+            <a:r>
+              <a:rPr sz="1300" b="0">
+                <a:solidFill>
+                  <a:srgbClr val="5F6368"/>
+                </a:solidFill>
+                <a:latin typeface="Calibri"/>
+              </a:rPr>
+              <a:t>Qualcomm IQ-9075, NEON+OpenMP  |  single core: 442.60 ms</a:t>
+            </a:r>
+          </a:p>
+        </p:txBody>
+      </p:sp>
+      <p:sp>
+        <p:nvSpPr>
+          <p:cNvPr id="5" name="TextBox 4"/>
+          <p:cNvSpPr txBox="1"/>
+          <p:nvPr/>
+        </p:nvSpPr>
+        <p:spPr>
+          <a:xfrm>
+            <a:off x="548640" y="1554480"/>
+            <a:ext cx="10515600" cy="365760"/>
+          </a:xfrm>
+          <a:prstGeom prst="rect">
+            <a:avLst/>
+          </a:prstGeom>
+          <a:noFill/>
+        </p:spPr>
+        <p:txBody>
+          <a:bodyPr wrap="square">
+            <a:spAutoFit/>
+          </a:bodyPr>
+          <a:lstStyle/>
+          <a:p>
+            <a:pPr algn="l"/>
+            <a:r>
+              <a:rPr sz="1600" b="1">
+                <a:solidFill>
+                  <a:srgbClr val="202124"/>
+                </a:solidFill>
+                <a:latin typeface="Calibri"/>
+              </a:rPr>
+              <a:t>The calculation (work-performed convention)</a:t>
+            </a:r>
+          </a:p>
+        </p:txBody>
+      </p:sp>
+      <p:sp>
+        <p:nvSpPr>
+          <p:cNvPr id="6" name="TextBox 5"/>
+          <p:cNvSpPr txBox="1"/>
+          <p:nvPr/>
+        </p:nvSpPr>
+        <p:spPr>
+          <a:xfrm>
+            <a:off x="548640" y="1965960"/>
+            <a:ext cx="10881360" cy="1554480"/>
+          </a:xfrm>
+          <a:prstGeom prst="rect">
+            <a:avLst/>
+          </a:prstGeom>
+          <a:noFill/>
+        </p:spPr>
+        <p:txBody>
+          <a:bodyPr wrap="square">
+            <a:spAutoFit/>
+          </a:bodyPr>
+          <a:lstStyle/>
+          <a:p>
+            <a:pPr algn="l"/>
+            <a:r>
+              <a:rPr sz="1400" b="0">
+                <a:solidFill>
+                  <a:srgbClr val="202124"/>
+                </a:solidFill>
+                <a:latin typeface="Consolas"/>
+              </a:rPr>
+              <a:t>MDE/s  =  (0.384 + 1.536) Mpx x 64 / runtime      (both full-search scales count)
+        =  122,880,000 disparity estimations / 0.21190 s
+        =  580 million disparity estimations per second
+frame rate  =  1000 / 211.90  =  4.72 fps   (960x400 disparity map out)</a:t>
+            </a:r>
+          </a:p>
+        </p:txBody>
+      </p:sp>
+      <p:sp>
+        <p:nvSpPr>
+          <p:cNvPr id="7" name="TextBox 6"/>
+          <p:cNvSpPr txBox="1"/>
+          <p:nvPr/>
+        </p:nvSpPr>
+        <p:spPr>
+          <a:xfrm>
+            <a:off x="548640" y="3657600"/>
+            <a:ext cx="10515600" cy="365760"/>
+          </a:xfrm>
+          <a:prstGeom prst="rect">
+            <a:avLst/>
+          </a:prstGeom>
+          <a:noFill/>
+        </p:spPr>
+        <p:txBody>
+          <a:bodyPr wrap="square">
+            <a:spAutoFit/>
+          </a:bodyPr>
+          <a:lstStyle/>
+          <a:p>
+            <a:pPr algn="l"/>
+            <a:r>
+              <a:rPr sz="1600" b="1">
+                <a:solidFill>
+                  <a:srgbClr val="202124"/>
+                </a:solidFill>
+                <a:latin typeface="Calibri"/>
+              </a:rPr>
+              <a:t>What the measurement means</a:t>
+            </a:r>
+          </a:p>
+        </p:txBody>
+      </p:sp>
+      <p:sp>
+        <p:nvSpPr>
+          <p:cNvPr id="8" name="TextBox 7"/>
+          <p:cNvSpPr txBox="1"/>
+          <p:nvPr/>
+        </p:nvSpPr>
+        <p:spPr>
+          <a:xfrm>
+            <a:off x="548640" y="4023360"/>
+            <a:ext cx="10881360" cy="2286000"/>
+          </a:xfrm>
+          <a:prstGeom prst="rect">
+            <a:avLst/>
+          </a:prstGeom>
+          <a:noFill/>
+        </p:spPr>
+        <p:txBody>
+          <a:bodyPr wrap="square">
+            <a:spAutoFit/>
+          </a:bodyPr>
+          <a:lstStyle/>
+          <a:p>
+            <a:pPr algn="l"/>
+            <a:r>
+              <a:rPr sz="1300" b="0">
+                <a:solidFill>
+                  <a:srgbClr val="202124"/>
+                </a:solidFill>
+                <a:latin typeface="Calibri"/>
+              </a:rPr>
+              <a:t>The best programmable embedded result -- and it was measured by the</a:t>
+            </a:r>
+          </a:p>
+          <a:p>
+            <a:r>
+              <a:rPr sz="1300">
+                <a:solidFill>
+                  <a:srgbClr val="202124"/>
+                </a:solidFill>
+                <a:latin typeface="Calibri"/>
+              </a:rPr>
+              <a:t>collaborating session running multiscale/sgm_ms_neon.c UNMODIFIED on their</a:t>
+            </a:r>
+          </a:p>
+          <a:p>
+            <a:r>
+              <a:rPr sz="1300">
+                <a:solidFill>
+                  <a:srgbClr val="202124"/>
+                </a:solidFill>
+                <a:latin typeface="Calibri"/>
+              </a:rPr>
+              <a:t>silicon, golden every run. Medians of five invocations on a board that is</a:t>
+            </a:r>
+          </a:p>
+          <a:p>
+            <a:r>
+              <a:rPr sz="1300">
+                <a:solidFill>
+                  <a:srgbClr val="202124"/>
+                </a:solidFill>
+                <a:latin typeface="Calibri"/>
+              </a:rPr>
+              <a:t>bimodal by ~9% between invocations; medians quoted, never minima.</a:t>
+            </a:r>
+          </a:p>
+          <a:p>
+            <a:r>
+              <a:rPr sz="1300">
+                <a:solidFill>
+                  <a:srgbClr val="202124"/>
+                </a:solidFill>
+                <a:latin typeface="Calibri"/>
+              </a:rPr>
+              <a:t>This row is also what corrected the record: at the oracle tier the NSP</a:t>
+            </a:r>
+          </a:p>
+          <a:p>
+            <a:r>
+              <a:rPr sz="1300">
+                <a:solidFill>
+                  <a:srgbClr val="202124"/>
+                </a:solidFill>
+                <a:latin typeface="Calibri"/>
+              </a:rPr>
+              <a:t>appeared to lead the cluster 3.29x; at the matched NEON tier the cluster</a:t>
+            </a:r>
+          </a:p>
+          <a:p>
+            <a:r>
+              <a:rPr sz="1300">
+                <a:solidFill>
+                  <a:srgbClr val="202124"/>
+                </a:solidFill>
+                <a:latin typeface="Calibri"/>
+              </a:rPr>
+              <a:t>leads 1.30x. A cross-tier comparison is a cross-configuration comparison</a:t>
+            </a:r>
+          </a:p>
+          <a:p>
+            <a:r>
+              <a:rPr sz="1300">
+                <a:solidFill>
+                  <a:srgbClr val="202124"/>
+                </a:solidFill>
+                <a:latin typeface="Calibri"/>
+              </a:rPr>
+              <a:t>wearing a platform comparison's clothes.</a:t>
+            </a:r>
+          </a:p>
+        </p:txBody>
+      </p:sp>
+      <p:sp>
+        <p:nvSpPr>
+          <p:cNvPr id="9" name="TextBox 8"/>
+          <p:cNvSpPr txBox="1"/>
+          <p:nvPr/>
+        </p:nvSpPr>
+        <p:spPr>
+          <a:xfrm>
+            <a:off x="548640" y="6446520"/>
+            <a:ext cx="10881360" cy="365760"/>
+          </a:xfrm>
+          <a:prstGeom prst="rect">
+            <a:avLst/>
+          </a:prstGeom>
+          <a:noFill/>
+        </p:spPr>
+        <p:txBody>
+          <a:bodyPr wrap="square">
+            <a:spAutoFit/>
+          </a:bodyPr>
+          <a:lstStyle/>
+          <a:p>
+            <a:pPr algn="l"/>
+            <a:r>
+              <a:rPr sz="1100" b="0">
+                <a:solidFill>
+                  <a:srgbClr val="5F6368"/>
+                </a:solidFill>
+                <a:latin typeface="Calibri"/>
+              </a:rPr>
+              <a:t>MEASURED -- median of the timed frames, bit-exact to golden bcb9cb0bd6f49799 in the same run.</a:t>
+            </a:r>
+          </a:p>
+        </p:txBody>
+      </p:sp>
+    </p:spTree>
+  </p:cSld>
+  <p:clrMapOvr>
+    <a:masterClrMapping/>
+  </p:clrMapOvr>
+</p:sld>
+</file>
+
 <file path=ppt/slides/slide2.xml><?xml version="1.0" encoding="utf-8"?>
 <p:sld xmlns:a="http://schemas.openxmlformats.org/drawingml/2006/main" xmlns:p="http://schemas.openxmlformats.org/presentationml/2006/main" xmlns:r="http://schemas.openxmlformats.org/officeDocument/2006/relationships">
   <p:cSld>
@@ -7518,6 +8908,2098 @@
                 <a:latin typeface="Calibri"/>
               </a:rPr>
               <a:t>MEASURED — median of the timed frames, golden hash verified in the same run.</a:t>
+            </a:r>
+          </a:p>
+        </p:txBody>
+      </p:sp>
+    </p:spTree>
+  </p:cSld>
+  <p:clrMapOvr>
+    <a:masterClrMapping/>
+  </p:clrMapOvr>
+</p:sld>
+</file>
+
+<file path=ppt/slides/slide20.xml><?xml version="1.0" encoding="utf-8"?>
+<p:sld xmlns:a="http://schemas.openxmlformats.org/drawingml/2006/main" xmlns:p="http://schemas.openxmlformats.org/presentationml/2006/main" xmlns:r="http://schemas.openxmlformats.org/officeDocument/2006/relationships">
+  <p:cSld>
+    <p:spTree>
+      <p:nvGrpSpPr>
+        <p:cNvPr id="1" name=""/>
+        <p:cNvGrpSpPr/>
+        <p:nvPr/>
+      </p:nvGrpSpPr>
+      <p:grpSpPr/>
+      <p:sp>
+        <p:nvSpPr>
+          <p:cNvPr id="2" name="TextBox 1"/>
+          <p:cNvSpPr txBox="1"/>
+          <p:nvPr/>
+        </p:nvSpPr>
+        <p:spPr>
+          <a:xfrm>
+            <a:off x="548640" y="320040"/>
+            <a:ext cx="10058400" cy="640080"/>
+          </a:xfrm>
+          <a:prstGeom prst="rect">
+            <a:avLst/>
+          </a:prstGeom>
+          <a:noFill/>
+        </p:spPr>
+        <p:txBody>
+          <a:bodyPr wrap="square">
+            <a:spAutoFit/>
+          </a:bodyPr>
+          <a:lstStyle/>
+          <a:p>
+            <a:pPr algn="l"/>
+            <a:r>
+              <a:rPr sz="3200" b="1">
+                <a:solidFill>
+                  <a:srgbClr val="E8710A"/>
+                </a:solidFill>
+                <a:latin typeface="Calibri"/>
+              </a:rPr>
+              <a:t>Cortex-A720 x8</a:t>
+            </a:r>
+          </a:p>
+        </p:txBody>
+      </p:sp>
+      <p:sp>
+        <p:nvSpPr>
+          <p:cNvPr id="3" name="TextBox 2"/>
+          <p:cNvSpPr txBox="1"/>
+          <p:nvPr/>
+        </p:nvSpPr>
+        <p:spPr>
+          <a:xfrm>
+            <a:off x="9509760" y="457200"/>
+            <a:ext cx="2194560" cy="365760"/>
+          </a:xfrm>
+          <a:prstGeom prst="rect">
+            <a:avLst/>
+          </a:prstGeom>
+          <a:noFill/>
+        </p:spPr>
+        <p:txBody>
+          <a:bodyPr wrap="square">
+            <a:spAutoFit/>
+          </a:bodyPr>
+          <a:lstStyle/>
+          <a:p>
+            <a:pPr algn="l"/>
+            <a:r>
+              <a:rPr sz="1200" b="1">
+                <a:solidFill>
+                  <a:srgbClr val="5F6368"/>
+                </a:solidFill>
+                <a:latin typeface="Calibri"/>
+              </a:rPr>
+              <a:t>CONFIGURATION B</a:t>
+            </a:r>
+          </a:p>
+        </p:txBody>
+      </p:sp>
+      <p:sp>
+        <p:nvSpPr>
+          <p:cNvPr id="4" name="TextBox 3"/>
+          <p:cNvSpPr txBox="1"/>
+          <p:nvPr/>
+        </p:nvSpPr>
+        <p:spPr>
+          <a:xfrm>
+            <a:off x="548640" y="914400"/>
+            <a:ext cx="10881360" cy="365760"/>
+          </a:xfrm>
+          <a:prstGeom prst="rect">
+            <a:avLst/>
+          </a:prstGeom>
+          <a:noFill/>
+        </p:spPr>
+        <p:txBody>
+          <a:bodyPr wrap="square">
+            <a:spAutoFit/>
+          </a:bodyPr>
+          <a:lstStyle/>
+          <a:p>
+            <a:pPr algn="l"/>
+            <a:r>
+              <a:rPr sz="1300" b="0">
+                <a:solidFill>
+                  <a:srgbClr val="5F6368"/>
+                </a:solidFill>
+                <a:latin typeface="Calibri"/>
+              </a:rPr>
+              <a:t>Radxa Orion O6, NEON+OpenMP  |  single core: 470.9 ms</a:t>
+            </a:r>
+          </a:p>
+        </p:txBody>
+      </p:sp>
+      <p:sp>
+        <p:nvSpPr>
+          <p:cNvPr id="5" name="TextBox 4"/>
+          <p:cNvSpPr txBox="1"/>
+          <p:nvPr/>
+        </p:nvSpPr>
+        <p:spPr>
+          <a:xfrm>
+            <a:off x="548640" y="1554480"/>
+            <a:ext cx="10515600" cy="365760"/>
+          </a:xfrm>
+          <a:prstGeom prst="rect">
+            <a:avLst/>
+          </a:prstGeom>
+          <a:noFill/>
+        </p:spPr>
+        <p:txBody>
+          <a:bodyPr wrap="square">
+            <a:spAutoFit/>
+          </a:bodyPr>
+          <a:lstStyle/>
+          <a:p>
+            <a:pPr algn="l"/>
+            <a:r>
+              <a:rPr sz="1600" b="1">
+                <a:solidFill>
+                  <a:srgbClr val="202124"/>
+                </a:solidFill>
+                <a:latin typeface="Calibri"/>
+              </a:rPr>
+              <a:t>The calculation (work-performed convention)</a:t>
+            </a:r>
+          </a:p>
+        </p:txBody>
+      </p:sp>
+      <p:sp>
+        <p:nvSpPr>
+          <p:cNvPr id="6" name="TextBox 5"/>
+          <p:cNvSpPr txBox="1"/>
+          <p:nvPr/>
+        </p:nvSpPr>
+        <p:spPr>
+          <a:xfrm>
+            <a:off x="548640" y="1965960"/>
+            <a:ext cx="10881360" cy="1554480"/>
+          </a:xfrm>
+          <a:prstGeom prst="rect">
+            <a:avLst/>
+          </a:prstGeom>
+          <a:noFill/>
+        </p:spPr>
+        <p:txBody>
+          <a:bodyPr wrap="square">
+            <a:spAutoFit/>
+          </a:bodyPr>
+          <a:lstStyle/>
+          <a:p>
+            <a:pPr algn="l"/>
+            <a:r>
+              <a:rPr sz="1400" b="0">
+                <a:solidFill>
+                  <a:srgbClr val="202124"/>
+                </a:solidFill>
+                <a:latin typeface="Consolas"/>
+              </a:rPr>
+              <a:t>MDE/s  =  (0.384 + 1.536) Mpx x 64 / runtime      (both full-search scales count)
+        =  122,880,000 disparity estimations / 0.23830 s
+        =  516 million disparity estimations per second
+frame rate  =  1000 / 238.30  =  4.20 fps   (960x400 disparity map out)</a:t>
+            </a:r>
+          </a:p>
+        </p:txBody>
+      </p:sp>
+      <p:sp>
+        <p:nvSpPr>
+          <p:cNvPr id="7" name="TextBox 6"/>
+          <p:cNvSpPr txBox="1"/>
+          <p:nvPr/>
+        </p:nvSpPr>
+        <p:spPr>
+          <a:xfrm>
+            <a:off x="548640" y="3657600"/>
+            <a:ext cx="10515600" cy="365760"/>
+          </a:xfrm>
+          <a:prstGeom prst="rect">
+            <a:avLst/>
+          </a:prstGeom>
+          <a:noFill/>
+        </p:spPr>
+        <p:txBody>
+          <a:bodyPr wrap="square">
+            <a:spAutoFit/>
+          </a:bodyPr>
+          <a:lstStyle/>
+          <a:p>
+            <a:pPr algn="l"/>
+            <a:r>
+              <a:rPr sz="1600" b="1">
+                <a:solidFill>
+                  <a:srgbClr val="202124"/>
+                </a:solidFill>
+                <a:latin typeface="Calibri"/>
+              </a:rPr>
+              <a:t>What the measurement means</a:t>
+            </a:r>
+          </a:p>
+        </p:txBody>
+      </p:sp>
+      <p:sp>
+        <p:nvSpPr>
+          <p:cNvPr id="8" name="TextBox 7"/>
+          <p:cNvSpPr txBox="1"/>
+          <p:nvPr/>
+        </p:nvSpPr>
+        <p:spPr>
+          <a:xfrm>
+            <a:off x="548640" y="4023360"/>
+            <a:ext cx="10881360" cy="2286000"/>
+          </a:xfrm>
+          <a:prstGeom prst="rect">
+            <a:avLst/>
+          </a:prstGeom>
+          <a:noFill/>
+        </p:spPr>
+        <p:txBody>
+          <a:bodyPr wrap="square">
+            <a:spAutoFit/>
+          </a:bodyPr>
+          <a:lstStyle/>
+          <a:p>
+            <a:pPr algn="l"/>
+            <a:r>
+              <a:rPr sz="1300" b="0">
+                <a:solidFill>
+                  <a:srgbClr val="202124"/>
+                </a:solidFill>
+                <a:latin typeface="Calibri"/>
+              </a:rPr>
+              <a:t>The NEON tier is 5.8x the scalar oracle on this cluster. The kernel keeps</a:t>
+            </a:r>
+          </a:p>
+          <a:p>
+            <a:r>
+              <a:rPr sz="1300">
+                <a:solidFill>
+                  <a:srgbClr val="202124"/>
+                </a:solidFill>
+                <a:latin typeface="Calibri"/>
+              </a:rPr>
+              <a:t>Configuration A's register scheme and adds the saturating step, the</a:t>
+            </a:r>
+          </a:p>
+          <a:p>
+            <a:r>
+              <a:rPr sz="1300">
+                <a:solidFill>
+                  <a:srgbClr val="202124"/>
+                </a:solidFill>
+                <a:latin typeface="Calibri"/>
+              </a:rPr>
+              <a:t>direction-weighted P1 per sweep, and a uint16 sum plane for 8-path S.</a:t>
+            </a:r>
+          </a:p>
+          <a:p>
+            <a:r>
+              <a:rPr sz="1300">
+                <a:solidFill>
+                  <a:srgbClr val="202124"/>
+                </a:solidFill>
+                <a:latin typeface="Calibri"/>
+              </a:rPr>
+              <a:t>OpenMP is output-neutral by construction: rows for horizontal sweeps,</a:t>
+            </a:r>
+          </a:p>
+          <a:p>
+            <a:r>
+              <a:rPr sz="1300">
+                <a:solidFill>
+                  <a:srgbClr val="202124"/>
+                </a:solidFill>
+                <a:latin typeface="Calibri"/>
+              </a:rPr>
+              <a:t>columns-within-row for vertical and diagonal, so the hash cannot move</a:t>
+            </a:r>
+          </a:p>
+          <a:p>
+            <a:r>
+              <a:rPr sz="1300">
+                <a:solidFill>
+                  <a:srgbClr val="202124"/>
+                </a:solidFill>
+                <a:latin typeface="Calibri"/>
+              </a:rPr>
+              <a:t>with the thread count.</a:t>
+            </a:r>
+          </a:p>
+        </p:txBody>
+      </p:sp>
+      <p:sp>
+        <p:nvSpPr>
+          <p:cNvPr id="9" name="TextBox 8"/>
+          <p:cNvSpPr txBox="1"/>
+          <p:nvPr/>
+        </p:nvSpPr>
+        <p:spPr>
+          <a:xfrm>
+            <a:off x="548640" y="6446520"/>
+            <a:ext cx="10881360" cy="365760"/>
+          </a:xfrm>
+          <a:prstGeom prst="rect">
+            <a:avLst/>
+          </a:prstGeom>
+          <a:noFill/>
+        </p:spPr>
+        <p:txBody>
+          <a:bodyPr wrap="square">
+            <a:spAutoFit/>
+          </a:bodyPr>
+          <a:lstStyle/>
+          <a:p>
+            <a:pPr algn="l"/>
+            <a:r>
+              <a:rPr sz="1100" b="0">
+                <a:solidFill>
+                  <a:srgbClr val="5F6368"/>
+                </a:solidFill>
+                <a:latin typeface="Calibri"/>
+              </a:rPr>
+              <a:t>MEASURED -- median of the timed frames, bit-exact to golden bcb9cb0bd6f49799 in the same run.</a:t>
+            </a:r>
+          </a:p>
+        </p:txBody>
+      </p:sp>
+    </p:spTree>
+  </p:cSld>
+  <p:clrMapOvr>
+    <a:masterClrMapping/>
+  </p:clrMapOvr>
+</p:sld>
+</file>
+
+<file path=ppt/slides/slide21.xml><?xml version="1.0" encoding="utf-8"?>
+<p:sld xmlns:a="http://schemas.openxmlformats.org/drawingml/2006/main" xmlns:p="http://schemas.openxmlformats.org/presentationml/2006/main" xmlns:r="http://schemas.openxmlformats.org/officeDocument/2006/relationships">
+  <p:cSld>
+    <p:spTree>
+      <p:nvGrpSpPr>
+        <p:cNvPr id="1" name=""/>
+        <p:cNvGrpSpPr/>
+        <p:nvPr/>
+      </p:nvGrpSpPr>
+      <p:grpSpPr/>
+      <p:sp>
+        <p:nvSpPr>
+          <p:cNvPr id="2" name="TextBox 1"/>
+          <p:cNvSpPr txBox="1"/>
+          <p:nvPr/>
+        </p:nvSpPr>
+        <p:spPr>
+          <a:xfrm>
+            <a:off x="548640" y="320040"/>
+            <a:ext cx="10058400" cy="640080"/>
+          </a:xfrm>
+          <a:prstGeom prst="rect">
+            <a:avLst/>
+          </a:prstGeom>
+          <a:noFill/>
+        </p:spPr>
+        <p:txBody>
+          <a:bodyPr wrap="square">
+            <a:spAutoFit/>
+          </a:bodyPr>
+          <a:lstStyle/>
+          <a:p>
+            <a:pPr algn="l"/>
+            <a:r>
+              <a:rPr sz="3200" b="1">
+                <a:solidFill>
+                  <a:srgbClr val="12B5A5"/>
+                </a:solidFill>
+                <a:latin typeface="Calibri"/>
+              </a:rPr>
+              <a:t>Hexagon v73 NSP</a:t>
+            </a:r>
+          </a:p>
+        </p:txBody>
+      </p:sp>
+      <p:sp>
+        <p:nvSpPr>
+          <p:cNvPr id="3" name="TextBox 2"/>
+          <p:cNvSpPr txBox="1"/>
+          <p:nvPr/>
+        </p:nvSpPr>
+        <p:spPr>
+          <a:xfrm>
+            <a:off x="9509760" y="457200"/>
+            <a:ext cx="2194560" cy="365760"/>
+          </a:xfrm>
+          <a:prstGeom prst="rect">
+            <a:avLst/>
+          </a:prstGeom>
+          <a:noFill/>
+        </p:spPr>
+        <p:txBody>
+          <a:bodyPr wrap="square">
+            <a:spAutoFit/>
+          </a:bodyPr>
+          <a:lstStyle/>
+          <a:p>
+            <a:pPr algn="l"/>
+            <a:r>
+              <a:rPr sz="1200" b="1">
+                <a:solidFill>
+                  <a:srgbClr val="5F6368"/>
+                </a:solidFill>
+                <a:latin typeface="Calibri"/>
+              </a:rPr>
+              <a:t>CONFIGURATION B</a:t>
+            </a:r>
+          </a:p>
+        </p:txBody>
+      </p:sp>
+      <p:sp>
+        <p:nvSpPr>
+          <p:cNvPr id="4" name="TextBox 3"/>
+          <p:cNvSpPr txBox="1"/>
+          <p:nvPr/>
+        </p:nvSpPr>
+        <p:spPr>
+          <a:xfrm>
+            <a:off x="548640" y="914400"/>
+            <a:ext cx="10881360" cy="365760"/>
+          </a:xfrm>
+          <a:prstGeom prst="rect">
+            <a:avLst/>
+          </a:prstGeom>
+          <a:noFill/>
+        </p:spPr>
+        <p:txBody>
+          <a:bodyPr wrap="square">
+            <a:spAutoFit/>
+          </a:bodyPr>
+          <a:lstStyle/>
+          <a:p>
+            <a:pPr algn="l"/>
+            <a:r>
+              <a:rPr sz="1300" b="0">
+                <a:solidFill>
+                  <a:srgbClr val="5F6368"/>
+                </a:solidFill>
+                <a:latin typeface="Calibri"/>
+              </a:rPr>
+              <a:t>Qualcomm IQ-9075, HVX, 4 contexts  |  median of 5, 0.75% spread, golden 10/10</a:t>
+            </a:r>
+          </a:p>
+        </p:txBody>
+      </p:sp>
+      <p:sp>
+        <p:nvSpPr>
+          <p:cNvPr id="5" name="TextBox 4"/>
+          <p:cNvSpPr txBox="1"/>
+          <p:nvPr/>
+        </p:nvSpPr>
+        <p:spPr>
+          <a:xfrm>
+            <a:off x="548640" y="1554480"/>
+            <a:ext cx="10515600" cy="365760"/>
+          </a:xfrm>
+          <a:prstGeom prst="rect">
+            <a:avLst/>
+          </a:prstGeom>
+          <a:noFill/>
+        </p:spPr>
+        <p:txBody>
+          <a:bodyPr wrap="square">
+            <a:spAutoFit/>
+          </a:bodyPr>
+          <a:lstStyle/>
+          <a:p>
+            <a:pPr algn="l"/>
+            <a:r>
+              <a:rPr sz="1600" b="1">
+                <a:solidFill>
+                  <a:srgbClr val="202124"/>
+                </a:solidFill>
+                <a:latin typeface="Calibri"/>
+              </a:rPr>
+              <a:t>The calculation (work-performed convention)</a:t>
+            </a:r>
+          </a:p>
+        </p:txBody>
+      </p:sp>
+      <p:sp>
+        <p:nvSpPr>
+          <p:cNvPr id="6" name="TextBox 5"/>
+          <p:cNvSpPr txBox="1"/>
+          <p:nvPr/>
+        </p:nvSpPr>
+        <p:spPr>
+          <a:xfrm>
+            <a:off x="548640" y="1965960"/>
+            <a:ext cx="10881360" cy="1554480"/>
+          </a:xfrm>
+          <a:prstGeom prst="rect">
+            <a:avLst/>
+          </a:prstGeom>
+          <a:noFill/>
+        </p:spPr>
+        <p:txBody>
+          <a:bodyPr wrap="square">
+            <a:spAutoFit/>
+          </a:bodyPr>
+          <a:lstStyle/>
+          <a:p>
+            <a:pPr algn="l"/>
+            <a:r>
+              <a:rPr sz="1400" b="0">
+                <a:solidFill>
+                  <a:srgbClr val="202124"/>
+                </a:solidFill>
+                <a:latin typeface="Consolas"/>
+              </a:rPr>
+              <a:t>MDE/s  =  (0.384 + 1.536) Mpx x 64 / runtime      (both full-search scales count)
+        =  122,880,000 disparity estimations / 0.27630 s
+        =  445 million disparity estimations per second
+frame rate  =  1000 / 276.30  =  3.62 fps   (960x400 disparity map out)</a:t>
+            </a:r>
+          </a:p>
+        </p:txBody>
+      </p:sp>
+      <p:sp>
+        <p:nvSpPr>
+          <p:cNvPr id="7" name="TextBox 6"/>
+          <p:cNvSpPr txBox="1"/>
+          <p:nvPr/>
+        </p:nvSpPr>
+        <p:spPr>
+          <a:xfrm>
+            <a:off x="548640" y="3657600"/>
+            <a:ext cx="10515600" cy="365760"/>
+          </a:xfrm>
+          <a:prstGeom prst="rect">
+            <a:avLst/>
+          </a:prstGeom>
+          <a:noFill/>
+        </p:spPr>
+        <p:txBody>
+          <a:bodyPr wrap="square">
+            <a:spAutoFit/>
+          </a:bodyPr>
+          <a:lstStyle/>
+          <a:p>
+            <a:pPr algn="l"/>
+            <a:r>
+              <a:rPr sz="1600" b="1">
+                <a:solidFill>
+                  <a:srgbClr val="202124"/>
+                </a:solidFill>
+                <a:latin typeface="Calibri"/>
+              </a:rPr>
+              <a:t>What the measurement means</a:t>
+            </a:r>
+          </a:p>
+        </p:txBody>
+      </p:sp>
+      <p:sp>
+        <p:nvSpPr>
+          <p:cNvPr id="8" name="TextBox 7"/>
+          <p:cNvSpPr txBox="1"/>
+          <p:nvPr/>
+        </p:nvSpPr>
+        <p:spPr>
+          <a:xfrm>
+            <a:off x="548640" y="4023360"/>
+            <a:ext cx="10881360" cy="2286000"/>
+          </a:xfrm>
+          <a:prstGeom prst="rect">
+            <a:avLst/>
+          </a:prstGeom>
+          <a:noFill/>
+        </p:spPr>
+        <p:txBody>
+          <a:bodyPr wrap="square">
+            <a:spAutoFit/>
+          </a:bodyPr>
+          <a:lstStyle/>
+          <a:p>
+            <a:pPr algn="l"/>
+            <a:r>
+              <a:rPr sz="1300" b="0">
+                <a:solidFill>
+                  <a:srgbClr val="202124"/>
+                </a:solidFill>
+                <a:latin typeface="Calibri"/>
+              </a:rPr>
+              <a:t>Contributed port, independently re-verified (three further gated runs,</a:t>
+            </a:r>
+          </a:p>
+          <a:p>
+            <a:r>
+              <a:rPr sz="1300">
+                <a:solidFill>
+                  <a:srgbClr val="202124"/>
+                </a:solidFill>
+                <a:latin typeface="Calibri"/>
+              </a:rPr>
+              <a:t>269-272 ms). Per ENGINE this is the embedded win: one NSP beats one A78C</a:t>
+            </a:r>
+          </a:p>
+          <a:p>
+            <a:r>
+              <a:rPr sz="1300">
+                <a:solidFill>
+                  <a:srgbClr val="202124"/>
+                </a:solidFill>
+                <a:latin typeface="Calibri"/>
+              </a:rPr>
+              <a:t>core 1.60x at matched tiers.</a:t>
+            </a:r>
+          </a:p>
+          <a:p>
+            <a:r>
+              <a:rPr sz="1300">
+                <a:solidFill>
+                  <a:srgbClr val="202124"/>
+                </a:solidFill>
+                <a:latin typeface="Calibri"/>
+              </a:rPr>
+              <a:t>Diagonals use a sync-free chain-band decomposition -- workers own equal-pixel</a:t>
+            </a:r>
+          </a:p>
+          <a:p>
+            <a:r>
+              <a:rPr sz="1300">
+                <a:solidFill>
+                  <a:srgbClr val="202124"/>
+                </a:solidFill>
+                <a:latin typeface="Calibri"/>
+              </a:rPr>
+              <a:t>bands of diagonal chains, S worker-disjoint, bit-exact with NO barriers.</a:t>
+            </a:r>
+          </a:p>
+          <a:p>
+            <a:r>
+              <a:rPr sz="1300">
+                <a:solidFill>
+                  <a:srgbClr val="202124"/>
+                </a:solidFill>
+                <a:latin typeface="Calibri"/>
+              </a:rPr>
+              <a:t>The two-scale merge is fused into the stage-2 cost build, saving ~200 MB</a:t>
+            </a:r>
+          </a:p>
+          <a:p>
+            <a:r>
+              <a:rPr sz="1300">
+                <a:solidFill>
+                  <a:srgbClr val="202124"/>
+                </a:solidFill>
+                <a:latin typeface="Calibri"/>
+              </a:rPr>
+              <a:t>of traffic per frame. The 4-HVX-context knee holds here too: 6 threads is</a:t>
+            </a:r>
+          </a:p>
+          <a:p>
+            <a:r>
+              <a:rPr sz="1300">
+                <a:solidFill>
+                  <a:srgbClr val="202124"/>
+                </a:solidFill>
+                <a:latin typeface="Calibri"/>
+              </a:rPr>
+              <a:t>29% WORSE than 4.</a:t>
+            </a:r>
+          </a:p>
+          <a:p>
+            <a:r>
+              <a:rPr sz="1300">
+                <a:solidFill>
+                  <a:srgbClr val="202124"/>
+                </a:solidFill>
+                <a:latin typeface="Calibri"/>
+              </a:rPr>
+              <a:t>P2=200 overflowed their packed (S&lt;&lt;6)|d argmin key at S=2040 -- the warned</a:t>
+            </a:r>
+          </a:p>
+          <a:p>
+            <a:r>
+              <a:rPr sz="1300">
+                <a:solidFill>
+                  <a:srgbClr val="202124"/>
+                </a:solidFill>
+                <a:latin typeface="Calibri"/>
+              </a:rPr>
+              <a:t>saturation failure mode, one stage downstream of the warned location.</a:t>
+            </a:r>
+          </a:p>
+          <a:p>
+            <a:r>
+              <a:rPr sz="1300">
+                <a:solidFill>
+                  <a:srgbClr val="202124"/>
+                </a:solidFill>
+                <a:latin typeface="Calibri"/>
+              </a:rPr>
+              <a:t>Redesigned and sim-proven on tie-storms at the cap before shipping.</a:t>
+            </a:r>
+          </a:p>
+        </p:txBody>
+      </p:sp>
+      <p:sp>
+        <p:nvSpPr>
+          <p:cNvPr id="9" name="TextBox 8"/>
+          <p:cNvSpPr txBox="1"/>
+          <p:nvPr/>
+        </p:nvSpPr>
+        <p:spPr>
+          <a:xfrm>
+            <a:off x="548640" y="6446520"/>
+            <a:ext cx="10881360" cy="365760"/>
+          </a:xfrm>
+          <a:prstGeom prst="rect">
+            <a:avLst/>
+          </a:prstGeom>
+          <a:noFill/>
+        </p:spPr>
+        <p:txBody>
+          <a:bodyPr wrap="square">
+            <a:spAutoFit/>
+          </a:bodyPr>
+          <a:lstStyle/>
+          <a:p>
+            <a:pPr algn="l"/>
+            <a:r>
+              <a:rPr sz="1100" b="0">
+                <a:solidFill>
+                  <a:srgbClr val="5F6368"/>
+                </a:solidFill>
+                <a:latin typeface="Calibri"/>
+              </a:rPr>
+              <a:t>MEASURED -- median of the timed frames, bit-exact to golden bcb9cb0bd6f49799 in the same run.</a:t>
+            </a:r>
+          </a:p>
+        </p:txBody>
+      </p:sp>
+    </p:spTree>
+  </p:cSld>
+  <p:clrMapOvr>
+    <a:masterClrMapping/>
+  </p:clrMapOvr>
+</p:sld>
+</file>
+
+<file path=ppt/slides/slide22.xml><?xml version="1.0" encoding="utf-8"?>
+<p:sld xmlns:a="http://schemas.openxmlformats.org/drawingml/2006/main" xmlns:p="http://schemas.openxmlformats.org/presentationml/2006/main" xmlns:r="http://schemas.openxmlformats.org/officeDocument/2006/relationships">
+  <p:cSld>
+    <p:spTree>
+      <p:nvGrpSpPr>
+        <p:cNvPr id="1" name=""/>
+        <p:cNvGrpSpPr/>
+        <p:nvPr/>
+      </p:nvGrpSpPr>
+      <p:grpSpPr/>
+      <p:sp>
+        <p:nvSpPr>
+          <p:cNvPr id="2" name="TextBox 1"/>
+          <p:cNvSpPr txBox="1"/>
+          <p:nvPr/>
+        </p:nvSpPr>
+        <p:spPr>
+          <a:xfrm>
+            <a:off x="548640" y="320040"/>
+            <a:ext cx="10058400" cy="640080"/>
+          </a:xfrm>
+          <a:prstGeom prst="rect">
+            <a:avLst/>
+          </a:prstGeom>
+          <a:noFill/>
+        </p:spPr>
+        <p:txBody>
+          <a:bodyPr wrap="square">
+            <a:spAutoFit/>
+          </a:bodyPr>
+          <a:lstStyle/>
+          <a:p>
+            <a:pPr algn="l"/>
+            <a:r>
+              <a:rPr sz="3200" b="1">
+                <a:solidFill>
+                  <a:srgbClr val="4C8BF5"/>
+                </a:solidFill>
+                <a:latin typeface="Calibri"/>
+              </a:rPr>
+              <a:t>Mali-G720</a:t>
+            </a:r>
+          </a:p>
+        </p:txBody>
+      </p:sp>
+      <p:sp>
+        <p:nvSpPr>
+          <p:cNvPr id="3" name="TextBox 2"/>
+          <p:cNvSpPr txBox="1"/>
+          <p:nvPr/>
+        </p:nvSpPr>
+        <p:spPr>
+          <a:xfrm>
+            <a:off x="9509760" y="457200"/>
+            <a:ext cx="2194560" cy="365760"/>
+          </a:xfrm>
+          <a:prstGeom prst="rect">
+            <a:avLst/>
+          </a:prstGeom>
+          <a:noFill/>
+        </p:spPr>
+        <p:txBody>
+          <a:bodyPr wrap="square">
+            <a:spAutoFit/>
+          </a:bodyPr>
+          <a:lstStyle/>
+          <a:p>
+            <a:pPr algn="l"/>
+            <a:r>
+              <a:rPr sz="1200" b="1">
+                <a:solidFill>
+                  <a:srgbClr val="5F6368"/>
+                </a:solidFill>
+                <a:latin typeface="Calibri"/>
+              </a:rPr>
+              <a:t>CONFIGURATION B</a:t>
+            </a:r>
+          </a:p>
+        </p:txBody>
+      </p:sp>
+      <p:sp>
+        <p:nvSpPr>
+          <p:cNvPr id="4" name="TextBox 3"/>
+          <p:cNvSpPr txBox="1"/>
+          <p:nvPr/>
+        </p:nvSpPr>
+        <p:spPr>
+          <a:xfrm>
+            <a:off x="548640" y="914400"/>
+            <a:ext cx="10881360" cy="365760"/>
+          </a:xfrm>
+          <a:prstGeom prst="rect">
+            <a:avLst/>
+          </a:prstGeom>
+          <a:noFill/>
+        </p:spPr>
+        <p:txBody>
+          <a:bodyPr wrap="square">
+            <a:spAutoFit/>
+          </a:bodyPr>
+          <a:lstStyle/>
+          <a:p>
+            <a:pPr algn="l"/>
+            <a:r>
+              <a:rPr sz="1300" b="0">
+                <a:solidFill>
+                  <a:srgbClr val="5F6368"/>
+                </a:solidFill>
+                <a:latin typeface="Calibri"/>
+              </a:rPr>
+              <a:t>Immortalis, 10 CU, OpenCL 3.0</a:t>
+            </a:r>
+          </a:p>
+        </p:txBody>
+      </p:sp>
+      <p:sp>
+        <p:nvSpPr>
+          <p:cNvPr id="5" name="TextBox 4"/>
+          <p:cNvSpPr txBox="1"/>
+          <p:nvPr/>
+        </p:nvSpPr>
+        <p:spPr>
+          <a:xfrm>
+            <a:off x="548640" y="1554480"/>
+            <a:ext cx="10515600" cy="365760"/>
+          </a:xfrm>
+          <a:prstGeom prst="rect">
+            <a:avLst/>
+          </a:prstGeom>
+          <a:noFill/>
+        </p:spPr>
+        <p:txBody>
+          <a:bodyPr wrap="square">
+            <a:spAutoFit/>
+          </a:bodyPr>
+          <a:lstStyle/>
+          <a:p>
+            <a:pPr algn="l"/>
+            <a:r>
+              <a:rPr sz="1600" b="1">
+                <a:solidFill>
+                  <a:srgbClr val="202124"/>
+                </a:solidFill>
+                <a:latin typeface="Calibri"/>
+              </a:rPr>
+              <a:t>The calculation (work-performed convention)</a:t>
+            </a:r>
+          </a:p>
+        </p:txBody>
+      </p:sp>
+      <p:sp>
+        <p:nvSpPr>
+          <p:cNvPr id="6" name="TextBox 5"/>
+          <p:cNvSpPr txBox="1"/>
+          <p:nvPr/>
+        </p:nvSpPr>
+        <p:spPr>
+          <a:xfrm>
+            <a:off x="548640" y="1965960"/>
+            <a:ext cx="10881360" cy="1554480"/>
+          </a:xfrm>
+          <a:prstGeom prst="rect">
+            <a:avLst/>
+          </a:prstGeom>
+          <a:noFill/>
+        </p:spPr>
+        <p:txBody>
+          <a:bodyPr wrap="square">
+            <a:spAutoFit/>
+          </a:bodyPr>
+          <a:lstStyle/>
+          <a:p>
+            <a:pPr algn="l"/>
+            <a:r>
+              <a:rPr sz="1400" b="0">
+                <a:solidFill>
+                  <a:srgbClr val="202124"/>
+                </a:solidFill>
+                <a:latin typeface="Consolas"/>
+              </a:rPr>
+              <a:t>MDE/s  =  (0.384 + 1.536) Mpx x 64 / runtime      (both full-search scales count)
+        =  122,880,000 disparity estimations / 0.38000 s
+        =  323 million disparity estimations per second
+frame rate  =  1000 / 380.00  =  2.63 fps   (960x400 disparity map out)</a:t>
+            </a:r>
+          </a:p>
+        </p:txBody>
+      </p:sp>
+      <p:sp>
+        <p:nvSpPr>
+          <p:cNvPr id="7" name="TextBox 6"/>
+          <p:cNvSpPr txBox="1"/>
+          <p:nvPr/>
+        </p:nvSpPr>
+        <p:spPr>
+          <a:xfrm>
+            <a:off x="548640" y="3657600"/>
+            <a:ext cx="10515600" cy="365760"/>
+          </a:xfrm>
+          <a:prstGeom prst="rect">
+            <a:avLst/>
+          </a:prstGeom>
+          <a:noFill/>
+        </p:spPr>
+        <p:txBody>
+          <a:bodyPr wrap="square">
+            <a:spAutoFit/>
+          </a:bodyPr>
+          <a:lstStyle/>
+          <a:p>
+            <a:pPr algn="l"/>
+            <a:r>
+              <a:rPr sz="1600" b="1">
+                <a:solidFill>
+                  <a:srgbClr val="202124"/>
+                </a:solidFill>
+                <a:latin typeface="Calibri"/>
+              </a:rPr>
+              <a:t>What the measurement means</a:t>
+            </a:r>
+          </a:p>
+        </p:txBody>
+      </p:sp>
+      <p:sp>
+        <p:nvSpPr>
+          <p:cNvPr id="8" name="TextBox 7"/>
+          <p:cNvSpPr txBox="1"/>
+          <p:nvPr/>
+        </p:nvSpPr>
+        <p:spPr>
+          <a:xfrm>
+            <a:off x="548640" y="4023360"/>
+            <a:ext cx="10881360" cy="2286000"/>
+          </a:xfrm>
+          <a:prstGeom prst="rect">
+            <a:avLst/>
+          </a:prstGeom>
+          <a:noFill/>
+        </p:spPr>
+        <p:txBody>
+          <a:bodyPr wrap="square">
+            <a:spAutoFit/>
+          </a:bodyPr>
+          <a:lstStyle/>
+          <a:p>
+            <a:pPr algn="l"/>
+            <a:r>
+              <a:rPr sz="1300" b="0">
+                <a:solidFill>
+                  <a:srgbClr val="202124"/>
+                </a:solidFill>
+                <a:latin typeface="Calibri"/>
+              </a:rPr>
+              <a:t>One 16-work-item work-group owns each path line; barriers are uniform</a:t>
+            </a:r>
+          </a:p>
+          <a:p>
+            <a:r>
+              <a:rPr sz="1300">
+                <a:solidFill>
+                  <a:srgbClr val="202124"/>
+                </a:solidFill>
+                <a:latin typeface="Calibri"/>
+              </a:rPr>
+              <a:t>because every work-item in the group walks the same line trajectory.</a:t>
+            </a:r>
+          </a:p>
+          <a:p>
+            <a:r>
+              <a:rPr sz="1300">
+                <a:solidFill>
+                  <a:srgbClr val="202124"/>
+                </a:solidFill>
+                <a:latin typeface="Calibri"/>
+              </a:rPr>
+              <a:t>Bit-exact on the first attempt. Same caveat as Configuration A: a</a:t>
+            </a:r>
+          </a:p>
+          <a:p>
+            <a:r>
+              <a:rPr sz="1300">
+                <a:solidFill>
+                  <a:srgbClr val="202124"/>
+                </a:solidFill>
+                <a:latin typeface="Calibri"/>
+              </a:rPr>
+              <a:t>single-chain-per-line kernel is an effort floor for this part, not a</a:t>
+            </a:r>
+          </a:p>
+          <a:p>
+            <a:r>
+              <a:rPr sz="1300">
+                <a:solidFill>
+                  <a:srgbClr val="202124"/>
+                </a:solidFill>
+                <a:latin typeface="Calibri"/>
+              </a:rPr>
+              <a:t>verdict on it.</a:t>
+            </a:r>
+          </a:p>
+        </p:txBody>
+      </p:sp>
+      <p:sp>
+        <p:nvSpPr>
+          <p:cNvPr id="9" name="TextBox 8"/>
+          <p:cNvSpPr txBox="1"/>
+          <p:nvPr/>
+        </p:nvSpPr>
+        <p:spPr>
+          <a:xfrm>
+            <a:off x="548640" y="6446520"/>
+            <a:ext cx="10881360" cy="365760"/>
+          </a:xfrm>
+          <a:prstGeom prst="rect">
+            <a:avLst/>
+          </a:prstGeom>
+          <a:noFill/>
+        </p:spPr>
+        <p:txBody>
+          <a:bodyPr wrap="square">
+            <a:spAutoFit/>
+          </a:bodyPr>
+          <a:lstStyle/>
+          <a:p>
+            <a:pPr algn="l"/>
+            <a:r>
+              <a:rPr sz="1100" b="0">
+                <a:solidFill>
+                  <a:srgbClr val="5F6368"/>
+                </a:solidFill>
+                <a:latin typeface="Calibri"/>
+              </a:rPr>
+              <a:t>MEASURED -- median of the timed frames, bit-exact to golden bcb9cb0bd6f49799 in the same run.</a:t>
+            </a:r>
+          </a:p>
+        </p:txBody>
+      </p:sp>
+    </p:spTree>
+  </p:cSld>
+  <p:clrMapOvr>
+    <a:masterClrMapping/>
+  </p:clrMapOvr>
+</p:sld>
+</file>
+
+<file path=ppt/slides/slide23.xml><?xml version="1.0" encoding="utf-8"?>
+<p:sld xmlns:a="http://schemas.openxmlformats.org/drawingml/2006/main" xmlns:p="http://schemas.openxmlformats.org/presentationml/2006/main" xmlns:r="http://schemas.openxmlformats.org/officeDocument/2006/relationships">
+  <p:cSld>
+    <p:spTree>
+      <p:nvGrpSpPr>
+        <p:cNvPr id="1" name=""/>
+        <p:cNvGrpSpPr/>
+        <p:nvPr/>
+      </p:nvGrpSpPr>
+      <p:grpSpPr/>
+      <p:sp>
+        <p:nvSpPr>
+          <p:cNvPr id="2" name="TextBox 1"/>
+          <p:cNvSpPr txBox="1"/>
+          <p:nvPr/>
+        </p:nvSpPr>
+        <p:spPr>
+          <a:xfrm>
+            <a:off x="548640" y="320040"/>
+            <a:ext cx="10058400" cy="640080"/>
+          </a:xfrm>
+          <a:prstGeom prst="rect">
+            <a:avLst/>
+          </a:prstGeom>
+          <a:noFill/>
+        </p:spPr>
+        <p:txBody>
+          <a:bodyPr wrap="square">
+            <a:spAutoFit/>
+          </a:bodyPr>
+          <a:lstStyle/>
+          <a:p>
+            <a:pPr algn="l"/>
+            <a:r>
+              <a:rPr sz="3200" b="1">
+                <a:solidFill>
+                  <a:srgbClr val="E8710A"/>
+                </a:solidFill>
+                <a:latin typeface="Calibri"/>
+              </a:rPr>
+              <a:t>Cortex-A55 x6</a:t>
+            </a:r>
+          </a:p>
+        </p:txBody>
+      </p:sp>
+      <p:sp>
+        <p:nvSpPr>
+          <p:cNvPr id="3" name="TextBox 2"/>
+          <p:cNvSpPr txBox="1"/>
+          <p:nvPr/>
+        </p:nvSpPr>
+        <p:spPr>
+          <a:xfrm>
+            <a:off x="9509760" y="457200"/>
+            <a:ext cx="2194560" cy="365760"/>
+          </a:xfrm>
+          <a:prstGeom prst="rect">
+            <a:avLst/>
+          </a:prstGeom>
+          <a:noFill/>
+        </p:spPr>
+        <p:txBody>
+          <a:bodyPr wrap="square">
+            <a:spAutoFit/>
+          </a:bodyPr>
+          <a:lstStyle/>
+          <a:p>
+            <a:pPr algn="l"/>
+            <a:r>
+              <a:rPr sz="1200" b="1">
+                <a:solidFill>
+                  <a:srgbClr val="5F6368"/>
+                </a:solidFill>
+                <a:latin typeface="Calibri"/>
+              </a:rPr>
+              <a:t>CONFIGURATION B</a:t>
+            </a:r>
+          </a:p>
+        </p:txBody>
+      </p:sp>
+      <p:sp>
+        <p:nvSpPr>
+          <p:cNvPr id="4" name="TextBox 3"/>
+          <p:cNvSpPr txBox="1"/>
+          <p:nvPr/>
+        </p:nvSpPr>
+        <p:spPr>
+          <a:xfrm>
+            <a:off x="548640" y="914400"/>
+            <a:ext cx="10881360" cy="365760"/>
+          </a:xfrm>
+          <a:prstGeom prst="rect">
+            <a:avLst/>
+          </a:prstGeom>
+          <a:noFill/>
+        </p:spPr>
+        <p:txBody>
+          <a:bodyPr wrap="square">
+            <a:spAutoFit/>
+          </a:bodyPr>
+          <a:lstStyle/>
+          <a:p>
+            <a:pPr algn="l"/>
+            <a:r>
+              <a:rPr sz="1300" b="0">
+                <a:solidFill>
+                  <a:srgbClr val="5F6368"/>
+                </a:solidFill>
+                <a:latin typeface="Calibri"/>
+              </a:rPr>
+              <a:t>i.MX 95 FRDM, 1.8 GHz, NEON+OpenMP  |  single core: 2,201 ms</a:t>
+            </a:r>
+          </a:p>
+        </p:txBody>
+      </p:sp>
+      <p:sp>
+        <p:nvSpPr>
+          <p:cNvPr id="5" name="TextBox 4"/>
+          <p:cNvSpPr txBox="1"/>
+          <p:nvPr/>
+        </p:nvSpPr>
+        <p:spPr>
+          <a:xfrm>
+            <a:off x="548640" y="1554480"/>
+            <a:ext cx="10515600" cy="365760"/>
+          </a:xfrm>
+          <a:prstGeom prst="rect">
+            <a:avLst/>
+          </a:prstGeom>
+          <a:noFill/>
+        </p:spPr>
+        <p:txBody>
+          <a:bodyPr wrap="square">
+            <a:spAutoFit/>
+          </a:bodyPr>
+          <a:lstStyle/>
+          <a:p>
+            <a:pPr algn="l"/>
+            <a:r>
+              <a:rPr sz="1600" b="1">
+                <a:solidFill>
+                  <a:srgbClr val="202124"/>
+                </a:solidFill>
+                <a:latin typeface="Calibri"/>
+              </a:rPr>
+              <a:t>The calculation (work-performed convention)</a:t>
+            </a:r>
+          </a:p>
+        </p:txBody>
+      </p:sp>
+      <p:sp>
+        <p:nvSpPr>
+          <p:cNvPr id="6" name="TextBox 5"/>
+          <p:cNvSpPr txBox="1"/>
+          <p:nvPr/>
+        </p:nvSpPr>
+        <p:spPr>
+          <a:xfrm>
+            <a:off x="548640" y="1965960"/>
+            <a:ext cx="10881360" cy="1554480"/>
+          </a:xfrm>
+          <a:prstGeom prst="rect">
+            <a:avLst/>
+          </a:prstGeom>
+          <a:noFill/>
+        </p:spPr>
+        <p:txBody>
+          <a:bodyPr wrap="square">
+            <a:spAutoFit/>
+          </a:bodyPr>
+          <a:lstStyle/>
+          <a:p>
+            <a:pPr algn="l"/>
+            <a:r>
+              <a:rPr sz="1400" b="0">
+                <a:solidFill>
+                  <a:srgbClr val="202124"/>
+                </a:solidFill>
+                <a:latin typeface="Consolas"/>
+              </a:rPr>
+              <a:t>MDE/s  =  (0.384 + 1.536) Mpx x 64 / runtime      (both full-search scales count)
+        =  122,880,000 disparity estimations / 0.64010 s
+        =  192 million disparity estimations per second
+frame rate  =  1000 / 640.10  =  1.56 fps   (960x400 disparity map out)</a:t>
+            </a:r>
+          </a:p>
+        </p:txBody>
+      </p:sp>
+      <p:sp>
+        <p:nvSpPr>
+          <p:cNvPr id="7" name="TextBox 6"/>
+          <p:cNvSpPr txBox="1"/>
+          <p:nvPr/>
+        </p:nvSpPr>
+        <p:spPr>
+          <a:xfrm>
+            <a:off x="548640" y="3657600"/>
+            <a:ext cx="10515600" cy="365760"/>
+          </a:xfrm>
+          <a:prstGeom prst="rect">
+            <a:avLst/>
+          </a:prstGeom>
+          <a:noFill/>
+        </p:spPr>
+        <p:txBody>
+          <a:bodyPr wrap="square">
+            <a:spAutoFit/>
+          </a:bodyPr>
+          <a:lstStyle/>
+          <a:p>
+            <a:pPr algn="l"/>
+            <a:r>
+              <a:rPr sz="1600" b="1">
+                <a:solidFill>
+                  <a:srgbClr val="202124"/>
+                </a:solidFill>
+                <a:latin typeface="Calibri"/>
+              </a:rPr>
+              <a:t>What the measurement means</a:t>
+            </a:r>
+          </a:p>
+        </p:txBody>
+      </p:sp>
+      <p:sp>
+        <p:nvSpPr>
+          <p:cNvPr id="8" name="TextBox 7"/>
+          <p:cNvSpPr txBox="1"/>
+          <p:nvPr/>
+        </p:nvSpPr>
+        <p:spPr>
+          <a:xfrm>
+            <a:off x="548640" y="4023360"/>
+            <a:ext cx="10881360" cy="2286000"/>
+          </a:xfrm>
+          <a:prstGeom prst="rect">
+            <a:avLst/>
+          </a:prstGeom>
+          <a:noFill/>
+        </p:spPr>
+        <p:txBody>
+          <a:bodyPr wrap="square">
+            <a:spAutoFit/>
+          </a:bodyPr>
+          <a:lstStyle/>
+          <a:p>
+            <a:pPr algn="l"/>
+            <a:r>
+              <a:rPr sz="1300" b="0">
+                <a:solidFill>
+                  <a:srgbClr val="202124"/>
+                </a:solidFill>
+                <a:latin typeface="Calibri"/>
+              </a:rPr>
+              <a:t>The anchor platform runs the full two-scale 8-path configuration at 1.56 fps</a:t>
+            </a:r>
+          </a:p>
+          <a:p>
+            <a:r>
+              <a:rPr sz="1300">
+                <a:solidFill>
+                  <a:srgbClr val="202124"/>
+                </a:solidFill>
+                <a:latin typeface="Calibri"/>
+              </a:rPr>
+              <a:t>-- 22x the scalar oracle on the same six cores' single-core floor.</a:t>
+            </a:r>
+          </a:p>
+          <a:p>
+            <a:r>
+              <a:rPr sz="1300">
+                <a:solidFill>
+                  <a:srgbClr val="202124"/>
+                </a:solidFill>
+                <a:latin typeface="Calibri"/>
+              </a:rPr>
+              <a:t>The saturating NEON step (vqaddq_u8 against P2=200) is the part Configuration</a:t>
+            </a:r>
+          </a:p>
+          <a:p>
+            <a:r>
+              <a:rPr sz="1300">
+                <a:solidFill>
+                  <a:srgbClr val="202124"/>
+                </a:solidFill>
+                <a:latin typeface="Calibri"/>
+              </a:rPr>
+              <a:t>A never needed: its static assert guarantees no overflow at P2=192, and</a:t>
+            </a:r>
+          </a:p>
+          <a:p>
+            <a:r>
+              <a:rPr sz="1300">
+                <a:solidFill>
+                  <a:srgbClr val="202124"/>
+                </a:solidFill>
+                <a:latin typeface="Calibri"/>
+              </a:rPr>
+              <a:t>Configuration B is the configuration that breaks that assumption.</a:t>
+            </a:r>
+          </a:p>
+        </p:txBody>
+      </p:sp>
+      <p:sp>
+        <p:nvSpPr>
+          <p:cNvPr id="9" name="TextBox 8"/>
+          <p:cNvSpPr txBox="1"/>
+          <p:nvPr/>
+        </p:nvSpPr>
+        <p:spPr>
+          <a:xfrm>
+            <a:off x="548640" y="6446520"/>
+            <a:ext cx="10881360" cy="365760"/>
+          </a:xfrm>
+          <a:prstGeom prst="rect">
+            <a:avLst/>
+          </a:prstGeom>
+          <a:noFill/>
+        </p:spPr>
+        <p:txBody>
+          <a:bodyPr wrap="square">
+            <a:spAutoFit/>
+          </a:bodyPr>
+          <a:lstStyle/>
+          <a:p>
+            <a:pPr algn="l"/>
+            <a:r>
+              <a:rPr sz="1100" b="0">
+                <a:solidFill>
+                  <a:srgbClr val="5F6368"/>
+                </a:solidFill>
+                <a:latin typeface="Calibri"/>
+              </a:rPr>
+              <a:t>MEASURED -- median of the timed frames, bit-exact to golden bcb9cb0bd6f49799 in the same run.</a:t>
+            </a:r>
+          </a:p>
+        </p:txBody>
+      </p:sp>
+    </p:spTree>
+  </p:cSld>
+  <p:clrMapOvr>
+    <a:masterClrMapping/>
+  </p:clrMapOvr>
+</p:sld>
+</file>
+
+<file path=ppt/slides/slide24.xml><?xml version="1.0" encoding="utf-8"?>
+<p:sld xmlns:a="http://schemas.openxmlformats.org/drawingml/2006/main" xmlns:p="http://schemas.openxmlformats.org/presentationml/2006/main" xmlns:r="http://schemas.openxmlformats.org/officeDocument/2006/relationships">
+  <p:cSld>
+    <p:spTree>
+      <p:nvGrpSpPr>
+        <p:cNvPr id="1" name=""/>
+        <p:cNvGrpSpPr/>
+        <p:nvPr/>
+      </p:nvGrpSpPr>
+      <p:grpSpPr/>
+      <p:sp>
+        <p:nvSpPr>
+          <p:cNvPr id="2" name="TextBox 1"/>
+          <p:cNvSpPr txBox="1"/>
+          <p:nvPr/>
+        </p:nvSpPr>
+        <p:spPr>
+          <a:xfrm>
+            <a:off x="548640" y="320040"/>
+            <a:ext cx="10058400" cy="640080"/>
+          </a:xfrm>
+          <a:prstGeom prst="rect">
+            <a:avLst/>
+          </a:prstGeom>
+          <a:noFill/>
+        </p:spPr>
+        <p:txBody>
+          <a:bodyPr wrap="square">
+            <a:spAutoFit/>
+          </a:bodyPr>
+          <a:lstStyle/>
+          <a:p>
+            <a:pPr algn="l"/>
+            <a:r>
+              <a:rPr sz="3200" b="1">
+                <a:solidFill>
+                  <a:srgbClr val="4C8BF5"/>
+                </a:solidFill>
+                <a:latin typeface="Calibri"/>
+              </a:rPr>
+              <a:t>Mali-G310</a:t>
+            </a:r>
+          </a:p>
+        </p:txBody>
+      </p:sp>
+      <p:sp>
+        <p:nvSpPr>
+          <p:cNvPr id="3" name="TextBox 2"/>
+          <p:cNvSpPr txBox="1"/>
+          <p:nvPr/>
+        </p:nvSpPr>
+        <p:spPr>
+          <a:xfrm>
+            <a:off x="9509760" y="457200"/>
+            <a:ext cx="2194560" cy="365760"/>
+          </a:xfrm>
+          <a:prstGeom prst="rect">
+            <a:avLst/>
+          </a:prstGeom>
+          <a:noFill/>
+        </p:spPr>
+        <p:txBody>
+          <a:bodyPr wrap="square">
+            <a:spAutoFit/>
+          </a:bodyPr>
+          <a:lstStyle/>
+          <a:p>
+            <a:pPr algn="l"/>
+            <a:r>
+              <a:rPr sz="1200" b="1">
+                <a:solidFill>
+                  <a:srgbClr val="5F6368"/>
+                </a:solidFill>
+                <a:latin typeface="Calibri"/>
+              </a:rPr>
+              <a:t>CONFIGURATION B</a:t>
+            </a:r>
+          </a:p>
+        </p:txBody>
+      </p:sp>
+      <p:sp>
+        <p:nvSpPr>
+          <p:cNvPr id="4" name="TextBox 3"/>
+          <p:cNvSpPr txBox="1"/>
+          <p:nvPr/>
+        </p:nvSpPr>
+        <p:spPr>
+          <a:xfrm>
+            <a:off x="548640" y="914400"/>
+            <a:ext cx="10881360" cy="365760"/>
+          </a:xfrm>
+          <a:prstGeom prst="rect">
+            <a:avLst/>
+          </a:prstGeom>
+          <a:noFill/>
+        </p:spPr>
+        <p:txBody>
+          <a:bodyPr wrap="square">
+            <a:spAutoFit/>
+          </a:bodyPr>
+          <a:lstStyle/>
+          <a:p>
+            <a:pPr algn="l"/>
+            <a:r>
+              <a:rPr sz="1300" b="0">
+                <a:solidFill>
+                  <a:srgbClr val="5F6368"/>
+                </a:solidFill>
+                <a:latin typeface="Calibri"/>
+              </a:rPr>
+              <a:t>1 CU, OpenCL 3.0</a:t>
+            </a:r>
+          </a:p>
+        </p:txBody>
+      </p:sp>
+      <p:sp>
+        <p:nvSpPr>
+          <p:cNvPr id="5" name="TextBox 4"/>
+          <p:cNvSpPr txBox="1"/>
+          <p:nvPr/>
+        </p:nvSpPr>
+        <p:spPr>
+          <a:xfrm>
+            <a:off x="548640" y="1554480"/>
+            <a:ext cx="10515600" cy="365760"/>
+          </a:xfrm>
+          <a:prstGeom prst="rect">
+            <a:avLst/>
+          </a:prstGeom>
+          <a:noFill/>
+        </p:spPr>
+        <p:txBody>
+          <a:bodyPr wrap="square">
+            <a:spAutoFit/>
+          </a:bodyPr>
+          <a:lstStyle/>
+          <a:p>
+            <a:pPr algn="l"/>
+            <a:r>
+              <a:rPr sz="1600" b="1">
+                <a:solidFill>
+                  <a:srgbClr val="202124"/>
+                </a:solidFill>
+                <a:latin typeface="Calibri"/>
+              </a:rPr>
+              <a:t>The calculation (work-performed convention)</a:t>
+            </a:r>
+          </a:p>
+        </p:txBody>
+      </p:sp>
+      <p:sp>
+        <p:nvSpPr>
+          <p:cNvPr id="6" name="TextBox 5"/>
+          <p:cNvSpPr txBox="1"/>
+          <p:nvPr/>
+        </p:nvSpPr>
+        <p:spPr>
+          <a:xfrm>
+            <a:off x="548640" y="1965960"/>
+            <a:ext cx="10881360" cy="1554480"/>
+          </a:xfrm>
+          <a:prstGeom prst="rect">
+            <a:avLst/>
+          </a:prstGeom>
+          <a:noFill/>
+        </p:spPr>
+        <p:txBody>
+          <a:bodyPr wrap="square">
+            <a:spAutoFit/>
+          </a:bodyPr>
+          <a:lstStyle/>
+          <a:p>
+            <a:pPr algn="l"/>
+            <a:r>
+              <a:rPr sz="1400" b="0">
+                <a:solidFill>
+                  <a:srgbClr val="202124"/>
+                </a:solidFill>
+                <a:latin typeface="Consolas"/>
+              </a:rPr>
+              <a:t>MDE/s  =  (0.384 + 1.536) Mpx x 64 / runtime      (both full-search scales count)
+        =  122,880,000 disparity estimations / 2.70400 s
+        =  45 million disparity estimations per second
+frame rate  =  1000 / 2,704.00  =  0.37 fps   (960x400 disparity map out)</a:t>
+            </a:r>
+          </a:p>
+        </p:txBody>
+      </p:sp>
+      <p:sp>
+        <p:nvSpPr>
+          <p:cNvPr id="7" name="TextBox 6"/>
+          <p:cNvSpPr txBox="1"/>
+          <p:nvPr/>
+        </p:nvSpPr>
+        <p:spPr>
+          <a:xfrm>
+            <a:off x="548640" y="3657600"/>
+            <a:ext cx="10515600" cy="365760"/>
+          </a:xfrm>
+          <a:prstGeom prst="rect">
+            <a:avLst/>
+          </a:prstGeom>
+          <a:noFill/>
+        </p:spPr>
+        <p:txBody>
+          <a:bodyPr wrap="square">
+            <a:spAutoFit/>
+          </a:bodyPr>
+          <a:lstStyle/>
+          <a:p>
+            <a:pPr algn="l"/>
+            <a:r>
+              <a:rPr sz="1600" b="1">
+                <a:solidFill>
+                  <a:srgbClr val="202124"/>
+                </a:solidFill>
+                <a:latin typeface="Calibri"/>
+              </a:rPr>
+              <a:t>What the measurement means</a:t>
+            </a:r>
+          </a:p>
+        </p:txBody>
+      </p:sp>
+      <p:sp>
+        <p:nvSpPr>
+          <p:cNvPr id="8" name="TextBox 7"/>
+          <p:cNvSpPr txBox="1"/>
+          <p:nvPr/>
+        </p:nvSpPr>
+        <p:spPr>
+          <a:xfrm>
+            <a:off x="548640" y="4023360"/>
+            <a:ext cx="10881360" cy="2286000"/>
+          </a:xfrm>
+          <a:prstGeom prst="rect">
+            <a:avLst/>
+          </a:prstGeom>
+          <a:noFill/>
+        </p:spPr>
+        <p:txBody>
+          <a:bodyPr wrap="square">
+            <a:spAutoFit/>
+          </a:bodyPr>
+          <a:lstStyle/>
+          <a:p>
+            <a:pPr algn="l"/>
+            <a:r>
+              <a:rPr sz="1300" b="0">
+                <a:solidFill>
+                  <a:srgbClr val="202124"/>
+                </a:solidFill>
+                <a:latin typeface="Calibri"/>
+              </a:rPr>
+              <a:t>Same OpenCL kernel as the G720, same hash, one compute unit.</a:t>
+            </a:r>
+          </a:p>
+        </p:txBody>
+      </p:sp>
+      <p:sp>
+        <p:nvSpPr>
+          <p:cNvPr id="9" name="TextBox 8"/>
+          <p:cNvSpPr txBox="1"/>
+          <p:nvPr/>
+        </p:nvSpPr>
+        <p:spPr>
+          <a:xfrm>
+            <a:off x="548640" y="6446520"/>
+            <a:ext cx="10881360" cy="365760"/>
+          </a:xfrm>
+          <a:prstGeom prst="rect">
+            <a:avLst/>
+          </a:prstGeom>
+          <a:noFill/>
+        </p:spPr>
+        <p:txBody>
+          <a:bodyPr wrap="square">
+            <a:spAutoFit/>
+          </a:bodyPr>
+          <a:lstStyle/>
+          <a:p>
+            <a:pPr algn="l"/>
+            <a:r>
+              <a:rPr sz="1100" b="0">
+                <a:solidFill>
+                  <a:srgbClr val="5F6368"/>
+                </a:solidFill>
+                <a:latin typeface="Calibri"/>
+              </a:rPr>
+              <a:t>MEASURED -- median of the timed frames, bit-exact to golden bcb9cb0bd6f49799 in the same run.</a:t>
+            </a:r>
+          </a:p>
+        </p:txBody>
+      </p:sp>
+    </p:spTree>
+  </p:cSld>
+  <p:clrMapOvr>
+    <a:masterClrMapping/>
+  </p:clrMapOvr>
+</p:sld>
+</file>
+
+<file path=ppt/slides/slide25.xml><?xml version="1.0" encoding="utf-8"?>
+<p:sld xmlns:a="http://schemas.openxmlformats.org/drawingml/2006/main" xmlns:p="http://schemas.openxmlformats.org/presentationml/2006/main" xmlns:r="http://schemas.openxmlformats.org/officeDocument/2006/relationships">
+  <p:cSld>
+    <p:spTree>
+      <p:nvGrpSpPr>
+        <p:cNvPr id="1" name=""/>
+        <p:cNvGrpSpPr/>
+        <p:nvPr/>
+      </p:nvGrpSpPr>
+      <p:grpSpPr/>
+      <p:sp>
+        <p:nvSpPr>
+          <p:cNvPr id="2" name="TextBox 1"/>
+          <p:cNvSpPr txBox="1"/>
+          <p:nvPr/>
+        </p:nvSpPr>
+        <p:spPr>
+          <a:xfrm>
+            <a:off x="548640" y="320040"/>
+            <a:ext cx="10058400" cy="640080"/>
+          </a:xfrm>
+          <a:prstGeom prst="rect">
+            <a:avLst/>
+          </a:prstGeom>
+          <a:noFill/>
+        </p:spPr>
+        <p:txBody>
+          <a:bodyPr wrap="square">
+            <a:spAutoFit/>
+          </a:bodyPr>
+          <a:lstStyle/>
+          <a:p>
+            <a:pPr algn="l"/>
+            <a:r>
+              <a:rPr sz="3200" b="1">
+                <a:solidFill>
+                  <a:srgbClr val="9AA0A6"/>
+                </a:solidFill>
+                <a:latin typeface="Calibri"/>
+              </a:rPr>
+              <a:t>scalar reference</a:t>
+            </a:r>
+          </a:p>
+        </p:txBody>
+      </p:sp>
+      <p:sp>
+        <p:nvSpPr>
+          <p:cNvPr id="3" name="TextBox 2"/>
+          <p:cNvSpPr txBox="1"/>
+          <p:nvPr/>
+        </p:nvSpPr>
+        <p:spPr>
+          <a:xfrm>
+            <a:off x="9509760" y="457200"/>
+            <a:ext cx="2194560" cy="365760"/>
+          </a:xfrm>
+          <a:prstGeom prst="rect">
+            <a:avLst/>
+          </a:prstGeom>
+          <a:noFill/>
+        </p:spPr>
+        <p:txBody>
+          <a:bodyPr wrap="square">
+            <a:spAutoFit/>
+          </a:bodyPr>
+          <a:lstStyle/>
+          <a:p>
+            <a:pPr algn="l"/>
+            <a:r>
+              <a:rPr sz="1200" b="1">
+                <a:solidFill>
+                  <a:srgbClr val="5F6368"/>
+                </a:solidFill>
+                <a:latin typeface="Calibri"/>
+              </a:rPr>
+              <a:t>CONFIGURATION B</a:t>
+            </a:r>
+          </a:p>
+        </p:txBody>
+      </p:sp>
+      <p:sp>
+        <p:nvSpPr>
+          <p:cNvPr id="4" name="TextBox 3"/>
+          <p:cNvSpPr txBox="1"/>
+          <p:nvPr/>
+        </p:nvSpPr>
+        <p:spPr>
+          <a:xfrm>
+            <a:off x="548640" y="914400"/>
+            <a:ext cx="10881360" cy="365760"/>
+          </a:xfrm>
+          <a:prstGeom prst="rect">
+            <a:avLst/>
+          </a:prstGeom>
+          <a:noFill/>
+        </p:spPr>
+        <p:txBody>
+          <a:bodyPr wrap="square">
+            <a:spAutoFit/>
+          </a:bodyPr>
+          <a:lstStyle/>
+          <a:p>
+            <a:pPr algn="l"/>
+            <a:r>
+              <a:rPr sz="1300" b="0">
+                <a:solidFill>
+                  <a:srgbClr val="5F6368"/>
+                </a:solidFill>
+                <a:latin typeface="Calibri"/>
+              </a:rPr>
+              <a:t>1x Cortex-A55, plain C, single thread</a:t>
+            </a:r>
+          </a:p>
+        </p:txBody>
+      </p:sp>
+      <p:sp>
+        <p:nvSpPr>
+          <p:cNvPr id="5" name="TextBox 4"/>
+          <p:cNvSpPr txBox="1"/>
+          <p:nvPr/>
+        </p:nvSpPr>
+        <p:spPr>
+          <a:xfrm>
+            <a:off x="548640" y="1554480"/>
+            <a:ext cx="10515600" cy="365760"/>
+          </a:xfrm>
+          <a:prstGeom prst="rect">
+            <a:avLst/>
+          </a:prstGeom>
+          <a:noFill/>
+        </p:spPr>
+        <p:txBody>
+          <a:bodyPr wrap="square">
+            <a:spAutoFit/>
+          </a:bodyPr>
+          <a:lstStyle/>
+          <a:p>
+            <a:pPr algn="l"/>
+            <a:r>
+              <a:rPr sz="1600" b="1">
+                <a:solidFill>
+                  <a:srgbClr val="202124"/>
+                </a:solidFill>
+                <a:latin typeface="Calibri"/>
+              </a:rPr>
+              <a:t>The calculation (work-performed convention)</a:t>
+            </a:r>
+          </a:p>
+        </p:txBody>
+      </p:sp>
+      <p:sp>
+        <p:nvSpPr>
+          <p:cNvPr id="6" name="TextBox 5"/>
+          <p:cNvSpPr txBox="1"/>
+          <p:nvPr/>
+        </p:nvSpPr>
+        <p:spPr>
+          <a:xfrm>
+            <a:off x="548640" y="1965960"/>
+            <a:ext cx="10881360" cy="1554480"/>
+          </a:xfrm>
+          <a:prstGeom prst="rect">
+            <a:avLst/>
+          </a:prstGeom>
+          <a:noFill/>
+        </p:spPr>
+        <p:txBody>
+          <a:bodyPr wrap="square">
+            <a:spAutoFit/>
+          </a:bodyPr>
+          <a:lstStyle/>
+          <a:p>
+            <a:pPr algn="l"/>
+            <a:r>
+              <a:rPr sz="1400" b="0">
+                <a:solidFill>
+                  <a:srgbClr val="202124"/>
+                </a:solidFill>
+                <a:latin typeface="Consolas"/>
+              </a:rPr>
+              <a:t>MDE/s  =  (0.384 + 1.536) Mpx x 64 / runtime      (both full-search scales count)
+        =  122,880,000 disparity estimations / 14.26500 s
+        =  9 million disparity estimations per second
+frame rate  =  1000 / 14,265.00  =  0.07 fps   (960x400 disparity map out)</a:t>
+            </a:r>
+          </a:p>
+        </p:txBody>
+      </p:sp>
+      <p:sp>
+        <p:nvSpPr>
+          <p:cNvPr id="7" name="TextBox 6"/>
+          <p:cNvSpPr txBox="1"/>
+          <p:nvPr/>
+        </p:nvSpPr>
+        <p:spPr>
+          <a:xfrm>
+            <a:off x="548640" y="3657600"/>
+            <a:ext cx="10515600" cy="365760"/>
+          </a:xfrm>
+          <a:prstGeom prst="rect">
+            <a:avLst/>
+          </a:prstGeom>
+          <a:noFill/>
+        </p:spPr>
+        <p:txBody>
+          <a:bodyPr wrap="square">
+            <a:spAutoFit/>
+          </a:bodyPr>
+          <a:lstStyle/>
+          <a:p>
+            <a:pPr algn="l"/>
+            <a:r>
+              <a:rPr sz="1600" b="1">
+                <a:solidFill>
+                  <a:srgbClr val="202124"/>
+                </a:solidFill>
+                <a:latin typeface="Calibri"/>
+              </a:rPr>
+              <a:t>What the measurement means</a:t>
+            </a:r>
+          </a:p>
+        </p:txBody>
+      </p:sp>
+      <p:sp>
+        <p:nvSpPr>
+          <p:cNvPr id="8" name="TextBox 7"/>
+          <p:cNvSpPr txBox="1"/>
+          <p:nvPr/>
+        </p:nvSpPr>
+        <p:spPr>
+          <a:xfrm>
+            <a:off x="548640" y="4023360"/>
+            <a:ext cx="10881360" cy="2286000"/>
+          </a:xfrm>
+          <a:prstGeom prst="rect">
+            <a:avLst/>
+          </a:prstGeom>
+          <a:noFill/>
+        </p:spPr>
+        <p:txBody>
+          <a:bodyPr wrap="square">
+            <a:spAutoFit/>
+          </a:bodyPr>
+          <a:lstStyle/>
+          <a:p>
+            <a:pPr algn="l"/>
+            <a:r>
+              <a:rPr sz="1300" b="0">
+                <a:solidFill>
+                  <a:srgbClr val="202124"/>
+                </a:solidFill>
+                <a:latin typeface="Calibri"/>
+              </a:rPr>
+              <a:t>multiscale/sgm_ms_ref.c defines golden bcb9cb0bd6f49799 and pins every</a:t>
+            </a:r>
+          </a:p>
+          <a:p>
+            <a:r>
+              <a:rPr sz="1300">
+                <a:solidFill>
+                  <a:srgbClr val="202124"/>
+                </a:solidFill>
+                <a:latin typeface="Calibri"/>
+              </a:rPr>
+              <a:t>contestable choice in its header: ties to lowest d, saturation at 255,</a:t>
+            </a:r>
+          </a:p>
+          <a:p>
+            <a:r>
+              <a:rPr sz="1300">
+                <a:solidFill>
+                  <a:srgbClr val="202124"/>
+                </a:solidFill>
+                <a:latin typeface="Calibri"/>
+              </a:rPr>
+              <a:t>2x2 box downsample, (x/2, y/2, d/2) merge indexing, x-d&lt;0 costs 63.</a:t>
+            </a:r>
+          </a:p>
+          <a:p>
+            <a:r>
+              <a:rPr sz="1300">
+                <a:solidFill>
+                  <a:srgbClr val="202124"/>
+                </a:solidFill>
+                <a:latin typeface="Calibri"/>
+              </a:rPr>
+              <a:t>Every row above reproduces it byte-exactly or its timing is void.</a:t>
+            </a:r>
+          </a:p>
+        </p:txBody>
+      </p:sp>
+      <p:sp>
+        <p:nvSpPr>
+          <p:cNvPr id="9" name="TextBox 8"/>
+          <p:cNvSpPr txBox="1"/>
+          <p:nvPr/>
+        </p:nvSpPr>
+        <p:spPr>
+          <a:xfrm>
+            <a:off x="548640" y="6446520"/>
+            <a:ext cx="10881360" cy="365760"/>
+          </a:xfrm>
+          <a:prstGeom prst="rect">
+            <a:avLst/>
+          </a:prstGeom>
+          <a:noFill/>
+        </p:spPr>
+        <p:txBody>
+          <a:bodyPr wrap="square">
+            <a:spAutoFit/>
+          </a:bodyPr>
+          <a:lstStyle/>
+          <a:p>
+            <a:pPr algn="l"/>
+            <a:r>
+              <a:rPr sz="1100" b="0">
+                <a:solidFill>
+                  <a:srgbClr val="5F6368"/>
+                </a:solidFill>
+                <a:latin typeface="Calibri"/>
+              </a:rPr>
+              <a:t>MEASURED -- median of the timed frames, bit-exact to golden bcb9cb0bd6f49799 in the same run.</a:t>
             </a:r>
           </a:p>
         </p:txBody>

</xml_diff>

<commit_message>
deck: Configuration B summary table slide (26 slides)
Mirrors the primary configuration's opening slide: full roster table with
runtime / fps / work-convention MDE/s / vs-scalar column, the OFA
cannot-run-it row stated rather than omitted, and the three callouts
(1,575x over the oracle; 1.30x cluster / 1.60x per-engine at matched tiers;
13 targets, 4 programming models, 1 golden hash).
</commit_message>
<xml_diff>
--- a/docs/sgm-results.pptx
+++ b/docs/sgm-results.pptx
@@ -30,6 +30,7 @@
     <p:sldId id="278" r:id="rId29"/>
     <p:sldId id="279" r:id="rId30"/>
     <p:sldId id="280" r:id="rId31"/>
+    <p:sldId id="281" r:id="rId32"/>
   </p:sldIdLst>
   <p:sldSz cx="12191695" cy="6858000" type="screen4x3"/>
   <p:notesSz cx="6858000" cy="9144000"/>
@@ -7029,29 +7030,29 @@
         </p:nvSpPr>
         <p:spPr>
           <a:xfrm>
-            <a:off x="548640" y="320040"/>
-            <a:ext cx="10972800" cy="640080"/>
-          </a:xfrm>
-          <a:prstGeom prst="rect">
-            <a:avLst/>
-          </a:prstGeom>
-          <a:noFill/>
-        </p:spPr>
-        <p:txBody>
-          <a:bodyPr wrap="square">
-            <a:spAutoFit/>
-          </a:bodyPr>
-          <a:lstStyle/>
-          <a:p>
-            <a:pPr algn="l"/>
-            <a:r>
-              <a:rPr sz="3000" b="1">
-                <a:solidFill>
-                  <a:srgbClr val="202124"/>
-                </a:solidFill>
-                <a:latin typeface="Calibri"/>
-              </a:rPr>
-              <a:t>Configuration B: multi-scale, 8-path</a:t>
+            <a:off x="548640" y="292608"/>
+            <a:ext cx="11155680" cy="822960"/>
+          </a:xfrm>
+          <a:prstGeom prst="rect">
+            <a:avLst/>
+          </a:prstGeom>
+          <a:noFill/>
+        </p:spPr>
+        <p:txBody>
+          <a:bodyPr wrap="square">
+            <a:spAutoFit/>
+          </a:bodyPr>
+          <a:lstStyle/>
+          <a:p>
+            <a:pPr algn="l"/>
+            <a:r>
+              <a:rPr sz="2800" b="1">
+                <a:solidFill>
+                  <a:srgbClr val="202124"/>
+                </a:solidFill>
+                <a:latin typeface="Calibri"/>
+              </a:rPr>
+              <a:t>Configuration B across the same roster</a:t>
             </a:r>
           </a:p>
         </p:txBody>
@@ -7064,8 +7065,1692 @@
         </p:nvSpPr>
         <p:spPr>
           <a:xfrm>
-            <a:off x="548640" y="914400"/>
-            <a:ext cx="11155680" cy="365760"/>
+            <a:off x="548640" y="1024128"/>
+            <a:ext cx="11155680" cy="457200"/>
+          </a:xfrm>
+          <a:prstGeom prst="rect">
+            <a:avLst/>
+          </a:prstGeom>
+          <a:noFill/>
+        </p:spPr>
+        <p:txBody>
+          <a:bodyPr wrap="square">
+            <a:spAutoFit/>
+          </a:bodyPr>
+          <a:lstStyle/>
+          <a:p>
+            <a:pPr algn="l"/>
+            <a:r>
+              <a:rPr sz="1300" b="0">
+                <a:solidFill>
+                  <a:srgbClr val="5F6368"/>
+                </a:solidFill>
+                <a:latin typeface="Calibri"/>
+              </a:rPr>
+              <a:t>1920x800 in, 960x400 out  ·  two full 64-D scales, costs averaged  ·  8 paths, weighted P1  ·  census 9x7 on SobelX  ·  P2=200 saturating  ·  every row bit-exact to golden bcb9cb0bd6f49799</a:t>
+            </a:r>
+          </a:p>
+        </p:txBody>
+      </p:sp>
+      <p:graphicFrame>
+        <p:nvGraphicFramePr>
+          <p:cNvPr id="4" name="Table 3"/>
+          <p:cNvGraphicFramePr>
+            <a:graphicFrameLocks noGrp="1"/>
+          </p:cNvGraphicFramePr>
+          <p:nvPr/>
+        </p:nvGraphicFramePr>
+        <p:xfrm>
+          <a:off x="548640" y="1572768"/>
+          <a:ext cx="11064240" cy="3703320"/>
+        </p:xfrm>
+        <a:graphic>
+          <a:graphicData uri="http://schemas.openxmlformats.org/drawingml/2006/table">
+            <a:tbl>
+              <a:tblPr firstRow="1" bandRow="1">
+                <a:tableStyleId>{5C22544A-7EE6-4342-B048-85BDC9FD1C3A}</a:tableStyleId>
+              </a:tblPr>
+              <a:tblGrid>
+                <a:gridCol w="3291840"/>
+                <a:gridCol w="914400"/>
+                <a:gridCol w="1737360"/>
+                <a:gridCol w="1188720"/>
+                <a:gridCol w="1737360"/>
+                <a:gridCol w="2194560"/>
+              </a:tblGrid>
+              <a:tr h="246888">
+                <a:tc>
+                  <a:txBody>
+                    <a:bodyPr/>
+                    <a:lstStyle/>
+                    <a:p>
+                      <a:r>
+                        <a:rPr sz="1100" b="1">
+                          <a:solidFill>
+                            <a:srgbClr val="FFFFFF"/>
+                          </a:solidFill>
+                        </a:rPr>
+                        <a:t>processing unit</a:t>
+                      </a:r>
+                    </a:p>
+                  </a:txBody>
+                  <a:tcPr>
+                    <a:solidFill>
+                      <a:srgbClr val="202124"/>
+                    </a:solidFill>
+                  </a:tcPr>
+                </a:tc>
+                <a:tc>
+                  <a:txBody>
+                    <a:bodyPr/>
+                    <a:lstStyle/>
+                    <a:p>
+                      <a:r>
+                        <a:rPr sz="1100" b="1">
+                          <a:solidFill>
+                            <a:srgbClr val="FFFFFF"/>
+                          </a:solidFill>
+                        </a:rPr>
+                        <a:t>class</a:t>
+                      </a:r>
+                    </a:p>
+                  </a:txBody>
+                  <a:tcPr>
+                    <a:solidFill>
+                      <a:srgbClr val="202124"/>
+                    </a:solidFill>
+                  </a:tcPr>
+                </a:tc>
+                <a:tc>
+                  <a:txBody>
+                    <a:bodyPr/>
+                    <a:lstStyle/>
+                    <a:p>
+                      <a:r>
+                        <a:rPr sz="1100" b="1">
+                          <a:solidFill>
+                            <a:srgbClr val="FFFFFF"/>
+                          </a:solidFill>
+                        </a:rPr>
+                        <a:t>runtime</a:t>
+                      </a:r>
+                    </a:p>
+                  </a:txBody>
+                  <a:tcPr>
+                    <a:solidFill>
+                      <a:srgbClr val="202124"/>
+                    </a:solidFill>
+                  </a:tcPr>
+                </a:tc>
+                <a:tc>
+                  <a:txBody>
+                    <a:bodyPr/>
+                    <a:lstStyle/>
+                    <a:p>
+                      <a:r>
+                        <a:rPr sz="1100" b="1">
+                          <a:solidFill>
+                            <a:srgbClr val="FFFFFF"/>
+                          </a:solidFill>
+                        </a:rPr>
+                        <a:t>fps</a:t>
+                      </a:r>
+                    </a:p>
+                  </a:txBody>
+                  <a:tcPr>
+                    <a:solidFill>
+                      <a:srgbClr val="202124"/>
+                    </a:solidFill>
+                  </a:tcPr>
+                </a:tc>
+                <a:tc>
+                  <a:txBody>
+                    <a:bodyPr/>
+                    <a:lstStyle/>
+                    <a:p>
+                      <a:r>
+                        <a:rPr sz="1100" b="1">
+                          <a:solidFill>
+                            <a:srgbClr val="FFFFFF"/>
+                          </a:solidFill>
+                        </a:rPr>
+                        <a:t>MDE/s (work)</a:t>
+                      </a:r>
+                    </a:p>
+                  </a:txBody>
+                  <a:tcPr>
+                    <a:solidFill>
+                      <a:srgbClr val="202124"/>
+                    </a:solidFill>
+                  </a:tcPr>
+                </a:tc>
+                <a:tc>
+                  <a:txBody>
+                    <a:bodyPr/>
+                    <a:lstStyle/>
+                    <a:p>
+                      <a:r>
+                        <a:rPr sz="1100" b="1">
+                          <a:solidFill>
+                            <a:srgbClr val="FFFFFF"/>
+                          </a:solidFill>
+                        </a:rPr>
+                        <a:t>vs scalar reference</a:t>
+                      </a:r>
+                    </a:p>
+                  </a:txBody>
+                  <a:tcPr>
+                    <a:solidFill>
+                      <a:srgbClr val="202124"/>
+                    </a:solidFill>
+                  </a:tcPr>
+                </a:tc>
+              </a:tr>
+              <a:tr h="246888">
+                <a:tc>
+                  <a:txBody>
+                    <a:bodyPr/>
+                    <a:lstStyle/>
+                    <a:p>
+                      <a:r>
+                        <a:rPr sz="1100" b="1">
+                          <a:solidFill>
+                            <a:srgbClr val="202124"/>
+                          </a:solidFill>
+                        </a:rPr>
+                        <a:t>NVIDIA RTX 5090</a:t>
+                      </a:r>
+                    </a:p>
+                  </a:txBody>
+                  <a:tcPr/>
+                </a:tc>
+                <a:tc>
+                  <a:txBody>
+                    <a:bodyPr/>
+                    <a:lstStyle/>
+                    <a:p>
+                      <a:r>
+                        <a:rPr sz="1100" b="1">
+                          <a:solidFill>
+                            <a:srgbClr val="4C8BF5"/>
+                          </a:solidFill>
+                        </a:rPr>
+                        <a:t>GPU</a:t>
+                      </a:r>
+                    </a:p>
+                  </a:txBody>
+                  <a:tcPr/>
+                </a:tc>
+                <a:tc>
+                  <a:txBody>
+                    <a:bodyPr/>
+                    <a:lstStyle/>
+                    <a:p>
+                      <a:r>
+                        <a:rPr sz="1100" b="0">
+                          <a:solidFill>
+                            <a:srgbClr val="202124"/>
+                          </a:solidFill>
+                        </a:rPr>
+                        <a:t>9.06 ms</a:t>
+                      </a:r>
+                    </a:p>
+                  </a:txBody>
+                  <a:tcPr/>
+                </a:tc>
+                <a:tc>
+                  <a:txBody>
+                    <a:bodyPr/>
+                    <a:lstStyle/>
+                    <a:p>
+                      <a:r>
+                        <a:rPr sz="1100" b="0">
+                          <a:solidFill>
+                            <a:srgbClr val="202124"/>
+                          </a:solidFill>
+                        </a:rPr>
+                        <a:t>110.4</a:t>
+                      </a:r>
+                    </a:p>
+                  </a:txBody>
+                  <a:tcPr/>
+                </a:tc>
+                <a:tc>
+                  <a:txBody>
+                    <a:bodyPr/>
+                    <a:lstStyle/>
+                    <a:p>
+                      <a:r>
+                        <a:rPr sz="1100" b="1">
+                          <a:solidFill>
+                            <a:srgbClr val="202124"/>
+                          </a:solidFill>
+                        </a:rPr>
+                        <a:t>13,559</a:t>
+                      </a:r>
+                    </a:p>
+                  </a:txBody>
+                  <a:tcPr/>
+                </a:tc>
+                <a:tc>
+                  <a:txBody>
+                    <a:bodyPr/>
+                    <a:lstStyle/>
+                    <a:p>
+                      <a:r>
+                        <a:rPr sz="1100" b="0">
+                          <a:solidFill>
+                            <a:srgbClr val="202124"/>
+                          </a:solidFill>
+                        </a:rPr>
+                        <a:t>1,575x faster</a:t>
+                      </a:r>
+                    </a:p>
+                  </a:txBody>
+                  <a:tcPr/>
+                </a:tc>
+              </a:tr>
+              <a:tr h="246888">
+                <a:tc>
+                  <a:txBody>
+                    <a:bodyPr/>
+                    <a:lstStyle/>
+                    <a:p>
+                      <a:r>
+                        <a:rPr sz="1100" b="1">
+                          <a:solidFill>
+                            <a:srgbClr val="202124"/>
+                          </a:solidFill>
+                        </a:rPr>
+                        <a:t>NVIDIA Thor</a:t>
+                      </a:r>
+                    </a:p>
+                  </a:txBody>
+                  <a:tcPr/>
+                </a:tc>
+                <a:tc>
+                  <a:txBody>
+                    <a:bodyPr/>
+                    <a:lstStyle/>
+                    <a:p>
+                      <a:r>
+                        <a:rPr sz="1100" b="1">
+                          <a:solidFill>
+                            <a:srgbClr val="4C8BF5"/>
+                          </a:solidFill>
+                        </a:rPr>
+                        <a:t>GPU</a:t>
+                      </a:r>
+                    </a:p>
+                  </a:txBody>
+                  <a:tcPr/>
+                </a:tc>
+                <a:tc>
+                  <a:txBody>
+                    <a:bodyPr/>
+                    <a:lstStyle/>
+                    <a:p>
+                      <a:r>
+                        <a:rPr sz="1100" b="0">
+                          <a:solidFill>
+                            <a:srgbClr val="202124"/>
+                          </a:solidFill>
+                        </a:rPr>
+                        <a:t>45.10 ms</a:t>
+                      </a:r>
+                    </a:p>
+                  </a:txBody>
+                  <a:tcPr/>
+                </a:tc>
+                <a:tc>
+                  <a:txBody>
+                    <a:bodyPr/>
+                    <a:lstStyle/>
+                    <a:p>
+                      <a:r>
+                        <a:rPr sz="1100" b="0">
+                          <a:solidFill>
+                            <a:srgbClr val="202124"/>
+                          </a:solidFill>
+                        </a:rPr>
+                        <a:t>22.2</a:t>
+                      </a:r>
+                    </a:p>
+                  </a:txBody>
+                  <a:tcPr/>
+                </a:tc>
+                <a:tc>
+                  <a:txBody>
+                    <a:bodyPr/>
+                    <a:lstStyle/>
+                    <a:p>
+                      <a:r>
+                        <a:rPr sz="1100" b="1">
+                          <a:solidFill>
+                            <a:srgbClr val="202124"/>
+                          </a:solidFill>
+                        </a:rPr>
+                        <a:t>2,723</a:t>
+                      </a:r>
+                    </a:p>
+                  </a:txBody>
+                  <a:tcPr/>
+                </a:tc>
+                <a:tc>
+                  <a:txBody>
+                    <a:bodyPr/>
+                    <a:lstStyle/>
+                    <a:p>
+                      <a:r>
+                        <a:rPr sz="1100" b="0">
+                          <a:solidFill>
+                            <a:srgbClr val="202124"/>
+                          </a:solidFill>
+                        </a:rPr>
+                        <a:t>316x faster</a:t>
+                      </a:r>
+                    </a:p>
+                  </a:txBody>
+                  <a:tcPr/>
+                </a:tc>
+              </a:tr>
+              <a:tr h="246888">
+                <a:tc>
+                  <a:txBody>
+                    <a:bodyPr/>
+                    <a:lstStyle/>
+                    <a:p>
+                      <a:r>
+                        <a:rPr sz="1100" b="1">
+                          <a:solidFill>
+                            <a:srgbClr val="202124"/>
+                          </a:solidFill>
+                        </a:rPr>
+                        <a:t>NVIDIA Orin AGX</a:t>
+                      </a:r>
+                    </a:p>
+                  </a:txBody>
+                  <a:tcPr/>
+                </a:tc>
+                <a:tc>
+                  <a:txBody>
+                    <a:bodyPr/>
+                    <a:lstStyle/>
+                    <a:p>
+                      <a:r>
+                        <a:rPr sz="1100" b="1">
+                          <a:solidFill>
+                            <a:srgbClr val="4C8BF5"/>
+                          </a:solidFill>
+                        </a:rPr>
+                        <a:t>GPU</a:t>
+                      </a:r>
+                    </a:p>
+                  </a:txBody>
+                  <a:tcPr/>
+                </a:tc>
+                <a:tc>
+                  <a:txBody>
+                    <a:bodyPr/>
+                    <a:lstStyle/>
+                    <a:p>
+                      <a:r>
+                        <a:rPr sz="1100" b="0">
+                          <a:solidFill>
+                            <a:srgbClr val="202124"/>
+                          </a:solidFill>
+                        </a:rPr>
+                        <a:t>72.80 ms</a:t>
+                      </a:r>
+                    </a:p>
+                  </a:txBody>
+                  <a:tcPr/>
+                </a:tc>
+                <a:tc>
+                  <a:txBody>
+                    <a:bodyPr/>
+                    <a:lstStyle/>
+                    <a:p>
+                      <a:r>
+                        <a:rPr sz="1100" b="0">
+                          <a:solidFill>
+                            <a:srgbClr val="202124"/>
+                          </a:solidFill>
+                        </a:rPr>
+                        <a:t>13.7</a:t>
+                      </a:r>
+                    </a:p>
+                  </a:txBody>
+                  <a:tcPr/>
+                </a:tc>
+                <a:tc>
+                  <a:txBody>
+                    <a:bodyPr/>
+                    <a:lstStyle/>
+                    <a:p>
+                      <a:r>
+                        <a:rPr sz="1100" b="1">
+                          <a:solidFill>
+                            <a:srgbClr val="202124"/>
+                          </a:solidFill>
+                        </a:rPr>
+                        <a:t>1,688</a:t>
+                      </a:r>
+                    </a:p>
+                  </a:txBody>
+                  <a:tcPr/>
+                </a:tc>
+                <a:tc>
+                  <a:txBody>
+                    <a:bodyPr/>
+                    <a:lstStyle/>
+                    <a:p>
+                      <a:r>
+                        <a:rPr sz="1100" b="0">
+                          <a:solidFill>
+                            <a:srgbClr val="202124"/>
+                          </a:solidFill>
+                        </a:rPr>
+                        <a:t>196x faster</a:t>
+                      </a:r>
+                    </a:p>
+                  </a:txBody>
+                  <a:tcPr/>
+                </a:tc>
+              </a:tr>
+              <a:tr h="246888">
+                <a:tc>
+                  <a:txBody>
+                    <a:bodyPr/>
+                    <a:lstStyle/>
+                    <a:p>
+                      <a:r>
+                        <a:rPr sz="1100" b="1">
+                          <a:solidFill>
+                            <a:srgbClr val="202124"/>
+                          </a:solidFill>
+                        </a:rPr>
+                        <a:t>Cortex-A78C x8 (6 threads)</a:t>
+                      </a:r>
+                    </a:p>
+                  </a:txBody>
+                  <a:tcPr/>
+                </a:tc>
+                <a:tc>
+                  <a:txBody>
+                    <a:bodyPr/>
+                    <a:lstStyle/>
+                    <a:p>
+                      <a:r>
+                        <a:rPr sz="1100" b="1">
+                          <a:solidFill>
+                            <a:srgbClr val="E8710A"/>
+                          </a:solidFill>
+                        </a:rPr>
+                        <a:t>CPU</a:t>
+                      </a:r>
+                    </a:p>
+                  </a:txBody>
+                  <a:tcPr/>
+                </a:tc>
+                <a:tc>
+                  <a:txBody>
+                    <a:bodyPr/>
+                    <a:lstStyle/>
+                    <a:p>
+                      <a:r>
+                        <a:rPr sz="1100" b="0">
+                          <a:solidFill>
+                            <a:srgbClr val="202124"/>
+                          </a:solidFill>
+                        </a:rPr>
+                        <a:t>211.90 ms</a:t>
+                      </a:r>
+                    </a:p>
+                  </a:txBody>
+                  <a:tcPr/>
+                </a:tc>
+                <a:tc>
+                  <a:txBody>
+                    <a:bodyPr/>
+                    <a:lstStyle/>
+                    <a:p>
+                      <a:r>
+                        <a:rPr sz="1100" b="0">
+                          <a:solidFill>
+                            <a:srgbClr val="202124"/>
+                          </a:solidFill>
+                        </a:rPr>
+                        <a:t>4.72</a:t>
+                      </a:r>
+                    </a:p>
+                  </a:txBody>
+                  <a:tcPr/>
+                </a:tc>
+                <a:tc>
+                  <a:txBody>
+                    <a:bodyPr/>
+                    <a:lstStyle/>
+                    <a:p>
+                      <a:r>
+                        <a:rPr sz="1100" b="1">
+                          <a:solidFill>
+                            <a:srgbClr val="202124"/>
+                          </a:solidFill>
+                        </a:rPr>
+                        <a:t>580</a:t>
+                      </a:r>
+                    </a:p>
+                  </a:txBody>
+                  <a:tcPr/>
+                </a:tc>
+                <a:tc>
+                  <a:txBody>
+                    <a:bodyPr/>
+                    <a:lstStyle/>
+                    <a:p>
+                      <a:r>
+                        <a:rPr sz="1100" b="0">
+                          <a:solidFill>
+                            <a:srgbClr val="202124"/>
+                          </a:solidFill>
+                        </a:rPr>
+                        <a:t>67x faster</a:t>
+                      </a:r>
+                    </a:p>
+                  </a:txBody>
+                  <a:tcPr/>
+                </a:tc>
+              </a:tr>
+              <a:tr h="246888">
+                <a:tc>
+                  <a:txBody>
+                    <a:bodyPr/>
+                    <a:lstStyle/>
+                    <a:p>
+                      <a:r>
+                        <a:rPr sz="1100" b="1">
+                          <a:solidFill>
+                            <a:srgbClr val="202124"/>
+                          </a:solidFill>
+                        </a:rPr>
+                        <a:t>Cortex-A720 x8</a:t>
+                      </a:r>
+                    </a:p>
+                  </a:txBody>
+                  <a:tcPr/>
+                </a:tc>
+                <a:tc>
+                  <a:txBody>
+                    <a:bodyPr/>
+                    <a:lstStyle/>
+                    <a:p>
+                      <a:r>
+                        <a:rPr sz="1100" b="1">
+                          <a:solidFill>
+                            <a:srgbClr val="E8710A"/>
+                          </a:solidFill>
+                        </a:rPr>
+                        <a:t>CPU</a:t>
+                      </a:r>
+                    </a:p>
+                  </a:txBody>
+                  <a:tcPr/>
+                </a:tc>
+                <a:tc>
+                  <a:txBody>
+                    <a:bodyPr/>
+                    <a:lstStyle/>
+                    <a:p>
+                      <a:r>
+                        <a:rPr sz="1100" b="0">
+                          <a:solidFill>
+                            <a:srgbClr val="202124"/>
+                          </a:solidFill>
+                        </a:rPr>
+                        <a:t>238.30 ms</a:t>
+                      </a:r>
+                    </a:p>
+                  </a:txBody>
+                  <a:tcPr/>
+                </a:tc>
+                <a:tc>
+                  <a:txBody>
+                    <a:bodyPr/>
+                    <a:lstStyle/>
+                    <a:p>
+                      <a:r>
+                        <a:rPr sz="1100" b="0">
+                          <a:solidFill>
+                            <a:srgbClr val="202124"/>
+                          </a:solidFill>
+                        </a:rPr>
+                        <a:t>4.20</a:t>
+                      </a:r>
+                    </a:p>
+                  </a:txBody>
+                  <a:tcPr/>
+                </a:tc>
+                <a:tc>
+                  <a:txBody>
+                    <a:bodyPr/>
+                    <a:lstStyle/>
+                    <a:p>
+                      <a:r>
+                        <a:rPr sz="1100" b="1">
+                          <a:solidFill>
+                            <a:srgbClr val="202124"/>
+                          </a:solidFill>
+                        </a:rPr>
+                        <a:t>516</a:t>
+                      </a:r>
+                    </a:p>
+                  </a:txBody>
+                  <a:tcPr/>
+                </a:tc>
+                <a:tc>
+                  <a:txBody>
+                    <a:bodyPr/>
+                    <a:lstStyle/>
+                    <a:p>
+                      <a:r>
+                        <a:rPr sz="1100" b="0">
+                          <a:solidFill>
+                            <a:srgbClr val="202124"/>
+                          </a:solidFill>
+                        </a:rPr>
+                        <a:t>60x faster</a:t>
+                      </a:r>
+                    </a:p>
+                  </a:txBody>
+                  <a:tcPr/>
+                </a:tc>
+              </a:tr>
+              <a:tr h="246888">
+                <a:tc>
+                  <a:txBody>
+                    <a:bodyPr/>
+                    <a:lstStyle/>
+                    <a:p>
+                      <a:r>
+                        <a:rPr sz="1100" b="1">
+                          <a:solidFill>
+                            <a:srgbClr val="202124"/>
+                          </a:solidFill>
+                        </a:rPr>
+                        <a:t>Hexagon v73 NSP</a:t>
+                      </a:r>
+                    </a:p>
+                  </a:txBody>
+                  <a:tcPr/>
+                </a:tc>
+                <a:tc>
+                  <a:txBody>
+                    <a:bodyPr/>
+                    <a:lstStyle/>
+                    <a:p>
+                      <a:r>
+                        <a:rPr sz="1100" b="1">
+                          <a:solidFill>
+                            <a:srgbClr val="12B5A5"/>
+                          </a:solidFill>
+                        </a:rPr>
+                        <a:t>DSP</a:t>
+                      </a:r>
+                    </a:p>
+                  </a:txBody>
+                  <a:tcPr/>
+                </a:tc>
+                <a:tc>
+                  <a:txBody>
+                    <a:bodyPr/>
+                    <a:lstStyle/>
+                    <a:p>
+                      <a:r>
+                        <a:rPr sz="1100" b="0">
+                          <a:solidFill>
+                            <a:srgbClr val="202124"/>
+                          </a:solidFill>
+                        </a:rPr>
+                        <a:t>276.30 ms</a:t>
+                      </a:r>
+                    </a:p>
+                  </a:txBody>
+                  <a:tcPr/>
+                </a:tc>
+                <a:tc>
+                  <a:txBody>
+                    <a:bodyPr/>
+                    <a:lstStyle/>
+                    <a:p>
+                      <a:r>
+                        <a:rPr sz="1100" b="0">
+                          <a:solidFill>
+                            <a:srgbClr val="202124"/>
+                          </a:solidFill>
+                        </a:rPr>
+                        <a:t>3.62</a:t>
+                      </a:r>
+                    </a:p>
+                  </a:txBody>
+                  <a:tcPr/>
+                </a:tc>
+                <a:tc>
+                  <a:txBody>
+                    <a:bodyPr/>
+                    <a:lstStyle/>
+                    <a:p>
+                      <a:r>
+                        <a:rPr sz="1100" b="1">
+                          <a:solidFill>
+                            <a:srgbClr val="202124"/>
+                          </a:solidFill>
+                        </a:rPr>
+                        <a:t>445</a:t>
+                      </a:r>
+                    </a:p>
+                  </a:txBody>
+                  <a:tcPr/>
+                </a:tc>
+                <a:tc>
+                  <a:txBody>
+                    <a:bodyPr/>
+                    <a:lstStyle/>
+                    <a:p>
+                      <a:r>
+                        <a:rPr sz="1100" b="0">
+                          <a:solidFill>
+                            <a:srgbClr val="202124"/>
+                          </a:solidFill>
+                        </a:rPr>
+                        <a:t>52x faster</a:t>
+                      </a:r>
+                    </a:p>
+                  </a:txBody>
+                  <a:tcPr/>
+                </a:tc>
+              </a:tr>
+              <a:tr h="246888">
+                <a:tc>
+                  <a:txBody>
+                    <a:bodyPr/>
+                    <a:lstStyle/>
+                    <a:p>
+                      <a:r>
+                        <a:rPr sz="1100" b="1">
+                          <a:solidFill>
+                            <a:srgbClr val="202124"/>
+                          </a:solidFill>
+                        </a:rPr>
+                        <a:t>Mali-G720 (10 CU)</a:t>
+                      </a:r>
+                    </a:p>
+                  </a:txBody>
+                  <a:tcPr/>
+                </a:tc>
+                <a:tc>
+                  <a:txBody>
+                    <a:bodyPr/>
+                    <a:lstStyle/>
+                    <a:p>
+                      <a:r>
+                        <a:rPr sz="1100" b="1">
+                          <a:solidFill>
+                            <a:srgbClr val="4C8BF5"/>
+                          </a:solidFill>
+                        </a:rPr>
+                        <a:t>GPU</a:t>
+                      </a:r>
+                    </a:p>
+                  </a:txBody>
+                  <a:tcPr/>
+                </a:tc>
+                <a:tc>
+                  <a:txBody>
+                    <a:bodyPr/>
+                    <a:lstStyle/>
+                    <a:p>
+                      <a:r>
+                        <a:rPr sz="1100" b="0">
+                          <a:solidFill>
+                            <a:srgbClr val="202124"/>
+                          </a:solidFill>
+                        </a:rPr>
+                        <a:t>380.00 ms</a:t>
+                      </a:r>
+                    </a:p>
+                  </a:txBody>
+                  <a:tcPr/>
+                </a:tc>
+                <a:tc>
+                  <a:txBody>
+                    <a:bodyPr/>
+                    <a:lstStyle/>
+                    <a:p>
+                      <a:r>
+                        <a:rPr sz="1100" b="0">
+                          <a:solidFill>
+                            <a:srgbClr val="202124"/>
+                          </a:solidFill>
+                        </a:rPr>
+                        <a:t>2.63</a:t>
+                      </a:r>
+                    </a:p>
+                  </a:txBody>
+                  <a:tcPr/>
+                </a:tc>
+                <a:tc>
+                  <a:txBody>
+                    <a:bodyPr/>
+                    <a:lstStyle/>
+                    <a:p>
+                      <a:r>
+                        <a:rPr sz="1100" b="1">
+                          <a:solidFill>
+                            <a:srgbClr val="202124"/>
+                          </a:solidFill>
+                        </a:rPr>
+                        <a:t>323</a:t>
+                      </a:r>
+                    </a:p>
+                  </a:txBody>
+                  <a:tcPr/>
+                </a:tc>
+                <a:tc>
+                  <a:txBody>
+                    <a:bodyPr/>
+                    <a:lstStyle/>
+                    <a:p>
+                      <a:r>
+                        <a:rPr sz="1100" b="0">
+                          <a:solidFill>
+                            <a:srgbClr val="202124"/>
+                          </a:solidFill>
+                        </a:rPr>
+                        <a:t>38x faster</a:t>
+                      </a:r>
+                    </a:p>
+                  </a:txBody>
+                  <a:tcPr/>
+                </a:tc>
+              </a:tr>
+              <a:tr h="246888">
+                <a:tc>
+                  <a:txBody>
+                    <a:bodyPr/>
+                    <a:lstStyle/>
+                    <a:p>
+                      <a:r>
+                        <a:rPr sz="1100" b="1">
+                          <a:solidFill>
+                            <a:srgbClr val="202124"/>
+                          </a:solidFill>
+                        </a:rPr>
+                        <a:t>Cortex-A78C x1</a:t>
+                      </a:r>
+                    </a:p>
+                  </a:txBody>
+                  <a:tcPr/>
+                </a:tc>
+                <a:tc>
+                  <a:txBody>
+                    <a:bodyPr/>
+                    <a:lstStyle/>
+                    <a:p>
+                      <a:r>
+                        <a:rPr sz="1100" b="1">
+                          <a:solidFill>
+                            <a:srgbClr val="E8710A"/>
+                          </a:solidFill>
+                        </a:rPr>
+                        <a:t>CPU</a:t>
+                      </a:r>
+                    </a:p>
+                  </a:txBody>
+                  <a:tcPr/>
+                </a:tc>
+                <a:tc>
+                  <a:txBody>
+                    <a:bodyPr/>
+                    <a:lstStyle/>
+                    <a:p>
+                      <a:r>
+                        <a:rPr sz="1100" b="0">
+                          <a:solidFill>
+                            <a:srgbClr val="202124"/>
+                          </a:solidFill>
+                        </a:rPr>
+                        <a:t>442.60 ms</a:t>
+                      </a:r>
+                    </a:p>
+                  </a:txBody>
+                  <a:tcPr/>
+                </a:tc>
+                <a:tc>
+                  <a:txBody>
+                    <a:bodyPr/>
+                    <a:lstStyle/>
+                    <a:p>
+                      <a:r>
+                        <a:rPr sz="1100" b="0">
+                          <a:solidFill>
+                            <a:srgbClr val="202124"/>
+                          </a:solidFill>
+                        </a:rPr>
+                        <a:t>2.26</a:t>
+                      </a:r>
+                    </a:p>
+                  </a:txBody>
+                  <a:tcPr/>
+                </a:tc>
+                <a:tc>
+                  <a:txBody>
+                    <a:bodyPr/>
+                    <a:lstStyle/>
+                    <a:p>
+                      <a:r>
+                        <a:rPr sz="1100" b="1">
+                          <a:solidFill>
+                            <a:srgbClr val="202124"/>
+                          </a:solidFill>
+                        </a:rPr>
+                        <a:t>278</a:t>
+                      </a:r>
+                    </a:p>
+                  </a:txBody>
+                  <a:tcPr/>
+                </a:tc>
+                <a:tc>
+                  <a:txBody>
+                    <a:bodyPr/>
+                    <a:lstStyle/>
+                    <a:p>
+                      <a:r>
+                        <a:rPr sz="1100" b="0">
+                          <a:solidFill>
+                            <a:srgbClr val="202124"/>
+                          </a:solidFill>
+                        </a:rPr>
+                        <a:t>32x faster</a:t>
+                      </a:r>
+                    </a:p>
+                  </a:txBody>
+                  <a:tcPr/>
+                </a:tc>
+              </a:tr>
+              <a:tr h="246888">
+                <a:tc>
+                  <a:txBody>
+                    <a:bodyPr/>
+                    <a:lstStyle/>
+                    <a:p>
+                      <a:r>
+                        <a:rPr sz="1100" b="1">
+                          <a:solidFill>
+                            <a:srgbClr val="202124"/>
+                          </a:solidFill>
+                        </a:rPr>
+                        <a:t>Cortex-A720 x1</a:t>
+                      </a:r>
+                    </a:p>
+                  </a:txBody>
+                  <a:tcPr/>
+                </a:tc>
+                <a:tc>
+                  <a:txBody>
+                    <a:bodyPr/>
+                    <a:lstStyle/>
+                    <a:p>
+                      <a:r>
+                        <a:rPr sz="1100" b="1">
+                          <a:solidFill>
+                            <a:srgbClr val="E8710A"/>
+                          </a:solidFill>
+                        </a:rPr>
+                        <a:t>CPU</a:t>
+                      </a:r>
+                    </a:p>
+                  </a:txBody>
+                  <a:tcPr/>
+                </a:tc>
+                <a:tc>
+                  <a:txBody>
+                    <a:bodyPr/>
+                    <a:lstStyle/>
+                    <a:p>
+                      <a:r>
+                        <a:rPr sz="1100" b="0">
+                          <a:solidFill>
+                            <a:srgbClr val="202124"/>
+                          </a:solidFill>
+                        </a:rPr>
+                        <a:t>470.90 ms</a:t>
+                      </a:r>
+                    </a:p>
+                  </a:txBody>
+                  <a:tcPr/>
+                </a:tc>
+                <a:tc>
+                  <a:txBody>
+                    <a:bodyPr/>
+                    <a:lstStyle/>
+                    <a:p>
+                      <a:r>
+                        <a:rPr sz="1100" b="0">
+                          <a:solidFill>
+                            <a:srgbClr val="202124"/>
+                          </a:solidFill>
+                        </a:rPr>
+                        <a:t>2.12</a:t>
+                      </a:r>
+                    </a:p>
+                  </a:txBody>
+                  <a:tcPr/>
+                </a:tc>
+                <a:tc>
+                  <a:txBody>
+                    <a:bodyPr/>
+                    <a:lstStyle/>
+                    <a:p>
+                      <a:r>
+                        <a:rPr sz="1100" b="1">
+                          <a:solidFill>
+                            <a:srgbClr val="202124"/>
+                          </a:solidFill>
+                        </a:rPr>
+                        <a:t>261</a:t>
+                      </a:r>
+                    </a:p>
+                  </a:txBody>
+                  <a:tcPr/>
+                </a:tc>
+                <a:tc>
+                  <a:txBody>
+                    <a:bodyPr/>
+                    <a:lstStyle/>
+                    <a:p>
+                      <a:r>
+                        <a:rPr sz="1100" b="0">
+                          <a:solidFill>
+                            <a:srgbClr val="202124"/>
+                          </a:solidFill>
+                        </a:rPr>
+                        <a:t>30x faster</a:t>
+                      </a:r>
+                    </a:p>
+                  </a:txBody>
+                  <a:tcPr/>
+                </a:tc>
+              </a:tr>
+              <a:tr h="246888">
+                <a:tc>
+                  <a:txBody>
+                    <a:bodyPr/>
+                    <a:lstStyle/>
+                    <a:p>
+                      <a:r>
+                        <a:rPr sz="1100" b="1">
+                          <a:solidFill>
+                            <a:srgbClr val="202124"/>
+                          </a:solidFill>
+                        </a:rPr>
+                        <a:t>Cortex-A55 x6</a:t>
+                      </a:r>
+                    </a:p>
+                  </a:txBody>
+                  <a:tcPr/>
+                </a:tc>
+                <a:tc>
+                  <a:txBody>
+                    <a:bodyPr/>
+                    <a:lstStyle/>
+                    <a:p>
+                      <a:r>
+                        <a:rPr sz="1100" b="1">
+                          <a:solidFill>
+                            <a:srgbClr val="E8710A"/>
+                          </a:solidFill>
+                        </a:rPr>
+                        <a:t>CPU</a:t>
+                      </a:r>
+                    </a:p>
+                  </a:txBody>
+                  <a:tcPr/>
+                </a:tc>
+                <a:tc>
+                  <a:txBody>
+                    <a:bodyPr/>
+                    <a:lstStyle/>
+                    <a:p>
+                      <a:r>
+                        <a:rPr sz="1100" b="0">
+                          <a:solidFill>
+                            <a:srgbClr val="202124"/>
+                          </a:solidFill>
+                        </a:rPr>
+                        <a:t>640.10 ms</a:t>
+                      </a:r>
+                    </a:p>
+                  </a:txBody>
+                  <a:tcPr/>
+                </a:tc>
+                <a:tc>
+                  <a:txBody>
+                    <a:bodyPr/>
+                    <a:lstStyle/>
+                    <a:p>
+                      <a:r>
+                        <a:rPr sz="1100" b="0">
+                          <a:solidFill>
+                            <a:srgbClr val="202124"/>
+                          </a:solidFill>
+                        </a:rPr>
+                        <a:t>1.56</a:t>
+                      </a:r>
+                    </a:p>
+                  </a:txBody>
+                  <a:tcPr/>
+                </a:tc>
+                <a:tc>
+                  <a:txBody>
+                    <a:bodyPr/>
+                    <a:lstStyle/>
+                    <a:p>
+                      <a:r>
+                        <a:rPr sz="1100" b="1">
+                          <a:solidFill>
+                            <a:srgbClr val="202124"/>
+                          </a:solidFill>
+                        </a:rPr>
+                        <a:t>192</a:t>
+                      </a:r>
+                    </a:p>
+                  </a:txBody>
+                  <a:tcPr/>
+                </a:tc>
+                <a:tc>
+                  <a:txBody>
+                    <a:bodyPr/>
+                    <a:lstStyle/>
+                    <a:p>
+                      <a:r>
+                        <a:rPr sz="1100" b="0">
+                          <a:solidFill>
+                            <a:srgbClr val="202124"/>
+                          </a:solidFill>
+                        </a:rPr>
+                        <a:t>22x faster</a:t>
+                      </a:r>
+                    </a:p>
+                  </a:txBody>
+                  <a:tcPr/>
+                </a:tc>
+              </a:tr>
+              <a:tr h="246888">
+                <a:tc>
+                  <a:txBody>
+                    <a:bodyPr/>
+                    <a:lstStyle/>
+                    <a:p>
+                      <a:r>
+                        <a:rPr sz="1100" b="1">
+                          <a:solidFill>
+                            <a:srgbClr val="202124"/>
+                          </a:solidFill>
+                        </a:rPr>
+                        <a:t>Cortex-A55 x1</a:t>
+                      </a:r>
+                    </a:p>
+                  </a:txBody>
+                  <a:tcPr/>
+                </a:tc>
+                <a:tc>
+                  <a:txBody>
+                    <a:bodyPr/>
+                    <a:lstStyle/>
+                    <a:p>
+                      <a:r>
+                        <a:rPr sz="1100" b="1">
+                          <a:solidFill>
+                            <a:srgbClr val="E8710A"/>
+                          </a:solidFill>
+                        </a:rPr>
+                        <a:t>CPU</a:t>
+                      </a:r>
+                    </a:p>
+                  </a:txBody>
+                  <a:tcPr/>
+                </a:tc>
+                <a:tc>
+                  <a:txBody>
+                    <a:bodyPr/>
+                    <a:lstStyle/>
+                    <a:p>
+                      <a:r>
+                        <a:rPr sz="1100" b="0">
+                          <a:solidFill>
+                            <a:srgbClr val="202124"/>
+                          </a:solidFill>
+                        </a:rPr>
+                        <a:t>2,201.00 ms</a:t>
+                      </a:r>
+                    </a:p>
+                  </a:txBody>
+                  <a:tcPr/>
+                </a:tc>
+                <a:tc>
+                  <a:txBody>
+                    <a:bodyPr/>
+                    <a:lstStyle/>
+                    <a:p>
+                      <a:r>
+                        <a:rPr sz="1100" b="0">
+                          <a:solidFill>
+                            <a:srgbClr val="202124"/>
+                          </a:solidFill>
+                        </a:rPr>
+                        <a:t>0.45</a:t>
+                      </a:r>
+                    </a:p>
+                  </a:txBody>
+                  <a:tcPr/>
+                </a:tc>
+                <a:tc>
+                  <a:txBody>
+                    <a:bodyPr/>
+                    <a:lstStyle/>
+                    <a:p>
+                      <a:r>
+                        <a:rPr sz="1100" b="1">
+                          <a:solidFill>
+                            <a:srgbClr val="202124"/>
+                          </a:solidFill>
+                        </a:rPr>
+                        <a:t>56</a:t>
+                      </a:r>
+                    </a:p>
+                  </a:txBody>
+                  <a:tcPr/>
+                </a:tc>
+                <a:tc>
+                  <a:txBody>
+                    <a:bodyPr/>
+                    <a:lstStyle/>
+                    <a:p>
+                      <a:r>
+                        <a:rPr sz="1100" b="0">
+                          <a:solidFill>
+                            <a:srgbClr val="202124"/>
+                          </a:solidFill>
+                        </a:rPr>
+                        <a:t>6x faster</a:t>
+                      </a:r>
+                    </a:p>
+                  </a:txBody>
+                  <a:tcPr/>
+                </a:tc>
+              </a:tr>
+              <a:tr h="246888">
+                <a:tc>
+                  <a:txBody>
+                    <a:bodyPr/>
+                    <a:lstStyle/>
+                    <a:p>
+                      <a:r>
+                        <a:rPr sz="1100" b="1">
+                          <a:solidFill>
+                            <a:srgbClr val="202124"/>
+                          </a:solidFill>
+                        </a:rPr>
+                        <a:t>Mali-G310 (1 CU)</a:t>
+                      </a:r>
+                    </a:p>
+                  </a:txBody>
+                  <a:tcPr/>
+                </a:tc>
+                <a:tc>
+                  <a:txBody>
+                    <a:bodyPr/>
+                    <a:lstStyle/>
+                    <a:p>
+                      <a:r>
+                        <a:rPr sz="1100" b="1">
+                          <a:solidFill>
+                            <a:srgbClr val="4C8BF5"/>
+                          </a:solidFill>
+                        </a:rPr>
+                        <a:t>GPU</a:t>
+                      </a:r>
+                    </a:p>
+                  </a:txBody>
+                  <a:tcPr/>
+                </a:tc>
+                <a:tc>
+                  <a:txBody>
+                    <a:bodyPr/>
+                    <a:lstStyle/>
+                    <a:p>
+                      <a:r>
+                        <a:rPr sz="1100" b="0">
+                          <a:solidFill>
+                            <a:srgbClr val="202124"/>
+                          </a:solidFill>
+                        </a:rPr>
+                        <a:t>2,704.00 ms</a:t>
+                      </a:r>
+                    </a:p>
+                  </a:txBody>
+                  <a:tcPr/>
+                </a:tc>
+                <a:tc>
+                  <a:txBody>
+                    <a:bodyPr/>
+                    <a:lstStyle/>
+                    <a:p>
+                      <a:r>
+                        <a:rPr sz="1100" b="0">
+                          <a:solidFill>
+                            <a:srgbClr val="202124"/>
+                          </a:solidFill>
+                        </a:rPr>
+                        <a:t>0.37</a:t>
+                      </a:r>
+                    </a:p>
+                  </a:txBody>
+                  <a:tcPr/>
+                </a:tc>
+                <a:tc>
+                  <a:txBody>
+                    <a:bodyPr/>
+                    <a:lstStyle/>
+                    <a:p>
+                      <a:r>
+                        <a:rPr sz="1100" b="1">
+                          <a:solidFill>
+                            <a:srgbClr val="202124"/>
+                          </a:solidFill>
+                        </a:rPr>
+                        <a:t>45</a:t>
+                      </a:r>
+                    </a:p>
+                  </a:txBody>
+                  <a:tcPr/>
+                </a:tc>
+                <a:tc>
+                  <a:txBody>
+                    <a:bodyPr/>
+                    <a:lstStyle/>
+                    <a:p>
+                      <a:r>
+                        <a:rPr sz="1100" b="0">
+                          <a:solidFill>
+                            <a:srgbClr val="202124"/>
+                          </a:solidFill>
+                        </a:rPr>
+                        <a:t>5x faster</a:t>
+                      </a:r>
+                    </a:p>
+                  </a:txBody>
+                  <a:tcPr/>
+                </a:tc>
+              </a:tr>
+              <a:tr h="246888">
+                <a:tc>
+                  <a:txBody>
+                    <a:bodyPr/>
+                    <a:lstStyle/>
+                    <a:p>
+                      <a:r>
+                        <a:rPr sz="1100" b="1">
+                          <a:solidFill>
+                            <a:srgbClr val="202124"/>
+                          </a:solidFill>
+                        </a:rPr>
+                        <a:t>scalar reference</a:t>
+                      </a:r>
+                    </a:p>
+                  </a:txBody>
+                  <a:tcPr/>
+                </a:tc>
+                <a:tc>
+                  <a:txBody>
+                    <a:bodyPr/>
+                    <a:lstStyle/>
+                    <a:p>
+                      <a:r>
+                        <a:rPr sz="1100" b="1">
+                          <a:solidFill>
+                            <a:srgbClr val="9AA0A6"/>
+                          </a:solidFill>
+                        </a:rPr>
+                        <a:t>REF</a:t>
+                      </a:r>
+                    </a:p>
+                  </a:txBody>
+                  <a:tcPr/>
+                </a:tc>
+                <a:tc>
+                  <a:txBody>
+                    <a:bodyPr/>
+                    <a:lstStyle/>
+                    <a:p>
+                      <a:r>
+                        <a:rPr sz="1100" b="0">
+                          <a:solidFill>
+                            <a:srgbClr val="202124"/>
+                          </a:solidFill>
+                        </a:rPr>
+                        <a:t>14,265.00 ms</a:t>
+                      </a:r>
+                    </a:p>
+                  </a:txBody>
+                  <a:tcPr/>
+                </a:tc>
+                <a:tc>
+                  <a:txBody>
+                    <a:bodyPr/>
+                    <a:lstStyle/>
+                    <a:p>
+                      <a:r>
+                        <a:rPr sz="1100" b="0">
+                          <a:solidFill>
+                            <a:srgbClr val="202124"/>
+                          </a:solidFill>
+                        </a:rPr>
+                        <a:t>0.07</a:t>
+                      </a:r>
+                    </a:p>
+                  </a:txBody>
+                  <a:tcPr/>
+                </a:tc>
+                <a:tc>
+                  <a:txBody>
+                    <a:bodyPr/>
+                    <a:lstStyle/>
+                    <a:p>
+                      <a:r>
+                        <a:rPr sz="1100" b="1">
+                          <a:solidFill>
+                            <a:srgbClr val="202124"/>
+                          </a:solidFill>
+                        </a:rPr>
+                        <a:t>8.6</a:t>
+                      </a:r>
+                    </a:p>
+                  </a:txBody>
+                  <a:tcPr/>
+                </a:tc>
+                <a:tc>
+                  <a:txBody>
+                    <a:bodyPr/>
+                    <a:lstStyle/>
+                    <a:p>
+                      <a:r>
+                        <a:rPr sz="1100" b="0">
+                          <a:solidFill>
+                            <a:srgbClr val="202124"/>
+                          </a:solidFill>
+                        </a:rPr>
+                        <a:t>the floor (1x)</a:t>
+                      </a:r>
+                    </a:p>
+                  </a:txBody>
+                  <a:tcPr/>
+                </a:tc>
+              </a:tr>
+              <a:tr h="246888">
+                <a:tc>
+                  <a:txBody>
+                    <a:bodyPr/>
+                    <a:lstStyle/>
+                    <a:p>
+                      <a:r>
+                        <a:rPr sz="1100" b="0">
+                          <a:solidFill>
+                            <a:srgbClr val="5F6368"/>
+                          </a:solidFill>
+                        </a:rPr>
+                        <a:t>NVIDIA OFA engines</a:t>
+                      </a:r>
+                    </a:p>
+                  </a:txBody>
+                  <a:tcPr/>
+                </a:tc>
+                <a:tc>
+                  <a:txBody>
+                    <a:bodyPr/>
+                    <a:lstStyle/>
+                    <a:p>
+                      <a:r>
+                        <a:rPr sz="1100" b="1">
+                          <a:solidFill>
+                            <a:srgbClr val="7B4FD1"/>
+                          </a:solidFill>
+                        </a:rPr>
+                        <a:t>HW</a:t>
+                      </a:r>
+                    </a:p>
+                  </a:txBody>
+                  <a:tcPr/>
+                </a:tc>
+                <a:tc>
+                  <a:txBody>
+                    <a:bodyPr/>
+                    <a:lstStyle/>
+                    <a:p>
+                      <a:r>
+                        <a:rPr sz="1100" b="0">
+                          <a:solidFill>
+                            <a:srgbClr val="5F6368"/>
+                          </a:solidFill>
+                        </a:rPr>
+                        <a:t>cannot run it</a:t>
+                      </a:r>
+                    </a:p>
+                  </a:txBody>
+                  <a:tcPr/>
+                </a:tc>
+                <a:tc>
+                  <a:txBody>
+                    <a:bodyPr/>
+                    <a:lstStyle/>
+                    <a:p>
+                      <a:r>
+                        <a:rPr sz="1100" b="0">
+                          <a:solidFill>
+                            <a:srgbClr val="5F6368"/>
+                          </a:solidFill>
+                        </a:rPr>
+                        <a:t>—</a:t>
+                      </a:r>
+                    </a:p>
+                  </a:txBody>
+                  <a:tcPr/>
+                </a:tc>
+                <a:tc>
+                  <a:txBody>
+                    <a:bodyPr/>
+                    <a:lstStyle/>
+                    <a:p>
+                      <a:r>
+                        <a:rPr sz="1100" b="0">
+                          <a:solidFill>
+                            <a:srgbClr val="5F6368"/>
+                          </a:solidFill>
+                        </a:rPr>
+                        <a:t>—</a:t>
+                      </a:r>
+                    </a:p>
+                  </a:txBody>
+                  <a:tcPr/>
+                </a:tc>
+                <a:tc>
+                  <a:txBody>
+                    <a:bodyPr/>
+                    <a:lstStyle/>
+                    <a:p>
+                      <a:r>
+                        <a:rPr sz="1100" b="0">
+                          <a:solidFill>
+                            <a:srgbClr val="5F6368"/>
+                          </a:solidFill>
+                        </a:rPr>
+                        <a:t>no 8-path, weighted-P1 or two-scale controls</a:t>
+                      </a:r>
+                    </a:p>
+                  </a:txBody>
+                  <a:tcPr/>
+                </a:tc>
+              </a:tr>
+            </a:tbl>
+          </a:graphicData>
+        </a:graphic>
+      </p:graphicFrame>
+      <p:sp>
+        <p:nvSpPr>
+          <p:cNvPr id="5" name="TextBox 4"/>
+          <p:cNvSpPr txBox="1"/>
+          <p:nvPr/>
+        </p:nvSpPr>
+        <p:spPr>
+          <a:xfrm>
+            <a:off x="548640" y="5806440"/>
+            <a:ext cx="3566160" cy="548640"/>
+          </a:xfrm>
+          <a:prstGeom prst="rect">
+            <a:avLst/>
+          </a:prstGeom>
+          <a:noFill/>
+        </p:spPr>
+        <p:txBody>
+          <a:bodyPr wrap="square">
+            <a:spAutoFit/>
+          </a:bodyPr>
+          <a:lstStyle/>
+          <a:p>
+            <a:pPr algn="l"/>
+            <a:r>
+              <a:rPr sz="2800" b="1">
+                <a:solidFill>
+                  <a:srgbClr val="4C8BF5"/>
+                </a:solidFill>
+                <a:latin typeface="Calibri"/>
+              </a:rPr>
+              <a:t>1,575x</a:t>
+            </a:r>
+          </a:p>
+        </p:txBody>
+      </p:sp>
+      <p:sp>
+        <p:nvSpPr>
+          <p:cNvPr id="6" name="TextBox 5"/>
+          <p:cNvSpPr txBox="1"/>
+          <p:nvPr/>
+        </p:nvSpPr>
+        <p:spPr>
+          <a:xfrm>
+            <a:off x="548640" y="6263640"/>
+            <a:ext cx="3566160" cy="731520"/>
           </a:xfrm>
           <a:prstGeom prst="rect">
             <a:avLst/>
@@ -7086,79 +8771,193 @@
                 </a:solidFill>
                 <a:latin typeface="Calibri"/>
               </a:rPr>
-              <a:t>1920x800 in, 960x400 out - two FULL 64-disparity scales with data costs averaged (multi-scale fusion, not coarse-to-fine), census 9x7 on SobelX, 8 paths with direction-weighted P1 (40/20/10), P2=200 saturating.</a:t>
-            </a:r>
-          </a:p>
-        </p:txBody>
-      </p:sp>
-      <p:pic>
-        <p:nvPicPr>
-          <p:cNvPr id="4" name="Picture 3" descr="results_b.png"/>
-          <p:cNvPicPr>
-            <a:picLocks noChangeAspect="1"/>
-          </p:cNvPicPr>
-          <p:nvPr/>
-        </p:nvPicPr>
-        <p:blipFill>
-          <a:blip r:embed="rId2"/>
-          <a:stretch>
-            <a:fillRect/>
-          </a:stretch>
-        </p:blipFill>
-        <p:spPr>
-          <a:xfrm>
-            <a:off x="1234440" y="1417320"/>
-            <a:ext cx="7034084" cy="4526280"/>
-          </a:xfrm>
-          <a:prstGeom prst="rect">
-            <a:avLst/>
-          </a:prstGeom>
-        </p:spPr>
-      </p:pic>
-      <p:sp>
-        <p:nvSpPr>
-          <p:cNvPr id="5" name="TextBox 4"/>
-          <p:cNvSpPr txBox="1"/>
-          <p:nvPr/>
-        </p:nvSpPr>
-        <p:spPr>
-          <a:xfrm>
-            <a:off x="548640" y="5943600"/>
-            <a:ext cx="11155680" cy="640080"/>
-          </a:xfrm>
-          <a:prstGeom prst="rect">
-            <a:avLst/>
-          </a:prstGeom>
-          <a:noFill/>
-        </p:spPr>
-        <p:txBody>
-          <a:bodyPr wrap="square">
-            <a:spAutoFit/>
-          </a:bodyPr>
-          <a:lstStyle/>
-          <a:p>
-            <a:pPr algn="l"/>
-            <a:r>
-              <a:rPr sz="1100" b="0">
-                <a:solidFill>
-                  <a:srgbClr val="202124"/>
-                </a:solidFill>
-                <a:latin typeface="Calibri"/>
-              </a:rPr>
-              <a:t>Same roster, same acceptance model: every row bit-exact to golden bcb9cb0bd6f49799, same implementation tiers as Configuration A (tuned CUDA / OpenCL / NEON+OpenMP / HVX, scalar oracle as the floor). At matched tiers it ranks like Configuration A - the CPU cluster leads one NSP ~1.3x on both; per engine, one NSP beats one A78C core 1.60x.</a:t>
-            </a:r>
-          </a:p>
-        </p:txBody>
-      </p:sp>
-      <p:sp>
-        <p:nvSpPr>
-          <p:cNvPr id="6" name="TextBox 5"/>
-          <p:cNvSpPr txBox="1"/>
-          <p:nvPr/>
-        </p:nvSpPr>
-        <p:spPr>
-          <a:xfrm>
-            <a:off x="548640" y="6565392"/>
+              <a:t>faster than the scalar reference,</a:t>
+            </a:r>
+          </a:p>
+          <a:p>
+            <a:r>
+              <a:rPr sz="1200">
+                <a:solidFill>
+                  <a:srgbClr val="5F6368"/>
+                </a:solidFill>
+                <a:latin typeface="Calibri"/>
+              </a:rPr>
+              <a:t>with byte-identical output</a:t>
+            </a:r>
+          </a:p>
+        </p:txBody>
+      </p:sp>
+      <p:sp>
+        <p:nvSpPr>
+          <p:cNvPr id="7" name="TextBox 6"/>
+          <p:cNvSpPr txBox="1"/>
+          <p:nvPr/>
+        </p:nvSpPr>
+        <p:spPr>
+          <a:xfrm>
+            <a:off x="4297679" y="5806440"/>
+            <a:ext cx="3566160" cy="548640"/>
+          </a:xfrm>
+          <a:prstGeom prst="rect">
+            <a:avLst/>
+          </a:prstGeom>
+          <a:noFill/>
+        </p:spPr>
+        <p:txBody>
+          <a:bodyPr wrap="square">
+            <a:spAutoFit/>
+          </a:bodyPr>
+          <a:lstStyle/>
+          <a:p>
+            <a:pPr algn="l"/>
+            <a:r>
+              <a:rPr sz="2800" b="1">
+                <a:solidFill>
+                  <a:srgbClr val="202124"/>
+                </a:solidFill>
+                <a:latin typeface="Calibri"/>
+              </a:rPr>
+              <a:t>1.30x / 1.60x</a:t>
+            </a:r>
+          </a:p>
+        </p:txBody>
+      </p:sp>
+      <p:sp>
+        <p:nvSpPr>
+          <p:cNvPr id="8" name="TextBox 7"/>
+          <p:cNvSpPr txBox="1"/>
+          <p:nvPr/>
+        </p:nvSpPr>
+        <p:spPr>
+          <a:xfrm>
+            <a:off x="4297679" y="6263640"/>
+            <a:ext cx="3566160" cy="731520"/>
+          </a:xfrm>
+          <a:prstGeom prst="rect">
+            <a:avLst/>
+          </a:prstGeom>
+          <a:noFill/>
+        </p:spPr>
+        <p:txBody>
+          <a:bodyPr wrap="square">
+            <a:spAutoFit/>
+          </a:bodyPr>
+          <a:lstStyle/>
+          <a:p>
+            <a:pPr algn="l"/>
+            <a:r>
+              <a:rPr sz="1200" b="0">
+                <a:solidFill>
+                  <a:srgbClr val="5F6368"/>
+                </a:solidFill>
+                <a:latin typeface="Calibri"/>
+              </a:rPr>
+              <a:t>cluster over one NSP at matched tiers</a:t>
+            </a:r>
+          </a:p>
+          <a:p>
+            <a:r>
+              <a:rPr sz="1200">
+                <a:solidFill>
+                  <a:srgbClr val="5F6368"/>
+                </a:solidFill>
+                <a:latin typeface="Calibri"/>
+              </a:rPr>
+              <a:t>/ one NSP over one A78C core</a:t>
+            </a:r>
+          </a:p>
+        </p:txBody>
+      </p:sp>
+      <p:sp>
+        <p:nvSpPr>
+          <p:cNvPr id="9" name="TextBox 8"/>
+          <p:cNvSpPr txBox="1"/>
+          <p:nvPr/>
+        </p:nvSpPr>
+        <p:spPr>
+          <a:xfrm>
+            <a:off x="8046719" y="5806440"/>
+            <a:ext cx="3566160" cy="548640"/>
+          </a:xfrm>
+          <a:prstGeom prst="rect">
+            <a:avLst/>
+          </a:prstGeom>
+          <a:noFill/>
+        </p:spPr>
+        <p:txBody>
+          <a:bodyPr wrap="square">
+            <a:spAutoFit/>
+          </a:bodyPr>
+          <a:lstStyle/>
+          <a:p>
+            <a:pPr algn="l"/>
+            <a:r>
+              <a:rPr sz="2800" b="1">
+                <a:solidFill>
+                  <a:srgbClr val="202124"/>
+                </a:solidFill>
+                <a:latin typeface="Calibri"/>
+              </a:rPr>
+              <a:t>13 / 4 / 1</a:t>
+            </a:r>
+          </a:p>
+        </p:txBody>
+      </p:sp>
+      <p:sp>
+        <p:nvSpPr>
+          <p:cNvPr id="10" name="TextBox 9"/>
+          <p:cNvSpPr txBox="1"/>
+          <p:nvPr/>
+        </p:nvSpPr>
+        <p:spPr>
+          <a:xfrm>
+            <a:off x="8046719" y="6263640"/>
+            <a:ext cx="3566160" cy="731520"/>
+          </a:xfrm>
+          <a:prstGeom prst="rect">
+            <a:avLst/>
+          </a:prstGeom>
+          <a:noFill/>
+        </p:spPr>
+        <p:txBody>
+          <a:bodyPr wrap="square">
+            <a:spAutoFit/>
+          </a:bodyPr>
+          <a:lstStyle/>
+          <a:p>
+            <a:pPr algn="l"/>
+            <a:r>
+              <a:rPr sz="1200" b="0">
+                <a:solidFill>
+                  <a:srgbClr val="5F6368"/>
+                </a:solidFill>
+                <a:latin typeface="Calibri"/>
+              </a:rPr>
+              <a:t>targets / programming models (CUDA,</a:t>
+            </a:r>
+          </a:p>
+          <a:p>
+            <a:r>
+              <a:rPr sz="1200">
+                <a:solidFill>
+                  <a:srgbClr val="5F6368"/>
+                </a:solidFill>
+                <a:latin typeface="Calibri"/>
+              </a:rPr>
+              <a:t>OpenCL, NEON, HVX) / one golden hash</a:t>
+            </a:r>
+          </a:p>
+        </p:txBody>
+      </p:sp>
+      <p:sp>
+        <p:nvSpPr>
+          <p:cNvPr id="11" name="TextBox 10"/>
+          <p:cNvSpPr txBox="1"/>
+          <p:nvPr/>
+        </p:nvSpPr>
+        <p:spPr>
+          <a:xfrm>
+            <a:off x="548640" y="6656832"/>
             <a:ext cx="11155680" cy="274320"/>
           </a:xfrm>
           <a:prstGeom prst="rect">
@@ -7180,7 +8979,7 @@
                 </a:solidFill>
                 <a:latin typeface="Calibri"/>
               </a:rPr>
-              <a:t>MDE/s is the work-performed convention - both scales count. The OFA engines cannot run this configuration (no 8-path, weighted-P1 or two-scale controls).</a:t>
+              <a:t>MDE/s (work) = work-performed convention, both full-search scales count: (0.384 + 1.536) Mpx x 64 / runtime. Same implementation tiers as Configuration A: tuned CUDA / OpenCL / NEON+OpenMP / HVX, scalar oracle as the floor.</a:t>
             </a:r>
           </a:p>
         </p:txBody>
@@ -7212,28 +9011,28 @@
         <p:spPr>
           <a:xfrm>
             <a:off x="548640" y="320040"/>
-            <a:ext cx="10058400" cy="640080"/>
-          </a:xfrm>
-          <a:prstGeom prst="rect">
-            <a:avLst/>
-          </a:prstGeom>
-          <a:noFill/>
-        </p:spPr>
-        <p:txBody>
-          <a:bodyPr wrap="square">
-            <a:spAutoFit/>
-          </a:bodyPr>
-          <a:lstStyle/>
-          <a:p>
-            <a:pPr algn="l"/>
-            <a:r>
-              <a:rPr sz="3200" b="1">
-                <a:solidFill>
-                  <a:srgbClr val="4C8BF5"/>
-                </a:solidFill>
-                <a:latin typeface="Calibri"/>
-              </a:rPr>
-              <a:t>NVIDIA RTX 5090</a:t>
+            <a:ext cx="10972800" cy="640080"/>
+          </a:xfrm>
+          <a:prstGeom prst="rect">
+            <a:avLst/>
+          </a:prstGeom>
+          <a:noFill/>
+        </p:spPr>
+        <p:txBody>
+          <a:bodyPr wrap="square">
+            <a:spAutoFit/>
+          </a:bodyPr>
+          <a:lstStyle/>
+          <a:p>
+            <a:pPr algn="l"/>
+            <a:r>
+              <a:rPr sz="3000" b="1">
+                <a:solidFill>
+                  <a:srgbClr val="202124"/>
+                </a:solidFill>
+                <a:latin typeface="Calibri"/>
+              </a:rPr>
+              <a:t>Configuration B: multi-scale, 8-path</a:t>
             </a:r>
           </a:p>
         </p:txBody>
@@ -7246,308 +9045,123 @@
         </p:nvSpPr>
         <p:spPr>
           <a:xfrm>
-            <a:off x="9509760" y="457200"/>
-            <a:ext cx="2194560" cy="365760"/>
-          </a:xfrm>
-          <a:prstGeom prst="rect">
-            <a:avLst/>
-          </a:prstGeom>
-          <a:noFill/>
-        </p:spPr>
-        <p:txBody>
-          <a:bodyPr wrap="square">
-            <a:spAutoFit/>
-          </a:bodyPr>
-          <a:lstStyle/>
-          <a:p>
-            <a:pPr algn="l"/>
-            <a:r>
-              <a:rPr sz="1200" b="1">
+            <a:off x="548640" y="914400"/>
+            <a:ext cx="11155680" cy="365760"/>
+          </a:xfrm>
+          <a:prstGeom prst="rect">
+            <a:avLst/>
+          </a:prstGeom>
+          <a:noFill/>
+        </p:spPr>
+        <p:txBody>
+          <a:bodyPr wrap="square">
+            <a:spAutoFit/>
+          </a:bodyPr>
+          <a:lstStyle/>
+          <a:p>
+            <a:pPr algn="l"/>
+            <a:r>
+              <a:rPr sz="1200" b="0">
                 <a:solidFill>
                   <a:srgbClr val="5F6368"/>
                 </a:solidFill>
                 <a:latin typeface="Calibri"/>
               </a:rPr>
-              <a:t>CONFIGURATION B</a:t>
-            </a:r>
-          </a:p>
-        </p:txBody>
-      </p:sp>
-      <p:sp>
-        <p:nvSpPr>
-          <p:cNvPr id="4" name="TextBox 3"/>
-          <p:cNvSpPr txBox="1"/>
-          <p:nvPr/>
-        </p:nvSpPr>
-        <p:spPr>
-          <a:xfrm>
-            <a:off x="548640" y="914400"/>
-            <a:ext cx="10881360" cy="365760"/>
-          </a:xfrm>
-          <a:prstGeom prst="rect">
-            <a:avLst/>
-          </a:prstGeom>
-          <a:noFill/>
-        </p:spPr>
-        <p:txBody>
-          <a:bodyPr wrap="square">
-            <a:spAutoFit/>
-          </a:bodyPr>
-          <a:lstStyle/>
-          <a:p>
-            <a:pPr algn="l"/>
-            <a:r>
-              <a:rPr sz="1300" b="0">
+              <a:t>1920x800 in, 960x400 out - two FULL 64-disparity scales with data costs averaged (multi-scale fusion, not coarse-to-fine), census 9x7 on SobelX, 8 paths with direction-weighted P1 (40/20/10), P2=200 saturating.</a:t>
+            </a:r>
+          </a:p>
+        </p:txBody>
+      </p:sp>
+      <p:pic>
+        <p:nvPicPr>
+          <p:cNvPr id="4" name="Picture 3" descr="results_b.png"/>
+          <p:cNvPicPr>
+            <a:picLocks noChangeAspect="1"/>
+          </p:cNvPicPr>
+          <p:nvPr/>
+        </p:nvPicPr>
+        <p:blipFill>
+          <a:blip r:embed="rId2"/>
+          <a:stretch>
+            <a:fillRect/>
+          </a:stretch>
+        </p:blipFill>
+        <p:spPr>
+          <a:xfrm>
+            <a:off x="1234440" y="1417320"/>
+            <a:ext cx="7034084" cy="4526280"/>
+          </a:xfrm>
+          <a:prstGeom prst="rect">
+            <a:avLst/>
+          </a:prstGeom>
+        </p:spPr>
+      </p:pic>
+      <p:sp>
+        <p:nvSpPr>
+          <p:cNvPr id="5" name="TextBox 4"/>
+          <p:cNvSpPr txBox="1"/>
+          <p:nvPr/>
+        </p:nvSpPr>
+        <p:spPr>
+          <a:xfrm>
+            <a:off x="548640" y="5943600"/>
+            <a:ext cx="11155680" cy="640080"/>
+          </a:xfrm>
+          <a:prstGeom prst="rect">
+            <a:avLst/>
+          </a:prstGeom>
+          <a:noFill/>
+        </p:spPr>
+        <p:txBody>
+          <a:bodyPr wrap="square">
+            <a:spAutoFit/>
+          </a:bodyPr>
+          <a:lstStyle/>
+          <a:p>
+            <a:pPr algn="l"/>
+            <a:r>
+              <a:rPr sz="1100" b="0">
+                <a:solidFill>
+                  <a:srgbClr val="202124"/>
+                </a:solidFill>
+                <a:latin typeface="Calibri"/>
+              </a:rPr>
+              <a:t>Same roster, same acceptance model: every row bit-exact to golden bcb9cb0bd6f49799, same implementation tiers as Configuration A (tuned CUDA / OpenCL / NEON+OpenMP / HVX, scalar oracle as the floor). At matched tiers it ranks like Configuration A - the CPU cluster leads one NSP ~1.3x on both; per engine, one NSP beats one A78C core 1.60x.</a:t>
+            </a:r>
+          </a:p>
+        </p:txBody>
+      </p:sp>
+      <p:sp>
+        <p:nvSpPr>
+          <p:cNvPr id="6" name="TextBox 5"/>
+          <p:cNvSpPr txBox="1"/>
+          <p:nvPr/>
+        </p:nvSpPr>
+        <p:spPr>
+          <a:xfrm>
+            <a:off x="548640" y="6565392"/>
+            <a:ext cx="11155680" cy="274320"/>
+          </a:xfrm>
+          <a:prstGeom prst="rect">
+            <a:avLst/>
+          </a:prstGeom>
+          <a:noFill/>
+        </p:spPr>
+        <p:txBody>
+          <a:bodyPr wrap="square">
+            <a:spAutoFit/>
+          </a:bodyPr>
+          <a:lstStyle/>
+          <a:p>
+            <a:pPr algn="l"/>
+            <a:r>
+              <a:rPr sz="1000" b="0">
                 <a:solidFill>
                   <a:srgbClr val="5F6368"/>
                 </a:solidFill>
                 <a:latin typeface="Calibri"/>
               </a:rPr>
-              <a:t>CUDA, tuned  |  second independent run: 9.59 ms (shared, unlocked card)</a:t>
-            </a:r>
-          </a:p>
-        </p:txBody>
-      </p:sp>
-      <p:sp>
-        <p:nvSpPr>
-          <p:cNvPr id="5" name="TextBox 4"/>
-          <p:cNvSpPr txBox="1"/>
-          <p:nvPr/>
-        </p:nvSpPr>
-        <p:spPr>
-          <a:xfrm>
-            <a:off x="548640" y="1554480"/>
-            <a:ext cx="10515600" cy="365760"/>
-          </a:xfrm>
-          <a:prstGeom prst="rect">
-            <a:avLst/>
-          </a:prstGeom>
-          <a:noFill/>
-        </p:spPr>
-        <p:txBody>
-          <a:bodyPr wrap="square">
-            <a:spAutoFit/>
-          </a:bodyPr>
-          <a:lstStyle/>
-          <a:p>
-            <a:pPr algn="l"/>
-            <a:r>
-              <a:rPr sz="1600" b="1">
-                <a:solidFill>
-                  <a:srgbClr val="202124"/>
-                </a:solidFill>
-                <a:latin typeface="Calibri"/>
-              </a:rPr>
-              <a:t>The calculation (work-performed convention)</a:t>
-            </a:r>
-          </a:p>
-        </p:txBody>
-      </p:sp>
-      <p:sp>
-        <p:nvSpPr>
-          <p:cNvPr id="6" name="TextBox 5"/>
-          <p:cNvSpPr txBox="1"/>
-          <p:nvPr/>
-        </p:nvSpPr>
-        <p:spPr>
-          <a:xfrm>
-            <a:off x="548640" y="1965960"/>
-            <a:ext cx="10881360" cy="1554480"/>
-          </a:xfrm>
-          <a:prstGeom prst="rect">
-            <a:avLst/>
-          </a:prstGeom>
-          <a:noFill/>
-        </p:spPr>
-        <p:txBody>
-          <a:bodyPr wrap="square">
-            <a:spAutoFit/>
-          </a:bodyPr>
-          <a:lstStyle/>
-          <a:p>
-            <a:pPr algn="l"/>
-            <a:r>
-              <a:rPr sz="1400" b="0">
-                <a:solidFill>
-                  <a:srgbClr val="202124"/>
-                </a:solidFill>
-                <a:latin typeface="Consolas"/>
-              </a:rPr>
-              <a:t>MDE/s  =  (0.384 + 1.536) Mpx x 64 / runtime      (both full-search scales count)
-        =  122,880,000 disparity estimations / 0.00906 s
-        =  13,563 million disparity estimations per second
-frame rate  =  1000 / 9.06  =  110.38 fps   (960x400 disparity map out)</a:t>
-            </a:r>
-          </a:p>
-        </p:txBody>
-      </p:sp>
-      <p:sp>
-        <p:nvSpPr>
-          <p:cNvPr id="7" name="TextBox 6"/>
-          <p:cNvSpPr txBox="1"/>
-          <p:nvPr/>
-        </p:nvSpPr>
-        <p:spPr>
-          <a:xfrm>
-            <a:off x="548640" y="3657600"/>
-            <a:ext cx="10515600" cy="365760"/>
-          </a:xfrm>
-          <a:prstGeom prst="rect">
-            <a:avLst/>
-          </a:prstGeom>
-          <a:noFill/>
-        </p:spPr>
-        <p:txBody>
-          <a:bodyPr wrap="square">
-            <a:spAutoFit/>
-          </a:bodyPr>
-          <a:lstStyle/>
-          <a:p>
-            <a:pPr algn="l"/>
-            <a:r>
-              <a:rPr sz="1600" b="1">
-                <a:solidFill>
-                  <a:srgbClr val="202124"/>
-                </a:solidFill>
-                <a:latin typeface="Calibri"/>
-              </a:rPr>
-              <a:t>What the measurement means</a:t>
-            </a:r>
-          </a:p>
-        </p:txBody>
-      </p:sp>
-      <p:sp>
-        <p:nvSpPr>
-          <p:cNvPr id="8" name="TextBox 7"/>
-          <p:cNvSpPr txBox="1"/>
-          <p:nvPr/>
-        </p:nvSpPr>
-        <p:spPr>
-          <a:xfrm>
-            <a:off x="548640" y="4023360"/>
-            <a:ext cx="10881360" cy="2286000"/>
-          </a:xfrm>
-          <a:prstGeom prst="rect">
-            <a:avLst/>
-          </a:prstGeom>
-          <a:noFill/>
-        </p:spPr>
-        <p:txBody>
-          <a:bodyPr wrap="square">
-            <a:spAutoFit/>
-          </a:bodyPr>
-          <a:lstStyle/>
-          <a:p>
-            <a:pPr algn="l"/>
-            <a:r>
-              <a:rPr sz="1300" b="0">
-                <a:solidFill>
-                  <a:srgbClr val="202124"/>
-                </a:solidFill>
-                <a:latin typeface="Calibri"/>
-              </a:rPr>
-              <a:t>The fastest Configuration B target: 110 fps of two-scale, 8-path, weighted-P1</a:t>
-            </a:r>
-          </a:p>
-          <a:p>
-            <a:r>
-              <a:rPr sz="1300">
-                <a:solidFill>
-                  <a:srgbClr val="202124"/>
-                </a:solidFill>
-                <a:latin typeface="Calibri"/>
-              </a:rPr>
-              <a:t>SGM on a workload designed for a fixed-function embedded block.</a:t>
-            </a:r>
-          </a:p>
-          <a:p>
-            <a:r>
-              <a:rPr sz="1300">
-                <a:solidFill>
-                  <a:srgbClr val="202124"/>
-                </a:solidFill>
-                <a:latin typeface="Calibri"/>
-              </a:rPr>
-              <a:t>The port is a GENERIC path kernel: one warp owns one path line in any of the 8</a:t>
-            </a:r>
-          </a:p>
-          <a:p>
-            <a:r>
-              <a:rPr sz="1300">
-                <a:solidFill>
-                  <a:srgbClr val="202124"/>
-                </a:solidFill>
-                <a:latin typeface="Calibri"/>
-              </a:rPr>
-              <a:t>directions, line start derived from the direction pair, P1 passed per launch</a:t>
-            </a:r>
-          </a:p>
-          <a:p>
-            <a:r>
-              <a:rPr sz="1300">
-                <a:solidFill>
-                  <a:srgbClr val="202124"/>
-                </a:solidFill>
-                <a:latin typeface="Calibri"/>
-              </a:rPr>
-              <a:t>so the direction weighting costs nothing. Bit-exact on the first full run.</a:t>
-            </a:r>
-          </a:p>
-          <a:p>
-            <a:r>
-              <a:rPr sz="1300">
-                <a:solidFill>
-                  <a:srgbClr val="202124"/>
-                </a:solidFill>
-                <a:latin typeface="Calibri"/>
-              </a:rPr>
-              <a:t>It lacks the primary kernel's path-pairing pass, so this row is the</a:t>
-            </a:r>
-          </a:p>
-          <a:p>
-            <a:r>
-              <a:rPr sz="1300">
-                <a:solidFill>
-                  <a:srgbClr val="202124"/>
-                </a:solidFill>
-                <a:latin typeface="Calibri"/>
-              </a:rPr>
-              <a:t>conservative side of what the card can do.</a:t>
-            </a:r>
-          </a:p>
-        </p:txBody>
-      </p:sp>
-      <p:sp>
-        <p:nvSpPr>
-          <p:cNvPr id="9" name="TextBox 8"/>
-          <p:cNvSpPr txBox="1"/>
-          <p:nvPr/>
-        </p:nvSpPr>
-        <p:spPr>
-          <a:xfrm>
-            <a:off x="548640" y="6446520"/>
-            <a:ext cx="10881360" cy="365760"/>
-          </a:xfrm>
-          <a:prstGeom prst="rect">
-            <a:avLst/>
-          </a:prstGeom>
-          <a:noFill/>
-        </p:spPr>
-        <p:txBody>
-          <a:bodyPr wrap="square">
-            <a:spAutoFit/>
-          </a:bodyPr>
-          <a:lstStyle/>
-          <a:p>
-            <a:pPr algn="l"/>
-            <a:r>
-              <a:rPr sz="1100" b="0">
-                <a:solidFill>
-                  <a:srgbClr val="5F6368"/>
-                </a:solidFill>
-                <a:latin typeface="Calibri"/>
-              </a:rPr>
-              <a:t>MEASURED -- median of the timed frames, bit-exact to golden bcb9cb0bd6f49799 in the same run.</a:t>
+              <a:t>MDE/s is the work-performed convention - both scales count. The OFA engines cannot run this configuration (no 8-path, weighted-P1 or two-scale controls).</a:t>
             </a:r>
           </a:p>
         </p:txBody>
@@ -7600,7 +9214,7 @@
                 </a:solidFill>
                 <a:latin typeface="Calibri"/>
               </a:rPr>
-              <a:t>NVIDIA Thor</a:t>
+              <a:t>NVIDIA RTX 5090</a:t>
             </a:r>
           </a:p>
         </p:txBody>
@@ -7670,7 +9284,7 @@
                 </a:solidFill>
                 <a:latin typeface="Calibri"/>
               </a:rPr>
-              <a:t>CUDA, same kernel, sm_110</a:t>
+              <a:t>CUDA, tuned  |  second independent run: 9.59 ms (shared, unlocked card)</a:t>
             </a:r>
           </a:p>
         </p:txBody>
@@ -7741,9 +9355,9 @@
                 <a:latin typeface="Consolas"/>
               </a:rPr>
               <a:t>MDE/s  =  (0.384 + 1.536) Mpx x 64 / runtime      (both full-search scales count)
-        =  122,880,000 disparity estimations / 0.04510 s
-        =  2,725 million disparity estimations per second
-frame rate  =  1000 / 45.10  =  22.17 fps   (960x400 disparity map out)</a:t>
+        =  122,880,000 disparity estimations / 0.00906 s
+        =  13,563 million disparity estimations per second
+frame rate  =  1000 / 9.06  =  110.38 fps   (960x400 disparity map out)</a:t>
             </a:r>
           </a:p>
         </p:txBody>
@@ -7813,7 +9427,7 @@
                 </a:solidFill>
                 <a:latin typeface="Calibri"/>
               </a:rPr>
-              <a:t>22 fps embedded. Same generic 8-direction kernel as the 5090, bit-exact.</a:t>
+              <a:t>The fastest Configuration B target: 110 fps of two-scale, 8-path, weighted-P1</a:t>
             </a:r>
           </a:p>
           <a:p>
@@ -7824,7 +9438,7 @@
                 </a:solidFill>
                 <a:latin typeface="Calibri"/>
               </a:rPr>
-              <a:t>The gap to the 5090 (5.0x) is close to the bandwidth ratio of the parts,</a:t>
+              <a:t>SGM on a workload designed for a fixed-function embedded block.</a:t>
             </a:r>
           </a:p>
           <a:p>
@@ -7835,7 +9449,7 @@
                 </a:solidFill>
                 <a:latin typeface="Calibri"/>
               </a:rPr>
-              <a:t>consistent with the Configuration A finding that tuned SGM converges on</a:t>
+              <a:t>The port is a GENERIC path kernel: one warp owns one path line in any of the 8</a:t>
             </a:r>
           </a:p>
           <a:p>
@@ -7846,7 +9460,40 @@
                 </a:solidFill>
                 <a:latin typeface="Calibri"/>
               </a:rPr>
-              <a:t>memory traffic once the arithmetic is done.</a:t>
+              <a:t>directions, line start derived from the direction pair, P1 passed per launch</a:t>
+            </a:r>
+          </a:p>
+          <a:p>
+            <a:r>
+              <a:rPr sz="1300">
+                <a:solidFill>
+                  <a:srgbClr val="202124"/>
+                </a:solidFill>
+                <a:latin typeface="Calibri"/>
+              </a:rPr>
+              <a:t>so the direction weighting costs nothing. Bit-exact on the first full run.</a:t>
+            </a:r>
+          </a:p>
+          <a:p>
+            <a:r>
+              <a:rPr sz="1300">
+                <a:solidFill>
+                  <a:srgbClr val="202124"/>
+                </a:solidFill>
+                <a:latin typeface="Calibri"/>
+              </a:rPr>
+              <a:t>It lacks the primary kernel's path-pairing pass, so this row is the</a:t>
+            </a:r>
+          </a:p>
+          <a:p>
+            <a:r>
+              <a:rPr sz="1300">
+                <a:solidFill>
+                  <a:srgbClr val="202124"/>
+                </a:solidFill>
+                <a:latin typeface="Calibri"/>
+              </a:rPr>
+              <a:t>conservative side of what the card can do.</a:t>
             </a:r>
           </a:p>
         </p:txBody>
@@ -7934,7 +9581,7 @@
                 </a:solidFill>
                 <a:latin typeface="Calibri"/>
               </a:rPr>
-              <a:t>NVIDIA Orin AGX</a:t>
+              <a:t>NVIDIA Thor</a:t>
             </a:r>
           </a:p>
         </p:txBody>
@@ -8004,7 +9651,7 @@
                 </a:solidFill>
                 <a:latin typeface="Calibri"/>
               </a:rPr>
-              <a:t>CUDA, same kernel, sm_87</a:t>
+              <a:t>CUDA, same kernel, sm_110</a:t>
             </a:r>
           </a:p>
         </p:txBody>
@@ -8075,9 +9722,9 @@
                 <a:latin typeface="Consolas"/>
               </a:rPr>
               <a:t>MDE/s  =  (0.384 + 1.536) Mpx x 64 / runtime      (both full-search scales count)
-        =  122,880,000 disparity estimations / 0.07280 s
-        =  1,688 million disparity estimations per second
-frame rate  =  1000 / 72.80  =  13.74 fps   (960x400 disparity map out)</a:t>
+        =  122,880,000 disparity estimations / 0.04510 s
+        =  2,725 million disparity estimations per second
+frame rate  =  1000 / 45.10  =  22.17 fps   (960x400 disparity map out)</a:t>
             </a:r>
           </a:p>
         </p:txBody>
@@ -8147,7 +9794,40 @@
                 </a:solidFill>
                 <a:latin typeface="Calibri"/>
               </a:rPr>
-              <a:t>14 fps on the previous embedded generation, bit-exact, no per-part tuning.</a:t>
+              <a:t>22 fps embedded. Same generic 8-direction kernel as the 5090, bit-exact.</a:t>
+            </a:r>
+          </a:p>
+          <a:p>
+            <a:r>
+              <a:rPr sz="1300">
+                <a:solidFill>
+                  <a:srgbClr val="202124"/>
+                </a:solidFill>
+                <a:latin typeface="Calibri"/>
+              </a:rPr>
+              <a:t>The gap to the 5090 (5.0x) is close to the bandwidth ratio of the parts,</a:t>
+            </a:r>
+          </a:p>
+          <a:p>
+            <a:r>
+              <a:rPr sz="1300">
+                <a:solidFill>
+                  <a:srgbClr val="202124"/>
+                </a:solidFill>
+                <a:latin typeface="Calibri"/>
+              </a:rPr>
+              <a:t>consistent with the Configuration A finding that tuned SGM converges on</a:t>
+            </a:r>
+          </a:p>
+          <a:p>
+            <a:r>
+              <a:rPr sz="1300">
+                <a:solidFill>
+                  <a:srgbClr val="202124"/>
+                </a:solidFill>
+                <a:latin typeface="Calibri"/>
+              </a:rPr>
+              <a:t>memory traffic once the arithmetic is done.</a:t>
             </a:r>
           </a:p>
         </p:txBody>
@@ -8231,11 +9911,11 @@
             <a:r>
               <a:rPr sz="3200" b="1">
                 <a:solidFill>
-                  <a:srgbClr val="E8710A"/>
-                </a:solidFill>
-                <a:latin typeface="Calibri"/>
-              </a:rPr>
-              <a:t>Cortex-A78C x8 (6 threads)</a:t>
+                  <a:srgbClr val="4C8BF5"/>
+                </a:solidFill>
+                <a:latin typeface="Calibri"/>
+              </a:rPr>
+              <a:t>NVIDIA Orin AGX</a:t>
             </a:r>
           </a:p>
         </p:txBody>
@@ -8305,7 +9985,7 @@
                 </a:solidFill>
                 <a:latin typeface="Calibri"/>
               </a:rPr>
-              <a:t>Qualcomm IQ-9075, NEON+OpenMP  |  single core: 442.60 ms</a:t>
+              <a:t>CUDA, same kernel, sm_87</a:t>
             </a:r>
           </a:p>
         </p:txBody>
@@ -8376,9 +10056,9 @@
                 <a:latin typeface="Consolas"/>
               </a:rPr>
               <a:t>MDE/s  =  (0.384 + 1.536) Mpx x 64 / runtime      (both full-search scales count)
-        =  122,880,000 disparity estimations / 0.21190 s
-        =  580 million disparity estimations per second
-frame rate  =  1000 / 211.90  =  4.72 fps   (960x400 disparity map out)</a:t>
+        =  122,880,000 disparity estimations / 0.07280 s
+        =  1,688 million disparity estimations per second
+frame rate  =  1000 / 72.80  =  13.74 fps   (960x400 disparity map out)</a:t>
             </a:r>
           </a:p>
         </p:txBody>
@@ -8448,84 +10128,7 @@
                 </a:solidFill>
                 <a:latin typeface="Calibri"/>
               </a:rPr>
-              <a:t>The best programmable embedded result -- and it was measured by the</a:t>
-            </a:r>
-          </a:p>
-          <a:p>
-            <a:r>
-              <a:rPr sz="1300">
-                <a:solidFill>
-                  <a:srgbClr val="202124"/>
-                </a:solidFill>
-                <a:latin typeface="Calibri"/>
-              </a:rPr>
-              <a:t>collaborating session running multiscale/sgm_ms_neon.c UNMODIFIED on their</a:t>
-            </a:r>
-          </a:p>
-          <a:p>
-            <a:r>
-              <a:rPr sz="1300">
-                <a:solidFill>
-                  <a:srgbClr val="202124"/>
-                </a:solidFill>
-                <a:latin typeface="Calibri"/>
-              </a:rPr>
-              <a:t>silicon, golden every run. Medians of five invocations on a board that is</a:t>
-            </a:r>
-          </a:p>
-          <a:p>
-            <a:r>
-              <a:rPr sz="1300">
-                <a:solidFill>
-                  <a:srgbClr val="202124"/>
-                </a:solidFill>
-                <a:latin typeface="Calibri"/>
-              </a:rPr>
-              <a:t>bimodal by ~9% between invocations; medians quoted, never minima.</a:t>
-            </a:r>
-          </a:p>
-          <a:p>
-            <a:r>
-              <a:rPr sz="1300">
-                <a:solidFill>
-                  <a:srgbClr val="202124"/>
-                </a:solidFill>
-                <a:latin typeface="Calibri"/>
-              </a:rPr>
-              <a:t>This row is also what corrected the record: at the oracle tier the NSP</a:t>
-            </a:r>
-          </a:p>
-          <a:p>
-            <a:r>
-              <a:rPr sz="1300">
-                <a:solidFill>
-                  <a:srgbClr val="202124"/>
-                </a:solidFill>
-                <a:latin typeface="Calibri"/>
-              </a:rPr>
-              <a:t>appeared to lead the cluster 3.29x; at the matched NEON tier the cluster</a:t>
-            </a:r>
-          </a:p>
-          <a:p>
-            <a:r>
-              <a:rPr sz="1300">
-                <a:solidFill>
-                  <a:srgbClr val="202124"/>
-                </a:solidFill>
-                <a:latin typeface="Calibri"/>
-              </a:rPr>
-              <a:t>leads 1.30x. A cross-tier comparison is a cross-configuration comparison</a:t>
-            </a:r>
-          </a:p>
-          <a:p>
-            <a:r>
-              <a:rPr sz="1300">
-                <a:solidFill>
-                  <a:srgbClr val="202124"/>
-                </a:solidFill>
-                <a:latin typeface="Calibri"/>
-              </a:rPr>
-              <a:t>wearing a platform comparison's clothes.</a:t>
+              <a:t>14 fps on the previous embedded generation, bit-exact, no per-part tuning.</a:t>
             </a:r>
           </a:p>
         </p:txBody>
@@ -8960,7 +10563,7 @@
                 </a:solidFill>
                 <a:latin typeface="Calibri"/>
               </a:rPr>
-              <a:t>Cortex-A720 x8</a:t>
+              <a:t>Cortex-A78C x8 (6 threads)</a:t>
             </a:r>
           </a:p>
         </p:txBody>
@@ -9030,7 +10633,7 @@
                 </a:solidFill>
                 <a:latin typeface="Calibri"/>
               </a:rPr>
-              <a:t>Radxa Orion O6, NEON+OpenMP  |  single core: 470.9 ms</a:t>
+              <a:t>Qualcomm IQ-9075, NEON+OpenMP  |  single core: 442.60 ms</a:t>
             </a:r>
           </a:p>
         </p:txBody>
@@ -9101,9 +10704,9 @@
                 <a:latin typeface="Consolas"/>
               </a:rPr>
               <a:t>MDE/s  =  (0.384 + 1.536) Mpx x 64 / runtime      (both full-search scales count)
-        =  122,880,000 disparity estimations / 0.23830 s
-        =  516 million disparity estimations per second
-frame rate  =  1000 / 238.30  =  4.20 fps   (960x400 disparity map out)</a:t>
+        =  122,880,000 disparity estimations / 0.21190 s
+        =  580 million disparity estimations per second
+frame rate  =  1000 / 211.90  =  4.72 fps   (960x400 disparity map out)</a:t>
             </a:r>
           </a:p>
         </p:txBody>
@@ -9173,7 +10776,7 @@
                 </a:solidFill>
                 <a:latin typeface="Calibri"/>
               </a:rPr>
-              <a:t>The NEON tier is 5.8x the scalar oracle on this cluster. The kernel keeps</a:t>
+              <a:t>The best programmable embedded result -- and it was measured by the</a:t>
             </a:r>
           </a:p>
           <a:p>
@@ -9184,7 +10787,7 @@
                 </a:solidFill>
                 <a:latin typeface="Calibri"/>
               </a:rPr>
-              <a:t>Configuration A's register scheme and adds the saturating step, the</a:t>
+              <a:t>collaborating session running multiscale/sgm_ms_neon.c UNMODIFIED on their</a:t>
             </a:r>
           </a:p>
           <a:p>
@@ -9195,7 +10798,7 @@
                 </a:solidFill>
                 <a:latin typeface="Calibri"/>
               </a:rPr>
-              <a:t>direction-weighted P1 per sweep, and a uint16 sum plane for 8-path S.</a:t>
+              <a:t>silicon, golden every run. Medians of five invocations on a board that is</a:t>
             </a:r>
           </a:p>
           <a:p>
@@ -9206,7 +10809,7 @@
                 </a:solidFill>
                 <a:latin typeface="Calibri"/>
               </a:rPr>
-              <a:t>OpenMP is output-neutral by construction: rows for horizontal sweeps,</a:t>
+              <a:t>bimodal by ~9% between invocations; medians quoted, never minima.</a:t>
             </a:r>
           </a:p>
           <a:p>
@@ -9217,7 +10820,7 @@
                 </a:solidFill>
                 <a:latin typeface="Calibri"/>
               </a:rPr>
-              <a:t>columns-within-row for vertical and diagonal, so the hash cannot move</a:t>
+              <a:t>This row is also what corrected the record: at the oracle tier the NSP</a:t>
             </a:r>
           </a:p>
           <a:p>
@@ -9228,7 +10831,29 @@
                 </a:solidFill>
                 <a:latin typeface="Calibri"/>
               </a:rPr>
-              <a:t>with the thread count.</a:t>
+              <a:t>appeared to lead the cluster 3.29x; at the matched NEON tier the cluster</a:t>
+            </a:r>
+          </a:p>
+          <a:p>
+            <a:r>
+              <a:rPr sz="1300">
+                <a:solidFill>
+                  <a:srgbClr val="202124"/>
+                </a:solidFill>
+                <a:latin typeface="Calibri"/>
+              </a:rPr>
+              <a:t>leads 1.30x. A cross-tier comparison is a cross-configuration comparison</a:t>
+            </a:r>
+          </a:p>
+          <a:p>
+            <a:r>
+              <a:rPr sz="1300">
+                <a:solidFill>
+                  <a:srgbClr val="202124"/>
+                </a:solidFill>
+                <a:latin typeface="Calibri"/>
+              </a:rPr>
+              <a:t>wearing a platform comparison's clothes.</a:t>
             </a:r>
           </a:p>
         </p:txBody>
@@ -9312,11 +10937,11 @@
             <a:r>
               <a:rPr sz="3200" b="1">
                 <a:solidFill>
-                  <a:srgbClr val="12B5A5"/>
-                </a:solidFill>
-                <a:latin typeface="Calibri"/>
-              </a:rPr>
-              <a:t>Hexagon v73 NSP</a:t>
+                  <a:srgbClr val="E8710A"/>
+                </a:solidFill>
+                <a:latin typeface="Calibri"/>
+              </a:rPr>
+              <a:t>Cortex-A720 x8</a:t>
             </a:r>
           </a:p>
         </p:txBody>
@@ -9386,7 +11011,7 @@
                 </a:solidFill>
                 <a:latin typeface="Calibri"/>
               </a:rPr>
-              <a:t>Qualcomm IQ-9075, HVX, 4 contexts  |  median of 5, 0.75% spread, golden 10/10</a:t>
+              <a:t>Radxa Orion O6, NEON+OpenMP  |  single core: 470.9 ms</a:t>
             </a:r>
           </a:p>
         </p:txBody>
@@ -9457,9 +11082,9 @@
                 <a:latin typeface="Consolas"/>
               </a:rPr>
               <a:t>MDE/s  =  (0.384 + 1.536) Mpx x 64 / runtime      (both full-search scales count)
-        =  122,880,000 disparity estimations / 0.27630 s
-        =  445 million disparity estimations per second
-frame rate  =  1000 / 276.30  =  3.62 fps   (960x400 disparity map out)</a:t>
+        =  122,880,000 disparity estimations / 0.23830 s
+        =  516 million disparity estimations per second
+frame rate  =  1000 / 238.30  =  4.20 fps   (960x400 disparity map out)</a:t>
             </a:r>
           </a:p>
         </p:txBody>
@@ -9529,7 +11154,7 @@
                 </a:solidFill>
                 <a:latin typeface="Calibri"/>
               </a:rPr>
-              <a:t>Contributed port, independently re-verified (three further gated runs,</a:t>
+              <a:t>The NEON tier is 5.8x the scalar oracle on this cluster. The kernel keeps</a:t>
             </a:r>
           </a:p>
           <a:p>
@@ -9540,7 +11165,7 @@
                 </a:solidFill>
                 <a:latin typeface="Calibri"/>
               </a:rPr>
-              <a:t>269-272 ms). Per ENGINE this is the embedded win: one NSP beats one A78C</a:t>
+              <a:t>Configuration A's register scheme and adds the saturating step, the</a:t>
             </a:r>
           </a:p>
           <a:p>
@@ -9551,7 +11176,7 @@
                 </a:solidFill>
                 <a:latin typeface="Calibri"/>
               </a:rPr>
-              <a:t>core 1.60x at matched tiers.</a:t>
+              <a:t>direction-weighted P1 per sweep, and a uint16 sum plane for 8-path S.</a:t>
             </a:r>
           </a:p>
           <a:p>
@@ -9562,7 +11187,7 @@
                 </a:solidFill>
                 <a:latin typeface="Calibri"/>
               </a:rPr>
-              <a:t>Diagonals use a sync-free chain-band decomposition -- workers own equal-pixel</a:t>
+              <a:t>OpenMP is output-neutral by construction: rows for horizontal sweeps,</a:t>
             </a:r>
           </a:p>
           <a:p>
@@ -9573,7 +11198,7 @@
                 </a:solidFill>
                 <a:latin typeface="Calibri"/>
               </a:rPr>
-              <a:t>bands of diagonal chains, S worker-disjoint, bit-exact with NO barriers.</a:t>
+              <a:t>columns-within-row for vertical and diagonal, so the hash cannot move</a:t>
             </a:r>
           </a:p>
           <a:p>
@@ -9584,62 +11209,7 @@
                 </a:solidFill>
                 <a:latin typeface="Calibri"/>
               </a:rPr>
-              <a:t>The two-scale merge is fused into the stage-2 cost build, saving ~200 MB</a:t>
-            </a:r>
-          </a:p>
-          <a:p>
-            <a:r>
-              <a:rPr sz="1300">
-                <a:solidFill>
-                  <a:srgbClr val="202124"/>
-                </a:solidFill>
-                <a:latin typeface="Calibri"/>
-              </a:rPr>
-              <a:t>of traffic per frame. The 4-HVX-context knee holds here too: 6 threads is</a:t>
-            </a:r>
-          </a:p>
-          <a:p>
-            <a:r>
-              <a:rPr sz="1300">
-                <a:solidFill>
-                  <a:srgbClr val="202124"/>
-                </a:solidFill>
-                <a:latin typeface="Calibri"/>
-              </a:rPr>
-              <a:t>29% WORSE than 4.</a:t>
-            </a:r>
-          </a:p>
-          <a:p>
-            <a:r>
-              <a:rPr sz="1300">
-                <a:solidFill>
-                  <a:srgbClr val="202124"/>
-                </a:solidFill>
-                <a:latin typeface="Calibri"/>
-              </a:rPr>
-              <a:t>P2=200 overflowed their packed (S&lt;&lt;6)|d argmin key at S=2040 -- the warned</a:t>
-            </a:r>
-          </a:p>
-          <a:p>
-            <a:r>
-              <a:rPr sz="1300">
-                <a:solidFill>
-                  <a:srgbClr val="202124"/>
-                </a:solidFill>
-                <a:latin typeface="Calibri"/>
-              </a:rPr>
-              <a:t>saturation failure mode, one stage downstream of the warned location.</a:t>
-            </a:r>
-          </a:p>
-          <a:p>
-            <a:r>
-              <a:rPr sz="1300">
-                <a:solidFill>
-                  <a:srgbClr val="202124"/>
-                </a:solidFill>
-                <a:latin typeface="Calibri"/>
-              </a:rPr>
-              <a:t>Redesigned and sim-proven on tie-storms at the cap before shipping.</a:t>
+              <a:t>with the thread count.</a:t>
             </a:r>
           </a:p>
         </p:txBody>
@@ -9723,11 +11293,11 @@
             <a:r>
               <a:rPr sz="3200" b="1">
                 <a:solidFill>
-                  <a:srgbClr val="4C8BF5"/>
-                </a:solidFill>
-                <a:latin typeface="Calibri"/>
-              </a:rPr>
-              <a:t>Mali-G720</a:t>
+                  <a:srgbClr val="12B5A5"/>
+                </a:solidFill>
+                <a:latin typeface="Calibri"/>
+              </a:rPr>
+              <a:t>Hexagon v73 NSP</a:t>
             </a:r>
           </a:p>
         </p:txBody>
@@ -9797,7 +11367,7 @@
                 </a:solidFill>
                 <a:latin typeface="Calibri"/>
               </a:rPr>
-              <a:t>Immortalis, 10 CU, OpenCL 3.0</a:t>
+              <a:t>Qualcomm IQ-9075, HVX, 4 contexts  |  median of 5, 0.75% spread, golden 10/10</a:t>
             </a:r>
           </a:p>
         </p:txBody>
@@ -9868,9 +11438,9 @@
                 <a:latin typeface="Consolas"/>
               </a:rPr>
               <a:t>MDE/s  =  (0.384 + 1.536) Mpx x 64 / runtime      (both full-search scales count)
-        =  122,880,000 disparity estimations / 0.38000 s
-        =  323 million disparity estimations per second
-frame rate  =  1000 / 380.00  =  2.63 fps   (960x400 disparity map out)</a:t>
+        =  122,880,000 disparity estimations / 0.27630 s
+        =  445 million disparity estimations per second
+frame rate  =  1000 / 276.30  =  3.62 fps   (960x400 disparity map out)</a:t>
             </a:r>
           </a:p>
         </p:txBody>
@@ -9940,7 +11510,7 @@
                 </a:solidFill>
                 <a:latin typeface="Calibri"/>
               </a:rPr>
-              <a:t>One 16-work-item work-group owns each path line; barriers are uniform</a:t>
+              <a:t>Contributed port, independently re-verified (three further gated runs,</a:t>
             </a:r>
           </a:p>
           <a:p>
@@ -9951,7 +11521,7 @@
                 </a:solidFill>
                 <a:latin typeface="Calibri"/>
               </a:rPr>
-              <a:t>because every work-item in the group walks the same line trajectory.</a:t>
+              <a:t>269-272 ms). Per ENGINE this is the embedded win: one NSP beats one A78C</a:t>
             </a:r>
           </a:p>
           <a:p>
@@ -9962,7 +11532,7 @@
                 </a:solidFill>
                 <a:latin typeface="Calibri"/>
               </a:rPr>
-              <a:t>Bit-exact on the first attempt. Same caveat as Configuration A: a</a:t>
+              <a:t>core 1.60x at matched tiers.</a:t>
             </a:r>
           </a:p>
           <a:p>
@@ -9973,7 +11543,7 @@
                 </a:solidFill>
                 <a:latin typeface="Calibri"/>
               </a:rPr>
-              <a:t>single-chain-per-line kernel is an effort floor for this part, not a</a:t>
+              <a:t>Diagonals use a sync-free chain-band decomposition -- workers own equal-pixel</a:t>
             </a:r>
           </a:p>
           <a:p>
@@ -9984,7 +11554,73 @@
                 </a:solidFill>
                 <a:latin typeface="Calibri"/>
               </a:rPr>
-              <a:t>verdict on it.</a:t>
+              <a:t>bands of diagonal chains, S worker-disjoint, bit-exact with NO barriers.</a:t>
+            </a:r>
+          </a:p>
+          <a:p>
+            <a:r>
+              <a:rPr sz="1300">
+                <a:solidFill>
+                  <a:srgbClr val="202124"/>
+                </a:solidFill>
+                <a:latin typeface="Calibri"/>
+              </a:rPr>
+              <a:t>The two-scale merge is fused into the stage-2 cost build, saving ~200 MB</a:t>
+            </a:r>
+          </a:p>
+          <a:p>
+            <a:r>
+              <a:rPr sz="1300">
+                <a:solidFill>
+                  <a:srgbClr val="202124"/>
+                </a:solidFill>
+                <a:latin typeface="Calibri"/>
+              </a:rPr>
+              <a:t>of traffic per frame. The 4-HVX-context knee holds here too: 6 threads is</a:t>
+            </a:r>
+          </a:p>
+          <a:p>
+            <a:r>
+              <a:rPr sz="1300">
+                <a:solidFill>
+                  <a:srgbClr val="202124"/>
+                </a:solidFill>
+                <a:latin typeface="Calibri"/>
+              </a:rPr>
+              <a:t>29% WORSE than 4.</a:t>
+            </a:r>
+          </a:p>
+          <a:p>
+            <a:r>
+              <a:rPr sz="1300">
+                <a:solidFill>
+                  <a:srgbClr val="202124"/>
+                </a:solidFill>
+                <a:latin typeface="Calibri"/>
+              </a:rPr>
+              <a:t>P2=200 overflowed their packed (S&lt;&lt;6)|d argmin key at S=2040 -- the warned</a:t>
+            </a:r>
+          </a:p>
+          <a:p>
+            <a:r>
+              <a:rPr sz="1300">
+                <a:solidFill>
+                  <a:srgbClr val="202124"/>
+                </a:solidFill>
+                <a:latin typeface="Calibri"/>
+              </a:rPr>
+              <a:t>saturation failure mode, one stage downstream of the warned location.</a:t>
+            </a:r>
+          </a:p>
+          <a:p>
+            <a:r>
+              <a:rPr sz="1300">
+                <a:solidFill>
+                  <a:srgbClr val="202124"/>
+                </a:solidFill>
+                <a:latin typeface="Calibri"/>
+              </a:rPr>
+              <a:t>Redesigned and sim-proven on tie-storms at the cap before shipping.</a:t>
             </a:r>
           </a:p>
         </p:txBody>
@@ -10068,11 +11704,11 @@
             <a:r>
               <a:rPr sz="3200" b="1">
                 <a:solidFill>
-                  <a:srgbClr val="E8710A"/>
-                </a:solidFill>
-                <a:latin typeface="Calibri"/>
-              </a:rPr>
-              <a:t>Cortex-A55 x6</a:t>
+                  <a:srgbClr val="4C8BF5"/>
+                </a:solidFill>
+                <a:latin typeface="Calibri"/>
+              </a:rPr>
+              <a:t>Mali-G720</a:t>
             </a:r>
           </a:p>
         </p:txBody>
@@ -10142,7 +11778,7 @@
                 </a:solidFill>
                 <a:latin typeface="Calibri"/>
               </a:rPr>
-              <a:t>i.MX 95 FRDM, 1.8 GHz, NEON+OpenMP  |  single core: 2,201 ms</a:t>
+              <a:t>Immortalis, 10 CU, OpenCL 3.0</a:t>
             </a:r>
           </a:p>
         </p:txBody>
@@ -10213,9 +11849,9 @@
                 <a:latin typeface="Consolas"/>
               </a:rPr>
               <a:t>MDE/s  =  (0.384 + 1.536) Mpx x 64 / runtime      (both full-search scales count)
-        =  122,880,000 disparity estimations / 0.64010 s
-        =  192 million disparity estimations per second
-frame rate  =  1000 / 640.10  =  1.56 fps   (960x400 disparity map out)</a:t>
+        =  122,880,000 disparity estimations / 0.38000 s
+        =  323 million disparity estimations per second
+frame rate  =  1000 / 380.00  =  2.63 fps   (960x400 disparity map out)</a:t>
             </a:r>
           </a:p>
         </p:txBody>
@@ -10285,7 +11921,7 @@
                 </a:solidFill>
                 <a:latin typeface="Calibri"/>
               </a:rPr>
-              <a:t>The anchor platform runs the full two-scale 8-path configuration at 1.56 fps</a:t>
+              <a:t>One 16-work-item work-group owns each path line; barriers are uniform</a:t>
             </a:r>
           </a:p>
           <a:p>
@@ -10296,7 +11932,7 @@
                 </a:solidFill>
                 <a:latin typeface="Calibri"/>
               </a:rPr>
-              <a:t>-- 22x the scalar oracle on the same six cores' single-core floor.</a:t>
+              <a:t>because every work-item in the group walks the same line trajectory.</a:t>
             </a:r>
           </a:p>
           <a:p>
@@ -10307,7 +11943,7 @@
                 </a:solidFill>
                 <a:latin typeface="Calibri"/>
               </a:rPr>
-              <a:t>The saturating NEON step (vqaddq_u8 against P2=200) is the part Configuration</a:t>
+              <a:t>Bit-exact on the first attempt. Same caveat as Configuration A: a</a:t>
             </a:r>
           </a:p>
           <a:p>
@@ -10318,7 +11954,7 @@
                 </a:solidFill>
                 <a:latin typeface="Calibri"/>
               </a:rPr>
-              <a:t>A never needed: its static assert guarantees no overflow at P2=192, and</a:t>
+              <a:t>single-chain-per-line kernel is an effort floor for this part, not a</a:t>
             </a:r>
           </a:p>
           <a:p>
@@ -10329,7 +11965,7 @@
                 </a:solidFill>
                 <a:latin typeface="Calibri"/>
               </a:rPr>
-              <a:t>Configuration B is the configuration that breaks that assumption.</a:t>
+              <a:t>verdict on it.</a:t>
             </a:r>
           </a:p>
         </p:txBody>
@@ -10413,11 +12049,11 @@
             <a:r>
               <a:rPr sz="3200" b="1">
                 <a:solidFill>
-                  <a:srgbClr val="4C8BF5"/>
-                </a:solidFill>
-                <a:latin typeface="Calibri"/>
-              </a:rPr>
-              <a:t>Mali-G310</a:t>
+                  <a:srgbClr val="E8710A"/>
+                </a:solidFill>
+                <a:latin typeface="Calibri"/>
+              </a:rPr>
+              <a:t>Cortex-A55 x6</a:t>
             </a:r>
           </a:p>
         </p:txBody>
@@ -10487,7 +12123,7 @@
                 </a:solidFill>
                 <a:latin typeface="Calibri"/>
               </a:rPr>
-              <a:t>1 CU, OpenCL 3.0</a:t>
+              <a:t>i.MX 95 FRDM, 1.8 GHz, NEON+OpenMP  |  single core: 2,201 ms</a:t>
             </a:r>
           </a:p>
         </p:txBody>
@@ -10558,9 +12194,9 @@
                 <a:latin typeface="Consolas"/>
               </a:rPr>
               <a:t>MDE/s  =  (0.384 + 1.536) Mpx x 64 / runtime      (both full-search scales count)
-        =  122,880,000 disparity estimations / 2.70400 s
-        =  45 million disparity estimations per second
-frame rate  =  1000 / 2,704.00  =  0.37 fps   (960x400 disparity map out)</a:t>
+        =  122,880,000 disparity estimations / 0.64010 s
+        =  192 million disparity estimations per second
+frame rate  =  1000 / 640.10  =  1.56 fps   (960x400 disparity map out)</a:t>
             </a:r>
           </a:p>
         </p:txBody>
@@ -10630,7 +12266,51 @@
                 </a:solidFill>
                 <a:latin typeface="Calibri"/>
               </a:rPr>
-              <a:t>Same OpenCL kernel as the G720, same hash, one compute unit.</a:t>
+              <a:t>The anchor platform runs the full two-scale 8-path configuration at 1.56 fps</a:t>
+            </a:r>
+          </a:p>
+          <a:p>
+            <a:r>
+              <a:rPr sz="1300">
+                <a:solidFill>
+                  <a:srgbClr val="202124"/>
+                </a:solidFill>
+                <a:latin typeface="Calibri"/>
+              </a:rPr>
+              <a:t>-- 22x the scalar oracle on the same six cores' single-core floor.</a:t>
+            </a:r>
+          </a:p>
+          <a:p>
+            <a:r>
+              <a:rPr sz="1300">
+                <a:solidFill>
+                  <a:srgbClr val="202124"/>
+                </a:solidFill>
+                <a:latin typeface="Calibri"/>
+              </a:rPr>
+              <a:t>The saturating NEON step (vqaddq_u8 against P2=200) is the part Configuration</a:t>
+            </a:r>
+          </a:p>
+          <a:p>
+            <a:r>
+              <a:rPr sz="1300">
+                <a:solidFill>
+                  <a:srgbClr val="202124"/>
+                </a:solidFill>
+                <a:latin typeface="Calibri"/>
+              </a:rPr>
+              <a:t>A never needed: its static assert guarantees no overflow at P2=192, and</a:t>
+            </a:r>
+          </a:p>
+          <a:p>
+            <a:r>
+              <a:rPr sz="1300">
+                <a:solidFill>
+                  <a:srgbClr val="202124"/>
+                </a:solidFill>
+                <a:latin typeface="Calibri"/>
+              </a:rPr>
+              <a:t>Configuration B is the configuration that breaks that assumption.</a:t>
             </a:r>
           </a:p>
         </p:txBody>
@@ -10679,6 +12359,307 @@
 </file>
 
 <file path=ppt/slides/slide25.xml><?xml version="1.0" encoding="utf-8"?>
+<p:sld xmlns:a="http://schemas.openxmlformats.org/drawingml/2006/main" xmlns:p="http://schemas.openxmlformats.org/presentationml/2006/main" xmlns:r="http://schemas.openxmlformats.org/officeDocument/2006/relationships">
+  <p:cSld>
+    <p:spTree>
+      <p:nvGrpSpPr>
+        <p:cNvPr id="1" name=""/>
+        <p:cNvGrpSpPr/>
+        <p:nvPr/>
+      </p:nvGrpSpPr>
+      <p:grpSpPr/>
+      <p:sp>
+        <p:nvSpPr>
+          <p:cNvPr id="2" name="TextBox 1"/>
+          <p:cNvSpPr txBox="1"/>
+          <p:nvPr/>
+        </p:nvSpPr>
+        <p:spPr>
+          <a:xfrm>
+            <a:off x="548640" y="320040"/>
+            <a:ext cx="10058400" cy="640080"/>
+          </a:xfrm>
+          <a:prstGeom prst="rect">
+            <a:avLst/>
+          </a:prstGeom>
+          <a:noFill/>
+        </p:spPr>
+        <p:txBody>
+          <a:bodyPr wrap="square">
+            <a:spAutoFit/>
+          </a:bodyPr>
+          <a:lstStyle/>
+          <a:p>
+            <a:pPr algn="l"/>
+            <a:r>
+              <a:rPr sz="3200" b="1">
+                <a:solidFill>
+                  <a:srgbClr val="4C8BF5"/>
+                </a:solidFill>
+                <a:latin typeface="Calibri"/>
+              </a:rPr>
+              <a:t>Mali-G310</a:t>
+            </a:r>
+          </a:p>
+        </p:txBody>
+      </p:sp>
+      <p:sp>
+        <p:nvSpPr>
+          <p:cNvPr id="3" name="TextBox 2"/>
+          <p:cNvSpPr txBox="1"/>
+          <p:nvPr/>
+        </p:nvSpPr>
+        <p:spPr>
+          <a:xfrm>
+            <a:off x="9509760" y="457200"/>
+            <a:ext cx="2194560" cy="365760"/>
+          </a:xfrm>
+          <a:prstGeom prst="rect">
+            <a:avLst/>
+          </a:prstGeom>
+          <a:noFill/>
+        </p:spPr>
+        <p:txBody>
+          <a:bodyPr wrap="square">
+            <a:spAutoFit/>
+          </a:bodyPr>
+          <a:lstStyle/>
+          <a:p>
+            <a:pPr algn="l"/>
+            <a:r>
+              <a:rPr sz="1200" b="1">
+                <a:solidFill>
+                  <a:srgbClr val="5F6368"/>
+                </a:solidFill>
+                <a:latin typeface="Calibri"/>
+              </a:rPr>
+              <a:t>CONFIGURATION B</a:t>
+            </a:r>
+          </a:p>
+        </p:txBody>
+      </p:sp>
+      <p:sp>
+        <p:nvSpPr>
+          <p:cNvPr id="4" name="TextBox 3"/>
+          <p:cNvSpPr txBox="1"/>
+          <p:nvPr/>
+        </p:nvSpPr>
+        <p:spPr>
+          <a:xfrm>
+            <a:off x="548640" y="914400"/>
+            <a:ext cx="10881360" cy="365760"/>
+          </a:xfrm>
+          <a:prstGeom prst="rect">
+            <a:avLst/>
+          </a:prstGeom>
+          <a:noFill/>
+        </p:spPr>
+        <p:txBody>
+          <a:bodyPr wrap="square">
+            <a:spAutoFit/>
+          </a:bodyPr>
+          <a:lstStyle/>
+          <a:p>
+            <a:pPr algn="l"/>
+            <a:r>
+              <a:rPr sz="1300" b="0">
+                <a:solidFill>
+                  <a:srgbClr val="5F6368"/>
+                </a:solidFill>
+                <a:latin typeface="Calibri"/>
+              </a:rPr>
+              <a:t>1 CU, OpenCL 3.0</a:t>
+            </a:r>
+          </a:p>
+        </p:txBody>
+      </p:sp>
+      <p:sp>
+        <p:nvSpPr>
+          <p:cNvPr id="5" name="TextBox 4"/>
+          <p:cNvSpPr txBox="1"/>
+          <p:nvPr/>
+        </p:nvSpPr>
+        <p:spPr>
+          <a:xfrm>
+            <a:off x="548640" y="1554480"/>
+            <a:ext cx="10515600" cy="365760"/>
+          </a:xfrm>
+          <a:prstGeom prst="rect">
+            <a:avLst/>
+          </a:prstGeom>
+          <a:noFill/>
+        </p:spPr>
+        <p:txBody>
+          <a:bodyPr wrap="square">
+            <a:spAutoFit/>
+          </a:bodyPr>
+          <a:lstStyle/>
+          <a:p>
+            <a:pPr algn="l"/>
+            <a:r>
+              <a:rPr sz="1600" b="1">
+                <a:solidFill>
+                  <a:srgbClr val="202124"/>
+                </a:solidFill>
+                <a:latin typeface="Calibri"/>
+              </a:rPr>
+              <a:t>The calculation (work-performed convention)</a:t>
+            </a:r>
+          </a:p>
+        </p:txBody>
+      </p:sp>
+      <p:sp>
+        <p:nvSpPr>
+          <p:cNvPr id="6" name="TextBox 5"/>
+          <p:cNvSpPr txBox="1"/>
+          <p:nvPr/>
+        </p:nvSpPr>
+        <p:spPr>
+          <a:xfrm>
+            <a:off x="548640" y="1965960"/>
+            <a:ext cx="10881360" cy="1554480"/>
+          </a:xfrm>
+          <a:prstGeom prst="rect">
+            <a:avLst/>
+          </a:prstGeom>
+          <a:noFill/>
+        </p:spPr>
+        <p:txBody>
+          <a:bodyPr wrap="square">
+            <a:spAutoFit/>
+          </a:bodyPr>
+          <a:lstStyle/>
+          <a:p>
+            <a:pPr algn="l"/>
+            <a:r>
+              <a:rPr sz="1400" b="0">
+                <a:solidFill>
+                  <a:srgbClr val="202124"/>
+                </a:solidFill>
+                <a:latin typeface="Consolas"/>
+              </a:rPr>
+              <a:t>MDE/s  =  (0.384 + 1.536) Mpx x 64 / runtime      (both full-search scales count)
+        =  122,880,000 disparity estimations / 2.70400 s
+        =  45 million disparity estimations per second
+frame rate  =  1000 / 2,704.00  =  0.37 fps   (960x400 disparity map out)</a:t>
+            </a:r>
+          </a:p>
+        </p:txBody>
+      </p:sp>
+      <p:sp>
+        <p:nvSpPr>
+          <p:cNvPr id="7" name="TextBox 6"/>
+          <p:cNvSpPr txBox="1"/>
+          <p:nvPr/>
+        </p:nvSpPr>
+        <p:spPr>
+          <a:xfrm>
+            <a:off x="548640" y="3657600"/>
+            <a:ext cx="10515600" cy="365760"/>
+          </a:xfrm>
+          <a:prstGeom prst="rect">
+            <a:avLst/>
+          </a:prstGeom>
+          <a:noFill/>
+        </p:spPr>
+        <p:txBody>
+          <a:bodyPr wrap="square">
+            <a:spAutoFit/>
+          </a:bodyPr>
+          <a:lstStyle/>
+          <a:p>
+            <a:pPr algn="l"/>
+            <a:r>
+              <a:rPr sz="1600" b="1">
+                <a:solidFill>
+                  <a:srgbClr val="202124"/>
+                </a:solidFill>
+                <a:latin typeface="Calibri"/>
+              </a:rPr>
+              <a:t>What the measurement means</a:t>
+            </a:r>
+          </a:p>
+        </p:txBody>
+      </p:sp>
+      <p:sp>
+        <p:nvSpPr>
+          <p:cNvPr id="8" name="TextBox 7"/>
+          <p:cNvSpPr txBox="1"/>
+          <p:nvPr/>
+        </p:nvSpPr>
+        <p:spPr>
+          <a:xfrm>
+            <a:off x="548640" y="4023360"/>
+            <a:ext cx="10881360" cy="2286000"/>
+          </a:xfrm>
+          <a:prstGeom prst="rect">
+            <a:avLst/>
+          </a:prstGeom>
+          <a:noFill/>
+        </p:spPr>
+        <p:txBody>
+          <a:bodyPr wrap="square">
+            <a:spAutoFit/>
+          </a:bodyPr>
+          <a:lstStyle/>
+          <a:p>
+            <a:pPr algn="l"/>
+            <a:r>
+              <a:rPr sz="1300" b="0">
+                <a:solidFill>
+                  <a:srgbClr val="202124"/>
+                </a:solidFill>
+                <a:latin typeface="Calibri"/>
+              </a:rPr>
+              <a:t>Same OpenCL kernel as the G720, same hash, one compute unit.</a:t>
+            </a:r>
+          </a:p>
+        </p:txBody>
+      </p:sp>
+      <p:sp>
+        <p:nvSpPr>
+          <p:cNvPr id="9" name="TextBox 8"/>
+          <p:cNvSpPr txBox="1"/>
+          <p:nvPr/>
+        </p:nvSpPr>
+        <p:spPr>
+          <a:xfrm>
+            <a:off x="548640" y="6446520"/>
+            <a:ext cx="10881360" cy="365760"/>
+          </a:xfrm>
+          <a:prstGeom prst="rect">
+            <a:avLst/>
+          </a:prstGeom>
+          <a:noFill/>
+        </p:spPr>
+        <p:txBody>
+          <a:bodyPr wrap="square">
+            <a:spAutoFit/>
+          </a:bodyPr>
+          <a:lstStyle/>
+          <a:p>
+            <a:pPr algn="l"/>
+            <a:r>
+              <a:rPr sz="1100" b="0">
+                <a:solidFill>
+                  <a:srgbClr val="5F6368"/>
+                </a:solidFill>
+                <a:latin typeface="Calibri"/>
+              </a:rPr>
+              <a:t>MEASURED -- median of the timed frames, bit-exact to golden bcb9cb0bd6f49799 in the same run.</a:t>
+            </a:r>
+          </a:p>
+        </p:txBody>
+      </p:sp>
+    </p:spTree>
+  </p:cSld>
+  <p:clrMapOvr>
+    <a:masterClrMapping/>
+  </p:clrMapOvr>
+</p:sld>
+</file>
+
+<file path=ppt/slides/slide26.xml><?xml version="1.0" encoding="utf-8"?>
 <p:sld xmlns:a="http://schemas.openxmlformats.org/drawingml/2006/main" xmlns:p="http://schemas.openxmlformats.org/presentationml/2006/main" xmlns:r="http://schemas.openxmlformats.org/officeDocument/2006/relationships">
   <p:cSld>
     <p:spTree>

</xml_diff>

<commit_message>
Configuration C: the NSP row completes the roster, and the reproduce-gap closes
The qualcomm session's Config B HVX kernels ran the 1080p scene unmodified:
372.38 ms median of five invocations (1.7% spread), golden 0f0961d623009df5
gated in-run 5/5. C/B = 1.348 against the 1.35x pixel prediction with
essentially constant MDE/s (444.8 -> 445.5) -- the cleanest counter-example to
the A720 cluster's 1.01x: a work-limited engine holds efficiency across the
resolution change; a slack-limited cluster absorbs the pixels for free.

With hvx/configA/ and hvx/configB/ contributed (60ecd03, swept independently
before this push), every row in all three configurations rebuilds from this
repository. The README's reproducibility-gap paragraph is replaced by its
closure.
</commit_message>
<xml_diff>
--- a/docs/sgm-results.pptx
+++ b/docs/sgm-results.pptx
@@ -9265,7 +9265,7 @@
         </p:nvGraphicFramePr>
         <p:xfrm>
           <a:off x="548640" y="1828800"/>
-          <a:ext cx="11064240" cy="3090672"/>
+          <a:ext cx="11064240" cy="3328416"/>
         </p:xfrm>
         <a:graphic>
           <a:graphicData uri="http://schemas.openxmlformats.org/drawingml/2006/table">
@@ -9834,6 +9834,93 @@
                             <a:srgbClr val="202124"/>
                           </a:solidFill>
                         </a:rPr>
+                        <a:t>Hexagon v73 NSP</a:t>
+                      </a:r>
+                    </a:p>
+                  </a:txBody>
+                  <a:tcPr/>
+                </a:tc>
+                <a:tc>
+                  <a:txBody>
+                    <a:bodyPr/>
+                    <a:lstStyle/>
+                    <a:p>
+                      <a:r>
+                        <a:rPr sz="1050" b="1">
+                          <a:solidFill>
+                            <a:srgbClr val="12B5A5"/>
+                          </a:solidFill>
+                        </a:rPr>
+                        <a:t>DSP</a:t>
+                      </a:r>
+                    </a:p>
+                  </a:txBody>
+                  <a:tcPr/>
+                </a:tc>
+                <a:tc>
+                  <a:txBody>
+                    <a:bodyPr/>
+                    <a:lstStyle/>
+                    <a:p>
+                      <a:r>
+                        <a:rPr sz="1050" b="0">
+                          <a:solidFill>
+                            <a:srgbClr val="202124"/>
+                          </a:solidFill>
+                        </a:rPr>
+                        <a:t>372.4 ms</a:t>
+                      </a:r>
+                    </a:p>
+                  </a:txBody>
+                  <a:tcPr/>
+                </a:tc>
+                <a:tc>
+                  <a:txBody>
+                    <a:bodyPr/>
+                    <a:lstStyle/>
+                    <a:p>
+                      <a:r>
+                        <a:rPr sz="1050" b="1">
+                          <a:solidFill>
+                            <a:srgbClr val="202124"/>
+                          </a:solidFill>
+                        </a:rPr>
+                        <a:t>446</a:t>
+                      </a:r>
+                    </a:p>
+                  </a:txBody>
+                  <a:tcPr/>
+                </a:tc>
+                <a:tc>
+                  <a:txBody>
+                    <a:bodyPr/>
+                    <a:lstStyle/>
+                    <a:p>
+                      <a:r>
+                        <a:rPr sz="1050" b="0">
+                          <a:solidFill>
+                            <a:srgbClr val="202124"/>
+                          </a:solidFill>
+                        </a:rPr>
+                        <a:t>1.35  (and constant MDE/s vs B)</a:t>
+                      </a:r>
+                    </a:p>
+                  </a:txBody>
+                  <a:tcPr/>
+                </a:tc>
+              </a:tr>
+              <a:tr h="237744">
+                <a:tc>
+                  <a:txBody>
+                    <a:bodyPr/>
+                    <a:lstStyle/>
+                    <a:p>
+                      <a:r>
+                        <a:rPr sz="1050" b="1">
+                          <a:solidFill>
+                            <a:srgbClr val="202124"/>
+                          </a:solidFill>
+                        </a:rPr>
                         <a:t>Mali-G720 (10 CU)</a:t>
                       </a:r>
                     </a:p>
@@ -10535,7 +10622,7 @@
                 </a:solidFill>
                 <a:latin typeface="Calibri"/>
               </a:rPr>
-              <a:t>Hexagon NSP row pending (contributed kernels). A78C cells are medians of repeated invocations on that bimodal board.</a:t>
+              <a:t>A78C and NSP cells are medians of repeated invocations on that bimodal board (NSP: 5 invocations, 1.7% spread, unmodified Config B kernels).</a:t>
             </a:r>
           </a:p>
         </p:txBody>

</xml_diff>

<commit_message>
OFA rows: slotted by performance rank, with time-only multipliers
Per Kyle: the OFA rows now sit where their speed places them in every table
(deck slides 1/15/17 and the README A/B/C tables) instead of being appended,
and the vs-scalar column carries the arithmetic with its condition attached --
'983x (time only)' etc. -- rather than refusing the division. The label still
does the honest work: time-only, own algorithm, not gated.
</commit_message>
<xml_diff>
--- a/docs/sgm-results.pptx
+++ b/docs/sgm-results.pptx
@@ -3595,7 +3595,7 @@
                             <a:srgbClr val="202124"/>
                           </a:solidFill>
                         </a:rPr>
-                        <a:t>throughput only</a:t>
+                        <a:t>983x (time only)</a:t>
                       </a:r>
                     </a:p>
                   </a:txBody>
@@ -4079,7 +4079,7 @@
                             <a:srgbClr val="202124"/>
                           </a:solidFill>
                         </a:rPr>
-                        <a:t>throughput only</a:t>
+                        <a:t>126x (time only)</a:t>
                       </a:r>
                     </a:p>
                   </a:txBody>
@@ -7259,7 +7259,7 @@
                             <a:srgbClr val="202124"/>
                           </a:solidFill>
                         </a:rPr>
-                        <a:t>NVIDIA RTX 5090</a:t>
+                        <a:t>NVIDIA OFA on Thor (ds=2)</a:t>
                       </a:r>
                     </a:p>
                   </a:txBody>
@@ -7273,10 +7273,10 @@
                       <a:r>
                         <a:rPr sz="1100" b="1">
                           <a:solidFill>
-                            <a:srgbClr val="4C8BF5"/>
-                          </a:solidFill>
-                        </a:rPr>
-                        <a:t>GPU</a:t>
+                            <a:srgbClr val="7B4FD1"/>
+                          </a:solidFill>
+                        </a:rPr>
+                        <a:t>HW</a:t>
                       </a:r>
                     </a:p>
                   </a:txBody>
@@ -7293,7 +7293,7 @@
                             <a:srgbClr val="202124"/>
                           </a:solidFill>
                         </a:rPr>
-                        <a:t>9.08 ms</a:t>
+                        <a:t>3.38 ms</a:t>
                       </a:r>
                     </a:p>
                   </a:txBody>
@@ -7310,7 +7310,7 @@
                             <a:srgbClr val="202124"/>
                           </a:solidFill>
                         </a:rPr>
-                        <a:t>110.1</a:t>
+                        <a:t>296</a:t>
                       </a:r>
                     </a:p>
                   </a:txBody>
@@ -7327,7 +7327,7 @@
                             <a:srgbClr val="202124"/>
                           </a:solidFill>
                         </a:rPr>
-                        <a:t>13,538</a:t>
+                        <a:t>—</a:t>
                       </a:r>
                     </a:p>
                   </a:txBody>
@@ -7344,7 +7344,7 @@
                             <a:srgbClr val="202124"/>
                           </a:solidFill>
                         </a:rPr>
-                        <a:t>1,571x faster</a:t>
+                        <a:t>4,220x (time only)</a:t>
                       </a:r>
                     </a:p>
                   </a:txBody>
@@ -7363,7 +7363,7 @@
                             <a:srgbClr val="202124"/>
                           </a:solidFill>
                         </a:rPr>
-                        <a:t>NVIDIA Thor</a:t>
+                        <a:t>NVIDIA RTX 5090</a:t>
                       </a:r>
                     </a:p>
                   </a:txBody>
@@ -7397,7 +7397,7 @@
                             <a:srgbClr val="202124"/>
                           </a:solidFill>
                         </a:rPr>
-                        <a:t>45.10 ms</a:t>
+                        <a:t>9.08 ms</a:t>
                       </a:r>
                     </a:p>
                   </a:txBody>
@@ -7414,7 +7414,7 @@
                             <a:srgbClr val="202124"/>
                           </a:solidFill>
                         </a:rPr>
-                        <a:t>22.2</a:t>
+                        <a:t>110.1</a:t>
                       </a:r>
                     </a:p>
                   </a:txBody>
@@ -7431,7 +7431,7 @@
                             <a:srgbClr val="202124"/>
                           </a:solidFill>
                         </a:rPr>
-                        <a:t>2,723</a:t>
+                        <a:t>13,538</a:t>
                       </a:r>
                     </a:p>
                   </a:txBody>
@@ -7448,7 +7448,7 @@
                             <a:srgbClr val="202124"/>
                           </a:solidFill>
                         </a:rPr>
-                        <a:t>316x faster</a:t>
+                        <a:t>1,571x faster</a:t>
                       </a:r>
                     </a:p>
                   </a:txBody>
@@ -7467,7 +7467,7 @@
                             <a:srgbClr val="202124"/>
                           </a:solidFill>
                         </a:rPr>
-                        <a:t>NVIDIA Orin AGX</a:t>
+                        <a:t>NVIDIA OFA on Orin (ds=2)</a:t>
                       </a:r>
                     </a:p>
                   </a:txBody>
@@ -7481,10 +7481,10 @@
                       <a:r>
                         <a:rPr sz="1100" b="1">
                           <a:solidFill>
-                            <a:srgbClr val="4C8BF5"/>
-                          </a:solidFill>
-                        </a:rPr>
-                        <a:t>GPU</a:t>
+                            <a:srgbClr val="7B4FD1"/>
+                          </a:solidFill>
+                        </a:rPr>
+                        <a:t>HW</a:t>
                       </a:r>
                     </a:p>
                   </a:txBody>
@@ -7501,7 +7501,7 @@
                             <a:srgbClr val="202124"/>
                           </a:solidFill>
                         </a:rPr>
-                        <a:t>72.80 ms</a:t>
+                        <a:t>14.90 ms</a:t>
                       </a:r>
                     </a:p>
                   </a:txBody>
@@ -7518,7 +7518,7 @@
                             <a:srgbClr val="202124"/>
                           </a:solidFill>
                         </a:rPr>
-                        <a:t>13.7</a:t>
+                        <a:t>67</a:t>
                       </a:r>
                     </a:p>
                   </a:txBody>
@@ -7535,7 +7535,7 @@
                             <a:srgbClr val="202124"/>
                           </a:solidFill>
                         </a:rPr>
-                        <a:t>1,688</a:t>
+                        <a:t>—</a:t>
                       </a:r>
                     </a:p>
                   </a:txBody>
@@ -7552,7 +7552,7 @@
                             <a:srgbClr val="202124"/>
                           </a:solidFill>
                         </a:rPr>
-                        <a:t>196x faster</a:t>
+                        <a:t>957x (time only)</a:t>
                       </a:r>
                     </a:p>
                   </a:txBody>
@@ -7571,7 +7571,7 @@
                             <a:srgbClr val="202124"/>
                           </a:solidFill>
                         </a:rPr>
-                        <a:t>Cortex-A78C x8 (6 threads)</a:t>
+                        <a:t>NVIDIA Thor</a:t>
                       </a:r>
                     </a:p>
                   </a:txBody>
@@ -7585,10 +7585,10 @@
                       <a:r>
                         <a:rPr sz="1100" b="1">
                           <a:solidFill>
-                            <a:srgbClr val="E8710A"/>
-                          </a:solidFill>
-                        </a:rPr>
-                        <a:t>CPU</a:t>
+                            <a:srgbClr val="4C8BF5"/>
+                          </a:solidFill>
+                        </a:rPr>
+                        <a:t>GPU</a:t>
                       </a:r>
                     </a:p>
                   </a:txBody>
@@ -7605,7 +7605,7 @@
                             <a:srgbClr val="202124"/>
                           </a:solidFill>
                         </a:rPr>
-                        <a:t>211.90 ms</a:t>
+                        <a:t>45.10 ms</a:t>
                       </a:r>
                     </a:p>
                   </a:txBody>
@@ -7622,7 +7622,7 @@
                             <a:srgbClr val="202124"/>
                           </a:solidFill>
                         </a:rPr>
-                        <a:t>4.72</a:t>
+                        <a:t>22.2</a:t>
                       </a:r>
                     </a:p>
                   </a:txBody>
@@ -7639,7 +7639,7 @@
                             <a:srgbClr val="202124"/>
                           </a:solidFill>
                         </a:rPr>
-                        <a:t>580</a:t>
+                        <a:t>2,723</a:t>
                       </a:r>
                     </a:p>
                   </a:txBody>
@@ -7656,7 +7656,7 @@
                             <a:srgbClr val="202124"/>
                           </a:solidFill>
                         </a:rPr>
-                        <a:t>67x faster</a:t>
+                        <a:t>316x faster</a:t>
                       </a:r>
                     </a:p>
                   </a:txBody>
@@ -7675,7 +7675,7 @@
                             <a:srgbClr val="202124"/>
                           </a:solidFill>
                         </a:rPr>
-                        <a:t>Cortex-A720 x8</a:t>
+                        <a:t>NVIDIA Orin AGX</a:t>
                       </a:r>
                     </a:p>
                   </a:txBody>
@@ -7689,10 +7689,10 @@
                       <a:r>
                         <a:rPr sz="1100" b="1">
                           <a:solidFill>
-                            <a:srgbClr val="E8710A"/>
-                          </a:solidFill>
-                        </a:rPr>
-                        <a:t>CPU</a:t>
+                            <a:srgbClr val="4C8BF5"/>
+                          </a:solidFill>
+                        </a:rPr>
+                        <a:t>GPU</a:t>
                       </a:r>
                     </a:p>
                   </a:txBody>
@@ -7709,7 +7709,7 @@
                             <a:srgbClr val="202124"/>
                           </a:solidFill>
                         </a:rPr>
-                        <a:t>238.30 ms</a:t>
+                        <a:t>72.80 ms</a:t>
                       </a:r>
                     </a:p>
                   </a:txBody>
@@ -7726,7 +7726,7 @@
                             <a:srgbClr val="202124"/>
                           </a:solidFill>
                         </a:rPr>
-                        <a:t>4.20</a:t>
+                        <a:t>13.7</a:t>
                       </a:r>
                     </a:p>
                   </a:txBody>
@@ -7743,7 +7743,7 @@
                             <a:srgbClr val="202124"/>
                           </a:solidFill>
                         </a:rPr>
-                        <a:t>516</a:t>
+                        <a:t>1,688</a:t>
                       </a:r>
                     </a:p>
                   </a:txBody>
@@ -7760,7 +7760,7 @@
                             <a:srgbClr val="202124"/>
                           </a:solidFill>
                         </a:rPr>
-                        <a:t>60x faster</a:t>
+                        <a:t>196x faster</a:t>
                       </a:r>
                     </a:p>
                   </a:txBody>
@@ -7779,7 +7779,7 @@
                             <a:srgbClr val="202124"/>
                           </a:solidFill>
                         </a:rPr>
-                        <a:t>Hexagon v73 NSP</a:t>
+                        <a:t>Cortex-A78C x8 (6 threads)</a:t>
                       </a:r>
                     </a:p>
                   </a:txBody>
@@ -7793,10 +7793,10 @@
                       <a:r>
                         <a:rPr sz="1100" b="1">
                           <a:solidFill>
-                            <a:srgbClr val="12B5A5"/>
-                          </a:solidFill>
-                        </a:rPr>
-                        <a:t>DSP</a:t>
+                            <a:srgbClr val="E8710A"/>
+                          </a:solidFill>
+                        </a:rPr>
+                        <a:t>CPU</a:t>
                       </a:r>
                     </a:p>
                   </a:txBody>
@@ -7813,7 +7813,7 @@
                             <a:srgbClr val="202124"/>
                           </a:solidFill>
                         </a:rPr>
-                        <a:t>276.30 ms</a:t>
+                        <a:t>211.90 ms</a:t>
                       </a:r>
                     </a:p>
                   </a:txBody>
@@ -7830,7 +7830,7 @@
                             <a:srgbClr val="202124"/>
                           </a:solidFill>
                         </a:rPr>
-                        <a:t>3.62</a:t>
+                        <a:t>4.72</a:t>
                       </a:r>
                     </a:p>
                   </a:txBody>
@@ -7847,7 +7847,7 @@
                             <a:srgbClr val="202124"/>
                           </a:solidFill>
                         </a:rPr>
-                        <a:t>445</a:t>
+                        <a:t>580</a:t>
                       </a:r>
                     </a:p>
                   </a:txBody>
@@ -7864,7 +7864,7 @@
                             <a:srgbClr val="202124"/>
                           </a:solidFill>
                         </a:rPr>
-                        <a:t>52x faster</a:t>
+                        <a:t>67x faster</a:t>
                       </a:r>
                     </a:p>
                   </a:txBody>
@@ -7883,7 +7883,7 @@
                             <a:srgbClr val="202124"/>
                           </a:solidFill>
                         </a:rPr>
-                        <a:t>Mali-G720 (10 CU)</a:t>
+                        <a:t>Cortex-A720 x8</a:t>
                       </a:r>
                     </a:p>
                   </a:txBody>
@@ -7897,10 +7897,10 @@
                       <a:r>
                         <a:rPr sz="1100" b="1">
                           <a:solidFill>
-                            <a:srgbClr val="4C8BF5"/>
-                          </a:solidFill>
-                        </a:rPr>
-                        <a:t>GPU</a:t>
+                            <a:srgbClr val="E8710A"/>
+                          </a:solidFill>
+                        </a:rPr>
+                        <a:t>CPU</a:t>
                       </a:r>
                     </a:p>
                   </a:txBody>
@@ -7917,7 +7917,7 @@
                             <a:srgbClr val="202124"/>
                           </a:solidFill>
                         </a:rPr>
-                        <a:t>380.00 ms</a:t>
+                        <a:t>238.30 ms</a:t>
                       </a:r>
                     </a:p>
                   </a:txBody>
@@ -7934,7 +7934,7 @@
                             <a:srgbClr val="202124"/>
                           </a:solidFill>
                         </a:rPr>
-                        <a:t>2.63</a:t>
+                        <a:t>4.20</a:t>
                       </a:r>
                     </a:p>
                   </a:txBody>
@@ -7951,7 +7951,7 @@
                             <a:srgbClr val="202124"/>
                           </a:solidFill>
                         </a:rPr>
-                        <a:t>323</a:t>
+                        <a:t>516</a:t>
                       </a:r>
                     </a:p>
                   </a:txBody>
@@ -7968,7 +7968,7 @@
                             <a:srgbClr val="202124"/>
                           </a:solidFill>
                         </a:rPr>
-                        <a:t>38x faster</a:t>
+                        <a:t>60x faster</a:t>
                       </a:r>
                     </a:p>
                   </a:txBody>
@@ -7987,7 +7987,7 @@
                             <a:srgbClr val="202124"/>
                           </a:solidFill>
                         </a:rPr>
-                        <a:t>Cortex-A78C x1</a:t>
+                        <a:t>Hexagon v73 NSP</a:t>
                       </a:r>
                     </a:p>
                   </a:txBody>
@@ -8001,10 +8001,10 @@
                       <a:r>
                         <a:rPr sz="1100" b="1">
                           <a:solidFill>
-                            <a:srgbClr val="E8710A"/>
-                          </a:solidFill>
-                        </a:rPr>
-                        <a:t>CPU</a:t>
+                            <a:srgbClr val="12B5A5"/>
+                          </a:solidFill>
+                        </a:rPr>
+                        <a:t>DSP</a:t>
                       </a:r>
                     </a:p>
                   </a:txBody>
@@ -8021,7 +8021,7 @@
                             <a:srgbClr val="202124"/>
                           </a:solidFill>
                         </a:rPr>
-                        <a:t>442.60 ms</a:t>
+                        <a:t>276.30 ms</a:t>
                       </a:r>
                     </a:p>
                   </a:txBody>
@@ -8038,7 +8038,7 @@
                             <a:srgbClr val="202124"/>
                           </a:solidFill>
                         </a:rPr>
-                        <a:t>2.26</a:t>
+                        <a:t>3.62</a:t>
                       </a:r>
                     </a:p>
                   </a:txBody>
@@ -8055,7 +8055,7 @@
                             <a:srgbClr val="202124"/>
                           </a:solidFill>
                         </a:rPr>
-                        <a:t>278</a:t>
+                        <a:t>445</a:t>
                       </a:r>
                     </a:p>
                   </a:txBody>
@@ -8072,7 +8072,7 @@
                             <a:srgbClr val="202124"/>
                           </a:solidFill>
                         </a:rPr>
-                        <a:t>32x faster</a:t>
+                        <a:t>52x faster</a:t>
                       </a:r>
                     </a:p>
                   </a:txBody>
@@ -8091,7 +8091,7 @@
                             <a:srgbClr val="202124"/>
                           </a:solidFill>
                         </a:rPr>
-                        <a:t>Cortex-A720 x1</a:t>
+                        <a:t>Mali-G720 (10 CU)</a:t>
                       </a:r>
                     </a:p>
                   </a:txBody>
@@ -8105,10 +8105,10 @@
                       <a:r>
                         <a:rPr sz="1100" b="1">
                           <a:solidFill>
-                            <a:srgbClr val="E8710A"/>
-                          </a:solidFill>
-                        </a:rPr>
-                        <a:t>CPU</a:t>
+                            <a:srgbClr val="4C8BF5"/>
+                          </a:solidFill>
+                        </a:rPr>
+                        <a:t>GPU</a:t>
                       </a:r>
                     </a:p>
                   </a:txBody>
@@ -8125,7 +8125,7 @@
                             <a:srgbClr val="202124"/>
                           </a:solidFill>
                         </a:rPr>
-                        <a:t>470.90 ms</a:t>
+                        <a:t>380.00 ms</a:t>
                       </a:r>
                     </a:p>
                   </a:txBody>
@@ -8142,7 +8142,7 @@
                             <a:srgbClr val="202124"/>
                           </a:solidFill>
                         </a:rPr>
-                        <a:t>2.12</a:t>
+                        <a:t>2.63</a:t>
                       </a:r>
                     </a:p>
                   </a:txBody>
@@ -8159,7 +8159,7 @@
                             <a:srgbClr val="202124"/>
                           </a:solidFill>
                         </a:rPr>
-                        <a:t>261</a:t>
+                        <a:t>323</a:t>
                       </a:r>
                     </a:p>
                   </a:txBody>
@@ -8176,7 +8176,7 @@
                             <a:srgbClr val="202124"/>
                           </a:solidFill>
                         </a:rPr>
-                        <a:t>30x faster</a:t>
+                        <a:t>38x faster</a:t>
                       </a:r>
                     </a:p>
                   </a:txBody>
@@ -8195,7 +8195,7 @@
                             <a:srgbClr val="202124"/>
                           </a:solidFill>
                         </a:rPr>
-                        <a:t>Cortex-A55 x6</a:t>
+                        <a:t>Cortex-A78C x1</a:t>
                       </a:r>
                     </a:p>
                   </a:txBody>
@@ -8229,7 +8229,7 @@
                             <a:srgbClr val="202124"/>
                           </a:solidFill>
                         </a:rPr>
-                        <a:t>640.10 ms</a:t>
+                        <a:t>442.60 ms</a:t>
                       </a:r>
                     </a:p>
                   </a:txBody>
@@ -8246,7 +8246,7 @@
                             <a:srgbClr val="202124"/>
                           </a:solidFill>
                         </a:rPr>
-                        <a:t>1.56</a:t>
+                        <a:t>2.26</a:t>
                       </a:r>
                     </a:p>
                   </a:txBody>
@@ -8263,7 +8263,7 @@
                             <a:srgbClr val="202124"/>
                           </a:solidFill>
                         </a:rPr>
-                        <a:t>192</a:t>
+                        <a:t>278</a:t>
                       </a:r>
                     </a:p>
                   </a:txBody>
@@ -8280,7 +8280,7 @@
                             <a:srgbClr val="202124"/>
                           </a:solidFill>
                         </a:rPr>
-                        <a:t>22x faster</a:t>
+                        <a:t>32x faster</a:t>
                       </a:r>
                     </a:p>
                   </a:txBody>
@@ -8299,7 +8299,7 @@
                             <a:srgbClr val="202124"/>
                           </a:solidFill>
                         </a:rPr>
-                        <a:t>Cortex-A55 x1</a:t>
+                        <a:t>Cortex-A720 x1</a:t>
                       </a:r>
                     </a:p>
                   </a:txBody>
@@ -8333,7 +8333,7 @@
                             <a:srgbClr val="202124"/>
                           </a:solidFill>
                         </a:rPr>
-                        <a:t>2,201.00 ms</a:t>
+                        <a:t>470.90 ms</a:t>
                       </a:r>
                     </a:p>
                   </a:txBody>
@@ -8350,7 +8350,7 @@
                             <a:srgbClr val="202124"/>
                           </a:solidFill>
                         </a:rPr>
-                        <a:t>0.45</a:t>
+                        <a:t>2.12</a:t>
                       </a:r>
                     </a:p>
                   </a:txBody>
@@ -8367,7 +8367,7 @@
                             <a:srgbClr val="202124"/>
                           </a:solidFill>
                         </a:rPr>
-                        <a:t>56</a:t>
+                        <a:t>261</a:t>
                       </a:r>
                     </a:p>
                   </a:txBody>
@@ -8384,7 +8384,7 @@
                             <a:srgbClr val="202124"/>
                           </a:solidFill>
                         </a:rPr>
-                        <a:t>6x faster</a:t>
+                        <a:t>30x faster</a:t>
                       </a:r>
                     </a:p>
                   </a:txBody>
@@ -8403,7 +8403,7 @@
                             <a:srgbClr val="202124"/>
                           </a:solidFill>
                         </a:rPr>
-                        <a:t>Mali-G310 (1 CU)</a:t>
+                        <a:t>Cortex-A55 x6</a:t>
                       </a:r>
                     </a:p>
                   </a:txBody>
@@ -8417,10 +8417,10 @@
                       <a:r>
                         <a:rPr sz="1100" b="1">
                           <a:solidFill>
-                            <a:srgbClr val="4C8BF5"/>
-                          </a:solidFill>
-                        </a:rPr>
-                        <a:t>GPU</a:t>
+                            <a:srgbClr val="E8710A"/>
+                          </a:solidFill>
+                        </a:rPr>
+                        <a:t>CPU</a:t>
                       </a:r>
                     </a:p>
                   </a:txBody>
@@ -8437,7 +8437,7 @@
                             <a:srgbClr val="202124"/>
                           </a:solidFill>
                         </a:rPr>
-                        <a:t>2,704.00 ms</a:t>
+                        <a:t>640.10 ms</a:t>
                       </a:r>
                     </a:p>
                   </a:txBody>
@@ -8454,7 +8454,7 @@
                             <a:srgbClr val="202124"/>
                           </a:solidFill>
                         </a:rPr>
-                        <a:t>0.37</a:t>
+                        <a:t>1.56</a:t>
                       </a:r>
                     </a:p>
                   </a:txBody>
@@ -8471,7 +8471,7 @@
                             <a:srgbClr val="202124"/>
                           </a:solidFill>
                         </a:rPr>
-                        <a:t>45</a:t>
+                        <a:t>192</a:t>
                       </a:r>
                     </a:p>
                   </a:txBody>
@@ -8488,7 +8488,7 @@
                             <a:srgbClr val="202124"/>
                           </a:solidFill>
                         </a:rPr>
-                        <a:t>5x faster</a:t>
+                        <a:t>22x faster</a:t>
                       </a:r>
                     </a:p>
                   </a:txBody>
@@ -8507,7 +8507,7 @@
                             <a:srgbClr val="202124"/>
                           </a:solidFill>
                         </a:rPr>
-                        <a:t>scalar reference</a:t>
+                        <a:t>Cortex-A55 x1</a:t>
                       </a:r>
                     </a:p>
                   </a:txBody>
@@ -8521,10 +8521,10 @@
                       <a:r>
                         <a:rPr sz="1100" b="1">
                           <a:solidFill>
-                            <a:srgbClr val="9AA0A6"/>
-                          </a:solidFill>
-                        </a:rPr>
-                        <a:t>REF</a:t>
+                            <a:srgbClr val="E8710A"/>
+                          </a:solidFill>
+                        </a:rPr>
+                        <a:t>CPU</a:t>
                       </a:r>
                     </a:p>
                   </a:txBody>
@@ -8541,7 +8541,7 @@
                             <a:srgbClr val="202124"/>
                           </a:solidFill>
                         </a:rPr>
-                        <a:t>14,265.00 ms</a:t>
+                        <a:t>2,201.00 ms</a:t>
                       </a:r>
                     </a:p>
                   </a:txBody>
@@ -8558,7 +8558,7 @@
                             <a:srgbClr val="202124"/>
                           </a:solidFill>
                         </a:rPr>
-                        <a:t>0.07</a:t>
+                        <a:t>0.45</a:t>
                       </a:r>
                     </a:p>
                   </a:txBody>
@@ -8575,7 +8575,7 @@
                             <a:srgbClr val="202124"/>
                           </a:solidFill>
                         </a:rPr>
-                        <a:t>8.6</a:t>
+                        <a:t>56</a:t>
                       </a:r>
                     </a:p>
                   </a:txBody>
@@ -8592,7 +8592,7 @@
                             <a:srgbClr val="202124"/>
                           </a:solidFill>
                         </a:rPr>
-                        <a:t>the floor (1x)</a:t>
+                        <a:t>6x faster</a:t>
                       </a:r>
                     </a:p>
                   </a:txBody>
@@ -8611,7 +8611,7 @@
                             <a:srgbClr val="202124"/>
                           </a:solidFill>
                         </a:rPr>
-                        <a:t>NVIDIA OFA on Thor (ds=2)</a:t>
+                        <a:t>Mali-G310 (1 CU)</a:t>
                       </a:r>
                     </a:p>
                   </a:txBody>
@@ -8625,10 +8625,10 @@
                       <a:r>
                         <a:rPr sz="1100" b="1">
                           <a:solidFill>
-                            <a:srgbClr val="7B4FD1"/>
-                          </a:solidFill>
-                        </a:rPr>
-                        <a:t>HW</a:t>
+                            <a:srgbClr val="4C8BF5"/>
+                          </a:solidFill>
+                        </a:rPr>
+                        <a:t>GPU</a:t>
                       </a:r>
                     </a:p>
                   </a:txBody>
@@ -8645,7 +8645,7 @@
                             <a:srgbClr val="202124"/>
                           </a:solidFill>
                         </a:rPr>
-                        <a:t>3.38 ms</a:t>
+                        <a:t>2,704.00 ms</a:t>
                       </a:r>
                     </a:p>
                   </a:txBody>
@@ -8662,7 +8662,7 @@
                             <a:srgbClr val="202124"/>
                           </a:solidFill>
                         </a:rPr>
-                        <a:t>296</a:t>
+                        <a:t>0.37</a:t>
                       </a:r>
                     </a:p>
                   </a:txBody>
@@ -8679,7 +8679,7 @@
                             <a:srgbClr val="202124"/>
                           </a:solidFill>
                         </a:rPr>
-                        <a:t>—</a:t>
+                        <a:t>45</a:t>
                       </a:r>
                     </a:p>
                   </a:txBody>
@@ -8696,7 +8696,7 @@
                             <a:srgbClr val="202124"/>
                           </a:solidFill>
                         </a:rPr>
-                        <a:t>own algorithm, matched geometry</a:t>
+                        <a:t>5x faster</a:t>
                       </a:r>
                     </a:p>
                   </a:txBody>
@@ -8715,7 +8715,7 @@
                             <a:srgbClr val="202124"/>
                           </a:solidFill>
                         </a:rPr>
-                        <a:t>NVIDIA OFA on Orin (ds=2)</a:t>
+                        <a:t>scalar reference</a:t>
                       </a:r>
                     </a:p>
                   </a:txBody>
@@ -8729,10 +8729,10 @@
                       <a:r>
                         <a:rPr sz="1100" b="1">
                           <a:solidFill>
-                            <a:srgbClr val="7B4FD1"/>
-                          </a:solidFill>
-                        </a:rPr>
-                        <a:t>HW</a:t>
+                            <a:srgbClr val="9AA0A6"/>
+                          </a:solidFill>
+                        </a:rPr>
+                        <a:t>REF</a:t>
                       </a:r>
                     </a:p>
                   </a:txBody>
@@ -8749,7 +8749,7 @@
                             <a:srgbClr val="202124"/>
                           </a:solidFill>
                         </a:rPr>
-                        <a:t>14.90 ms</a:t>
+                        <a:t>14,265.00 ms</a:t>
                       </a:r>
                     </a:p>
                   </a:txBody>
@@ -8766,7 +8766,7 @@
                             <a:srgbClr val="202124"/>
                           </a:solidFill>
                         </a:rPr>
-                        <a:t>67</a:t>
+                        <a:t>0.07</a:t>
                       </a:r>
                     </a:p>
                   </a:txBody>
@@ -8783,7 +8783,7 @@
                             <a:srgbClr val="202124"/>
                           </a:solidFill>
                         </a:rPr>
-                        <a:t>—</a:t>
+                        <a:t>8.6</a:t>
                       </a:r>
                     </a:p>
                   </a:txBody>
@@ -8800,7 +8800,7 @@
                             <a:srgbClr val="202124"/>
                           </a:solidFill>
                         </a:rPr>
-                        <a:t>own algorithm, matched geometry</a:t>
+                        <a:t>the floor (1x)</a:t>
                       </a:r>
                     </a:p>
                   </a:txBody>
@@ -9332,8 +9332,8 @@
         </p:nvSpPr>
         <p:spPr>
           <a:xfrm>
-            <a:off x="548640" y="1024128"/>
-            <a:ext cx="11155680" cy="548640"/>
+            <a:off x="548640" y="1005840"/>
+            <a:ext cx="11155680" cy="457200"/>
           </a:xfrm>
           <a:prstGeom prst="rect">
             <a:avLst/>
@@ -9354,7 +9354,7 @@
                 </a:solidFill>
                 <a:latin typeface="Calibri"/>
               </a:rPr>
-              <a:t>A and B differ in TWO ways at once - algorithm AND resolution - so their fps cannot be compared without compounding explanations. C is exactly B's algorithm on A's own 1920x1080 stereo pair (out 960x540). A-&gt;C isolates the algorithm; C-&gt;B isolates resolution. Golden 0f0961d623009df5, every row bit-exact.</a:t>
+              <a:t>C is exactly B's algorithm on A's own 1920x1080 stereo pair (out 960x540): A-&gt;C isolates the ALGORITHM, C-&gt;B isolates RESOLUTION - one knob each. Golden 0f0961d623009df5, every software row bit-exact.</a:t>
             </a:r>
           </a:p>
         </p:txBody>
@@ -9368,8 +9368,8 @@
           <p:nvPr/>
         </p:nvGraphicFramePr>
         <p:xfrm>
-          <a:off x="548640" y="1828800"/>
-          <a:ext cx="11064240" cy="3072384"/>
+          <a:off x="548640" y="1517904"/>
+          <a:ext cx="11064240" cy="3511296"/>
         </p:xfrm>
         <a:graphic>
           <a:graphicData uri="http://schemas.openxmlformats.org/drawingml/2006/table">
@@ -9503,6 +9503,93 @@
                             <a:srgbClr val="202124"/>
                           </a:solidFill>
                         </a:rPr>
+                        <a:t>NVIDIA OFA on Thor (ds=2)</a:t>
+                      </a:r>
+                    </a:p>
+                  </a:txBody>
+                  <a:tcPr/>
+                </a:tc>
+                <a:tc>
+                  <a:txBody>
+                    <a:bodyPr/>
+                    <a:lstStyle/>
+                    <a:p>
+                      <a:r>
+                        <a:rPr sz="1050" b="1">
+                          <a:solidFill>
+                            <a:srgbClr val="7B4FD1"/>
+                          </a:solidFill>
+                        </a:rPr>
+                        <a:t>HW</a:t>
+                      </a:r>
+                    </a:p>
+                  </a:txBody>
+                  <a:tcPr/>
+                </a:tc>
+                <a:tc>
+                  <a:txBody>
+                    <a:bodyPr/>
+                    <a:lstStyle/>
+                    <a:p>
+                      <a:r>
+                        <a:rPr sz="1050" b="0">
+                          <a:solidFill>
+                            <a:srgbClr val="202124"/>
+                          </a:solidFill>
+                        </a:rPr>
+                        <a:t>4.1 ms</a:t>
+                      </a:r>
+                    </a:p>
+                  </a:txBody>
+                  <a:tcPr/>
+                </a:tc>
+                <a:tc>
+                  <a:txBody>
+                    <a:bodyPr/>
+                    <a:lstStyle/>
+                    <a:p>
+                      <a:r>
+                        <a:rPr sz="1050" b="1">
+                          <a:solidFill>
+                            <a:srgbClr val="202124"/>
+                          </a:solidFill>
+                        </a:rPr>
+                        <a:t>—</a:t>
+                      </a:r>
+                    </a:p>
+                  </a:txBody>
+                  <a:tcPr/>
+                </a:tc>
+                <a:tc>
+                  <a:txBody>
+                    <a:bodyPr/>
+                    <a:lstStyle/>
+                    <a:p>
+                      <a:r>
+                        <a:rPr sz="1050" b="0">
+                          <a:solidFill>
+                            <a:srgbClr val="202124"/>
+                          </a:solidFill>
+                        </a:rPr>
+                        <a:t>1.21  (time only — own algorithm)</a:t>
+                      </a:r>
+                    </a:p>
+                  </a:txBody>
+                  <a:tcPr/>
+                </a:tc>
+              </a:tr>
+              <a:tr h="219456">
+                <a:tc>
+                  <a:txBody>
+                    <a:bodyPr/>
+                    <a:lstStyle/>
+                    <a:p>
+                      <a:r>
+                        <a:rPr sz="1050" b="1">
+                          <a:solidFill>
+                            <a:srgbClr val="202124"/>
+                          </a:solidFill>
+                        </a:rPr>
                         <a:t>NVIDIA RTX 5090</a:t>
                       </a:r>
                     </a:p>
@@ -9572,6 +9659,93 @@
                           </a:solidFill>
                         </a:rPr>
                         <a:t>1.32</a:t>
+                      </a:r>
+                    </a:p>
+                  </a:txBody>
+                  <a:tcPr/>
+                </a:tc>
+              </a:tr>
+              <a:tr h="219456">
+                <a:tc>
+                  <a:txBody>
+                    <a:bodyPr/>
+                    <a:lstStyle/>
+                    <a:p>
+                      <a:r>
+                        <a:rPr sz="1050" b="1">
+                          <a:solidFill>
+                            <a:srgbClr val="202124"/>
+                          </a:solidFill>
+                        </a:rPr>
+                        <a:t>NVIDIA OFA on Orin (ds=2)</a:t>
+                      </a:r>
+                    </a:p>
+                  </a:txBody>
+                  <a:tcPr/>
+                </a:tc>
+                <a:tc>
+                  <a:txBody>
+                    <a:bodyPr/>
+                    <a:lstStyle/>
+                    <a:p>
+                      <a:r>
+                        <a:rPr sz="1050" b="1">
+                          <a:solidFill>
+                            <a:srgbClr val="7B4FD1"/>
+                          </a:solidFill>
+                        </a:rPr>
+                        <a:t>HW</a:t>
+                      </a:r>
+                    </a:p>
+                  </a:txBody>
+                  <a:tcPr/>
+                </a:tc>
+                <a:tc>
+                  <a:txBody>
+                    <a:bodyPr/>
+                    <a:lstStyle/>
+                    <a:p>
+                      <a:r>
+                        <a:rPr sz="1050" b="0">
+                          <a:solidFill>
+                            <a:srgbClr val="202124"/>
+                          </a:solidFill>
+                        </a:rPr>
+                        <a:t>19.5 ms</a:t>
+                      </a:r>
+                    </a:p>
+                  </a:txBody>
+                  <a:tcPr/>
+                </a:tc>
+                <a:tc>
+                  <a:txBody>
+                    <a:bodyPr/>
+                    <a:lstStyle/>
+                    <a:p>
+                      <a:r>
+                        <a:rPr sz="1050" b="1">
+                          <a:solidFill>
+                            <a:srgbClr val="202124"/>
+                          </a:solidFill>
+                        </a:rPr>
+                        <a:t>—</a:t>
+                      </a:r>
+                    </a:p>
+                  </a:txBody>
+                  <a:tcPr/>
+                </a:tc>
+                <a:tc>
+                  <a:txBody>
+                    <a:bodyPr/>
+                    <a:lstStyle/>
+                    <a:p>
+                      <a:r>
+                        <a:rPr sz="1050" b="0">
+                          <a:solidFill>
+                            <a:srgbClr val="202124"/>
+                          </a:solidFill>
+                        </a:rPr>
+                        <a:t>1.31  (time only — own algorithm)</a:t>
                       </a:r>
                     </a:p>
                   </a:txBody>
@@ -10634,23 +10808,23 @@
         </p:nvSpPr>
         <p:spPr>
           <a:xfrm>
-            <a:off x="548640" y="5349240"/>
-            <a:ext cx="11155680" cy="731520"/>
-          </a:xfrm>
-          <a:prstGeom prst="rect">
-            <a:avLst/>
-          </a:prstGeom>
-          <a:noFill/>
-        </p:spPr>
-        <p:txBody>
-          <a:bodyPr wrap="square">
-            <a:spAutoFit/>
-          </a:bodyPr>
-          <a:lstStyle/>
-          <a:p>
-            <a:pPr algn="l"/>
-            <a:r>
-              <a:rPr sz="1200" b="1">
+            <a:off x="548640" y="5440680"/>
+            <a:ext cx="11155680" cy="640080"/>
+          </a:xfrm>
+          <a:prstGeom prst="rect">
+            <a:avLst/>
+          </a:prstGeom>
+          <a:noFill/>
+        </p:spPr>
+        <p:txBody>
+          <a:bodyPr wrap="square">
+            <a:spAutoFit/>
+          </a:bodyPr>
+          <a:lstStyle/>
+          <a:p>
+            <a:pPr algn="l"/>
+            <a:r>
+              <a:rPr sz="1150" b="1">
                 <a:solidFill>
                   <a:srgbClr val="202124"/>
                 </a:solidFill>
@@ -10669,23 +10843,23 @@
         </p:nvSpPr>
         <p:spPr>
           <a:xfrm>
-            <a:off x="548640" y="6053328"/>
-            <a:ext cx="11155680" cy="548640"/>
-          </a:xfrm>
-          <a:prstGeom prst="rect">
-            <a:avLst/>
-          </a:prstGeom>
-          <a:noFill/>
-        </p:spPr>
-        <p:txBody>
-          <a:bodyPr wrap="square">
-            <a:spAutoFit/>
-          </a:bodyPr>
-          <a:lstStyle/>
-          <a:p>
-            <a:pPr algn="l"/>
-            <a:r>
-              <a:rPr sz="1100" b="0">
+            <a:off x="548640" y="6108192"/>
+            <a:ext cx="11155680" cy="457200"/>
+          </a:xfrm>
+          <a:prstGeom prst="rect">
+            <a:avLst/>
+          </a:prstGeom>
+          <a:noFill/>
+        </p:spPr>
+        <p:txBody>
+          <a:bodyPr wrap="square">
+            <a:spAutoFit/>
+          </a:bodyPr>
+          <a:lstStyle/>
+          <a:p>
+            <a:pPr algn="l"/>
+            <a:r>
+              <a:rPr sz="1050" b="0">
                 <a:solidFill>
                   <a:srgbClr val="202124"/>
                 </a:solidFill>
@@ -10704,8 +10878,8 @@
         </p:nvSpPr>
         <p:spPr>
           <a:xfrm>
-            <a:off x="548640" y="6528816"/>
-            <a:ext cx="11155680" cy="329184"/>
+            <a:off x="548640" y="6583680"/>
+            <a:ext cx="11155680" cy="274320"/>
           </a:xfrm>
           <a:prstGeom prst="rect">
             <a:avLst/>
@@ -10726,7 +10900,7 @@
                 </a:solidFill>
                 <a:latin typeface="Calibri"/>
               </a:rPr>
-              <a:t>A78C and NSP cells are medians of repeated invocations on that bimodal board (NSP: 5 invocations, 1.7% spread, unmodified Config B kernels). OFA engines at matched geometry, running their OWN algorithm (not gated): Thor 4.08 ms, Orin 19.51 ms.</a:t>
+              <a:t>A78C/NSP cells: medians of repeated invocations (bimodal board). OFA rows: matched geometry, OWN algorithm at D=128 — not bit-exact, MDE/s(work) undefined.</a:t>
             </a:r>
           </a:p>
         </p:txBody>

</xml_diff>

<commit_message>
Configuration C tables: identical columns and types to Configuration B
Per Kyle: the C tables (README and deck slide) now mirror B's exactly --
target / ms / fps / MDE/s(work) in the README, plus class and vs-scalar on
the deck slide, same formats, same OFA treatment, multipliers against C's own
scalar floor (18,020 ms). The xB column moves to prose: the C/B ratios
cluster at the 1.35x pixel prediction with the A720-cluster 1.01x exception
called out where the finding is discussed.
</commit_message>
<xml_diff>
--- a/docs/sgm-results.pptx
+++ b/docs/sgm-results.pptx
@@ -9369,7 +9369,7 @@
         </p:nvGraphicFramePr>
         <p:xfrm>
           <a:off x="548640" y="1517904"/>
-          <a:ext cx="11064240" cy="3511296"/>
+          <a:ext cx="11064240" cy="3657600"/>
         </p:xfrm>
         <a:graphic>
           <a:graphicData uri="http://schemas.openxmlformats.org/drawingml/2006/table">
@@ -9378,13 +9378,14 @@
                 <a:tableStyleId>{5C22544A-7EE6-4342-B048-85BDC9FD1C3A}</a:tableStyleId>
               </a:tblPr>
               <a:tblGrid>
-                <a:gridCol w="3474720"/>
+                <a:gridCol w="3291840"/>
                 <a:gridCol w="914400"/>
-                <a:gridCol w="1828800"/>
-                <a:gridCol w="2011680"/>
-                <a:gridCol w="2834640"/>
+                <a:gridCol w="1737360"/>
+                <a:gridCol w="1188720"/>
+                <a:gridCol w="1737360"/>
+                <a:gridCol w="2194560"/>
               </a:tblGrid>
-              <a:tr h="219456">
+              <a:tr h="228600">
                 <a:tc>
                   <a:txBody>
                     <a:bodyPr/>
@@ -9459,7 +9460,7 @@
                             <a:srgbClr val="FFFFFF"/>
                           </a:solidFill>
                         </a:rPr>
-                        <a:t>MDE/s (work)</a:t>
+                        <a:t>fps</a:t>
                       </a:r>
                     </a:p>
                   </a:txBody>
@@ -9480,7 +9481,7 @@
                             <a:srgbClr val="FFFFFF"/>
                           </a:solidFill>
                         </a:rPr>
-                        <a:t>xB  (pixels predict 1.35x)</a:t>
+                        <a:t>MDE/s (work)</a:t>
                       </a:r>
                     </a:p>
                   </a:txBody>
@@ -9490,8 +9491,46 @@
                     </a:solidFill>
                   </a:tcPr>
                 </a:tc>
+                <a:tc>
+                  <a:txBody>
+                    <a:bodyPr/>
+                    <a:lstStyle/>
+                    <a:p>
+                      <a:r>
+                        <a:rPr sz="1100" b="1">
+                          <a:solidFill>
+                            <a:srgbClr val="FFFFFF"/>
+                          </a:solidFill>
+                        </a:rPr>
+                        <a:t>vs scalar reference</a:t>
+                      </a:r>
+                    </a:p>
+                  </a:txBody>
+                  <a:tcPr>
+                    <a:solidFill>
+                      <a:srgbClr val="202124"/>
+                    </a:solidFill>
+                  </a:tcPr>
+                </a:tc>
               </a:tr>
-              <a:tr h="219456">
+              <a:tr h="228600">
+                <a:tc>
+                  <a:txBody>
+                    <a:bodyPr/>
+                    <a:lstStyle/>
+                    <a:p>
+                      <a:r>
+                        <a:rPr sz="1050" b="0">
+                          <a:solidFill>
+                            <a:srgbClr val="202124"/>
+                          </a:solidFill>
+                        </a:rPr>
+                        <a:t>NVIDIA OFA on Thor (ds=2)</a:t>
+                      </a:r>
+                    </a:p>
+                  </a:txBody>
+                  <a:tcPr/>
+                </a:tc>
                 <a:tc>
                   <a:txBody>
                     <a:bodyPr/>
@@ -9500,15 +9539,85 @@
                       <a:r>
                         <a:rPr sz="1050" b="1">
                           <a:solidFill>
-                            <a:srgbClr val="202124"/>
-                          </a:solidFill>
-                        </a:rPr>
-                        <a:t>NVIDIA OFA on Thor (ds=2)</a:t>
-                      </a:r>
-                    </a:p>
-                  </a:txBody>
-                  <a:tcPr/>
-                </a:tc>
+                            <a:srgbClr val="7B4FD1"/>
+                          </a:solidFill>
+                        </a:rPr>
+                        <a:t>HW</a:t>
+                      </a:r>
+                    </a:p>
+                  </a:txBody>
+                  <a:tcPr/>
+                </a:tc>
+                <a:tc>
+                  <a:txBody>
+                    <a:bodyPr/>
+                    <a:lstStyle/>
+                    <a:p>
+                      <a:r>
+                        <a:rPr sz="1050" b="0">
+                          <a:solidFill>
+                            <a:srgbClr val="202124"/>
+                          </a:solidFill>
+                        </a:rPr>
+                        <a:t>4.08 ms</a:t>
+                      </a:r>
+                    </a:p>
+                  </a:txBody>
+                  <a:tcPr/>
+                </a:tc>
+                <a:tc>
+                  <a:txBody>
+                    <a:bodyPr/>
+                    <a:lstStyle/>
+                    <a:p>
+                      <a:r>
+                        <a:rPr sz="1050" b="0">
+                          <a:solidFill>
+                            <a:srgbClr val="202124"/>
+                          </a:solidFill>
+                        </a:rPr>
+                        <a:t>245</a:t>
+                      </a:r>
+                    </a:p>
+                  </a:txBody>
+                  <a:tcPr/>
+                </a:tc>
+                <a:tc>
+                  <a:txBody>
+                    <a:bodyPr/>
+                    <a:lstStyle/>
+                    <a:p>
+                      <a:r>
+                        <a:rPr sz="1050" b="0">
+                          <a:solidFill>
+                            <a:srgbClr val="202124"/>
+                          </a:solidFill>
+                        </a:rPr>
+                        <a:t>—</a:t>
+                      </a:r>
+                    </a:p>
+                  </a:txBody>
+                  <a:tcPr/>
+                </a:tc>
+                <a:tc>
+                  <a:txBody>
+                    <a:bodyPr/>
+                    <a:lstStyle/>
+                    <a:p>
+                      <a:r>
+                        <a:rPr sz="1050" b="0">
+                          <a:solidFill>
+                            <a:srgbClr val="202124"/>
+                          </a:solidFill>
+                        </a:rPr>
+                        <a:t>4,417x (time only)</a:t>
+                      </a:r>
+                    </a:p>
+                  </a:txBody>
+                  <a:tcPr/>
+                </a:tc>
+              </a:tr>
+              <a:tr h="228600">
                 <a:tc>
                   <a:txBody>
                     <a:bodyPr/>
@@ -9517,6 +9626,127 @@
                       <a:r>
                         <a:rPr sz="1050" b="1">
                           <a:solidFill>
+                            <a:srgbClr val="202124"/>
+                          </a:solidFill>
+                        </a:rPr>
+                        <a:t>NVIDIA RTX 5090</a:t>
+                      </a:r>
+                    </a:p>
+                  </a:txBody>
+                  <a:tcPr/>
+                </a:tc>
+                <a:tc>
+                  <a:txBody>
+                    <a:bodyPr/>
+                    <a:lstStyle/>
+                    <a:p>
+                      <a:r>
+                        <a:rPr sz="1050" b="1">
+                          <a:solidFill>
+                            <a:srgbClr val="4C8BF5"/>
+                          </a:solidFill>
+                        </a:rPr>
+                        <a:t>GPU</a:t>
+                      </a:r>
+                    </a:p>
+                  </a:txBody>
+                  <a:tcPr/>
+                </a:tc>
+                <a:tc>
+                  <a:txBody>
+                    <a:bodyPr/>
+                    <a:lstStyle/>
+                    <a:p>
+                      <a:r>
+                        <a:rPr sz="1050" b="0">
+                          <a:solidFill>
+                            <a:srgbClr val="202124"/>
+                          </a:solidFill>
+                        </a:rPr>
+                        <a:t>11.96 ms</a:t>
+                      </a:r>
+                    </a:p>
+                  </a:txBody>
+                  <a:tcPr/>
+                </a:tc>
+                <a:tc>
+                  <a:txBody>
+                    <a:bodyPr/>
+                    <a:lstStyle/>
+                    <a:p>
+                      <a:r>
+                        <a:rPr sz="1050" b="0">
+                          <a:solidFill>
+                            <a:srgbClr val="202124"/>
+                          </a:solidFill>
+                        </a:rPr>
+                        <a:t>83.6</a:t>
+                      </a:r>
+                    </a:p>
+                  </a:txBody>
+                  <a:tcPr/>
+                </a:tc>
+                <a:tc>
+                  <a:txBody>
+                    <a:bodyPr/>
+                    <a:lstStyle/>
+                    <a:p>
+                      <a:r>
+                        <a:rPr sz="1050" b="1">
+                          <a:solidFill>
+                            <a:srgbClr val="202124"/>
+                          </a:solidFill>
+                        </a:rPr>
+                        <a:t>13,870</a:t>
+                      </a:r>
+                    </a:p>
+                  </a:txBody>
+                  <a:tcPr/>
+                </a:tc>
+                <a:tc>
+                  <a:txBody>
+                    <a:bodyPr/>
+                    <a:lstStyle/>
+                    <a:p>
+                      <a:r>
+                        <a:rPr sz="1050" b="0">
+                          <a:solidFill>
+                            <a:srgbClr val="202124"/>
+                          </a:solidFill>
+                        </a:rPr>
+                        <a:t>1,507x faster</a:t>
+                      </a:r>
+                    </a:p>
+                  </a:txBody>
+                  <a:tcPr/>
+                </a:tc>
+              </a:tr>
+              <a:tr h="228600">
+                <a:tc>
+                  <a:txBody>
+                    <a:bodyPr/>
+                    <a:lstStyle/>
+                    <a:p>
+                      <a:r>
+                        <a:rPr sz="1050" b="0">
+                          <a:solidFill>
+                            <a:srgbClr val="202124"/>
+                          </a:solidFill>
+                        </a:rPr>
+                        <a:t>NVIDIA OFA on Orin (ds=2)</a:t>
+                      </a:r>
+                    </a:p>
+                  </a:txBody>
+                  <a:tcPr/>
+                </a:tc>
+                <a:tc>
+                  <a:txBody>
+                    <a:bodyPr/>
+                    <a:lstStyle/>
+                    <a:p>
+                      <a:r>
+                        <a:rPr sz="1050" b="1">
+                          <a:solidFill>
                             <a:srgbClr val="7B4FD1"/>
                           </a:solidFill>
                         </a:rPr>
@@ -9537,12 +9767,65 @@
                             <a:srgbClr val="202124"/>
                           </a:solidFill>
                         </a:rPr>
-                        <a:t>4.1 ms</a:t>
-                      </a:r>
-                    </a:p>
-                  </a:txBody>
-                  <a:tcPr/>
-                </a:tc>
+                        <a:t>19.51 ms</a:t>
+                      </a:r>
+                    </a:p>
+                  </a:txBody>
+                  <a:tcPr/>
+                </a:tc>
+                <a:tc>
+                  <a:txBody>
+                    <a:bodyPr/>
+                    <a:lstStyle/>
+                    <a:p>
+                      <a:r>
+                        <a:rPr sz="1050" b="0">
+                          <a:solidFill>
+                            <a:srgbClr val="202124"/>
+                          </a:solidFill>
+                        </a:rPr>
+                        <a:t>51</a:t>
+                      </a:r>
+                    </a:p>
+                  </a:txBody>
+                  <a:tcPr/>
+                </a:tc>
+                <a:tc>
+                  <a:txBody>
+                    <a:bodyPr/>
+                    <a:lstStyle/>
+                    <a:p>
+                      <a:r>
+                        <a:rPr sz="1050" b="0">
+                          <a:solidFill>
+                            <a:srgbClr val="202124"/>
+                          </a:solidFill>
+                        </a:rPr>
+                        <a:t>—</a:t>
+                      </a:r>
+                    </a:p>
+                  </a:txBody>
+                  <a:tcPr/>
+                </a:tc>
+                <a:tc>
+                  <a:txBody>
+                    <a:bodyPr/>
+                    <a:lstStyle/>
+                    <a:p>
+                      <a:r>
+                        <a:rPr sz="1050" b="0">
+                          <a:solidFill>
+                            <a:srgbClr val="202124"/>
+                          </a:solidFill>
+                        </a:rPr>
+                        <a:t>924x (time only)</a:t>
+                      </a:r>
+                    </a:p>
+                  </a:txBody>
+                  <a:tcPr/>
+                </a:tc>
+              </a:tr>
+              <a:tr h="228600">
                 <a:tc>
                   <a:txBody>
                     <a:bodyPr/>
@@ -9554,7 +9837,24 @@
                             <a:srgbClr val="202124"/>
                           </a:solidFill>
                         </a:rPr>
-                        <a:t>—</a:t>
+                        <a:t>NVIDIA Thor</a:t>
+                      </a:r>
+                    </a:p>
+                  </a:txBody>
+                  <a:tcPr/>
+                </a:tc>
+                <a:tc>
+                  <a:txBody>
+                    <a:bodyPr/>
+                    <a:lstStyle/>
+                    <a:p>
+                      <a:r>
+                        <a:rPr sz="1050" b="1">
+                          <a:solidFill>
+                            <a:srgbClr val="4C8BF5"/>
+                          </a:solidFill>
+                        </a:rPr>
+                        <a:t>GPU</a:t>
                       </a:r>
                     </a:p>
                   </a:txBody>
@@ -9571,14 +9871,65 @@
                             <a:srgbClr val="202124"/>
                           </a:solidFill>
                         </a:rPr>
-                        <a:t>1.21  (time only — own algorithm)</a:t>
+                        <a:t>56.70 ms</a:t>
+                      </a:r>
+                    </a:p>
+                  </a:txBody>
+                  <a:tcPr/>
+                </a:tc>
+                <a:tc>
+                  <a:txBody>
+                    <a:bodyPr/>
+                    <a:lstStyle/>
+                    <a:p>
+                      <a:r>
+                        <a:rPr sz="1050" b="0">
+                          <a:solidFill>
+                            <a:srgbClr val="202124"/>
+                          </a:solidFill>
+                        </a:rPr>
+                        <a:t>17.6</a:t>
+                      </a:r>
+                    </a:p>
+                  </a:txBody>
+                  <a:tcPr/>
+                </a:tc>
+                <a:tc>
+                  <a:txBody>
+                    <a:bodyPr/>
+                    <a:lstStyle/>
+                    <a:p>
+                      <a:r>
+                        <a:rPr sz="1050" b="1">
+                          <a:solidFill>
+                            <a:srgbClr val="202124"/>
+                          </a:solidFill>
+                        </a:rPr>
+                        <a:t>2,928</a:t>
+                      </a:r>
+                    </a:p>
+                  </a:txBody>
+                  <a:tcPr/>
+                </a:tc>
+                <a:tc>
+                  <a:txBody>
+                    <a:bodyPr/>
+                    <a:lstStyle/>
+                    <a:p>
+                      <a:r>
+                        <a:rPr sz="1050" b="0">
+                          <a:solidFill>
+                            <a:srgbClr val="202124"/>
+                          </a:solidFill>
+                        </a:rPr>
+                        <a:t>318x faster</a:t>
                       </a:r>
                     </a:p>
                   </a:txBody>
                   <a:tcPr/>
                 </a:tc>
               </a:tr>
-              <a:tr h="219456">
+              <a:tr h="228600">
                 <a:tc>
                   <a:txBody>
                     <a:bodyPr/>
@@ -9590,7 +9941,7 @@
                             <a:srgbClr val="202124"/>
                           </a:solidFill>
                         </a:rPr>
-                        <a:t>NVIDIA RTX 5090</a:t>
+                        <a:t>NVIDIA Orin AGX</a:t>
                       </a:r>
                     </a:p>
                   </a:txBody>
@@ -9624,7 +9975,24 @@
                             <a:srgbClr val="202124"/>
                           </a:solidFill>
                         </a:rPr>
-                        <a:t>12.0 ms</a:t>
+                        <a:t>96.90 ms</a:t>
+                      </a:r>
+                    </a:p>
+                  </a:txBody>
+                  <a:tcPr/>
+                </a:tc>
+                <a:tc>
+                  <a:txBody>
+                    <a:bodyPr/>
+                    <a:lstStyle/>
+                    <a:p>
+                      <a:r>
+                        <a:rPr sz="1050" b="0">
+                          <a:solidFill>
+                            <a:srgbClr val="202124"/>
+                          </a:solidFill>
+                        </a:rPr>
+                        <a:t>10.3</a:t>
                       </a:r>
                     </a:p>
                   </a:txBody>
@@ -9641,7 +10009,7 @@
                             <a:srgbClr val="202124"/>
                           </a:solidFill>
                         </a:rPr>
-                        <a:t>13,870</a:t>
+                        <a:t>1,711</a:t>
                       </a:r>
                     </a:p>
                   </a:txBody>
@@ -9658,14 +10026,14 @@
                             <a:srgbClr val="202124"/>
                           </a:solidFill>
                         </a:rPr>
-                        <a:t>1.32</a:t>
+                        <a:t>186x faster</a:t>
                       </a:r>
                     </a:p>
                   </a:txBody>
                   <a:tcPr/>
                 </a:tc>
               </a:tr>
-              <a:tr h="219456">
+              <a:tr h="228600">
                 <a:tc>
                   <a:txBody>
                     <a:bodyPr/>
@@ -9677,7 +10045,7 @@
                             <a:srgbClr val="202124"/>
                           </a:solidFill>
                         </a:rPr>
-                        <a:t>NVIDIA OFA on Orin (ds=2)</a:t>
+                        <a:t>Cortex-A720 x8</a:t>
                       </a:r>
                     </a:p>
                   </a:txBody>
@@ -9691,10 +10059,10 @@
                       <a:r>
                         <a:rPr sz="1050" b="1">
                           <a:solidFill>
-                            <a:srgbClr val="7B4FD1"/>
-                          </a:solidFill>
-                        </a:rPr>
-                        <a:t>HW</a:t>
+                            <a:srgbClr val="E8710A"/>
+                          </a:solidFill>
+                        </a:rPr>
+                        <a:t>CPU</a:t>
                       </a:r>
                     </a:p>
                   </a:txBody>
@@ -9711,7 +10079,24 @@
                             <a:srgbClr val="202124"/>
                           </a:solidFill>
                         </a:rPr>
-                        <a:t>19.5 ms</a:t>
+                        <a:t>239.60 ms</a:t>
+                      </a:r>
+                    </a:p>
+                  </a:txBody>
+                  <a:tcPr/>
+                </a:tc>
+                <a:tc>
+                  <a:txBody>
+                    <a:bodyPr/>
+                    <a:lstStyle/>
+                    <a:p>
+                      <a:r>
+                        <a:rPr sz="1050" b="0">
+                          <a:solidFill>
+                            <a:srgbClr val="202124"/>
+                          </a:solidFill>
+                        </a:rPr>
+                        <a:t>4.17</a:t>
                       </a:r>
                     </a:p>
                   </a:txBody>
@@ -9728,7 +10113,7 @@
                             <a:srgbClr val="202124"/>
                           </a:solidFill>
                         </a:rPr>
-                        <a:t>—</a:t>
+                        <a:t>692</a:t>
                       </a:r>
                     </a:p>
                   </a:txBody>
@@ -9745,14 +10130,14 @@
                             <a:srgbClr val="202124"/>
                           </a:solidFill>
                         </a:rPr>
-                        <a:t>1.31  (time only — own algorithm)</a:t>
+                        <a:t>75x faster</a:t>
                       </a:r>
                     </a:p>
                   </a:txBody>
                   <a:tcPr/>
                 </a:tc>
               </a:tr>
-              <a:tr h="219456">
+              <a:tr h="228600">
                 <a:tc>
                   <a:txBody>
                     <a:bodyPr/>
@@ -9764,7 +10149,7 @@
                             <a:srgbClr val="202124"/>
                           </a:solidFill>
                         </a:rPr>
-                        <a:t>NVIDIA Thor</a:t>
+                        <a:t>Cortex-A78C x8 (6 threads)</a:t>
                       </a:r>
                     </a:p>
                   </a:txBody>
@@ -9778,6 +10163,214 @@
                       <a:r>
                         <a:rPr sz="1050" b="1">
                           <a:solidFill>
+                            <a:srgbClr val="E8710A"/>
+                          </a:solidFill>
+                        </a:rPr>
+                        <a:t>CPU</a:t>
+                      </a:r>
+                    </a:p>
+                  </a:txBody>
+                  <a:tcPr/>
+                </a:tc>
+                <a:tc>
+                  <a:txBody>
+                    <a:bodyPr/>
+                    <a:lstStyle/>
+                    <a:p>
+                      <a:r>
+                        <a:rPr sz="1050" b="0">
+                          <a:solidFill>
+                            <a:srgbClr val="202124"/>
+                          </a:solidFill>
+                        </a:rPr>
+                        <a:t>291.80 ms</a:t>
+                      </a:r>
+                    </a:p>
+                  </a:txBody>
+                  <a:tcPr/>
+                </a:tc>
+                <a:tc>
+                  <a:txBody>
+                    <a:bodyPr/>
+                    <a:lstStyle/>
+                    <a:p>
+                      <a:r>
+                        <a:rPr sz="1050" b="0">
+                          <a:solidFill>
+                            <a:srgbClr val="202124"/>
+                          </a:solidFill>
+                        </a:rPr>
+                        <a:t>3.43</a:t>
+                      </a:r>
+                    </a:p>
+                  </a:txBody>
+                  <a:tcPr/>
+                </a:tc>
+                <a:tc>
+                  <a:txBody>
+                    <a:bodyPr/>
+                    <a:lstStyle/>
+                    <a:p>
+                      <a:r>
+                        <a:rPr sz="1050" b="1">
+                          <a:solidFill>
+                            <a:srgbClr val="202124"/>
+                          </a:solidFill>
+                        </a:rPr>
+                        <a:t>569</a:t>
+                      </a:r>
+                    </a:p>
+                  </a:txBody>
+                  <a:tcPr/>
+                </a:tc>
+                <a:tc>
+                  <a:txBody>
+                    <a:bodyPr/>
+                    <a:lstStyle/>
+                    <a:p>
+                      <a:r>
+                        <a:rPr sz="1050" b="0">
+                          <a:solidFill>
+                            <a:srgbClr val="202124"/>
+                          </a:solidFill>
+                        </a:rPr>
+                        <a:t>62x faster</a:t>
+                      </a:r>
+                    </a:p>
+                  </a:txBody>
+                  <a:tcPr/>
+                </a:tc>
+              </a:tr>
+              <a:tr h="228600">
+                <a:tc>
+                  <a:txBody>
+                    <a:bodyPr/>
+                    <a:lstStyle/>
+                    <a:p>
+                      <a:r>
+                        <a:rPr sz="1050" b="1">
+                          <a:solidFill>
+                            <a:srgbClr val="202124"/>
+                          </a:solidFill>
+                        </a:rPr>
+                        <a:t>Hexagon v73 NSP</a:t>
+                      </a:r>
+                    </a:p>
+                  </a:txBody>
+                  <a:tcPr/>
+                </a:tc>
+                <a:tc>
+                  <a:txBody>
+                    <a:bodyPr/>
+                    <a:lstStyle/>
+                    <a:p>
+                      <a:r>
+                        <a:rPr sz="1050" b="1">
+                          <a:solidFill>
+                            <a:srgbClr val="12B5A5"/>
+                          </a:solidFill>
+                        </a:rPr>
+                        <a:t>DSP</a:t>
+                      </a:r>
+                    </a:p>
+                  </a:txBody>
+                  <a:tcPr/>
+                </a:tc>
+                <a:tc>
+                  <a:txBody>
+                    <a:bodyPr/>
+                    <a:lstStyle/>
+                    <a:p>
+                      <a:r>
+                        <a:rPr sz="1050" b="0">
+                          <a:solidFill>
+                            <a:srgbClr val="202124"/>
+                          </a:solidFill>
+                        </a:rPr>
+                        <a:t>372.40 ms</a:t>
+                      </a:r>
+                    </a:p>
+                  </a:txBody>
+                  <a:tcPr/>
+                </a:tc>
+                <a:tc>
+                  <a:txBody>
+                    <a:bodyPr/>
+                    <a:lstStyle/>
+                    <a:p>
+                      <a:r>
+                        <a:rPr sz="1050" b="0">
+                          <a:solidFill>
+                            <a:srgbClr val="202124"/>
+                          </a:solidFill>
+                        </a:rPr>
+                        <a:t>2.69</a:t>
+                      </a:r>
+                    </a:p>
+                  </a:txBody>
+                  <a:tcPr/>
+                </a:tc>
+                <a:tc>
+                  <a:txBody>
+                    <a:bodyPr/>
+                    <a:lstStyle/>
+                    <a:p>
+                      <a:r>
+                        <a:rPr sz="1050" b="1">
+                          <a:solidFill>
+                            <a:srgbClr val="202124"/>
+                          </a:solidFill>
+                        </a:rPr>
+                        <a:t>446</a:t>
+                      </a:r>
+                    </a:p>
+                  </a:txBody>
+                  <a:tcPr/>
+                </a:tc>
+                <a:tc>
+                  <a:txBody>
+                    <a:bodyPr/>
+                    <a:lstStyle/>
+                    <a:p>
+                      <a:r>
+                        <a:rPr sz="1050" b="0">
+                          <a:solidFill>
+                            <a:srgbClr val="202124"/>
+                          </a:solidFill>
+                        </a:rPr>
+                        <a:t>48x faster</a:t>
+                      </a:r>
+                    </a:p>
+                  </a:txBody>
+                  <a:tcPr/>
+                </a:tc>
+              </a:tr>
+              <a:tr h="228600">
+                <a:tc>
+                  <a:txBody>
+                    <a:bodyPr/>
+                    <a:lstStyle/>
+                    <a:p>
+                      <a:r>
+                        <a:rPr sz="1050" b="1">
+                          <a:solidFill>
+                            <a:srgbClr val="202124"/>
+                          </a:solidFill>
+                        </a:rPr>
+                        <a:t>Mali-G720 (10 CU)</a:t>
+                      </a:r>
+                    </a:p>
+                  </a:txBody>
+                  <a:tcPr/>
+                </a:tc>
+                <a:tc>
+                  <a:txBody>
+                    <a:bodyPr/>
+                    <a:lstStyle/>
+                    <a:p>
+                      <a:r>
+                        <a:rPr sz="1050" b="1">
+                          <a:solidFill>
                             <a:srgbClr val="4C8BF5"/>
                           </a:solidFill>
                         </a:rPr>
@@ -9798,7 +10391,24 @@
                             <a:srgbClr val="202124"/>
                           </a:solidFill>
                         </a:rPr>
-                        <a:t>56.7 ms</a:t>
+                        <a:t>509.40 ms</a:t>
+                      </a:r>
+                    </a:p>
+                  </a:txBody>
+                  <a:tcPr/>
+                </a:tc>
+                <a:tc>
+                  <a:txBody>
+                    <a:bodyPr/>
+                    <a:lstStyle/>
+                    <a:p>
+                      <a:r>
+                        <a:rPr sz="1050" b="0">
+                          <a:solidFill>
+                            <a:srgbClr val="202124"/>
+                          </a:solidFill>
+                        </a:rPr>
+                        <a:t>1.96</a:t>
                       </a:r>
                     </a:p>
                   </a:txBody>
@@ -9815,7 +10425,7 @@
                             <a:srgbClr val="202124"/>
                           </a:solidFill>
                         </a:rPr>
-                        <a:t>2,928</a:t>
+                        <a:t>326</a:t>
                       </a:r>
                     </a:p>
                   </a:txBody>
@@ -9832,14 +10442,14 @@
                             <a:srgbClr val="202124"/>
                           </a:solidFill>
                         </a:rPr>
-                        <a:t>1.26</a:t>
+                        <a:t>35x faster</a:t>
                       </a:r>
                     </a:p>
                   </a:txBody>
                   <a:tcPr/>
                 </a:tc>
               </a:tr>
-              <a:tr h="219456">
+              <a:tr h="228600">
                 <a:tc>
                   <a:txBody>
                     <a:bodyPr/>
@@ -9851,7 +10461,7 @@
                             <a:srgbClr val="202124"/>
                           </a:solidFill>
                         </a:rPr>
-                        <a:t>NVIDIA Orin AGX</a:t>
+                        <a:t>Cortex-A78C x1</a:t>
                       </a:r>
                     </a:p>
                   </a:txBody>
@@ -9865,6 +10475,422 @@
                       <a:r>
                         <a:rPr sz="1050" b="1">
                           <a:solidFill>
+                            <a:srgbClr val="E8710A"/>
+                          </a:solidFill>
+                        </a:rPr>
+                        <a:t>CPU</a:t>
+                      </a:r>
+                    </a:p>
+                  </a:txBody>
+                  <a:tcPr/>
+                </a:tc>
+                <a:tc>
+                  <a:txBody>
+                    <a:bodyPr/>
+                    <a:lstStyle/>
+                    <a:p>
+                      <a:r>
+                        <a:rPr sz="1050" b="0">
+                          <a:solidFill>
+                            <a:srgbClr val="202124"/>
+                          </a:solidFill>
+                        </a:rPr>
+                        <a:t>595.30 ms</a:t>
+                      </a:r>
+                    </a:p>
+                  </a:txBody>
+                  <a:tcPr/>
+                </a:tc>
+                <a:tc>
+                  <a:txBody>
+                    <a:bodyPr/>
+                    <a:lstStyle/>
+                    <a:p>
+                      <a:r>
+                        <a:rPr sz="1050" b="0">
+                          <a:solidFill>
+                            <a:srgbClr val="202124"/>
+                          </a:solidFill>
+                        </a:rPr>
+                        <a:t>1.68</a:t>
+                      </a:r>
+                    </a:p>
+                  </a:txBody>
+                  <a:tcPr/>
+                </a:tc>
+                <a:tc>
+                  <a:txBody>
+                    <a:bodyPr/>
+                    <a:lstStyle/>
+                    <a:p>
+                      <a:r>
+                        <a:rPr sz="1050" b="1">
+                          <a:solidFill>
+                            <a:srgbClr val="202124"/>
+                          </a:solidFill>
+                        </a:rPr>
+                        <a:t>279</a:t>
+                      </a:r>
+                    </a:p>
+                  </a:txBody>
+                  <a:tcPr/>
+                </a:tc>
+                <a:tc>
+                  <a:txBody>
+                    <a:bodyPr/>
+                    <a:lstStyle/>
+                    <a:p>
+                      <a:r>
+                        <a:rPr sz="1050" b="0">
+                          <a:solidFill>
+                            <a:srgbClr val="202124"/>
+                          </a:solidFill>
+                        </a:rPr>
+                        <a:t>30x faster</a:t>
+                      </a:r>
+                    </a:p>
+                  </a:txBody>
+                  <a:tcPr/>
+                </a:tc>
+              </a:tr>
+              <a:tr h="228600">
+                <a:tc>
+                  <a:txBody>
+                    <a:bodyPr/>
+                    <a:lstStyle/>
+                    <a:p>
+                      <a:r>
+                        <a:rPr sz="1050" b="1">
+                          <a:solidFill>
+                            <a:srgbClr val="202124"/>
+                          </a:solidFill>
+                        </a:rPr>
+                        <a:t>Cortex-A720 x1</a:t>
+                      </a:r>
+                    </a:p>
+                  </a:txBody>
+                  <a:tcPr/>
+                </a:tc>
+                <a:tc>
+                  <a:txBody>
+                    <a:bodyPr/>
+                    <a:lstStyle/>
+                    <a:p>
+                      <a:r>
+                        <a:rPr sz="1050" b="1">
+                          <a:solidFill>
+                            <a:srgbClr val="E8710A"/>
+                          </a:solidFill>
+                        </a:rPr>
+                        <a:t>CPU</a:t>
+                      </a:r>
+                    </a:p>
+                  </a:txBody>
+                  <a:tcPr/>
+                </a:tc>
+                <a:tc>
+                  <a:txBody>
+                    <a:bodyPr/>
+                    <a:lstStyle/>
+                    <a:p>
+                      <a:r>
+                        <a:rPr sz="1050" b="0">
+                          <a:solidFill>
+                            <a:srgbClr val="202124"/>
+                          </a:solidFill>
+                        </a:rPr>
+                        <a:t>643.10 ms</a:t>
+                      </a:r>
+                    </a:p>
+                  </a:txBody>
+                  <a:tcPr/>
+                </a:tc>
+                <a:tc>
+                  <a:txBody>
+                    <a:bodyPr/>
+                    <a:lstStyle/>
+                    <a:p>
+                      <a:r>
+                        <a:rPr sz="1050" b="0">
+                          <a:solidFill>
+                            <a:srgbClr val="202124"/>
+                          </a:solidFill>
+                        </a:rPr>
+                        <a:t>1.55</a:t>
+                      </a:r>
+                    </a:p>
+                  </a:txBody>
+                  <a:tcPr/>
+                </a:tc>
+                <a:tc>
+                  <a:txBody>
+                    <a:bodyPr/>
+                    <a:lstStyle/>
+                    <a:p>
+                      <a:r>
+                        <a:rPr sz="1050" b="1">
+                          <a:solidFill>
+                            <a:srgbClr val="202124"/>
+                          </a:solidFill>
+                        </a:rPr>
+                        <a:t>258</a:t>
+                      </a:r>
+                    </a:p>
+                  </a:txBody>
+                  <a:tcPr/>
+                </a:tc>
+                <a:tc>
+                  <a:txBody>
+                    <a:bodyPr/>
+                    <a:lstStyle/>
+                    <a:p>
+                      <a:r>
+                        <a:rPr sz="1050" b="0">
+                          <a:solidFill>
+                            <a:srgbClr val="202124"/>
+                          </a:solidFill>
+                        </a:rPr>
+                        <a:t>28x faster</a:t>
+                      </a:r>
+                    </a:p>
+                  </a:txBody>
+                  <a:tcPr/>
+                </a:tc>
+              </a:tr>
+              <a:tr h="228600">
+                <a:tc>
+                  <a:txBody>
+                    <a:bodyPr/>
+                    <a:lstStyle/>
+                    <a:p>
+                      <a:r>
+                        <a:rPr sz="1050" b="1">
+                          <a:solidFill>
+                            <a:srgbClr val="202124"/>
+                          </a:solidFill>
+                        </a:rPr>
+                        <a:t>Cortex-A55 x6</a:t>
+                      </a:r>
+                    </a:p>
+                  </a:txBody>
+                  <a:tcPr/>
+                </a:tc>
+                <a:tc>
+                  <a:txBody>
+                    <a:bodyPr/>
+                    <a:lstStyle/>
+                    <a:p>
+                      <a:r>
+                        <a:rPr sz="1050" b="1">
+                          <a:solidFill>
+                            <a:srgbClr val="E8710A"/>
+                          </a:solidFill>
+                        </a:rPr>
+                        <a:t>CPU</a:t>
+                      </a:r>
+                    </a:p>
+                  </a:txBody>
+                  <a:tcPr/>
+                </a:tc>
+                <a:tc>
+                  <a:txBody>
+                    <a:bodyPr/>
+                    <a:lstStyle/>
+                    <a:p>
+                      <a:r>
+                        <a:rPr sz="1050" b="0">
+                          <a:solidFill>
+                            <a:srgbClr val="202124"/>
+                          </a:solidFill>
+                        </a:rPr>
+                        <a:t>844.80 ms</a:t>
+                      </a:r>
+                    </a:p>
+                  </a:txBody>
+                  <a:tcPr/>
+                </a:tc>
+                <a:tc>
+                  <a:txBody>
+                    <a:bodyPr/>
+                    <a:lstStyle/>
+                    <a:p>
+                      <a:r>
+                        <a:rPr sz="1050" b="0">
+                          <a:solidFill>
+                            <a:srgbClr val="202124"/>
+                          </a:solidFill>
+                        </a:rPr>
+                        <a:t>1.18</a:t>
+                      </a:r>
+                    </a:p>
+                  </a:txBody>
+                  <a:tcPr/>
+                </a:tc>
+                <a:tc>
+                  <a:txBody>
+                    <a:bodyPr/>
+                    <a:lstStyle/>
+                    <a:p>
+                      <a:r>
+                        <a:rPr sz="1050" b="1">
+                          <a:solidFill>
+                            <a:srgbClr val="202124"/>
+                          </a:solidFill>
+                        </a:rPr>
+                        <a:t>196</a:t>
+                      </a:r>
+                    </a:p>
+                  </a:txBody>
+                  <a:tcPr/>
+                </a:tc>
+                <a:tc>
+                  <a:txBody>
+                    <a:bodyPr/>
+                    <a:lstStyle/>
+                    <a:p>
+                      <a:r>
+                        <a:rPr sz="1050" b="0">
+                          <a:solidFill>
+                            <a:srgbClr val="202124"/>
+                          </a:solidFill>
+                        </a:rPr>
+                        <a:t>21x faster</a:t>
+                      </a:r>
+                    </a:p>
+                  </a:txBody>
+                  <a:tcPr/>
+                </a:tc>
+              </a:tr>
+              <a:tr h="228600">
+                <a:tc>
+                  <a:txBody>
+                    <a:bodyPr/>
+                    <a:lstStyle/>
+                    <a:p>
+                      <a:r>
+                        <a:rPr sz="1050" b="1">
+                          <a:solidFill>
+                            <a:srgbClr val="202124"/>
+                          </a:solidFill>
+                        </a:rPr>
+                        <a:t>Cortex-A55 x1</a:t>
+                      </a:r>
+                    </a:p>
+                  </a:txBody>
+                  <a:tcPr/>
+                </a:tc>
+                <a:tc>
+                  <a:txBody>
+                    <a:bodyPr/>
+                    <a:lstStyle/>
+                    <a:p>
+                      <a:r>
+                        <a:rPr sz="1050" b="1">
+                          <a:solidFill>
+                            <a:srgbClr val="E8710A"/>
+                          </a:solidFill>
+                        </a:rPr>
+                        <a:t>CPU</a:t>
+                      </a:r>
+                    </a:p>
+                  </a:txBody>
+                  <a:tcPr/>
+                </a:tc>
+                <a:tc>
+                  <a:txBody>
+                    <a:bodyPr/>
+                    <a:lstStyle/>
+                    <a:p>
+                      <a:r>
+                        <a:rPr sz="1050" b="0">
+                          <a:solidFill>
+                            <a:srgbClr val="202124"/>
+                          </a:solidFill>
+                        </a:rPr>
+                        <a:t>2,954.00 ms</a:t>
+                      </a:r>
+                    </a:p>
+                  </a:txBody>
+                  <a:tcPr/>
+                </a:tc>
+                <a:tc>
+                  <a:txBody>
+                    <a:bodyPr/>
+                    <a:lstStyle/>
+                    <a:p>
+                      <a:r>
+                        <a:rPr sz="1050" b="0">
+                          <a:solidFill>
+                            <a:srgbClr val="202124"/>
+                          </a:solidFill>
+                        </a:rPr>
+                        <a:t>0.34</a:t>
+                      </a:r>
+                    </a:p>
+                  </a:txBody>
+                  <a:tcPr/>
+                </a:tc>
+                <a:tc>
+                  <a:txBody>
+                    <a:bodyPr/>
+                    <a:lstStyle/>
+                    <a:p>
+                      <a:r>
+                        <a:rPr sz="1050" b="1">
+                          <a:solidFill>
+                            <a:srgbClr val="202124"/>
+                          </a:solidFill>
+                        </a:rPr>
+                        <a:t>56</a:t>
+                      </a:r>
+                    </a:p>
+                  </a:txBody>
+                  <a:tcPr/>
+                </a:tc>
+                <a:tc>
+                  <a:txBody>
+                    <a:bodyPr/>
+                    <a:lstStyle/>
+                    <a:p>
+                      <a:r>
+                        <a:rPr sz="1050" b="0">
+                          <a:solidFill>
+                            <a:srgbClr val="202124"/>
+                          </a:solidFill>
+                        </a:rPr>
+                        <a:t>6x faster</a:t>
+                      </a:r>
+                    </a:p>
+                  </a:txBody>
+                  <a:tcPr/>
+                </a:tc>
+              </a:tr>
+              <a:tr h="228600">
+                <a:tc>
+                  <a:txBody>
+                    <a:bodyPr/>
+                    <a:lstStyle/>
+                    <a:p>
+                      <a:r>
+                        <a:rPr sz="1050" b="1">
+                          <a:solidFill>
+                            <a:srgbClr val="202124"/>
+                          </a:solidFill>
+                        </a:rPr>
+                        <a:t>Mali-G310 (1 CU)</a:t>
+                      </a:r>
+                    </a:p>
+                  </a:txBody>
+                  <a:tcPr/>
+                </a:tc>
+                <a:tc>
+                  <a:txBody>
+                    <a:bodyPr/>
+                    <a:lstStyle/>
+                    <a:p>
+                      <a:r>
+                        <a:rPr sz="1050" b="1">
+                          <a:solidFill>
                             <a:srgbClr val="4C8BF5"/>
                           </a:solidFill>
                         </a:rPr>
@@ -9885,7 +10911,24 @@
                             <a:srgbClr val="202124"/>
                           </a:solidFill>
                         </a:rPr>
-                        <a:t>96.9 ms</a:t>
+                        <a:t>3,657.00 ms</a:t>
+                      </a:r>
+                    </a:p>
+                  </a:txBody>
+                  <a:tcPr/>
+                </a:tc>
+                <a:tc>
+                  <a:txBody>
+                    <a:bodyPr/>
+                    <a:lstStyle/>
+                    <a:p>
+                      <a:r>
+                        <a:rPr sz="1050" b="0">
+                          <a:solidFill>
+                            <a:srgbClr val="202124"/>
+                          </a:solidFill>
+                        </a:rPr>
+                        <a:t>0.27</a:t>
                       </a:r>
                     </a:p>
                   </a:txBody>
@@ -9902,7 +10945,7 @@
                             <a:srgbClr val="202124"/>
                           </a:solidFill>
                         </a:rPr>
-                        <a:t>1,711</a:t>
+                        <a:t>45</a:t>
                       </a:r>
                     </a:p>
                   </a:txBody>
@@ -9919,14 +10962,14 @@
                             <a:srgbClr val="202124"/>
                           </a:solidFill>
                         </a:rPr>
-                        <a:t>1.33</a:t>
+                        <a:t>5x faster</a:t>
                       </a:r>
                     </a:p>
                   </a:txBody>
                   <a:tcPr/>
                 </a:tc>
               </a:tr>
-              <a:tr h="219456">
+              <a:tr h="228600">
                 <a:tc>
                   <a:txBody>
                     <a:bodyPr/>
@@ -9938,7 +10981,7 @@
                             <a:srgbClr val="202124"/>
                           </a:solidFill>
                         </a:rPr>
-                        <a:t>Cortex-A720 x8</a:t>
+                        <a:t>scalar reference</a:t>
                       </a:r>
                     </a:p>
                   </a:txBody>
@@ -9952,10 +10995,10 @@
                       <a:r>
                         <a:rPr sz="1050" b="1">
                           <a:solidFill>
-                            <a:srgbClr val="E8710A"/>
-                          </a:solidFill>
-                        </a:rPr>
-                        <a:t>CPU</a:t>
+                            <a:srgbClr val="9AA0A6"/>
+                          </a:solidFill>
+                        </a:rPr>
+                        <a:t>REF</a:t>
                       </a:r>
                     </a:p>
                   </a:txBody>
@@ -9972,7 +11015,24 @@
                             <a:srgbClr val="202124"/>
                           </a:solidFill>
                         </a:rPr>
-                        <a:t>239.6 ms</a:t>
+                        <a:t>18,020.00 ms</a:t>
+                      </a:r>
+                    </a:p>
+                  </a:txBody>
+                  <a:tcPr/>
+                </a:tc>
+                <a:tc>
+                  <a:txBody>
+                    <a:bodyPr/>
+                    <a:lstStyle/>
+                    <a:p>
+                      <a:r>
+                        <a:rPr sz="1050" b="0">
+                          <a:solidFill>
+                            <a:srgbClr val="202124"/>
+                          </a:solidFill>
+                        </a:rPr>
+                        <a:t>0.06</a:t>
                       </a:r>
                     </a:p>
                   </a:txBody>
@@ -9989,7 +11049,7 @@
                             <a:srgbClr val="202124"/>
                           </a:solidFill>
                         </a:rPr>
-                        <a:t>692</a:t>
+                        <a:t>9.2</a:t>
                       </a:r>
                     </a:p>
                   </a:txBody>
@@ -10006,790 +11066,7 @@
                             <a:srgbClr val="202124"/>
                           </a:solidFill>
                         </a:rPr>
-                        <a:t>1.01  &lt;- see note</a:t>
-                      </a:r>
-                    </a:p>
-                  </a:txBody>
-                  <a:tcPr/>
-                </a:tc>
-              </a:tr>
-              <a:tr h="219456">
-                <a:tc>
-                  <a:txBody>
-                    <a:bodyPr/>
-                    <a:lstStyle/>
-                    <a:p>
-                      <a:r>
-                        <a:rPr sz="1050" b="1">
-                          <a:solidFill>
-                            <a:srgbClr val="202124"/>
-                          </a:solidFill>
-                        </a:rPr>
-                        <a:t>Cortex-A78C x8 (6 threads)</a:t>
-                      </a:r>
-                    </a:p>
-                  </a:txBody>
-                  <a:tcPr/>
-                </a:tc>
-                <a:tc>
-                  <a:txBody>
-                    <a:bodyPr/>
-                    <a:lstStyle/>
-                    <a:p>
-                      <a:r>
-                        <a:rPr sz="1050" b="1">
-                          <a:solidFill>
-                            <a:srgbClr val="E8710A"/>
-                          </a:solidFill>
-                        </a:rPr>
-                        <a:t>CPU</a:t>
-                      </a:r>
-                    </a:p>
-                  </a:txBody>
-                  <a:tcPr/>
-                </a:tc>
-                <a:tc>
-                  <a:txBody>
-                    <a:bodyPr/>
-                    <a:lstStyle/>
-                    <a:p>
-                      <a:r>
-                        <a:rPr sz="1050" b="0">
-                          <a:solidFill>
-                            <a:srgbClr val="202124"/>
-                          </a:solidFill>
-                        </a:rPr>
-                        <a:t>291.8 ms</a:t>
-                      </a:r>
-                    </a:p>
-                  </a:txBody>
-                  <a:tcPr/>
-                </a:tc>
-                <a:tc>
-                  <a:txBody>
-                    <a:bodyPr/>
-                    <a:lstStyle/>
-                    <a:p>
-                      <a:r>
-                        <a:rPr sz="1050" b="1">
-                          <a:solidFill>
-                            <a:srgbClr val="202124"/>
-                          </a:solidFill>
-                        </a:rPr>
-                        <a:t>569</a:t>
-                      </a:r>
-                    </a:p>
-                  </a:txBody>
-                  <a:tcPr/>
-                </a:tc>
-                <a:tc>
-                  <a:txBody>
-                    <a:bodyPr/>
-                    <a:lstStyle/>
-                    <a:p>
-                      <a:r>
-                        <a:rPr sz="1050" b="0">
-                          <a:solidFill>
-                            <a:srgbClr val="202124"/>
-                          </a:solidFill>
-                        </a:rPr>
-                        <a:t>1.38</a:t>
-                      </a:r>
-                    </a:p>
-                  </a:txBody>
-                  <a:tcPr/>
-                </a:tc>
-              </a:tr>
-              <a:tr h="219456">
-                <a:tc>
-                  <a:txBody>
-                    <a:bodyPr/>
-                    <a:lstStyle/>
-                    <a:p>
-                      <a:r>
-                        <a:rPr sz="1050" b="1">
-                          <a:solidFill>
-                            <a:srgbClr val="202124"/>
-                          </a:solidFill>
-                        </a:rPr>
-                        <a:t>Hexagon v73 NSP</a:t>
-                      </a:r>
-                    </a:p>
-                  </a:txBody>
-                  <a:tcPr/>
-                </a:tc>
-                <a:tc>
-                  <a:txBody>
-                    <a:bodyPr/>
-                    <a:lstStyle/>
-                    <a:p>
-                      <a:r>
-                        <a:rPr sz="1050" b="1">
-                          <a:solidFill>
-                            <a:srgbClr val="12B5A5"/>
-                          </a:solidFill>
-                        </a:rPr>
-                        <a:t>DSP</a:t>
-                      </a:r>
-                    </a:p>
-                  </a:txBody>
-                  <a:tcPr/>
-                </a:tc>
-                <a:tc>
-                  <a:txBody>
-                    <a:bodyPr/>
-                    <a:lstStyle/>
-                    <a:p>
-                      <a:r>
-                        <a:rPr sz="1050" b="0">
-                          <a:solidFill>
-                            <a:srgbClr val="202124"/>
-                          </a:solidFill>
-                        </a:rPr>
-                        <a:t>372.4 ms</a:t>
-                      </a:r>
-                    </a:p>
-                  </a:txBody>
-                  <a:tcPr/>
-                </a:tc>
-                <a:tc>
-                  <a:txBody>
-                    <a:bodyPr/>
-                    <a:lstStyle/>
-                    <a:p>
-                      <a:r>
-                        <a:rPr sz="1050" b="1">
-                          <a:solidFill>
-                            <a:srgbClr val="202124"/>
-                          </a:solidFill>
-                        </a:rPr>
-                        <a:t>446</a:t>
-                      </a:r>
-                    </a:p>
-                  </a:txBody>
-                  <a:tcPr/>
-                </a:tc>
-                <a:tc>
-                  <a:txBody>
-                    <a:bodyPr/>
-                    <a:lstStyle/>
-                    <a:p>
-                      <a:r>
-                        <a:rPr sz="1050" b="0">
-                          <a:solidFill>
-                            <a:srgbClr val="202124"/>
-                          </a:solidFill>
-                        </a:rPr>
-                        <a:t>1.35  (and constant MDE/s vs B)</a:t>
-                      </a:r>
-                    </a:p>
-                  </a:txBody>
-                  <a:tcPr/>
-                </a:tc>
-              </a:tr>
-              <a:tr h="219456">
-                <a:tc>
-                  <a:txBody>
-                    <a:bodyPr/>
-                    <a:lstStyle/>
-                    <a:p>
-                      <a:r>
-                        <a:rPr sz="1050" b="1">
-                          <a:solidFill>
-                            <a:srgbClr val="202124"/>
-                          </a:solidFill>
-                        </a:rPr>
-                        <a:t>Mali-G720 (10 CU)</a:t>
-                      </a:r>
-                    </a:p>
-                  </a:txBody>
-                  <a:tcPr/>
-                </a:tc>
-                <a:tc>
-                  <a:txBody>
-                    <a:bodyPr/>
-                    <a:lstStyle/>
-                    <a:p>
-                      <a:r>
-                        <a:rPr sz="1050" b="1">
-                          <a:solidFill>
-                            <a:srgbClr val="4C8BF5"/>
-                          </a:solidFill>
-                        </a:rPr>
-                        <a:t>GPU</a:t>
-                      </a:r>
-                    </a:p>
-                  </a:txBody>
-                  <a:tcPr/>
-                </a:tc>
-                <a:tc>
-                  <a:txBody>
-                    <a:bodyPr/>
-                    <a:lstStyle/>
-                    <a:p>
-                      <a:r>
-                        <a:rPr sz="1050" b="0">
-                          <a:solidFill>
-                            <a:srgbClr val="202124"/>
-                          </a:solidFill>
-                        </a:rPr>
-                        <a:t>509.4 ms</a:t>
-                      </a:r>
-                    </a:p>
-                  </a:txBody>
-                  <a:tcPr/>
-                </a:tc>
-                <a:tc>
-                  <a:txBody>
-                    <a:bodyPr/>
-                    <a:lstStyle/>
-                    <a:p>
-                      <a:r>
-                        <a:rPr sz="1050" b="1">
-                          <a:solidFill>
-                            <a:srgbClr val="202124"/>
-                          </a:solidFill>
-                        </a:rPr>
-                        <a:t>326</a:t>
-                      </a:r>
-                    </a:p>
-                  </a:txBody>
-                  <a:tcPr/>
-                </a:tc>
-                <a:tc>
-                  <a:txBody>
-                    <a:bodyPr/>
-                    <a:lstStyle/>
-                    <a:p>
-                      <a:r>
-                        <a:rPr sz="1050" b="0">
-                          <a:solidFill>
-                            <a:srgbClr val="202124"/>
-                          </a:solidFill>
-                        </a:rPr>
-                        <a:t>1.34</a:t>
-                      </a:r>
-                    </a:p>
-                  </a:txBody>
-                  <a:tcPr/>
-                </a:tc>
-              </a:tr>
-              <a:tr h="219456">
-                <a:tc>
-                  <a:txBody>
-                    <a:bodyPr/>
-                    <a:lstStyle/>
-                    <a:p>
-                      <a:r>
-                        <a:rPr sz="1050" b="1">
-                          <a:solidFill>
-                            <a:srgbClr val="202124"/>
-                          </a:solidFill>
-                        </a:rPr>
-                        <a:t>Cortex-A78C x1</a:t>
-                      </a:r>
-                    </a:p>
-                  </a:txBody>
-                  <a:tcPr/>
-                </a:tc>
-                <a:tc>
-                  <a:txBody>
-                    <a:bodyPr/>
-                    <a:lstStyle/>
-                    <a:p>
-                      <a:r>
-                        <a:rPr sz="1050" b="1">
-                          <a:solidFill>
-                            <a:srgbClr val="E8710A"/>
-                          </a:solidFill>
-                        </a:rPr>
-                        <a:t>CPU</a:t>
-                      </a:r>
-                    </a:p>
-                  </a:txBody>
-                  <a:tcPr/>
-                </a:tc>
-                <a:tc>
-                  <a:txBody>
-                    <a:bodyPr/>
-                    <a:lstStyle/>
-                    <a:p>
-                      <a:r>
-                        <a:rPr sz="1050" b="0">
-                          <a:solidFill>
-                            <a:srgbClr val="202124"/>
-                          </a:solidFill>
-                        </a:rPr>
-                        <a:t>595.3 ms</a:t>
-                      </a:r>
-                    </a:p>
-                  </a:txBody>
-                  <a:tcPr/>
-                </a:tc>
-                <a:tc>
-                  <a:txBody>
-                    <a:bodyPr/>
-                    <a:lstStyle/>
-                    <a:p>
-                      <a:r>
-                        <a:rPr sz="1050" b="1">
-                          <a:solidFill>
-                            <a:srgbClr val="202124"/>
-                          </a:solidFill>
-                        </a:rPr>
-                        <a:t>279</a:t>
-                      </a:r>
-                    </a:p>
-                  </a:txBody>
-                  <a:tcPr/>
-                </a:tc>
-                <a:tc>
-                  <a:txBody>
-                    <a:bodyPr/>
-                    <a:lstStyle/>
-                    <a:p>
-                      <a:r>
-                        <a:rPr sz="1050" b="0">
-                          <a:solidFill>
-                            <a:srgbClr val="202124"/>
-                          </a:solidFill>
-                        </a:rPr>
-                        <a:t>1.34</a:t>
-                      </a:r>
-                    </a:p>
-                  </a:txBody>
-                  <a:tcPr/>
-                </a:tc>
-              </a:tr>
-              <a:tr h="219456">
-                <a:tc>
-                  <a:txBody>
-                    <a:bodyPr/>
-                    <a:lstStyle/>
-                    <a:p>
-                      <a:r>
-                        <a:rPr sz="1050" b="1">
-                          <a:solidFill>
-                            <a:srgbClr val="202124"/>
-                          </a:solidFill>
-                        </a:rPr>
-                        <a:t>Cortex-A720 x1</a:t>
-                      </a:r>
-                    </a:p>
-                  </a:txBody>
-                  <a:tcPr/>
-                </a:tc>
-                <a:tc>
-                  <a:txBody>
-                    <a:bodyPr/>
-                    <a:lstStyle/>
-                    <a:p>
-                      <a:r>
-                        <a:rPr sz="1050" b="1">
-                          <a:solidFill>
-                            <a:srgbClr val="E8710A"/>
-                          </a:solidFill>
-                        </a:rPr>
-                        <a:t>CPU</a:t>
-                      </a:r>
-                    </a:p>
-                  </a:txBody>
-                  <a:tcPr/>
-                </a:tc>
-                <a:tc>
-                  <a:txBody>
-                    <a:bodyPr/>
-                    <a:lstStyle/>
-                    <a:p>
-                      <a:r>
-                        <a:rPr sz="1050" b="0">
-                          <a:solidFill>
-                            <a:srgbClr val="202124"/>
-                          </a:solidFill>
-                        </a:rPr>
-                        <a:t>643.1 ms</a:t>
-                      </a:r>
-                    </a:p>
-                  </a:txBody>
-                  <a:tcPr/>
-                </a:tc>
-                <a:tc>
-                  <a:txBody>
-                    <a:bodyPr/>
-                    <a:lstStyle/>
-                    <a:p>
-                      <a:r>
-                        <a:rPr sz="1050" b="1">
-                          <a:solidFill>
-                            <a:srgbClr val="202124"/>
-                          </a:solidFill>
-                        </a:rPr>
-                        <a:t>258</a:t>
-                      </a:r>
-                    </a:p>
-                  </a:txBody>
-                  <a:tcPr/>
-                </a:tc>
-                <a:tc>
-                  <a:txBody>
-                    <a:bodyPr/>
-                    <a:lstStyle/>
-                    <a:p>
-                      <a:r>
-                        <a:rPr sz="1050" b="0">
-                          <a:solidFill>
-                            <a:srgbClr val="202124"/>
-                          </a:solidFill>
-                        </a:rPr>
-                        <a:t>1.37</a:t>
-                      </a:r>
-                    </a:p>
-                  </a:txBody>
-                  <a:tcPr/>
-                </a:tc>
-              </a:tr>
-              <a:tr h="219456">
-                <a:tc>
-                  <a:txBody>
-                    <a:bodyPr/>
-                    <a:lstStyle/>
-                    <a:p>
-                      <a:r>
-                        <a:rPr sz="1050" b="1">
-                          <a:solidFill>
-                            <a:srgbClr val="202124"/>
-                          </a:solidFill>
-                        </a:rPr>
-                        <a:t>Cortex-A55 x6</a:t>
-                      </a:r>
-                    </a:p>
-                  </a:txBody>
-                  <a:tcPr/>
-                </a:tc>
-                <a:tc>
-                  <a:txBody>
-                    <a:bodyPr/>
-                    <a:lstStyle/>
-                    <a:p>
-                      <a:r>
-                        <a:rPr sz="1050" b="1">
-                          <a:solidFill>
-                            <a:srgbClr val="E8710A"/>
-                          </a:solidFill>
-                        </a:rPr>
-                        <a:t>CPU</a:t>
-                      </a:r>
-                    </a:p>
-                  </a:txBody>
-                  <a:tcPr/>
-                </a:tc>
-                <a:tc>
-                  <a:txBody>
-                    <a:bodyPr/>
-                    <a:lstStyle/>
-                    <a:p>
-                      <a:r>
-                        <a:rPr sz="1050" b="0">
-                          <a:solidFill>
-                            <a:srgbClr val="202124"/>
-                          </a:solidFill>
-                        </a:rPr>
-                        <a:t>844.8 ms</a:t>
-                      </a:r>
-                    </a:p>
-                  </a:txBody>
-                  <a:tcPr/>
-                </a:tc>
-                <a:tc>
-                  <a:txBody>
-                    <a:bodyPr/>
-                    <a:lstStyle/>
-                    <a:p>
-                      <a:r>
-                        <a:rPr sz="1050" b="1">
-                          <a:solidFill>
-                            <a:srgbClr val="202124"/>
-                          </a:solidFill>
-                        </a:rPr>
-                        <a:t>196</a:t>
-                      </a:r>
-                    </a:p>
-                  </a:txBody>
-                  <a:tcPr/>
-                </a:tc>
-                <a:tc>
-                  <a:txBody>
-                    <a:bodyPr/>
-                    <a:lstStyle/>
-                    <a:p>
-                      <a:r>
-                        <a:rPr sz="1050" b="0">
-                          <a:solidFill>
-                            <a:srgbClr val="202124"/>
-                          </a:solidFill>
-                        </a:rPr>
-                        <a:t>1.32</a:t>
-                      </a:r>
-                    </a:p>
-                  </a:txBody>
-                  <a:tcPr/>
-                </a:tc>
-              </a:tr>
-              <a:tr h="219456">
-                <a:tc>
-                  <a:txBody>
-                    <a:bodyPr/>
-                    <a:lstStyle/>
-                    <a:p>
-                      <a:r>
-                        <a:rPr sz="1050" b="1">
-                          <a:solidFill>
-                            <a:srgbClr val="202124"/>
-                          </a:solidFill>
-                        </a:rPr>
-                        <a:t>Cortex-A55 x1</a:t>
-                      </a:r>
-                    </a:p>
-                  </a:txBody>
-                  <a:tcPr/>
-                </a:tc>
-                <a:tc>
-                  <a:txBody>
-                    <a:bodyPr/>
-                    <a:lstStyle/>
-                    <a:p>
-                      <a:r>
-                        <a:rPr sz="1050" b="1">
-                          <a:solidFill>
-                            <a:srgbClr val="E8710A"/>
-                          </a:solidFill>
-                        </a:rPr>
-                        <a:t>CPU</a:t>
-                      </a:r>
-                    </a:p>
-                  </a:txBody>
-                  <a:tcPr/>
-                </a:tc>
-                <a:tc>
-                  <a:txBody>
-                    <a:bodyPr/>
-                    <a:lstStyle/>
-                    <a:p>
-                      <a:r>
-                        <a:rPr sz="1050" b="0">
-                          <a:solidFill>
-                            <a:srgbClr val="202124"/>
-                          </a:solidFill>
-                        </a:rPr>
-                        <a:t>2,954.0 ms</a:t>
-                      </a:r>
-                    </a:p>
-                  </a:txBody>
-                  <a:tcPr/>
-                </a:tc>
-                <a:tc>
-                  <a:txBody>
-                    <a:bodyPr/>
-                    <a:lstStyle/>
-                    <a:p>
-                      <a:r>
-                        <a:rPr sz="1050" b="1">
-                          <a:solidFill>
-                            <a:srgbClr val="202124"/>
-                          </a:solidFill>
-                        </a:rPr>
-                        <a:t>56</a:t>
-                      </a:r>
-                    </a:p>
-                  </a:txBody>
-                  <a:tcPr/>
-                </a:tc>
-                <a:tc>
-                  <a:txBody>
-                    <a:bodyPr/>
-                    <a:lstStyle/>
-                    <a:p>
-                      <a:r>
-                        <a:rPr sz="1050" b="0">
-                          <a:solidFill>
-                            <a:srgbClr val="202124"/>
-                          </a:solidFill>
-                        </a:rPr>
-                        <a:t>1.34</a:t>
-                      </a:r>
-                    </a:p>
-                  </a:txBody>
-                  <a:tcPr/>
-                </a:tc>
-              </a:tr>
-              <a:tr h="219456">
-                <a:tc>
-                  <a:txBody>
-                    <a:bodyPr/>
-                    <a:lstStyle/>
-                    <a:p>
-                      <a:r>
-                        <a:rPr sz="1050" b="1">
-                          <a:solidFill>
-                            <a:srgbClr val="202124"/>
-                          </a:solidFill>
-                        </a:rPr>
-                        <a:t>Mali-G310 (1 CU)</a:t>
-                      </a:r>
-                    </a:p>
-                  </a:txBody>
-                  <a:tcPr/>
-                </a:tc>
-                <a:tc>
-                  <a:txBody>
-                    <a:bodyPr/>
-                    <a:lstStyle/>
-                    <a:p>
-                      <a:r>
-                        <a:rPr sz="1050" b="1">
-                          <a:solidFill>
-                            <a:srgbClr val="4C8BF5"/>
-                          </a:solidFill>
-                        </a:rPr>
-                        <a:t>GPU</a:t>
-                      </a:r>
-                    </a:p>
-                  </a:txBody>
-                  <a:tcPr/>
-                </a:tc>
-                <a:tc>
-                  <a:txBody>
-                    <a:bodyPr/>
-                    <a:lstStyle/>
-                    <a:p>
-                      <a:r>
-                        <a:rPr sz="1050" b="0">
-                          <a:solidFill>
-                            <a:srgbClr val="202124"/>
-                          </a:solidFill>
-                        </a:rPr>
-                        <a:t>3,657.0 ms</a:t>
-                      </a:r>
-                    </a:p>
-                  </a:txBody>
-                  <a:tcPr/>
-                </a:tc>
-                <a:tc>
-                  <a:txBody>
-                    <a:bodyPr/>
-                    <a:lstStyle/>
-                    <a:p>
-                      <a:r>
-                        <a:rPr sz="1050" b="1">
-                          <a:solidFill>
-                            <a:srgbClr val="202124"/>
-                          </a:solidFill>
-                        </a:rPr>
-                        <a:t>45</a:t>
-                      </a:r>
-                    </a:p>
-                  </a:txBody>
-                  <a:tcPr/>
-                </a:tc>
-                <a:tc>
-                  <a:txBody>
-                    <a:bodyPr/>
-                    <a:lstStyle/>
-                    <a:p>
-                      <a:r>
-                        <a:rPr sz="1050" b="0">
-                          <a:solidFill>
-                            <a:srgbClr val="202124"/>
-                          </a:solidFill>
-                        </a:rPr>
-                        <a:t>1.35</a:t>
-                      </a:r>
-                    </a:p>
-                  </a:txBody>
-                  <a:tcPr/>
-                </a:tc>
-              </a:tr>
-              <a:tr h="219456">
-                <a:tc>
-                  <a:txBody>
-                    <a:bodyPr/>
-                    <a:lstStyle/>
-                    <a:p>
-                      <a:r>
-                        <a:rPr sz="1050" b="1">
-                          <a:solidFill>
-                            <a:srgbClr val="202124"/>
-                          </a:solidFill>
-                        </a:rPr>
-                        <a:t>scalar reference</a:t>
-                      </a:r>
-                    </a:p>
-                  </a:txBody>
-                  <a:tcPr/>
-                </a:tc>
-                <a:tc>
-                  <a:txBody>
-                    <a:bodyPr/>
-                    <a:lstStyle/>
-                    <a:p>
-                      <a:r>
-                        <a:rPr sz="1050" b="1">
-                          <a:solidFill>
-                            <a:srgbClr val="9AA0A6"/>
-                          </a:solidFill>
-                        </a:rPr>
-                        <a:t>REF</a:t>
-                      </a:r>
-                    </a:p>
-                  </a:txBody>
-                  <a:tcPr/>
-                </a:tc>
-                <a:tc>
-                  <a:txBody>
-                    <a:bodyPr/>
-                    <a:lstStyle/>
-                    <a:p>
-                      <a:r>
-                        <a:rPr sz="1050" b="0">
-                          <a:solidFill>
-                            <a:srgbClr val="202124"/>
-                          </a:solidFill>
-                        </a:rPr>
-                        <a:t>18,020.0 ms</a:t>
-                      </a:r>
-                    </a:p>
-                  </a:txBody>
-                  <a:tcPr/>
-                </a:tc>
-                <a:tc>
-                  <a:txBody>
-                    <a:bodyPr/>
-                    <a:lstStyle/>
-                    <a:p>
-                      <a:r>
-                        <a:rPr sz="1050" b="1">
-                          <a:solidFill>
-                            <a:srgbClr val="202124"/>
-                          </a:solidFill>
-                        </a:rPr>
-                        <a:t>9.2</a:t>
-                      </a:r>
-                    </a:p>
-                  </a:txBody>
-                  <a:tcPr/>
-                </a:tc>
-                <a:tc>
-                  <a:txBody>
-                    <a:bodyPr/>
-                    <a:lstStyle/>
-                    <a:p>
-                      <a:r>
-                        <a:rPr sz="1050" b="0">
-                          <a:solidFill>
-                            <a:srgbClr val="202124"/>
-                          </a:solidFill>
-                        </a:rPr>
-                        <a:t>1.26</a:t>
+                        <a:t>the floor (1x)</a:t>
                       </a:r>
                     </a:p>
                   </a:txBody>
@@ -10830,7 +11107,7 @@
                 </a:solidFill>
                 <a:latin typeface="Calibri"/>
               </a:rPr>
-              <a:t>Two clean statements on the 5090, one knob each:  A -&gt; C (same input images, algorithm swap): 3.46 -&gt; 11.96 ms - the two-scale 8-path algorithm costs ~3.5x the single-scale 4-path one.  C -&gt; B (same algorithm, 1080 -&gt; 800 rows): 11.96 -&gt; 9.08 ms - the smaller frame buys back exactly its pixel share.</a:t>
+              <a:t>Two clean statements on the 5090, one knob each:  A -&gt; C (same input images, algorithm swap): 3.46 -&gt; 11.96 ms - the two-scale 8-path algorithm costs ~3.5x the single-scale 4-path one.  C -&gt; B (same algorithm, 1080 -&gt; 800 rows): 11.96 -&gt; 9.08 ms. Row for row, C/B ratios cluster at the 1.35x the pixels predict (5090 1.32, Thor 1.26, NSP 1.348, Malis 1.34-1.35) - one exception below.</a:t>
             </a:r>
           </a:p>
         </p:txBody>

</xml_diff>

<commit_message>
deck: the DRAM bandwidth story gets its slide (28 slides)
The README's achieved/ceiling data and the 'is it just bandwidth?' analysis
were repo-only; the deck now carries them as slide 2 -- the per-part table
(MEASURED ceilings, DERIVED achieved, utilisation, and which wall each part
hits: memory-bound GPUs at 42-58%, compute-bound CPUs/Malis at 8-35%, the
latency-bound Hexagon as the third wall), plus the cross-GPU MDE-per-GB/s
sanity check. B and C slides state honestly that their per-phase byte models
are not separately derived -- same silicon, same measured ceilings, no
invented achieved column.
</commit_message>
<xml_diff>
--- a/docs/sgm-results.pptx
+++ b/docs/sgm-results.pptx
@@ -32,6 +32,7 @@
     <p:sldId id="280" r:id="rId31"/>
     <p:sldId id="281" r:id="rId32"/>
     <p:sldId id="282" r:id="rId33"/>
+    <p:sldId id="283" r:id="rId34"/>
   </p:sldIdLst>
   <p:sldSz cx="12191695" cy="6858000" type="screen4x3"/>
   <p:notesSz cx="6858000" cy="9144000"/>
@@ -5529,7 +5530,7 @@
                 </a:solidFill>
                 <a:latin typeface="Calibri"/>
               </a:rPr>
-              <a:t>NVIDIA Orin AGX OFA</a:t>
+              <a:t>NVIDIA Thor OFA</a:t>
             </a:r>
           </a:p>
         </p:txBody>
@@ -5564,7 +5565,7 @@
                 </a:solidFill>
                 <a:latin typeface="Calibri"/>
               </a:rPr>
-              <a:t>Fixed-function SGM engine, VPI 3.2.4  |  1080p D=128, downscaleFactor=1</a:t>
+              <a:t>Fixed-function SGM engine (Optical Flow Accelerator), VPI 4.1.4  |  1080p D=128, downscaleFactor=1</a:t>
             </a:r>
           </a:p>
         </p:txBody>
@@ -5635,11 +5636,11 @@
                 <a:latin typeface="Consolas"/>
               </a:rPr>
               <a:t>MDE/s  =  W x H x D / runtime
-        =  1,920 x 1,080 x 64 / 72.64 ms
-        =  132,710,400 disparity estimations / 0.07264 s
-        =  1,827 million disparity estimations per second
-frame rate  =  1000 / 72.64  =  13.8 fps
-pixel rate  =  2.0736 Mpx x 13.8  =  28.55 Mpix/s</a:t>
+        =  1,920 x 1,080 x 64 / 9.35 ms
+        =  132,710,400 disparity estimations / 0.00935 s
+        =  14,201 million disparity estimations per second
+frame rate  =  1000 / 9.35  =  107.0 fps
+pixel rate  =  2.0736 Mpx x 107.0  =  221.89 Mpix/s</a:t>
             </a:r>
           </a:p>
         </p:txBody>
@@ -5709,7 +5710,7 @@
                 </a:solidFill>
                 <a:latin typeface="Calibri"/>
               </a:rPr>
-              <a:t>The same fixed-function engine one generation earlier, and here it LOSES:</a:t>
+              <a:t>DEDICATED STEREO HARDWARE, and it beats our tuned CUDA on the same chip</a:t>
             </a:r>
           </a:p>
           <a:p>
@@ -5720,7 +5721,7 @@
                 </a:solidFill>
                 <a:latin typeface="Calibri"/>
               </a:rPr>
-              <a:t>our CUDA kernel does the same work in 33.16 ms against the hardware's 72.64.</a:t>
+              <a:t>by 2.34x (9.35 ms vs 21.86 ms at 1920x1080 D=128).</a:t>
             </a:r>
           </a:p>
           <a:p>
@@ -5731,7 +5732,7 @@
                 </a:solidFill>
                 <a:latin typeface="Calibri"/>
               </a:rPr>
-              <a:t>Software wins by 2.19x on the silicon built for this exact job.</a:t>
+              <a:t>NOT bit-exact to our golden: VPI's SGM is a different implementation with</a:t>
             </a:r>
           </a:p>
           <a:p>
@@ -5742,7 +5743,7 @@
                 </a:solidFill>
                 <a:latin typeface="Calibri"/>
               </a:rPr>
-              <a:t>Thor's OFA is 7.8x faster than Orin's at identical settings -- a far larger</a:t>
+              <a:t>its own census, penalties and confidence output. Throughput comparison at</a:t>
             </a:r>
           </a:p>
           <a:p>
@@ -5753,7 +5754,7 @@
                 </a:solidFill>
                 <a:latin typeface="Calibri"/>
               </a:rPr>
-              <a:t>generational jump than the 1.5x between the two GPUs.</a:t>
+              <a:t>matched resolution and D -- NOT the same test, and NOT a quality claim.</a:t>
             </a:r>
           </a:p>
           <a:p>
@@ -5764,7 +5765,7 @@
                 </a:solidFill>
                 <a:latin typeface="Calibri"/>
               </a:rPr>
-              <a:t>Taken together these two rows are the interesting result: whether dedicated</a:t>
+              <a:t>🔴 ACCURACY WITHDRAWN. Scored against ground truth our SGM gets 2.6% bad&gt;1px</a:t>
             </a:r>
           </a:p>
           <a:p>
@@ -5775,7 +5776,7 @@
                 </a:solidFill>
                 <a:latin typeface="Calibri"/>
               </a:rPr>
-              <a:t>hardware beats a tuned kernel is a property of the generation, not of the</a:t>
+              <a:t>(MAE 0.45); OFA aligns under no simple descaling, so its accuracy is</a:t>
             </a:r>
           </a:p>
           <a:p>
@@ -5786,7 +5787,7 @@
                 </a:solidFill>
                 <a:latin typeface="Calibri"/>
               </a:rPr>
-              <a:t>idea of dedicated hardware.</a:t>
+              <a:t>UNMEASURED and this 2.34x is throughput only.</a:t>
             </a:r>
           </a:p>
           <a:p>
@@ -5797,7 +5798,7 @@
                 </a:solidFill>
                 <a:latin typeface="Calibri"/>
               </a:rPr>
-              <a:t>Same caveats as the Thor row: not bit-exact, accuracy unmeasured, and the</a:t>
+              <a:t>VPI defaults to includeDiagonals=1, so OFA ran 8 paths against our 4. Measured,</a:t>
             </a:r>
           </a:p>
           <a:p>
@@ -5808,7 +5809,40 @@
                 </a:solidFill>
                 <a:latin typeface="Calibri"/>
               </a:rPr>
-              <a:t>timed region excludes format conversion where ours is end-to-end (&lt;5%).</a:t>
+              <a:t>not assumed: OFA costs 9.42 ms at 8 paths and 9.85 at 4 -- path-count</a:t>
+            </a:r>
+          </a:p>
+          <a:p>
+            <a:r>
+              <a:rPr sz="1300">
+                <a:solidFill>
+                  <a:srgbClr val="202124"/>
+                </a:solidFill>
+                <a:latin typeface="Calibri"/>
+              </a:rPr>
+              <a:t>independent. The timing stands and OFA delivers an 8-path result in our time.</a:t>
+            </a:r>
+          </a:p>
+          <a:p>
+            <a:r>
+              <a:rPr sz="1300">
+                <a:solidFill>
+                  <a:srgbClr val="202124"/>
+                </a:solidFill>
+                <a:latin typeface="Calibri"/>
+              </a:rPr>
+              <a:t>⚠️ It defaults to downscaleFactor=2, which emits a 960x540 map from 1080p</a:t>
+            </a:r>
+          </a:p>
+          <a:p>
+            <a:r>
+              <a:rPr sz="1300">
+                <a:solidFill>
+                  <a:srgbClr val="202124"/>
+                </a:solidFill>
+                <a:latin typeface="Calibri"/>
+              </a:rPr>
+              <a:t>input in 4.14 ms. Quoting that as a 1080p figure overstates it by 2.3x.</a:t>
             </a:r>
           </a:p>
         </p:txBody>
@@ -5916,11 +5950,11 @@
             <a:r>
               <a:rPr sz="3200" b="1">
                 <a:solidFill>
-                  <a:srgbClr val="E8710A"/>
-                </a:solidFill>
-                <a:latin typeface="Calibri"/>
-              </a:rPr>
-              <a:t>Cortex-A55 x6</a:t>
+                  <a:srgbClr val="7B4FD1"/>
+                </a:solidFill>
+                <a:latin typeface="Calibri"/>
+              </a:rPr>
+              <a:t>NVIDIA Orin AGX OFA</a:t>
             </a:r>
           </a:p>
         </p:txBody>
@@ -5955,7 +5989,7 @@
                 </a:solidFill>
                 <a:latin typeface="Calibri"/>
               </a:rPr>
-              <a:t>i.MX 95 FRDM, 1.8 GHz, NEON  |  single core: 1,588.74 ms = 84 MDE/s</a:t>
+              <a:t>Fixed-function SGM engine, VPI 3.2.4  |  1080p D=128, downscaleFactor=1</a:t>
             </a:r>
           </a:p>
         </p:txBody>
@@ -6026,11 +6060,11 @@
                 <a:latin typeface="Consolas"/>
               </a:rPr>
               <a:t>MDE/s  =  W x H x D / runtime
-        =  1,920 x 1,080 x 64 / 341.30 ms
-        =  132,710,400 disparity estimations / 0.34130 s
-        =  389 million disparity estimations per second
-frame rate  =  1000 / 341.30  =  2.9 fps
-pixel rate  =  2.0736 Mpx x 2.9  =  6.08 Mpix/s</a:t>
+        =  1,920 x 1,080 x 64 / 72.64 ms
+        =  132,710,400 disparity estimations / 0.07264 s
+        =  1,827 million disparity estimations per second
+frame rate  =  1000 / 72.64  =  13.8 fps
+pixel rate  =  2.0736 Mpx x 13.8  =  28.55 Mpix/s</a:t>
             </a:r>
           </a:p>
         </p:txBody>
@@ -6100,7 +6134,7 @@
                 </a:solidFill>
                 <a:latin typeface="Calibri"/>
               </a:rPr>
-              <a:t>The reference platform this project is anchored to, and the slowest CPU here.</a:t>
+              <a:t>The same fixed-function engine one generation earlier, and here it LOSES:</a:t>
             </a:r>
           </a:p>
           <a:p>
@@ -6111,7 +6145,7 @@
                 </a:solidFill>
                 <a:latin typeface="Calibri"/>
               </a:rPr>
-              <a:t>Scales 4.65x from 1 to 6 cores (1,588.74 -&gt; 341.30 ms) -- that spread is also</a:t>
+              <a:t>our CUDA kernel does the same work in 33.16 ms against the hardware's 72.64.</a:t>
             </a:r>
           </a:p>
           <a:p>
@@ -6122,7 +6156,7 @@
                 </a:solidFill>
                 <a:latin typeface="Calibri"/>
               </a:rPr>
-              <a:t>the proof that the -t thread flag was working on these runs, since the inert</a:t>
+              <a:t>Software wins by 2.19x on the silicon built for this exact job.</a:t>
             </a:r>
           </a:p>
           <a:p>
@@ -6133,7 +6167,7 @@
                 </a:solidFill>
                 <a:latin typeface="Calibri"/>
               </a:rPr>
-              <a:t>flag it was found to have would have collapsed every count to one timing.</a:t>
+              <a:t>Thor's OFA is 7.8x faster than Orin's at identical settings -- a far larger</a:t>
             </a:r>
           </a:p>
           <a:p>
@@ -6144,7 +6178,7 @@
                 </a:solidFill>
                 <a:latin typeface="Calibri"/>
               </a:rPr>
-              <a:t>Per core 84 MDE/s against the A720's 423: a 5.0x gap between an in-order</a:t>
+              <a:t>generational jump than the 1.5x between the two GPUs.</a:t>
             </a:r>
           </a:p>
           <a:p>
@@ -6155,7 +6189,7 @@
                 </a:solidFill>
                 <a:latin typeface="Calibri"/>
               </a:rPr>
-              <a:t>little core at 1.8 GHz and a wide out-of-order core at 2.5 GHz.</a:t>
+              <a:t>Taken together these two rows are the interesting result: whether dedicated</a:t>
             </a:r>
           </a:p>
           <a:p>
@@ -6166,7 +6200,40 @@
                 </a:solidFill>
                 <a:latin typeface="Calibri"/>
               </a:rPr>
-              <a:t>Block-width optimum is 192 here and 256 on the A720 -- not the same number.</a:t>
+              <a:t>hardware beats a tuned kernel is a property of the generation, not of the</a:t>
+            </a:r>
+          </a:p>
+          <a:p>
+            <a:r>
+              <a:rPr sz="1300">
+                <a:solidFill>
+                  <a:srgbClr val="202124"/>
+                </a:solidFill>
+                <a:latin typeface="Calibri"/>
+              </a:rPr>
+              <a:t>idea of dedicated hardware.</a:t>
+            </a:r>
+          </a:p>
+          <a:p>
+            <a:r>
+              <a:rPr sz="1300">
+                <a:solidFill>
+                  <a:srgbClr val="202124"/>
+                </a:solidFill>
+                <a:latin typeface="Calibri"/>
+              </a:rPr>
+              <a:t>Same caveats as the Thor row: not bit-exact, accuracy unmeasured, and the</a:t>
+            </a:r>
+          </a:p>
+          <a:p>
+            <a:r>
+              <a:rPr sz="1300">
+                <a:solidFill>
+                  <a:srgbClr val="202124"/>
+                </a:solidFill>
+                <a:latin typeface="Calibri"/>
+              </a:rPr>
+              <a:t>timed region excludes format conversion where ours is end-to-end (&lt;5%).</a:t>
             </a:r>
           </a:p>
         </p:txBody>
@@ -6274,11 +6341,11 @@
             <a:r>
               <a:rPr sz="3200" b="1">
                 <a:solidFill>
-                  <a:srgbClr val="4C8BF5"/>
-                </a:solidFill>
-                <a:latin typeface="Calibri"/>
-              </a:rPr>
-              <a:t>Mali-G310</a:t>
+                  <a:srgbClr val="E8710A"/>
+                </a:solidFill>
+                <a:latin typeface="Calibri"/>
+              </a:rPr>
+              <a:t>Cortex-A55 x6</a:t>
             </a:r>
           </a:p>
         </p:txBody>
@@ -6313,7 +6380,7 @@
                 </a:solidFill>
                 <a:latin typeface="Calibri"/>
               </a:rPr>
-              <a:t>1 CU, OpenCL 3.0</a:t>
+              <a:t>i.MX 95 FRDM, 1.8 GHz, NEON  |  single core: 1,588.74 ms = 84 MDE/s</a:t>
             </a:r>
           </a:p>
         </p:txBody>
@@ -6384,11 +6451,11 @@
                 <a:latin typeface="Consolas"/>
               </a:rPr>
               <a:t>MDE/s  =  W x H x D / runtime
-        =  1,920 x 1,080 x 64 / 1,846.00 ms
-        =  132,710,400 disparity estimations / 1.84600 s
-        =  72 million disparity estimations per second
-frame rate  =  1000 / 1,846.00  =  0.5 fps
-pixel rate  =  2.0736 Mpx x 0.5  =  1.12 Mpix/s</a:t>
+        =  1,920 x 1,080 x 64 / 341.30 ms
+        =  132,710,400 disparity estimations / 0.34130 s
+        =  389 million disparity estimations per second
+frame rate  =  1000 / 341.30  =  2.9 fps
+pixel rate  =  2.0736 Mpx x 2.9  =  6.08 Mpix/s</a:t>
             </a:r>
           </a:p>
         </p:txBody>
@@ -6458,7 +6525,7 @@
                 </a:solidFill>
                 <a:latin typeface="Calibri"/>
               </a:rPr>
-              <a:t>The entry-tier part, same kernel, same hash. Its 'no compute driver'</a:t>
+              <a:t>The reference platform this project is anchored to, and the slowest CPU here.</a:t>
             </a:r>
           </a:p>
           <a:p>
@@ -6469,7 +6536,62 @@
                 </a:solidFill>
                 <a:latin typeface="Calibri"/>
               </a:rPr>
-              <a:t>reputation is wrong — it ships working OpenCL 3.0 and merely lacks clinfo.</a:t>
+              <a:t>Scales 4.65x from 1 to 6 cores (1,588.74 -&gt; 341.30 ms) -- that spread is also</a:t>
+            </a:r>
+          </a:p>
+          <a:p>
+            <a:r>
+              <a:rPr sz="1300">
+                <a:solidFill>
+                  <a:srgbClr val="202124"/>
+                </a:solidFill>
+                <a:latin typeface="Calibri"/>
+              </a:rPr>
+              <a:t>the proof that the -t thread flag was working on these runs, since the inert</a:t>
+            </a:r>
+          </a:p>
+          <a:p>
+            <a:r>
+              <a:rPr sz="1300">
+                <a:solidFill>
+                  <a:srgbClr val="202124"/>
+                </a:solidFill>
+                <a:latin typeface="Calibri"/>
+              </a:rPr>
+              <a:t>flag it was found to have would have collapsed every count to one timing.</a:t>
+            </a:r>
+          </a:p>
+          <a:p>
+            <a:r>
+              <a:rPr sz="1300">
+                <a:solidFill>
+                  <a:srgbClr val="202124"/>
+                </a:solidFill>
+                <a:latin typeface="Calibri"/>
+              </a:rPr>
+              <a:t>Per core 84 MDE/s against the A720's 423: a 5.0x gap between an in-order</a:t>
+            </a:r>
+          </a:p>
+          <a:p>
+            <a:r>
+              <a:rPr sz="1300">
+                <a:solidFill>
+                  <a:srgbClr val="202124"/>
+                </a:solidFill>
+                <a:latin typeface="Calibri"/>
+              </a:rPr>
+              <a:t>little core at 1.8 GHz and a wide out-of-order core at 2.5 GHz.</a:t>
+            </a:r>
+          </a:p>
+          <a:p>
+            <a:r>
+              <a:rPr sz="1300">
+                <a:solidFill>
+                  <a:srgbClr val="202124"/>
+                </a:solidFill>
+                <a:latin typeface="Calibri"/>
+              </a:rPr>
+              <a:t>Block-width optimum is 192 here and 256 on the A720 -- not the same number.</a:t>
             </a:r>
           </a:p>
         </p:txBody>
@@ -6577,11 +6699,11 @@
             <a:r>
               <a:rPr sz="3200" b="1">
                 <a:solidFill>
-                  <a:srgbClr val="9AA0A6"/>
-                </a:solidFill>
-                <a:latin typeface="Calibri"/>
-              </a:rPr>
-              <a:t>scalar reference</a:t>
+                  <a:srgbClr val="4C8BF5"/>
+                </a:solidFill>
+                <a:latin typeface="Calibri"/>
+              </a:rPr>
+              <a:t>Mali-G310</a:t>
             </a:r>
           </a:p>
         </p:txBody>
@@ -6616,7 +6738,7 @@
                 </a:solidFill>
                 <a:latin typeface="Calibri"/>
               </a:rPr>
-              <a:t>1x Cortex-A55, -O2, no SIMD, single thread</a:t>
+              <a:t>1 CU, OpenCL 3.0</a:t>
             </a:r>
           </a:p>
         </p:txBody>
@@ -6687,11 +6809,11 @@
                 <a:latin typeface="Consolas"/>
               </a:rPr>
               <a:t>MDE/s  =  W x H x D / runtime
-        =  1,920 x 1,080 x 64 / 9,188.00 ms
-        =  132,710,400 disparity estimations / 9.18800 s
-        =  14 million disparity estimations per second
-frame rate  =  1000 / 9,188.00  =  0.1 fps
-pixel rate  =  2.0736 Mpx x 0.1  =  0.23 Mpix/s</a:t>
+        =  1,920 x 1,080 x 64 / 1,846.00 ms
+        =  132,710,400 disparity estimations / 1.84600 s
+        =  72 million disparity estimations per second
+frame rate  =  1000 / 1,846.00  =  0.5 fps
+pixel rate  =  2.0736 Mpx x 0.5  =  1.12 Mpix/s</a:t>
             </a:r>
           </a:p>
         </p:txBody>
@@ -6761,7 +6883,7 @@
                 </a:solidFill>
                 <a:latin typeface="Calibri"/>
               </a:rPr>
-              <a:t>Deliberately boring: the oracle every other bar is checked against.</a:t>
+              <a:t>The entry-tier part, same kernel, same hash. Its 'no compute driver'</a:t>
             </a:r>
           </a:p>
           <a:p>
@@ -6772,18 +6894,7 @@
                 </a:solidFill>
                 <a:latin typeface="Calibri"/>
               </a:rPr>
-              <a:t>It defines the golden hash, so it cannot be wrong by construction —</a:t>
-            </a:r>
-          </a:p>
-          <a:p>
-            <a:r>
-              <a:rPr sz="1300">
-                <a:solidFill>
-                  <a:srgbClr val="202124"/>
-                </a:solidFill>
-                <a:latin typeface="Calibri"/>
-              </a:rPr>
-              <a:t>it can only be slow, and it is 699x slower than the fastest bar.</a:t>
+              <a:t>reputation is wrong — it ships working OpenCL 3.0 and merely lacks clinfo.</a:t>
             </a:r>
           </a:p>
         </p:txBody>
@@ -6849,43 +6960,67 @@
         </p:nvSpPr>
         <p:spPr>
           <a:xfrm>
+            <a:off x="0" y="0"/>
+            <a:ext cx="12191695" cy="109728"/>
+          </a:xfrm>
+          <a:prstGeom prst="rect">
+            <a:avLst/>
+          </a:prstGeom>
+          <a:noFill/>
+        </p:spPr>
+        <p:txBody>
+          <a:bodyPr wrap="none">
+            <a:spAutoFit/>
+          </a:bodyPr>
+          <a:lstStyle/>
+          <a:p/>
+        </p:txBody>
+      </p:sp>
+      <p:sp>
+        <p:nvSpPr>
+          <p:cNvPr id="3" name="TextBox 2"/>
+          <p:cNvSpPr txBox="1"/>
+          <p:nvPr/>
+        </p:nvSpPr>
+        <p:spPr>
+          <a:xfrm>
             <a:off x="548640" y="320040"/>
-            <a:ext cx="10972800" cy="640080"/>
-          </a:xfrm>
-          <a:prstGeom prst="rect">
-            <a:avLst/>
-          </a:prstGeom>
-          <a:noFill/>
-        </p:spPr>
-        <p:txBody>
-          <a:bodyPr wrap="square">
-            <a:spAutoFit/>
-          </a:bodyPr>
-          <a:lstStyle/>
-          <a:p>
-            <a:pPr algn="l"/>
-            <a:r>
-              <a:rPr sz="3000" b="1">
-                <a:solidFill>
-                  <a:srgbClr val="202124"/>
-                </a:solidFill>
-                <a:latin typeface="Calibri"/>
-              </a:rPr>
-              <a:t>On real stereo imagery</a:t>
-            </a:r>
-          </a:p>
-        </p:txBody>
-      </p:sp>
-      <p:sp>
-        <p:nvSpPr>
-          <p:cNvPr id="3" name="TextBox 2"/>
+            <a:ext cx="10058400" cy="640080"/>
+          </a:xfrm>
+          <a:prstGeom prst="rect">
+            <a:avLst/>
+          </a:prstGeom>
+          <a:noFill/>
+        </p:spPr>
+        <p:txBody>
+          <a:bodyPr wrap="square">
+            <a:spAutoFit/>
+          </a:bodyPr>
+          <a:lstStyle/>
+          <a:p>
+            <a:pPr algn="l"/>
+            <a:r>
+              <a:rPr sz="3200" b="1">
+                <a:solidFill>
+                  <a:srgbClr val="9AA0A6"/>
+                </a:solidFill>
+                <a:latin typeface="Calibri"/>
+              </a:rPr>
+              <a:t>scalar reference</a:t>
+            </a:r>
+          </a:p>
+        </p:txBody>
+      </p:sp>
+      <p:sp>
+        <p:nvSpPr>
+          <p:cNvPr id="4" name="TextBox 3"/>
           <p:cNvSpPr txBox="1"/>
           <p:nvPr/>
         </p:nvSpPr>
         <p:spPr>
           <a:xfrm>
             <a:off x="548640" y="914400"/>
-            <a:ext cx="10972800" cy="365760"/>
+            <a:ext cx="10058400" cy="365760"/>
           </a:xfrm>
           <a:prstGeom prst="rect">
             <a:avLst/>
@@ -6906,35 +7041,11 @@
                 </a:solidFill>
                 <a:latin typeface="Calibri"/>
               </a:rPr>
-              <a:t>Middlebury 2014 'Motorcycle' — a real calibrated two-camera capture, dense structured-light ground truth — 1482x1000, D=128</a:t>
-            </a:r>
-          </a:p>
-        </p:txBody>
-      </p:sp>
-      <p:pic>
-        <p:nvPicPr>
-          <p:cNvPr id="4" name="Picture 3" descr="motorcycle_real.png"/>
-          <p:cNvPicPr>
-            <a:picLocks noChangeAspect="1"/>
-          </p:cNvPicPr>
-          <p:nvPr/>
-        </p:nvPicPr>
-        <p:blipFill>
-          <a:blip r:embed="rId2"/>
-          <a:stretch>
-            <a:fillRect/>
-          </a:stretch>
-        </p:blipFill>
-        <p:spPr>
-          <a:xfrm>
-            <a:off x="548640" y="1371600"/>
-            <a:ext cx="11064240" cy="3288028"/>
-          </a:xfrm>
-          <a:prstGeom prst="rect">
-            <a:avLst/>
-          </a:prstGeom>
-        </p:spPr>
-      </p:pic>
+              <a:t>1x Cortex-A55, -O2, no SIMD, single thread</a:t>
+            </a:r>
+          </a:p>
+        </p:txBody>
+      </p:sp>
       <p:sp>
         <p:nvSpPr>
           <p:cNvPr id="5" name="TextBox 4"/>
@@ -6943,29 +7054,29 @@
         </p:nvSpPr>
         <p:spPr>
           <a:xfrm>
-            <a:off x="548640" y="5989320"/>
-            <a:ext cx="11155680" cy="822960"/>
-          </a:xfrm>
-          <a:prstGeom prst="rect">
-            <a:avLst/>
-          </a:prstGeom>
-          <a:noFill/>
-        </p:spPr>
-        <p:txBody>
-          <a:bodyPr wrap="square">
-            <a:spAutoFit/>
-          </a:bodyPr>
-          <a:lstStyle/>
-          <a:p>
-            <a:pPr algn="l"/>
-            <a:r>
-              <a:rPr sz="1200" b="0">
-                <a:solidFill>
-                  <a:srgbClr val="202124"/>
-                </a:solidFill>
-                <a:latin typeface="Calibri"/>
-              </a:rPr>
-              <a:t>All seven targets produce the identical golden e8a95242882013f0 — the picture is the same, only the time differs. Accuracy vs dense ground truth: bad&gt;1px 16.2%, bad&gt;2px 11.2%, MAE 3.35, independently reproduced by another party on hardware we have never touched.</a:t>
+            <a:off x="548640" y="1554480"/>
+            <a:ext cx="10515600" cy="365760"/>
+          </a:xfrm>
+          <a:prstGeom prst="rect">
+            <a:avLst/>
+          </a:prstGeom>
+          <a:noFill/>
+        </p:spPr>
+        <p:txBody>
+          <a:bodyPr wrap="square">
+            <a:spAutoFit/>
+          </a:bodyPr>
+          <a:lstStyle/>
+          <a:p>
+            <a:pPr algn="l"/>
+            <a:r>
+              <a:rPr sz="1600" b="1">
+                <a:solidFill>
+                  <a:srgbClr val="202124"/>
+                </a:solidFill>
+                <a:latin typeface="Calibri"/>
+              </a:rPr>
+              <a:t>The calculation</a:t>
             </a:r>
           </a:p>
         </p:txBody>
@@ -6978,8 +7089,140 @@
         </p:nvSpPr>
         <p:spPr>
           <a:xfrm>
-            <a:off x="548640" y="6510528"/>
-            <a:ext cx="11155680" cy="365760"/>
+            <a:off x="548640" y="1965960"/>
+            <a:ext cx="10515600" cy="2011680"/>
+          </a:xfrm>
+          <a:prstGeom prst="rect">
+            <a:avLst/>
+          </a:prstGeom>
+          <a:noFill/>
+        </p:spPr>
+        <p:txBody>
+          <a:bodyPr wrap="square">
+            <a:spAutoFit/>
+          </a:bodyPr>
+          <a:lstStyle/>
+          <a:p>
+            <a:pPr algn="l"/>
+            <a:r>
+              <a:rPr sz="1400" b="0">
+                <a:solidFill>
+                  <a:srgbClr val="202124"/>
+                </a:solidFill>
+                <a:latin typeface="Consolas"/>
+              </a:rPr>
+              <a:t>MDE/s  =  W x H x D / runtime
+        =  1,920 x 1,080 x 64 / 9,188.00 ms
+        =  132,710,400 disparity estimations / 9.18800 s
+        =  14 million disparity estimations per second
+frame rate  =  1000 / 9,188.00  =  0.1 fps
+pixel rate  =  2.0736 Mpx x 0.1  =  0.23 Mpix/s</a:t>
+            </a:r>
+          </a:p>
+        </p:txBody>
+      </p:sp>
+      <p:sp>
+        <p:nvSpPr>
+          <p:cNvPr id="7" name="TextBox 6"/>
+          <p:cNvSpPr txBox="1"/>
+          <p:nvPr/>
+        </p:nvSpPr>
+        <p:spPr>
+          <a:xfrm>
+            <a:off x="548640" y="4114800"/>
+            <a:ext cx="10515600" cy="365760"/>
+          </a:xfrm>
+          <a:prstGeom prst="rect">
+            <a:avLst/>
+          </a:prstGeom>
+          <a:noFill/>
+        </p:spPr>
+        <p:txBody>
+          <a:bodyPr wrap="square">
+            <a:spAutoFit/>
+          </a:bodyPr>
+          <a:lstStyle/>
+          <a:p>
+            <a:pPr algn="l"/>
+            <a:r>
+              <a:rPr sz="1600" b="1">
+                <a:solidFill>
+                  <a:srgbClr val="202124"/>
+                </a:solidFill>
+                <a:latin typeface="Calibri"/>
+              </a:rPr>
+              <a:t>What the measurement means</a:t>
+            </a:r>
+          </a:p>
+        </p:txBody>
+      </p:sp>
+      <p:sp>
+        <p:nvSpPr>
+          <p:cNvPr id="8" name="TextBox 7"/>
+          <p:cNvSpPr txBox="1"/>
+          <p:nvPr/>
+        </p:nvSpPr>
+        <p:spPr>
+          <a:xfrm>
+            <a:off x="548640" y="4480560"/>
+            <a:ext cx="10881360" cy="2011680"/>
+          </a:xfrm>
+          <a:prstGeom prst="rect">
+            <a:avLst/>
+          </a:prstGeom>
+          <a:noFill/>
+        </p:spPr>
+        <p:txBody>
+          <a:bodyPr wrap="square">
+            <a:spAutoFit/>
+          </a:bodyPr>
+          <a:lstStyle/>
+          <a:p>
+            <a:pPr algn="l"/>
+            <a:r>
+              <a:rPr sz="1300" b="0">
+                <a:solidFill>
+                  <a:srgbClr val="202124"/>
+                </a:solidFill>
+                <a:latin typeface="Calibri"/>
+              </a:rPr>
+              <a:t>Deliberately boring: the oracle every other bar is checked against.</a:t>
+            </a:r>
+          </a:p>
+          <a:p>
+            <a:r>
+              <a:rPr sz="1300">
+                <a:solidFill>
+                  <a:srgbClr val="202124"/>
+                </a:solidFill>
+                <a:latin typeface="Calibri"/>
+              </a:rPr>
+              <a:t>It defines the golden hash, so it cannot be wrong by construction —</a:t>
+            </a:r>
+          </a:p>
+          <a:p>
+            <a:r>
+              <a:rPr sz="1300">
+                <a:solidFill>
+                  <a:srgbClr val="202124"/>
+                </a:solidFill>
+                <a:latin typeface="Calibri"/>
+              </a:rPr>
+              <a:t>it can only be slow, and it is 699x slower than the fastest bar.</a:t>
+            </a:r>
+          </a:p>
+        </p:txBody>
+      </p:sp>
+      <p:sp>
+        <p:nvSpPr>
+          <p:cNvPr id="9" name="TextBox 8"/>
+          <p:cNvSpPr txBox="1"/>
+          <p:nvPr/>
+        </p:nvSpPr>
+        <p:spPr>
+          <a:xfrm>
+            <a:off x="548640" y="6400800"/>
+            <a:ext cx="10515600" cy="365760"/>
           </a:xfrm>
           <a:prstGeom prst="rect">
             <a:avLst/>
@@ -7000,7 +7243,7 @@
                 </a:solidFill>
                 <a:latin typeface="Calibri"/>
               </a:rPr>
-              <a:t>Real imagery is a better ACCEPTANCE test, not just a more realistic one: 14,417 pixels have a tied minimum here against 20 on the synthetic scene, so the hash-critical tie-break rule is pinned 720x harder.</a:t>
+              <a:t>MEASURED — median of the timed frames, golden hash verified in the same run.</a:t>
             </a:r>
           </a:p>
         </p:txBody>
@@ -7014,6 +7257,188 @@
 </file>
 
 <file path=ppt/slides/slide15.xml><?xml version="1.0" encoding="utf-8"?>
+<p:sld xmlns:a="http://schemas.openxmlformats.org/drawingml/2006/main" xmlns:p="http://schemas.openxmlformats.org/presentationml/2006/main" xmlns:r="http://schemas.openxmlformats.org/officeDocument/2006/relationships">
+  <p:cSld>
+    <p:spTree>
+      <p:nvGrpSpPr>
+        <p:cNvPr id="1" name=""/>
+        <p:cNvGrpSpPr/>
+        <p:nvPr/>
+      </p:nvGrpSpPr>
+      <p:grpSpPr/>
+      <p:sp>
+        <p:nvSpPr>
+          <p:cNvPr id="2" name="TextBox 1"/>
+          <p:cNvSpPr txBox="1"/>
+          <p:nvPr/>
+        </p:nvSpPr>
+        <p:spPr>
+          <a:xfrm>
+            <a:off x="548640" y="320040"/>
+            <a:ext cx="10972800" cy="640080"/>
+          </a:xfrm>
+          <a:prstGeom prst="rect">
+            <a:avLst/>
+          </a:prstGeom>
+          <a:noFill/>
+        </p:spPr>
+        <p:txBody>
+          <a:bodyPr wrap="square">
+            <a:spAutoFit/>
+          </a:bodyPr>
+          <a:lstStyle/>
+          <a:p>
+            <a:pPr algn="l"/>
+            <a:r>
+              <a:rPr sz="3000" b="1">
+                <a:solidFill>
+                  <a:srgbClr val="202124"/>
+                </a:solidFill>
+                <a:latin typeface="Calibri"/>
+              </a:rPr>
+              <a:t>On real stereo imagery</a:t>
+            </a:r>
+          </a:p>
+        </p:txBody>
+      </p:sp>
+      <p:sp>
+        <p:nvSpPr>
+          <p:cNvPr id="3" name="TextBox 2"/>
+          <p:cNvSpPr txBox="1"/>
+          <p:nvPr/>
+        </p:nvSpPr>
+        <p:spPr>
+          <a:xfrm>
+            <a:off x="548640" y="914400"/>
+            <a:ext cx="10972800" cy="365760"/>
+          </a:xfrm>
+          <a:prstGeom prst="rect">
+            <a:avLst/>
+          </a:prstGeom>
+          <a:noFill/>
+        </p:spPr>
+        <p:txBody>
+          <a:bodyPr wrap="square">
+            <a:spAutoFit/>
+          </a:bodyPr>
+          <a:lstStyle/>
+          <a:p>
+            <a:pPr algn="l"/>
+            <a:r>
+              <a:rPr sz="1300" b="0">
+                <a:solidFill>
+                  <a:srgbClr val="5F6368"/>
+                </a:solidFill>
+                <a:latin typeface="Calibri"/>
+              </a:rPr>
+              <a:t>Middlebury 2014 'Motorcycle' — a real calibrated two-camera capture, dense structured-light ground truth — 1482x1000, D=128</a:t>
+            </a:r>
+          </a:p>
+        </p:txBody>
+      </p:sp>
+      <p:pic>
+        <p:nvPicPr>
+          <p:cNvPr id="4" name="Picture 3" descr="motorcycle_real.png"/>
+          <p:cNvPicPr>
+            <a:picLocks noChangeAspect="1"/>
+          </p:cNvPicPr>
+          <p:nvPr/>
+        </p:nvPicPr>
+        <p:blipFill>
+          <a:blip r:embed="rId2"/>
+          <a:stretch>
+            <a:fillRect/>
+          </a:stretch>
+        </p:blipFill>
+        <p:spPr>
+          <a:xfrm>
+            <a:off x="548640" y="1371600"/>
+            <a:ext cx="11064240" cy="3288028"/>
+          </a:xfrm>
+          <a:prstGeom prst="rect">
+            <a:avLst/>
+          </a:prstGeom>
+        </p:spPr>
+      </p:pic>
+      <p:sp>
+        <p:nvSpPr>
+          <p:cNvPr id="5" name="TextBox 4"/>
+          <p:cNvSpPr txBox="1"/>
+          <p:nvPr/>
+        </p:nvSpPr>
+        <p:spPr>
+          <a:xfrm>
+            <a:off x="548640" y="5989320"/>
+            <a:ext cx="11155680" cy="822960"/>
+          </a:xfrm>
+          <a:prstGeom prst="rect">
+            <a:avLst/>
+          </a:prstGeom>
+          <a:noFill/>
+        </p:spPr>
+        <p:txBody>
+          <a:bodyPr wrap="square">
+            <a:spAutoFit/>
+          </a:bodyPr>
+          <a:lstStyle/>
+          <a:p>
+            <a:pPr algn="l"/>
+            <a:r>
+              <a:rPr sz="1200" b="0">
+                <a:solidFill>
+                  <a:srgbClr val="202124"/>
+                </a:solidFill>
+                <a:latin typeface="Calibri"/>
+              </a:rPr>
+              <a:t>All seven targets produce the identical golden e8a95242882013f0 — the picture is the same, only the time differs. Accuracy vs dense ground truth: bad&gt;1px 16.2%, bad&gt;2px 11.2%, MAE 3.35, independently reproduced by another party on hardware we have never touched.</a:t>
+            </a:r>
+          </a:p>
+        </p:txBody>
+      </p:sp>
+      <p:sp>
+        <p:nvSpPr>
+          <p:cNvPr id="6" name="TextBox 5"/>
+          <p:cNvSpPr txBox="1"/>
+          <p:nvPr/>
+        </p:nvSpPr>
+        <p:spPr>
+          <a:xfrm>
+            <a:off x="548640" y="6510528"/>
+            <a:ext cx="11155680" cy="365760"/>
+          </a:xfrm>
+          <a:prstGeom prst="rect">
+            <a:avLst/>
+          </a:prstGeom>
+          <a:noFill/>
+        </p:spPr>
+        <p:txBody>
+          <a:bodyPr wrap="square">
+            <a:spAutoFit/>
+          </a:bodyPr>
+          <a:lstStyle/>
+          <a:p>
+            <a:pPr algn="l"/>
+            <a:r>
+              <a:rPr sz="1100" b="0">
+                <a:solidFill>
+                  <a:srgbClr val="5F6368"/>
+                </a:solidFill>
+                <a:latin typeface="Calibri"/>
+              </a:rPr>
+              <a:t>Real imagery is a better ACCEPTANCE test, not just a more realistic one: 14,417 pixels have a tied minimum here against 20 on the synthetic scene, so the hash-critical tie-break rule is pinned 720x harder.</a:t>
+            </a:r>
+          </a:p>
+        </p:txBody>
+      </p:sp>
+    </p:spTree>
+  </p:cSld>
+  <p:clrMapOvr>
+    <a:masterClrMapping/>
+  </p:clrMapOvr>
+</p:sld>
+</file>
+
+<file path=ppt/slides/slide16.xml><?xml version="1.0" encoding="utf-8"?>
 <p:sld xmlns:a="http://schemas.openxmlformats.org/drawingml/2006/main" xmlns:p="http://schemas.openxmlformats.org/presentationml/2006/main" xmlns:r="http://schemas.openxmlformats.org/officeDocument/2006/relationships">
   <p:cSld>
     <p:spTree>
@@ -9084,7 +9509,7 @@
                 </a:solidFill>
                 <a:latin typeface="Calibri"/>
               </a:rPr>
-              <a:t>MDE/s (work) = both full-search scales count: (0.384 + 1.536) Mpx x 64 / runtime. OFA rows: the engines' OWN SGM at matched in/out geometry (1920x800 -&gt; 960x400 via downscaleFactor=2, D=128) - throughput only, not gated; full-res-out variants 9.15 / 54.94 ms. Software tiers as Configuration A.</a:t>
+              <a:t>MDE/s (work) = both full-search scales count: (0.384 + 1.536) Mpx x 64 / runtime. OFA rows: the engines' OWN SGM at matched geometry (downscaleFactor=2, D=128), throughput only; full-res-out variants 9.15 / 54.94 ms. DRAM: same silicon and MEASURED ceilings as the bandwidth slide; Config B's per-phase byte model is not separately derived, so no achieved column is claimed here.</a:t>
             </a:r>
           </a:p>
         </p:txBody>
@@ -9097,7 +9522,7 @@
 </p:sld>
 </file>
 
-<file path=ppt/slides/slide16.xml><?xml version="1.0" encoding="utf-8"?>
+<file path=ppt/slides/slide17.xml><?xml version="1.0" encoding="utf-8"?>
 <p:sld xmlns:a="http://schemas.openxmlformats.org/drawingml/2006/main" xmlns:p="http://schemas.openxmlformats.org/presentationml/2006/main" xmlns:r="http://schemas.openxmlformats.org/officeDocument/2006/relationships">
   <p:cSld>
     <p:spTree>
@@ -9279,7 +9704,7 @@
 </p:sld>
 </file>
 
-<file path=ppt/slides/slide17.xml><?xml version="1.0" encoding="utf-8"?>
+<file path=ppt/slides/slide18.xml><?xml version="1.0" encoding="utf-8"?>
 <p:sld xmlns:a="http://schemas.openxmlformats.org/drawingml/2006/main" xmlns:p="http://schemas.openxmlformats.org/presentationml/2006/main" xmlns:r="http://schemas.openxmlformats.org/officeDocument/2006/relationships">
   <p:cSld>
     <p:spTree>
@@ -11177,374 +11602,7 @@
                 </a:solidFill>
                 <a:latin typeface="Calibri"/>
               </a:rPr>
-              <a:t>A78C/NSP cells: medians of repeated invocations (bimodal board). OFA rows: matched geometry, OWN algorithm at D=128 — not bit-exact, MDE/s(work) undefined.</a:t>
-            </a:r>
-          </a:p>
-        </p:txBody>
-      </p:sp>
-    </p:spTree>
-  </p:cSld>
-  <p:clrMapOvr>
-    <a:masterClrMapping/>
-  </p:clrMapOvr>
-</p:sld>
-</file>
-
-<file path=ppt/slides/slide18.xml><?xml version="1.0" encoding="utf-8"?>
-<p:sld xmlns:a="http://schemas.openxmlformats.org/drawingml/2006/main" xmlns:p="http://schemas.openxmlformats.org/presentationml/2006/main" xmlns:r="http://schemas.openxmlformats.org/officeDocument/2006/relationships">
-  <p:cSld>
-    <p:spTree>
-      <p:nvGrpSpPr>
-        <p:cNvPr id="1" name=""/>
-        <p:cNvGrpSpPr/>
-        <p:nvPr/>
-      </p:nvGrpSpPr>
-      <p:grpSpPr/>
-      <p:sp>
-        <p:nvSpPr>
-          <p:cNvPr id="2" name="TextBox 1"/>
-          <p:cNvSpPr txBox="1"/>
-          <p:nvPr/>
-        </p:nvSpPr>
-        <p:spPr>
-          <a:xfrm>
-            <a:off x="548640" y="320040"/>
-            <a:ext cx="10058400" cy="640080"/>
-          </a:xfrm>
-          <a:prstGeom prst="rect">
-            <a:avLst/>
-          </a:prstGeom>
-          <a:noFill/>
-        </p:spPr>
-        <p:txBody>
-          <a:bodyPr wrap="square">
-            <a:spAutoFit/>
-          </a:bodyPr>
-          <a:lstStyle/>
-          <a:p>
-            <a:pPr algn="l"/>
-            <a:r>
-              <a:rPr sz="3200" b="1">
-                <a:solidFill>
-                  <a:srgbClr val="4C8BF5"/>
-                </a:solidFill>
-                <a:latin typeface="Calibri"/>
-              </a:rPr>
-              <a:t>NVIDIA RTX 5090</a:t>
-            </a:r>
-          </a:p>
-        </p:txBody>
-      </p:sp>
-      <p:sp>
-        <p:nvSpPr>
-          <p:cNvPr id="3" name="TextBox 2"/>
-          <p:cNvSpPr txBox="1"/>
-          <p:nvPr/>
-        </p:nvSpPr>
-        <p:spPr>
-          <a:xfrm>
-            <a:off x="9509760" y="457200"/>
-            <a:ext cx="2194560" cy="365760"/>
-          </a:xfrm>
-          <a:prstGeom prst="rect">
-            <a:avLst/>
-          </a:prstGeom>
-          <a:noFill/>
-        </p:spPr>
-        <p:txBody>
-          <a:bodyPr wrap="square">
-            <a:spAutoFit/>
-          </a:bodyPr>
-          <a:lstStyle/>
-          <a:p>
-            <a:pPr algn="l"/>
-            <a:r>
-              <a:rPr sz="1200" b="1">
-                <a:solidFill>
-                  <a:srgbClr val="5F6368"/>
-                </a:solidFill>
-                <a:latin typeface="Calibri"/>
-              </a:rPr>
-              <a:t>CONFIGURATION B</a:t>
-            </a:r>
-          </a:p>
-        </p:txBody>
-      </p:sp>
-      <p:sp>
-        <p:nvSpPr>
-          <p:cNvPr id="4" name="TextBox 3"/>
-          <p:cNvSpPr txBox="1"/>
-          <p:nvPr/>
-        </p:nvSpPr>
-        <p:spPr>
-          <a:xfrm>
-            <a:off x="548640" y="914400"/>
-            <a:ext cx="10881360" cy="365760"/>
-          </a:xfrm>
-          <a:prstGeom prst="rect">
-            <a:avLst/>
-          </a:prstGeom>
-          <a:noFill/>
-        </p:spPr>
-        <p:txBody>
-          <a:bodyPr wrap="square">
-            <a:spAutoFit/>
-          </a:bodyPr>
-          <a:lstStyle/>
-          <a:p>
-            <a:pPr algn="l"/>
-            <a:r>
-              <a:rPr sz="1300" b="0">
-                <a:solidFill>
-                  <a:srgbClr val="5F6368"/>
-                </a:solidFill>
-                <a:latin typeface="Calibri"/>
-              </a:rPr>
-              <a:t>CUDA, tuned  |  canonical: median of 5 invocations x 20 frames, 0.1% spread on a quiet card</a:t>
-            </a:r>
-          </a:p>
-        </p:txBody>
-      </p:sp>
-      <p:sp>
-        <p:nvSpPr>
-          <p:cNvPr id="5" name="TextBox 4"/>
-          <p:cNvSpPr txBox="1"/>
-          <p:nvPr/>
-        </p:nvSpPr>
-        <p:spPr>
-          <a:xfrm>
-            <a:off x="548640" y="1554480"/>
-            <a:ext cx="10515600" cy="365760"/>
-          </a:xfrm>
-          <a:prstGeom prst="rect">
-            <a:avLst/>
-          </a:prstGeom>
-          <a:noFill/>
-        </p:spPr>
-        <p:txBody>
-          <a:bodyPr wrap="square">
-            <a:spAutoFit/>
-          </a:bodyPr>
-          <a:lstStyle/>
-          <a:p>
-            <a:pPr algn="l"/>
-            <a:r>
-              <a:rPr sz="1600" b="1">
-                <a:solidFill>
-                  <a:srgbClr val="202124"/>
-                </a:solidFill>
-                <a:latin typeface="Calibri"/>
-              </a:rPr>
-              <a:t>The calculation (work-performed convention)</a:t>
-            </a:r>
-          </a:p>
-        </p:txBody>
-      </p:sp>
-      <p:sp>
-        <p:nvSpPr>
-          <p:cNvPr id="6" name="TextBox 5"/>
-          <p:cNvSpPr txBox="1"/>
-          <p:nvPr/>
-        </p:nvSpPr>
-        <p:spPr>
-          <a:xfrm>
-            <a:off x="548640" y="1965960"/>
-            <a:ext cx="10881360" cy="1554480"/>
-          </a:xfrm>
-          <a:prstGeom prst="rect">
-            <a:avLst/>
-          </a:prstGeom>
-          <a:noFill/>
-        </p:spPr>
-        <p:txBody>
-          <a:bodyPr wrap="square">
-            <a:spAutoFit/>
-          </a:bodyPr>
-          <a:lstStyle/>
-          <a:p>
-            <a:pPr algn="l"/>
-            <a:r>
-              <a:rPr sz="1400" b="0">
-                <a:solidFill>
-                  <a:srgbClr val="202124"/>
-                </a:solidFill>
-                <a:latin typeface="Consolas"/>
-              </a:rPr>
-              <a:t>MDE/s  =  (0.384 + 1.536) Mpx x 64 / runtime      (both full-search scales count)
-        =  122,880,000 disparity estimations / 0.00908 s
-        =  13,533 million disparity estimations per second
-frame rate  =  1000 / 9.08  =  110.13 fps   (960x400 disparity map out)</a:t>
-            </a:r>
-          </a:p>
-        </p:txBody>
-      </p:sp>
-      <p:sp>
-        <p:nvSpPr>
-          <p:cNvPr id="7" name="TextBox 6"/>
-          <p:cNvSpPr txBox="1"/>
-          <p:nvPr/>
-        </p:nvSpPr>
-        <p:spPr>
-          <a:xfrm>
-            <a:off x="548640" y="3657600"/>
-            <a:ext cx="10515600" cy="365760"/>
-          </a:xfrm>
-          <a:prstGeom prst="rect">
-            <a:avLst/>
-          </a:prstGeom>
-          <a:noFill/>
-        </p:spPr>
-        <p:txBody>
-          <a:bodyPr wrap="square">
-            <a:spAutoFit/>
-          </a:bodyPr>
-          <a:lstStyle/>
-          <a:p>
-            <a:pPr algn="l"/>
-            <a:r>
-              <a:rPr sz="1600" b="1">
-                <a:solidFill>
-                  <a:srgbClr val="202124"/>
-                </a:solidFill>
-                <a:latin typeface="Calibri"/>
-              </a:rPr>
-              <a:t>What the measurement means</a:t>
-            </a:r>
-          </a:p>
-        </p:txBody>
-      </p:sp>
-      <p:sp>
-        <p:nvSpPr>
-          <p:cNvPr id="8" name="TextBox 7"/>
-          <p:cNvSpPr txBox="1"/>
-          <p:nvPr/>
-        </p:nvSpPr>
-        <p:spPr>
-          <a:xfrm>
-            <a:off x="548640" y="4023360"/>
-            <a:ext cx="10881360" cy="2286000"/>
-          </a:xfrm>
-          <a:prstGeom prst="rect">
-            <a:avLst/>
-          </a:prstGeom>
-          <a:noFill/>
-        </p:spPr>
-        <p:txBody>
-          <a:bodyPr wrap="square">
-            <a:spAutoFit/>
-          </a:bodyPr>
-          <a:lstStyle/>
-          <a:p>
-            <a:pPr algn="l"/>
-            <a:r>
-              <a:rPr sz="1300" b="0">
-                <a:solidFill>
-                  <a:srgbClr val="202124"/>
-                </a:solidFill>
-                <a:latin typeface="Calibri"/>
-              </a:rPr>
-              <a:t>The fastest Configuration B target: 110 fps of two-scale, 8-path, weighted-P1</a:t>
-            </a:r>
-          </a:p>
-          <a:p>
-            <a:r>
-              <a:rPr sz="1300">
-                <a:solidFill>
-                  <a:srgbClr val="202124"/>
-                </a:solidFill>
-                <a:latin typeface="Calibri"/>
-              </a:rPr>
-              <a:t>SGM on a workload designed for a fixed-function embedded block.</a:t>
-            </a:r>
-          </a:p>
-          <a:p>
-            <a:r>
-              <a:rPr sz="1300">
-                <a:solidFill>
-                  <a:srgbClr val="202124"/>
-                </a:solidFill>
-                <a:latin typeface="Calibri"/>
-              </a:rPr>
-              <a:t>The port is a GENERIC path kernel: one warp owns one path line in any of the 8</a:t>
-            </a:r>
-          </a:p>
-          <a:p>
-            <a:r>
-              <a:rPr sz="1300">
-                <a:solidFill>
-                  <a:srgbClr val="202124"/>
-                </a:solidFill>
-                <a:latin typeface="Calibri"/>
-              </a:rPr>
-              <a:t>directions, line start derived from the direction pair, P1 passed per launch</a:t>
-            </a:r>
-          </a:p>
-          <a:p>
-            <a:r>
-              <a:rPr sz="1300">
-                <a:solidFill>
-                  <a:srgbClr val="202124"/>
-                </a:solidFill>
-                <a:latin typeface="Calibri"/>
-              </a:rPr>
-              <a:t>so the direction weighting costs nothing. Bit-exact on the first full run.</a:t>
-            </a:r>
-          </a:p>
-          <a:p>
-            <a:r>
-              <a:rPr sz="1300">
-                <a:solidFill>
-                  <a:srgbClr val="202124"/>
-                </a:solidFill>
-                <a:latin typeface="Calibri"/>
-              </a:rPr>
-              <a:t>It lacks the primary kernel's path-pairing pass, so this row is the</a:t>
-            </a:r>
-          </a:p>
-          <a:p>
-            <a:r>
-              <a:rPr sz="1300">
-                <a:solidFill>
-                  <a:srgbClr val="202124"/>
-                </a:solidFill>
-                <a:latin typeface="Calibri"/>
-              </a:rPr>
-              <a:t>conservative side of what the card can do.</a:t>
-            </a:r>
-          </a:p>
-        </p:txBody>
-      </p:sp>
-      <p:sp>
-        <p:nvSpPr>
-          <p:cNvPr id="9" name="TextBox 8"/>
-          <p:cNvSpPr txBox="1"/>
-          <p:nvPr/>
-        </p:nvSpPr>
-        <p:spPr>
-          <a:xfrm>
-            <a:off x="548640" y="6446520"/>
-            <a:ext cx="10881360" cy="365760"/>
-          </a:xfrm>
-          <a:prstGeom prst="rect">
-            <a:avLst/>
-          </a:prstGeom>
-          <a:noFill/>
-        </p:spPr>
-        <p:txBody>
-          <a:bodyPr wrap="square">
-            <a:spAutoFit/>
-          </a:bodyPr>
-          <a:lstStyle/>
-          <a:p>
-            <a:pPr algn="l"/>
-            <a:r>
-              <a:rPr sz="1100" b="0">
-                <a:solidFill>
-                  <a:srgbClr val="5F6368"/>
-                </a:solidFill>
-                <a:latin typeface="Calibri"/>
-              </a:rPr>
-              <a:t>MEASURED -- median of the timed frames, bit-exact to golden bcb9cb0bd6f49799 in the same run.</a:t>
+              <a:t>A78C/NSP cells: medians of repeated invocations (bimodal board). OFA rows: matched geometry, OWN algorithm at D=128 — not bit-exact, MDE/s(work) undefined. DRAM: ceilings as on the bandwidth slide; no per-phase achieved bytes derived for C.</a:t>
             </a:r>
           </a:p>
         </p:txBody>
@@ -11597,7 +11655,7 @@
                 </a:solidFill>
                 <a:latin typeface="Calibri"/>
               </a:rPr>
-              <a:t>NVIDIA Thor</a:t>
+              <a:t>NVIDIA RTX 5090</a:t>
             </a:r>
           </a:p>
         </p:txBody>
@@ -11667,7 +11725,7 @@
                 </a:solidFill>
                 <a:latin typeface="Calibri"/>
               </a:rPr>
-              <a:t>CUDA, same kernel, sm_110</a:t>
+              <a:t>CUDA, tuned  |  canonical: median of 5 invocations x 20 frames, 0.1% spread on a quiet card</a:t>
             </a:r>
           </a:p>
         </p:txBody>
@@ -11738,9 +11796,9 @@
                 <a:latin typeface="Consolas"/>
               </a:rPr>
               <a:t>MDE/s  =  (0.384 + 1.536) Mpx x 64 / runtime      (both full-search scales count)
-        =  122,880,000 disparity estimations / 0.04510 s
-        =  2,725 million disparity estimations per second
-frame rate  =  1000 / 45.10  =  22.17 fps   (960x400 disparity map out)</a:t>
+        =  122,880,000 disparity estimations / 0.00908 s
+        =  13,533 million disparity estimations per second
+frame rate  =  1000 / 9.08  =  110.13 fps   (960x400 disparity map out)</a:t>
             </a:r>
           </a:p>
         </p:txBody>
@@ -11810,7 +11868,7 @@
                 </a:solidFill>
                 <a:latin typeface="Calibri"/>
               </a:rPr>
-              <a:t>22 fps embedded. Same generic 8-direction kernel as the 5090, bit-exact.</a:t>
+              <a:t>The fastest Configuration B target: 110 fps of two-scale, 8-path, weighted-P1</a:t>
             </a:r>
           </a:p>
           <a:p>
@@ -11821,7 +11879,7 @@
                 </a:solidFill>
                 <a:latin typeface="Calibri"/>
               </a:rPr>
-              <a:t>The gap to the 5090 (5.0x) is close to the bandwidth ratio of the parts,</a:t>
+              <a:t>SGM on a workload designed for a fixed-function embedded block.</a:t>
             </a:r>
           </a:p>
           <a:p>
@@ -11832,7 +11890,7 @@
                 </a:solidFill>
                 <a:latin typeface="Calibri"/>
               </a:rPr>
-              <a:t>consistent with the Configuration A finding that tuned SGM converges on</a:t>
+              <a:t>The port is a GENERIC path kernel: one warp owns one path line in any of the 8</a:t>
             </a:r>
           </a:p>
           <a:p>
@@ -11843,7 +11901,40 @@
                 </a:solidFill>
                 <a:latin typeface="Calibri"/>
               </a:rPr>
-              <a:t>memory traffic once the arithmetic is done.</a:t>
+              <a:t>directions, line start derived from the direction pair, P1 passed per launch</a:t>
+            </a:r>
+          </a:p>
+          <a:p>
+            <a:r>
+              <a:rPr sz="1300">
+                <a:solidFill>
+                  <a:srgbClr val="202124"/>
+                </a:solidFill>
+                <a:latin typeface="Calibri"/>
+              </a:rPr>
+              <a:t>so the direction weighting costs nothing. Bit-exact on the first full run.</a:t>
+            </a:r>
+          </a:p>
+          <a:p>
+            <a:r>
+              <a:rPr sz="1300">
+                <a:solidFill>
+                  <a:srgbClr val="202124"/>
+                </a:solidFill>
+                <a:latin typeface="Calibri"/>
+              </a:rPr>
+              <a:t>It lacks the primary kernel's path-pairing pass, so this row is the</a:t>
+            </a:r>
+          </a:p>
+          <a:p>
+            <a:r>
+              <a:rPr sz="1300">
+                <a:solidFill>
+                  <a:srgbClr val="202124"/>
+                </a:solidFill>
+                <a:latin typeface="Calibri"/>
+              </a:rPr>
+              <a:t>conservative side of what the card can do.</a:t>
             </a:r>
           </a:p>
         </p:txBody>
@@ -11909,20 +12000,31 @@
         </p:nvSpPr>
         <p:spPr>
           <a:xfrm>
-            <a:off x="0" y="0"/>
-            <a:ext cx="12191695" cy="109728"/>
-          </a:xfrm>
-          <a:prstGeom prst="rect">
-            <a:avLst/>
-          </a:prstGeom>
-          <a:noFill/>
-        </p:spPr>
-        <p:txBody>
-          <a:bodyPr wrap="none">
-            <a:spAutoFit/>
-          </a:bodyPr>
-          <a:lstStyle/>
-          <a:p/>
+            <a:off x="548640" y="292608"/>
+            <a:ext cx="11155680" cy="731520"/>
+          </a:xfrm>
+          <a:prstGeom prst="rect">
+            <a:avLst/>
+          </a:prstGeom>
+          <a:noFill/>
+        </p:spPr>
+        <p:txBody>
+          <a:bodyPr wrap="square">
+            <a:spAutoFit/>
+          </a:bodyPr>
+          <a:lstStyle/>
+          <a:p>
+            <a:pPr algn="l"/>
+            <a:r>
+              <a:rPr sz="3000" b="1">
+                <a:solidFill>
+                  <a:srgbClr val="202124"/>
+                </a:solidFill>
+                <a:latin typeface="Calibri"/>
+              </a:rPr>
+              <a:t>This workload is about moving data</a:t>
+            </a:r>
+          </a:p>
         </p:txBody>
       </p:sp>
       <p:sp>
@@ -11933,68 +12035,1023 @@
         </p:nvSpPr>
         <p:spPr>
           <a:xfrm>
-            <a:off x="548640" y="320040"/>
-            <a:ext cx="10058400" cy="640080"/>
-          </a:xfrm>
-          <a:prstGeom prst="rect">
-            <a:avLst/>
-          </a:prstGeom>
-          <a:noFill/>
-        </p:spPr>
-        <p:txBody>
-          <a:bodyPr wrap="square">
-            <a:spAutoFit/>
-          </a:bodyPr>
-          <a:lstStyle/>
-          <a:p>
-            <a:pPr algn="l"/>
-            <a:r>
-              <a:rPr sz="3200" b="1">
-                <a:solidFill>
-                  <a:srgbClr val="4C8BF5"/>
-                </a:solidFill>
-                <a:latin typeface="Calibri"/>
-              </a:rPr>
-              <a:t>NVIDIA Thor GPU</a:t>
-            </a:r>
-          </a:p>
-        </p:txBody>
-      </p:sp>
-      <p:sp>
-        <p:nvSpPr>
-          <p:cNvPr id="4" name="TextBox 3"/>
-          <p:cNvSpPr txBox="1"/>
-          <p:nvPr/>
-        </p:nvSpPr>
-        <p:spPr>
-          <a:xfrm>
-            <a:off x="548640" y="914400"/>
-            <a:ext cx="10058400" cy="365760"/>
-          </a:xfrm>
-          <a:prstGeom prst="rect">
-            <a:avLst/>
-          </a:prstGeom>
-          <a:noFill/>
-        </p:spPr>
-        <p:txBody>
-          <a:bodyPr wrap="square">
-            <a:spAutoFit/>
-          </a:bodyPr>
-          <a:lstStyle/>
-          <a:p>
-            <a:pPr algn="l"/>
-            <a:r>
-              <a:rPr sz="1300" b="0">
+            <a:off x="548640" y="1005840"/>
+            <a:ext cx="11155680" cy="457200"/>
+          </a:xfrm>
+          <a:prstGeom prst="rect">
+            <a:avLst/>
+          </a:prstGeom>
+          <a:noFill/>
+        </p:spPr>
+        <p:txBody>
+          <a:bodyPr wrap="square">
+            <a:spAutoFit/>
+          </a:bodyPr>
+          <a:lstStyle/>
+          <a:p>
+            <a:pPr algn="l"/>
+            <a:r>
+              <a:rPr sz="1200" b="0">
                 <a:solidFill>
                   <a:srgbClr val="5F6368"/>
                 </a:solidFill>
                 <a:latin typeface="Calibri"/>
               </a:rPr>
-              <a:t>Blackwell, 20 SM, CUDA 13.2, sm_110</a:t>
-            </a:r>
-          </a:p>
-        </p:txBody>
-      </p:sp>
+              <a:t>At 1080p D=64 the aggregation phase alone streams 1.46 GB per frame (the summed cost volume is 265 MB, touched four times). Every ceiling is MEASURED with a streaming-copy probe on the part itself; every achieved figure is DERIVED as the kernel's exact modelled byte count / the measured phase time.</a:t>
+            </a:r>
+          </a:p>
+        </p:txBody>
+      </p:sp>
+      <p:graphicFrame>
+        <p:nvGraphicFramePr>
+          <p:cNvPr id="4" name="Table 3"/>
+          <p:cNvGraphicFramePr>
+            <a:graphicFrameLocks noGrp="1"/>
+          </p:cNvGraphicFramePr>
+          <p:nvPr/>
+        </p:nvGraphicFramePr>
+        <p:xfrm>
+          <a:off x="548640" y="1828800"/>
+          <a:ext cx="11064240" cy="2798064"/>
+        </p:xfrm>
+        <a:graphic>
+          <a:graphicData uri="http://schemas.openxmlformats.org/drawingml/2006/table">
+            <a:tbl>
+              <a:tblPr firstRow="1" bandRow="1">
+                <a:tableStyleId>{5C22544A-7EE6-4342-B048-85BDC9FD1C3A}</a:tableStyleId>
+              </a:tblPr>
+              <a:tblGrid>
+                <a:gridCol w="2377440"/>
+                <a:gridCol w="1371600"/>
+                <a:gridCol w="1463040"/>
+                <a:gridCol w="1371600"/>
+                <a:gridCol w="1005840"/>
+                <a:gridCol w="3474720"/>
+              </a:tblGrid>
+              <a:tr h="310896">
+                <a:tc>
+                  <a:txBody>
+                    <a:bodyPr/>
+                    <a:lstStyle/>
+                    <a:p>
+                      <a:r>
+                        <a:rPr sz="1100" b="1">
+                          <a:solidFill>
+                            <a:srgbClr val="FFFFFF"/>
+                          </a:solidFill>
+                        </a:rPr>
+                        <a:t>processing unit</a:t>
+                      </a:r>
+                    </a:p>
+                  </a:txBody>
+                  <a:tcPr>
+                    <a:solidFill>
+                      <a:srgbClr val="202124"/>
+                    </a:solidFill>
+                  </a:tcPr>
+                </a:tc>
+                <a:tc>
+                  <a:txBody>
+                    <a:bodyPr/>
+                    <a:lstStyle/>
+                    <a:p>
+                      <a:r>
+                        <a:rPr sz="1100" b="1">
+                          <a:solidFill>
+                            <a:srgbClr val="FFFFFF"/>
+                          </a:solidFill>
+                        </a:rPr>
+                        <a:t>aggregate</a:t>
+                      </a:r>
+                    </a:p>
+                  </a:txBody>
+                  <a:tcPr>
+                    <a:solidFill>
+                      <a:srgbClr val="202124"/>
+                    </a:solidFill>
+                  </a:tcPr>
+                </a:tc>
+                <a:tc>
+                  <a:txBody>
+                    <a:bodyPr/>
+                    <a:lstStyle/>
+                    <a:p>
+                      <a:r>
+                        <a:rPr sz="1100" b="1">
+                          <a:solidFill>
+                            <a:srgbClr val="FFFFFF"/>
+                          </a:solidFill>
+                        </a:rPr>
+                        <a:t>achieved GB/s</a:t>
+                      </a:r>
+                    </a:p>
+                  </a:txBody>
+                  <a:tcPr>
+                    <a:solidFill>
+                      <a:srgbClr val="202124"/>
+                    </a:solidFill>
+                  </a:tcPr>
+                </a:tc>
+                <a:tc>
+                  <a:txBody>
+                    <a:bodyPr/>
+                    <a:lstStyle/>
+                    <a:p>
+                      <a:r>
+                        <a:rPr sz="1100" b="1">
+                          <a:solidFill>
+                            <a:srgbClr val="FFFFFF"/>
+                          </a:solidFill>
+                        </a:rPr>
+                        <a:t>ceiling GB/s</a:t>
+                      </a:r>
+                    </a:p>
+                  </a:txBody>
+                  <a:tcPr>
+                    <a:solidFill>
+                      <a:srgbClr val="202124"/>
+                    </a:solidFill>
+                  </a:tcPr>
+                </a:tc>
+                <a:tc>
+                  <a:txBody>
+                    <a:bodyPr/>
+                    <a:lstStyle/>
+                    <a:p>
+                      <a:r>
+                        <a:rPr sz="1100" b="1">
+                          <a:solidFill>
+                            <a:srgbClr val="FFFFFF"/>
+                          </a:solidFill>
+                        </a:rPr>
+                        <a:t>util</a:t>
+                      </a:r>
+                    </a:p>
+                  </a:txBody>
+                  <a:tcPr>
+                    <a:solidFill>
+                      <a:srgbClr val="202124"/>
+                    </a:solidFill>
+                  </a:tcPr>
+                </a:tc>
+                <a:tc>
+                  <a:txBody>
+                    <a:bodyPr/>
+                    <a:lstStyle/>
+                    <a:p>
+                      <a:r>
+                        <a:rPr sz="1100" b="1">
+                          <a:solidFill>
+                            <a:srgbClr val="FFFFFF"/>
+                          </a:solidFill>
+                        </a:rPr>
+                        <a:t>wall</a:t>
+                      </a:r>
+                    </a:p>
+                  </a:txBody>
+                  <a:tcPr>
+                    <a:solidFill>
+                      <a:srgbClr val="202124"/>
+                    </a:solidFill>
+                  </a:tcPr>
+                </a:tc>
+              </a:tr>
+              <a:tr h="310896">
+                <a:tc>
+                  <a:txBody>
+                    <a:bodyPr/>
+                    <a:lstStyle/>
+                    <a:p>
+                      <a:r>
+                        <a:rPr sz="1100" b="1">
+                          <a:solidFill>
+                            <a:srgbClr val="202124"/>
+                          </a:solidFill>
+                        </a:rPr>
+                        <a:t>NVIDIA RTX 5090</a:t>
+                      </a:r>
+                    </a:p>
+                  </a:txBody>
+                  <a:tcPr/>
+                </a:tc>
+                <a:tc>
+                  <a:txBody>
+                    <a:bodyPr/>
+                    <a:lstStyle/>
+                    <a:p>
+                      <a:r>
+                        <a:rPr sz="1100" b="0">
+                          <a:solidFill>
+                            <a:srgbClr val="202124"/>
+                          </a:solidFill>
+                        </a:rPr>
+                        <a:t>2.49 ms</a:t>
+                      </a:r>
+                    </a:p>
+                  </a:txBody>
+                  <a:tcPr/>
+                </a:tc>
+                <a:tc>
+                  <a:txBody>
+                    <a:bodyPr/>
+                    <a:lstStyle/>
+                    <a:p>
+                      <a:r>
+                        <a:rPr sz="1100" b="1">
+                          <a:solidFill>
+                            <a:srgbClr val="202124"/>
+                          </a:solidFill>
+                        </a:rPr>
+                        <a:t>587</a:t>
+                      </a:r>
+                    </a:p>
+                  </a:txBody>
+                  <a:tcPr/>
+                </a:tc>
+                <a:tc>
+                  <a:txBody>
+                    <a:bodyPr/>
+                    <a:lstStyle/>
+                    <a:p>
+                      <a:r>
+                        <a:rPr sz="1100" b="0">
+                          <a:solidFill>
+                            <a:srgbClr val="202124"/>
+                          </a:solidFill>
+                        </a:rPr>
+                        <a:t>1,385</a:t>
+                      </a:r>
+                    </a:p>
+                  </a:txBody>
+                  <a:tcPr/>
+                </a:tc>
+                <a:tc>
+                  <a:txBody>
+                    <a:bodyPr/>
+                    <a:lstStyle/>
+                    <a:p>
+                      <a:r>
+                        <a:rPr sz="1100" b="0">
+                          <a:solidFill>
+                            <a:srgbClr val="202124"/>
+                          </a:solidFill>
+                        </a:rPr>
+                        <a:t>42%</a:t>
+                      </a:r>
+                    </a:p>
+                  </a:txBody>
+                  <a:tcPr/>
+                </a:tc>
+                <a:tc>
+                  <a:txBody>
+                    <a:bodyPr/>
+                    <a:lstStyle/>
+                    <a:p>
+                      <a:r>
+                        <a:rPr sz="1100" b="0">
+                          <a:solidFill>
+                            <a:srgbClr val="202124"/>
+                          </a:solidFill>
+                        </a:rPr>
+                        <a:t>memory-bound -- and the LEAST efficient of the three</a:t>
+                      </a:r>
+                    </a:p>
+                  </a:txBody>
+                  <a:tcPr/>
+                </a:tc>
+              </a:tr>
+              <a:tr h="310896">
+                <a:tc>
+                  <a:txBody>
+                    <a:bodyPr/>
+                    <a:lstStyle/>
+                    <a:p>
+                      <a:r>
+                        <a:rPr sz="1100" b="1">
+                          <a:solidFill>
+                            <a:srgbClr val="202124"/>
+                          </a:solidFill>
+                        </a:rPr>
+                        <a:t>NVIDIA Thor</a:t>
+                      </a:r>
+                    </a:p>
+                  </a:txBody>
+                  <a:tcPr/>
+                </a:tc>
+                <a:tc>
+                  <a:txBody>
+                    <a:bodyPr/>
+                    <a:lstStyle/>
+                    <a:p>
+                      <a:r>
+                        <a:rPr sz="1100" b="0">
+                          <a:solidFill>
+                            <a:srgbClr val="202124"/>
+                          </a:solidFill>
+                        </a:rPr>
+                        <a:t>10.04 ms</a:t>
+                      </a:r>
+                    </a:p>
+                  </a:txBody>
+                  <a:tcPr/>
+                </a:tc>
+                <a:tc>
+                  <a:txBody>
+                    <a:bodyPr/>
+                    <a:lstStyle/>
+                    <a:p>
+                      <a:r>
+                        <a:rPr sz="1100" b="1">
+                          <a:solidFill>
+                            <a:srgbClr val="202124"/>
+                          </a:solidFill>
+                        </a:rPr>
+                        <a:t>145</a:t>
+                      </a:r>
+                    </a:p>
+                  </a:txBody>
+                  <a:tcPr/>
+                </a:tc>
+                <a:tc>
+                  <a:txBody>
+                    <a:bodyPr/>
+                    <a:lstStyle/>
+                    <a:p>
+                      <a:r>
+                        <a:rPr sz="1100" b="0">
+                          <a:solidFill>
+                            <a:srgbClr val="202124"/>
+                          </a:solidFill>
+                        </a:rPr>
+                        <a:t>249</a:t>
+                      </a:r>
+                    </a:p>
+                  </a:txBody>
+                  <a:tcPr/>
+                </a:tc>
+                <a:tc>
+                  <a:txBody>
+                    <a:bodyPr/>
+                    <a:lstStyle/>
+                    <a:p>
+                      <a:r>
+                        <a:rPr sz="1100" b="0">
+                          <a:solidFill>
+                            <a:srgbClr val="202124"/>
+                          </a:solidFill>
+                        </a:rPr>
+                        <a:t>58%</a:t>
+                      </a:r>
+                    </a:p>
+                  </a:txBody>
+                  <a:tcPr/>
+                </a:tc>
+                <a:tc>
+                  <a:txBody>
+                    <a:bodyPr/>
+                    <a:lstStyle/>
+                    <a:p>
+                      <a:r>
+                        <a:rPr sz="1100" b="0">
+                          <a:solidFill>
+                            <a:srgbClr val="202124"/>
+                          </a:solidFill>
+                        </a:rPr>
+                        <a:t>memory-bound</a:t>
+                      </a:r>
+                    </a:p>
+                  </a:txBody>
+                  <a:tcPr/>
+                </a:tc>
+              </a:tr>
+              <a:tr h="310896">
+                <a:tc>
+                  <a:txBody>
+                    <a:bodyPr/>
+                    <a:lstStyle/>
+                    <a:p>
+                      <a:r>
+                        <a:rPr sz="1100" b="1">
+                          <a:solidFill>
+                            <a:srgbClr val="202124"/>
+                          </a:solidFill>
+                        </a:rPr>
+                        <a:t>NVIDIA Orin AGX</a:t>
+                      </a:r>
+                    </a:p>
+                  </a:txBody>
+                  <a:tcPr/>
+                </a:tc>
+                <a:tc>
+                  <a:txBody>
+                    <a:bodyPr/>
+                    <a:lstStyle/>
+                    <a:p>
+                      <a:r>
+                        <a:rPr sz="1100" b="0">
+                          <a:solidFill>
+                            <a:srgbClr val="202124"/>
+                          </a:solidFill>
+                        </a:rPr>
+                        <a:t>16.83 ms</a:t>
+                      </a:r>
+                    </a:p>
+                  </a:txBody>
+                  <a:tcPr/>
+                </a:tc>
+                <a:tc>
+                  <a:txBody>
+                    <a:bodyPr/>
+                    <a:lstStyle/>
+                    <a:p>
+                      <a:r>
+                        <a:rPr sz="1100" b="1">
+                          <a:solidFill>
+                            <a:srgbClr val="202124"/>
+                          </a:solidFill>
+                        </a:rPr>
+                        <a:t>87</a:t>
+                      </a:r>
+                    </a:p>
+                  </a:txBody>
+                  <a:tcPr/>
+                </a:tc>
+                <a:tc>
+                  <a:txBody>
+                    <a:bodyPr/>
+                    <a:lstStyle/>
+                    <a:p>
+                      <a:r>
+                        <a:rPr sz="1100" b="0">
+                          <a:solidFill>
+                            <a:srgbClr val="202124"/>
+                          </a:solidFill>
+                        </a:rPr>
+                        <a:t>175</a:t>
+                      </a:r>
+                    </a:p>
+                  </a:txBody>
+                  <a:tcPr/>
+                </a:tc>
+                <a:tc>
+                  <a:txBody>
+                    <a:bodyPr/>
+                    <a:lstStyle/>
+                    <a:p>
+                      <a:r>
+                        <a:rPr sz="1100" b="0">
+                          <a:solidFill>
+                            <a:srgbClr val="202124"/>
+                          </a:solidFill>
+                        </a:rPr>
+                        <a:t>49%</a:t>
+                      </a:r>
+                    </a:p>
+                  </a:txBody>
+                  <a:tcPr/>
+                </a:tc>
+                <a:tc>
+                  <a:txBody>
+                    <a:bodyPr/>
+                    <a:lstStyle/>
+                    <a:p>
+                      <a:r>
+                        <a:rPr sz="1100" b="0">
+                          <a:solidFill>
+                            <a:srgbClr val="202124"/>
+                          </a:solidFill>
+                        </a:rPr>
+                        <a:t>memory-bound</a:t>
+                      </a:r>
+                    </a:p>
+                  </a:txBody>
+                  <a:tcPr/>
+                </a:tc>
+              </a:tr>
+              <a:tr h="310896">
+                <a:tc>
+                  <a:txBody>
+                    <a:bodyPr/>
+                    <a:lstStyle/>
+                    <a:p>
+                      <a:r>
+                        <a:rPr sz="1100" b="1">
+                          <a:solidFill>
+                            <a:srgbClr val="202124"/>
+                          </a:solidFill>
+                        </a:rPr>
+                        <a:t>Mali-G720 (10 CU)</a:t>
+                      </a:r>
+                    </a:p>
+                  </a:txBody>
+                  <a:tcPr/>
+                </a:tc>
+                <a:tc>
+                  <a:txBody>
+                    <a:bodyPr/>
+                    <a:lstStyle/>
+                    <a:p>
+                      <a:r>
+                        <a:rPr sz="1100" b="0">
+                          <a:solidFill>
+                            <a:srgbClr val="202124"/>
+                          </a:solidFill>
+                        </a:rPr>
+                        <a:t>--</a:t>
+                      </a:r>
+                    </a:p>
+                  </a:txBody>
+                  <a:tcPr/>
+                </a:tc>
+                <a:tc>
+                  <a:txBody>
+                    <a:bodyPr/>
+                    <a:lstStyle/>
+                    <a:p>
+                      <a:r>
+                        <a:rPr sz="1100" b="1">
+                          <a:solidFill>
+                            <a:srgbClr val="202124"/>
+                          </a:solidFill>
+                        </a:rPr>
+                        <a:t>16.1</a:t>
+                      </a:r>
+                    </a:p>
+                  </a:txBody>
+                  <a:tcPr/>
+                </a:tc>
+                <a:tc>
+                  <a:txBody>
+                    <a:bodyPr/>
+                    <a:lstStyle/>
+                    <a:p>
+                      <a:r>
+                        <a:rPr sz="1100" b="0">
+                          <a:solidFill>
+                            <a:srgbClr val="202124"/>
+                          </a:solidFill>
+                        </a:rPr>
+                        <a:t>46.3</a:t>
+                      </a:r>
+                    </a:p>
+                  </a:txBody>
+                  <a:tcPr/>
+                </a:tc>
+                <a:tc>
+                  <a:txBody>
+                    <a:bodyPr/>
+                    <a:lstStyle/>
+                    <a:p>
+                      <a:r>
+                        <a:rPr sz="1100" b="0">
+                          <a:solidFill>
+                            <a:srgbClr val="202124"/>
+                          </a:solidFill>
+                        </a:rPr>
+                        <a:t>35%</a:t>
+                      </a:r>
+                    </a:p>
+                  </a:txBody>
+                  <a:tcPr/>
+                </a:tc>
+                <a:tc>
+                  <a:txBody>
+                    <a:bodyPr/>
+                    <a:lstStyle/>
+                    <a:p>
+                      <a:r>
+                        <a:rPr sz="1100" b="0">
+                          <a:solidFill>
+                            <a:srgbClr val="202124"/>
+                          </a:solidFill>
+                        </a:rPr>
+                        <a:t>not bandwidth-bound</a:t>
+                      </a:r>
+                    </a:p>
+                  </a:txBody>
+                  <a:tcPr/>
+                </a:tc>
+              </a:tr>
+              <a:tr h="310896">
+                <a:tc>
+                  <a:txBody>
+                    <a:bodyPr/>
+                    <a:lstStyle/>
+                    <a:p>
+                      <a:r>
+                        <a:rPr sz="1100" b="1">
+                          <a:solidFill>
+                            <a:srgbClr val="202124"/>
+                          </a:solidFill>
+                        </a:rPr>
+                        <a:t>8x Cortex-A720</a:t>
+                      </a:r>
+                    </a:p>
+                  </a:txBody>
+                  <a:tcPr/>
+                </a:tc>
+                <a:tc>
+                  <a:txBody>
+                    <a:bodyPr/>
+                    <a:lstStyle/>
+                    <a:p>
+                      <a:r>
+                        <a:rPr sz="1100" b="0">
+                          <a:solidFill>
+                            <a:srgbClr val="202124"/>
+                          </a:solidFill>
+                        </a:rPr>
+                        <a:t>--</a:t>
+                      </a:r>
+                    </a:p>
+                  </a:txBody>
+                  <a:tcPr/>
+                </a:tc>
+                <a:tc>
+                  <a:txBody>
+                    <a:bodyPr/>
+                    <a:lstStyle/>
+                    <a:p>
+                      <a:r>
+                        <a:rPr sz="1100" b="1">
+                          <a:solidFill>
+                            <a:srgbClr val="202124"/>
+                          </a:solidFill>
+                        </a:rPr>
+                        <a:t>6.6</a:t>
+                      </a:r>
+                    </a:p>
+                  </a:txBody>
+                  <a:tcPr/>
+                </a:tc>
+                <a:tc>
+                  <a:txBody>
+                    <a:bodyPr/>
+                    <a:lstStyle/>
+                    <a:p>
+                      <a:r>
+                        <a:rPr sz="1100" b="0">
+                          <a:solidFill>
+                            <a:srgbClr val="202124"/>
+                          </a:solidFill>
+                        </a:rPr>
+                        <a:t>46.3</a:t>
+                      </a:r>
+                    </a:p>
+                  </a:txBody>
+                  <a:tcPr/>
+                </a:tc>
+                <a:tc>
+                  <a:txBody>
+                    <a:bodyPr/>
+                    <a:lstStyle/>
+                    <a:p>
+                      <a:r>
+                        <a:rPr sz="1100" b="0">
+                          <a:solidFill>
+                            <a:srgbClr val="202124"/>
+                          </a:solidFill>
+                        </a:rPr>
+                        <a:t>14%</a:t>
+                      </a:r>
+                    </a:p>
+                  </a:txBody>
+                  <a:tcPr/>
+                </a:tc>
+                <a:tc>
+                  <a:txBody>
+                    <a:bodyPr/>
+                    <a:lstStyle/>
+                    <a:p>
+                      <a:r>
+                        <a:rPr sz="1100" b="0">
+                          <a:solidFill>
+                            <a:srgbClr val="202124"/>
+                          </a:solidFill>
+                        </a:rPr>
+                        <a:t>compute-bound</a:t>
+                      </a:r>
+                    </a:p>
+                  </a:txBody>
+                  <a:tcPr/>
+                </a:tc>
+              </a:tr>
+              <a:tr h="310896">
+                <a:tc>
+                  <a:txBody>
+                    <a:bodyPr/>
+                    <a:lstStyle/>
+                    <a:p>
+                      <a:r>
+                        <a:rPr sz="1100" b="1">
+                          <a:solidFill>
+                            <a:srgbClr val="202124"/>
+                          </a:solidFill>
+                        </a:rPr>
+                        <a:t>Hexagon v73 NSP</a:t>
+                      </a:r>
+                    </a:p>
+                  </a:txBody>
+                  <a:tcPr/>
+                </a:tc>
+                <a:tc>
+                  <a:txBody>
+                    <a:bodyPr/>
+                    <a:lstStyle/>
+                    <a:p>
+                      <a:r>
+                        <a:rPr sz="1100" b="0">
+                          <a:solidFill>
+                            <a:srgbClr val="202124"/>
+                          </a:solidFill>
+                        </a:rPr>
+                        <a:t>--</a:t>
+                      </a:r>
+                    </a:p>
+                  </a:txBody>
+                  <a:tcPr/>
+                </a:tc>
+                <a:tc>
+                  <a:txBody>
+                    <a:bodyPr/>
+                    <a:lstStyle/>
+                    <a:p>
+                      <a:r>
+                        <a:rPr sz="1100" b="1">
+                          <a:solidFill>
+                            <a:srgbClr val="202124"/>
+                          </a:solidFill>
+                        </a:rPr>
+                        <a:t>6.8</a:t>
+                      </a:r>
+                    </a:p>
+                  </a:txBody>
+                  <a:tcPr/>
+                </a:tc>
+                <a:tc>
+                  <a:txBody>
+                    <a:bodyPr/>
+                    <a:lstStyle/>
+                    <a:p>
+                      <a:r>
+                        <a:rPr sz="1100" b="0">
+                          <a:solidFill>
+                            <a:srgbClr val="202124"/>
+                          </a:solidFill>
+                        </a:rPr>
+                        <a:t>28</a:t>
+                      </a:r>
+                    </a:p>
+                  </a:txBody>
+                  <a:tcPr/>
+                </a:tc>
+                <a:tc>
+                  <a:txBody>
+                    <a:bodyPr/>
+                    <a:lstStyle/>
+                    <a:p>
+                      <a:r>
+                        <a:rPr sz="1100" b="0">
+                          <a:solidFill>
+                            <a:srgbClr val="202124"/>
+                          </a:solidFill>
+                        </a:rPr>
+                        <a:t>24%</a:t>
+                      </a:r>
+                    </a:p>
+                  </a:txBody>
+                  <a:tcPr/>
+                </a:tc>
+                <a:tc>
+                  <a:txBody>
+                    <a:bodyPr/>
+                    <a:lstStyle/>
+                    <a:p>
+                      <a:r>
+                        <a:rPr sz="1100" b="0">
+                          <a:solidFill>
+                            <a:srgbClr val="202124"/>
+                          </a:solidFill>
+                        </a:rPr>
+                        <a:t>LATENCY-bound (28 GB/s available, 6.8 used)</a:t>
+                      </a:r>
+                    </a:p>
+                  </a:txBody>
+                  <a:tcPr/>
+                </a:tc>
+              </a:tr>
+              <a:tr h="310896">
+                <a:tc>
+                  <a:txBody>
+                    <a:bodyPr/>
+                    <a:lstStyle/>
+                    <a:p>
+                      <a:r>
+                        <a:rPr sz="1100" b="1">
+                          <a:solidFill>
+                            <a:srgbClr val="202124"/>
+                          </a:solidFill>
+                        </a:rPr>
+                        <a:t>8x Cortex-A78C</a:t>
+                      </a:r>
+                    </a:p>
+                  </a:txBody>
+                  <a:tcPr/>
+                </a:tc>
+                <a:tc>
+                  <a:txBody>
+                    <a:bodyPr/>
+                    <a:lstStyle/>
+                    <a:p>
+                      <a:r>
+                        <a:rPr sz="1100" b="0">
+                          <a:solidFill>
+                            <a:srgbClr val="202124"/>
+                          </a:solidFill>
+                        </a:rPr>
+                        <a:t>--</a:t>
+                      </a:r>
+                    </a:p>
+                  </a:txBody>
+                  <a:tcPr/>
+                </a:tc>
+                <a:tc>
+                  <a:txBody>
+                    <a:bodyPr/>
+                    <a:lstStyle/>
+                    <a:p>
+                      <a:r>
+                        <a:rPr sz="1100" b="1">
+                          <a:solidFill>
+                            <a:srgbClr val="202124"/>
+                          </a:solidFill>
+                        </a:rPr>
+                        <a:t>3.4</a:t>
+                      </a:r>
+                    </a:p>
+                  </a:txBody>
+                  <a:tcPr/>
+                </a:tc>
+                <a:tc>
+                  <a:txBody>
+                    <a:bodyPr/>
+                    <a:lstStyle/>
+                    <a:p>
+                      <a:r>
+                        <a:rPr sz="1100" b="0">
+                          <a:solidFill>
+                            <a:srgbClr val="202124"/>
+                          </a:solidFill>
+                        </a:rPr>
+                        <a:t>--</a:t>
+                      </a:r>
+                    </a:p>
+                  </a:txBody>
+                  <a:tcPr/>
+                </a:tc>
+                <a:tc>
+                  <a:txBody>
+                    <a:bodyPr/>
+                    <a:lstStyle/>
+                    <a:p>
+                      <a:r>
+                        <a:rPr sz="1100" b="0">
+                          <a:solidFill>
+                            <a:srgbClr val="202124"/>
+                          </a:solidFill>
+                        </a:rPr>
+                        <a:t>--</a:t>
+                      </a:r>
+                    </a:p>
+                  </a:txBody>
+                  <a:tcPr/>
+                </a:tc>
+                <a:tc>
+                  <a:txBody>
+                    <a:bodyPr/>
+                    <a:lstStyle/>
+                    <a:p>
+                      <a:r>
+                        <a:rPr sz="1100" b="0">
+                          <a:solidFill>
+                            <a:srgbClr val="202124"/>
+                          </a:solidFill>
+                        </a:rPr>
+                        <a:t>ceiling unmeasured on that board -- stated, not guessed</a:t>
+                      </a:r>
+                    </a:p>
+                  </a:txBody>
+                  <a:tcPr/>
+                </a:tc>
+              </a:tr>
+              <a:tr h="310896">
+                <a:tc>
+                  <a:txBody>
+                    <a:bodyPr/>
+                    <a:lstStyle/>
+                    <a:p>
+                      <a:r>
+                        <a:rPr sz="1100" b="1">
+                          <a:solidFill>
+                            <a:srgbClr val="202124"/>
+                          </a:solidFill>
+                        </a:rPr>
+                        <a:t>6x Cortex-A55</a:t>
+                      </a:r>
+                    </a:p>
+                  </a:txBody>
+                  <a:tcPr/>
+                </a:tc>
+                <a:tc>
+                  <a:txBody>
+                    <a:bodyPr/>
+                    <a:lstStyle/>
+                    <a:p>
+                      <a:r>
+                        <a:rPr sz="1100" b="0">
+                          <a:solidFill>
+                            <a:srgbClr val="202124"/>
+                          </a:solidFill>
+                        </a:rPr>
+                        <a:t>--</a:t>
+                      </a:r>
+                    </a:p>
+                  </a:txBody>
+                  <a:tcPr/>
+                </a:tc>
+                <a:tc>
+                  <a:txBody>
+                    <a:bodyPr/>
+                    <a:lstStyle/>
+                    <a:p>
+                      <a:r>
+                        <a:rPr sz="1100" b="1">
+                          <a:solidFill>
+                            <a:srgbClr val="202124"/>
+                          </a:solidFill>
+                        </a:rPr>
+                        <a:t>1.1</a:t>
+                      </a:r>
+                    </a:p>
+                  </a:txBody>
+                  <a:tcPr/>
+                </a:tc>
+                <a:tc>
+                  <a:txBody>
+                    <a:bodyPr/>
+                    <a:lstStyle/>
+                    <a:p>
+                      <a:r>
+                        <a:rPr sz="1100" b="0">
+                          <a:solidFill>
+                            <a:srgbClr val="202124"/>
+                          </a:solidFill>
+                        </a:rPr>
+                        <a:t>13.7</a:t>
+                      </a:r>
+                    </a:p>
+                  </a:txBody>
+                  <a:tcPr/>
+                </a:tc>
+                <a:tc>
+                  <a:txBody>
+                    <a:bodyPr/>
+                    <a:lstStyle/>
+                    <a:p>
+                      <a:r>
+                        <a:rPr sz="1100" b="0">
+                          <a:solidFill>
+                            <a:srgbClr val="202124"/>
+                          </a:solidFill>
+                        </a:rPr>
+                        <a:t>8%</a:t>
+                      </a:r>
+                    </a:p>
+                  </a:txBody>
+                  <a:tcPr/>
+                </a:tc>
+                <a:tc>
+                  <a:txBody>
+                    <a:bodyPr/>
+                    <a:lstStyle/>
+                    <a:p>
+                      <a:r>
+                        <a:rPr sz="1100" b="0">
+                          <a:solidFill>
+                            <a:srgbClr val="202124"/>
+                          </a:solidFill>
+                        </a:rPr>
+                        <a:t>compute-bound</a:t>
+                      </a:r>
+                    </a:p>
+                  </a:txBody>
+                  <a:tcPr/>
+                </a:tc>
+              </a:tr>
+            </a:tbl>
+          </a:graphicData>
+        </a:graphic>
+      </p:graphicFrame>
       <p:sp>
         <p:nvSpPr>
           <p:cNvPr id="5" name="TextBox 4"/>
@@ -12003,29 +13060,29 @@
         </p:nvSpPr>
         <p:spPr>
           <a:xfrm>
-            <a:off x="548640" y="1554480"/>
-            <a:ext cx="10515600" cy="365760"/>
-          </a:xfrm>
-          <a:prstGeom prst="rect">
-            <a:avLst/>
-          </a:prstGeom>
-          <a:noFill/>
-        </p:spPr>
-        <p:txBody>
-          <a:bodyPr wrap="square">
-            <a:spAutoFit/>
-          </a:bodyPr>
-          <a:lstStyle/>
-          <a:p>
-            <a:pPr algn="l"/>
-            <a:r>
-              <a:rPr sz="1600" b="1">
-                <a:solidFill>
-                  <a:srgbClr val="202124"/>
-                </a:solidFill>
-                <a:latin typeface="Calibri"/>
-              </a:rPr>
-              <a:t>The calculation</a:t>
+            <a:off x="548640" y="4937760"/>
+            <a:ext cx="11155680" cy="822960"/>
+          </a:xfrm>
+          <a:prstGeom prst="rect">
+            <a:avLst/>
+          </a:prstGeom>
+          <a:noFill/>
+        </p:spPr>
+        <p:txBody>
+          <a:bodyPr wrap="square">
+            <a:spAutoFit/>
+          </a:bodyPr>
+          <a:lstStyle/>
+          <a:p>
+            <a:pPr algn="l"/>
+            <a:r>
+              <a:rPr sz="1250" b="1">
+                <a:solidFill>
+                  <a:srgbClr val="202124"/>
+                </a:solidFill>
+                <a:latin typeface="Calibri"/>
+              </a:rPr>
+              <a:t>One column, two walls: the NVIDIA GPUs sit at 42-58% of their measured ceilings -- memory-bound, which is why their optimisation ended at traffic reduction. The CPUs and Malis sit at 8-35% -- NOT bandwidth-bound, which is why their wins came from arithmetic (vectorised argmin, blocking, lane tricks). The Hexagon is a third wall: latency-bound, hidden by interleaving independent dependency chains.</a:t>
             </a:r>
           </a:p>
         </p:txBody>
@@ -12038,173 +13095,8 @@
         </p:nvSpPr>
         <p:spPr>
           <a:xfrm>
-            <a:off x="548640" y="1965960"/>
-            <a:ext cx="10515600" cy="2011680"/>
-          </a:xfrm>
-          <a:prstGeom prst="rect">
-            <a:avLst/>
-          </a:prstGeom>
-          <a:noFill/>
-        </p:spPr>
-        <p:txBody>
-          <a:bodyPr wrap="square">
-            <a:spAutoFit/>
-          </a:bodyPr>
-          <a:lstStyle/>
-          <a:p>
-            <a:pPr algn="l"/>
-            <a:r>
-              <a:rPr sz="1400" b="0">
-                <a:solidFill>
-                  <a:srgbClr val="202124"/>
-                </a:solidFill>
-                <a:latin typeface="Consolas"/>
-              </a:rPr>
-              <a:t>MDE/s  =  W x H x D / runtime
-        =  1,920 x 1,080 x 64 / 13.19 ms
-        =  132,710,400 disparity estimations / 0.01319 s
-        =  10,061 million disparity estimations per second
-frame rate  =  1000 / 13.19  =  75.8 fps
-pixel rate  =  2.0736 Mpx x 75.8  =  157.21 Mpix/s</a:t>
-            </a:r>
-          </a:p>
-        </p:txBody>
-      </p:sp>
-      <p:sp>
-        <p:nvSpPr>
-          <p:cNvPr id="7" name="TextBox 6"/>
-          <p:cNvSpPr txBox="1"/>
-          <p:nvPr/>
-        </p:nvSpPr>
-        <p:spPr>
-          <a:xfrm>
-            <a:off x="548640" y="4114800"/>
-            <a:ext cx="10515600" cy="365760"/>
-          </a:xfrm>
-          <a:prstGeom prst="rect">
-            <a:avLst/>
-          </a:prstGeom>
-          <a:noFill/>
-        </p:spPr>
-        <p:txBody>
-          <a:bodyPr wrap="square">
-            <a:spAutoFit/>
-          </a:bodyPr>
-          <a:lstStyle/>
-          <a:p>
-            <a:pPr algn="l"/>
-            <a:r>
-              <a:rPr sz="1600" b="1">
-                <a:solidFill>
-                  <a:srgbClr val="202124"/>
-                </a:solidFill>
-                <a:latin typeface="Calibri"/>
-              </a:rPr>
-              <a:t>What the measurement means</a:t>
-            </a:r>
-          </a:p>
-        </p:txBody>
-      </p:sp>
-      <p:sp>
-        <p:nvSpPr>
-          <p:cNvPr id="8" name="TextBox 7"/>
-          <p:cNvSpPr txBox="1"/>
-          <p:nvPr/>
-        </p:nvSpPr>
-        <p:spPr>
-          <a:xfrm>
-            <a:off x="548640" y="4480560"/>
-            <a:ext cx="10881360" cy="2011680"/>
-          </a:xfrm>
-          <a:prstGeom prst="rect">
-            <a:avLst/>
-          </a:prstGeom>
-          <a:noFill/>
-        </p:spPr>
-        <p:txBody>
-          <a:bodyPr wrap="square">
-            <a:spAutoFit/>
-          </a:bodyPr>
-          <a:lstStyle/>
-          <a:p>
-            <a:pPr algn="l"/>
-            <a:r>
-              <a:rPr sz="1300" b="0">
-                <a:solidFill>
-                  <a:srgbClr val="202124"/>
-                </a:solidFill>
-                <a:latin typeface="Calibri"/>
-              </a:rPr>
-              <a:t>Rewritten warp-centric: one warp owns a scanline's whole disparity range,</a:t>
-            </a:r>
-          </a:p>
-          <a:p>
-            <a:r>
-              <a:rPr sz="1300">
-                <a:solidFill>
-                  <a:srgbClr val="202124"/>
-                </a:solidFill>
-                <a:latin typeface="Calibri"/>
-              </a:rPr>
-              <a:t>L in registers, min-reduce by __shfl_xor, ZERO barriers in the recurrence.</a:t>
-            </a:r>
-          </a:p>
-          <a:p>
-            <a:r>
-              <a:rPr sz="1300">
-                <a:solidFill>
-                  <a:srgbClr val="202124"/>
-                </a:solidFill>
-                <a:latin typeface="Calibri"/>
-              </a:rPr>
-              <a:t>2.69x over the naive OpenCL transliteration (35.39 -&gt; 13.19 ms).</a:t>
-            </a:r>
-          </a:p>
-          <a:p>
-            <a:r>
-              <a:rPr sz="1300">
-                <a:solidFill>
-                  <a:srgbClr val="202124"/>
-                </a:solidFill>
-                <a:latin typeface="Calibri"/>
-              </a:rPr>
-              <a:t>MEMORY BOUND: aggregate moves 1.46 GB in 10.04 ms = 145 GB/s,</a:t>
-            </a:r>
-          </a:p>
-          <a:p>
-            <a:r>
-              <a:rPr sz="1300">
-                <a:solidFill>
-                  <a:srgbClr val="202124"/>
-                </a:solidFill>
-                <a:latin typeface="Calibri"/>
-              </a:rPr>
-              <a:t>against a 247 GB/s copy ceiling measured on this same part.</a:t>
-            </a:r>
-          </a:p>
-          <a:p>
-            <a:r>
-              <a:rPr sz="1300">
-                <a:solidFill>
-                  <a:srgbClr val="202124"/>
-                </a:solidFill>
-                <a:latin typeface="Calibri"/>
-              </a:rPr>
-              <a:t>Peak across the D sweep is 12,138 MDE/s at D=128; D=256 falls back to 9,409.</a:t>
-            </a:r>
-          </a:p>
-        </p:txBody>
-      </p:sp>
-      <p:sp>
-        <p:nvSpPr>
-          <p:cNvPr id="9" name="TextBox 8"/>
-          <p:cNvSpPr txBox="1"/>
-          <p:nvPr/>
-        </p:nvSpPr>
-        <p:spPr>
-          <a:xfrm>
-            <a:off x="548640" y="6400800"/>
-            <a:ext cx="10515600" cy="365760"/>
+            <a:off x="548640" y="5943600"/>
+            <a:ext cx="11155680" cy="640080"/>
           </a:xfrm>
           <a:prstGeom prst="rect">
             <a:avLst/>
@@ -12225,7 +13117,7 @@
                 </a:solidFill>
                 <a:latin typeface="Calibri"/>
               </a:rPr>
-              <a:t>MEASURED — median of the timed frames, golden hash verified in the same run.</a:t>
+              <a:t>Cross-GPU sanity: MDE/s per GB/s of ceiling is 27 / 40 / 33 across a 7.9x bandwidth spread -- throughput largely IS bandwidth for the tuned GPU kernels, and the residual (the 5090's 42%) says the fastest part is no longer purely bandwidth-bound. Achieved-byte instrumentation exists for Configuration A; the B/C runs reuse the same silicon and ceilings but their per-phase byte models are not separately derived.</a:t>
             </a:r>
           </a:p>
         </p:txBody>
@@ -12278,7 +13170,7 @@
                 </a:solidFill>
                 <a:latin typeface="Calibri"/>
               </a:rPr>
-              <a:t>NVIDIA Orin AGX</a:t>
+              <a:t>NVIDIA Thor</a:t>
             </a:r>
           </a:p>
         </p:txBody>
@@ -12348,7 +13240,7 @@
                 </a:solidFill>
                 <a:latin typeface="Calibri"/>
               </a:rPr>
-              <a:t>CUDA, same kernel, sm_87</a:t>
+              <a:t>CUDA, same kernel, sm_110</a:t>
             </a:r>
           </a:p>
         </p:txBody>
@@ -12419,9 +13311,9 @@
                 <a:latin typeface="Consolas"/>
               </a:rPr>
               <a:t>MDE/s  =  (0.384 + 1.536) Mpx x 64 / runtime      (both full-search scales count)
-        =  122,880,000 disparity estimations / 0.07280 s
-        =  1,688 million disparity estimations per second
-frame rate  =  1000 / 72.80  =  13.74 fps   (960x400 disparity map out)</a:t>
+        =  122,880,000 disparity estimations / 0.04510 s
+        =  2,725 million disparity estimations per second
+frame rate  =  1000 / 45.10  =  22.17 fps   (960x400 disparity map out)</a:t>
             </a:r>
           </a:p>
         </p:txBody>
@@ -12491,7 +13383,40 @@
                 </a:solidFill>
                 <a:latin typeface="Calibri"/>
               </a:rPr>
-              <a:t>14 fps on the previous embedded generation, bit-exact, no per-part tuning.</a:t>
+              <a:t>22 fps embedded. Same generic 8-direction kernel as the 5090, bit-exact.</a:t>
+            </a:r>
+          </a:p>
+          <a:p>
+            <a:r>
+              <a:rPr sz="1300">
+                <a:solidFill>
+                  <a:srgbClr val="202124"/>
+                </a:solidFill>
+                <a:latin typeface="Calibri"/>
+              </a:rPr>
+              <a:t>The gap to the 5090 (5.0x) is close to the bandwidth ratio of the parts,</a:t>
+            </a:r>
+          </a:p>
+          <a:p>
+            <a:r>
+              <a:rPr sz="1300">
+                <a:solidFill>
+                  <a:srgbClr val="202124"/>
+                </a:solidFill>
+                <a:latin typeface="Calibri"/>
+              </a:rPr>
+              <a:t>consistent with the Configuration A finding that tuned SGM converges on</a:t>
+            </a:r>
+          </a:p>
+          <a:p>
+            <a:r>
+              <a:rPr sz="1300">
+                <a:solidFill>
+                  <a:srgbClr val="202124"/>
+                </a:solidFill>
+                <a:latin typeface="Calibri"/>
+              </a:rPr>
+              <a:t>memory traffic once the arithmetic is done.</a:t>
             </a:r>
           </a:p>
         </p:txBody>
@@ -12575,11 +13500,11 @@
             <a:r>
               <a:rPr sz="3200" b="1">
                 <a:solidFill>
-                  <a:srgbClr val="E8710A"/>
-                </a:solidFill>
-                <a:latin typeface="Calibri"/>
-              </a:rPr>
-              <a:t>Cortex-A78C x8 (6 threads)</a:t>
+                  <a:srgbClr val="4C8BF5"/>
+                </a:solidFill>
+                <a:latin typeface="Calibri"/>
+              </a:rPr>
+              <a:t>NVIDIA Orin AGX</a:t>
             </a:r>
           </a:p>
         </p:txBody>
@@ -12649,7 +13574,7 @@
                 </a:solidFill>
                 <a:latin typeface="Calibri"/>
               </a:rPr>
-              <a:t>Qualcomm IQ-9075, NEON+OpenMP  |  single core: 442.60 ms</a:t>
+              <a:t>CUDA, same kernel, sm_87</a:t>
             </a:r>
           </a:p>
         </p:txBody>
@@ -12720,9 +13645,9 @@
                 <a:latin typeface="Consolas"/>
               </a:rPr>
               <a:t>MDE/s  =  (0.384 + 1.536) Mpx x 64 / runtime      (both full-search scales count)
-        =  122,880,000 disparity estimations / 0.21190 s
-        =  580 million disparity estimations per second
-frame rate  =  1000 / 211.90  =  4.72 fps   (960x400 disparity map out)</a:t>
+        =  122,880,000 disparity estimations / 0.07280 s
+        =  1,688 million disparity estimations per second
+frame rate  =  1000 / 72.80  =  13.74 fps   (960x400 disparity map out)</a:t>
             </a:r>
           </a:p>
         </p:txBody>
@@ -12792,84 +13717,7 @@
                 </a:solidFill>
                 <a:latin typeface="Calibri"/>
               </a:rPr>
-              <a:t>The best programmable embedded result -- and it was measured by the</a:t>
-            </a:r>
-          </a:p>
-          <a:p>
-            <a:r>
-              <a:rPr sz="1300">
-                <a:solidFill>
-                  <a:srgbClr val="202124"/>
-                </a:solidFill>
-                <a:latin typeface="Calibri"/>
-              </a:rPr>
-              <a:t>collaborating session running multiscale/sgm_ms_neon.c UNMODIFIED on their</a:t>
-            </a:r>
-          </a:p>
-          <a:p>
-            <a:r>
-              <a:rPr sz="1300">
-                <a:solidFill>
-                  <a:srgbClr val="202124"/>
-                </a:solidFill>
-                <a:latin typeface="Calibri"/>
-              </a:rPr>
-              <a:t>silicon, golden every run. Medians of five invocations on a board that is</a:t>
-            </a:r>
-          </a:p>
-          <a:p>
-            <a:r>
-              <a:rPr sz="1300">
-                <a:solidFill>
-                  <a:srgbClr val="202124"/>
-                </a:solidFill>
-                <a:latin typeface="Calibri"/>
-              </a:rPr>
-              <a:t>bimodal by ~9% between invocations; medians quoted, never minima.</a:t>
-            </a:r>
-          </a:p>
-          <a:p>
-            <a:r>
-              <a:rPr sz="1300">
-                <a:solidFill>
-                  <a:srgbClr val="202124"/>
-                </a:solidFill>
-                <a:latin typeface="Calibri"/>
-              </a:rPr>
-              <a:t>This row is also what corrected the record: at the oracle tier the NSP</a:t>
-            </a:r>
-          </a:p>
-          <a:p>
-            <a:r>
-              <a:rPr sz="1300">
-                <a:solidFill>
-                  <a:srgbClr val="202124"/>
-                </a:solidFill>
-                <a:latin typeface="Calibri"/>
-              </a:rPr>
-              <a:t>appeared to lead the cluster 3.29x; at the matched NEON tier the cluster</a:t>
-            </a:r>
-          </a:p>
-          <a:p>
-            <a:r>
-              <a:rPr sz="1300">
-                <a:solidFill>
-                  <a:srgbClr val="202124"/>
-                </a:solidFill>
-                <a:latin typeface="Calibri"/>
-              </a:rPr>
-              <a:t>leads 1.30x. A cross-tier comparison is a cross-configuration comparison</a:t>
-            </a:r>
-          </a:p>
-          <a:p>
-            <a:r>
-              <a:rPr sz="1300">
-                <a:solidFill>
-                  <a:srgbClr val="202124"/>
-                </a:solidFill>
-                <a:latin typeface="Calibri"/>
-              </a:rPr>
-              <a:t>wearing a platform comparison's clothes.</a:t>
+              <a:t>14 fps on the previous embedded generation, bit-exact, no per-part tuning.</a:t>
             </a:r>
           </a:p>
         </p:txBody>
@@ -12957,7 +13805,7 @@
                 </a:solidFill>
                 <a:latin typeface="Calibri"/>
               </a:rPr>
-              <a:t>Cortex-A720 x8</a:t>
+              <a:t>Cortex-A78C x8 (6 threads)</a:t>
             </a:r>
           </a:p>
         </p:txBody>
@@ -13027,7 +13875,7 @@
                 </a:solidFill>
                 <a:latin typeface="Calibri"/>
               </a:rPr>
-              <a:t>Radxa Orion O6, NEON+OpenMP  |  single core: 470.9 ms</a:t>
+              <a:t>Qualcomm IQ-9075, NEON+OpenMP  |  single core: 442.60 ms</a:t>
             </a:r>
           </a:p>
         </p:txBody>
@@ -13098,9 +13946,9 @@
                 <a:latin typeface="Consolas"/>
               </a:rPr>
               <a:t>MDE/s  =  (0.384 + 1.536) Mpx x 64 / runtime      (both full-search scales count)
-        =  122,880,000 disparity estimations / 0.23830 s
-        =  516 million disparity estimations per second
-frame rate  =  1000 / 238.30  =  4.20 fps   (960x400 disparity map out)</a:t>
+        =  122,880,000 disparity estimations / 0.21190 s
+        =  580 million disparity estimations per second
+frame rate  =  1000 / 211.90  =  4.72 fps   (960x400 disparity map out)</a:t>
             </a:r>
           </a:p>
         </p:txBody>
@@ -13170,7 +14018,7 @@
                 </a:solidFill>
                 <a:latin typeface="Calibri"/>
               </a:rPr>
-              <a:t>The NEON tier is 5.8x the scalar oracle on this cluster. The kernel keeps</a:t>
+              <a:t>The best programmable embedded result -- and it was measured by the</a:t>
             </a:r>
           </a:p>
           <a:p>
@@ -13181,7 +14029,7 @@
                 </a:solidFill>
                 <a:latin typeface="Calibri"/>
               </a:rPr>
-              <a:t>Configuration A's register scheme and adds the saturating step, the</a:t>
+              <a:t>collaborating session running multiscale/sgm_ms_neon.c UNMODIFIED on their</a:t>
             </a:r>
           </a:p>
           <a:p>
@@ -13192,7 +14040,7 @@
                 </a:solidFill>
                 <a:latin typeface="Calibri"/>
               </a:rPr>
-              <a:t>direction-weighted P1 per sweep, and a uint16 sum plane for 8-path S.</a:t>
+              <a:t>silicon, golden every run. Medians of five invocations on a board that is</a:t>
             </a:r>
           </a:p>
           <a:p>
@@ -13203,7 +14051,7 @@
                 </a:solidFill>
                 <a:latin typeface="Calibri"/>
               </a:rPr>
-              <a:t>OpenMP is output-neutral by construction: rows for horizontal sweeps,</a:t>
+              <a:t>bimodal by ~9% between invocations; medians quoted, never minima.</a:t>
             </a:r>
           </a:p>
           <a:p>
@@ -13214,7 +14062,7 @@
                 </a:solidFill>
                 <a:latin typeface="Calibri"/>
               </a:rPr>
-              <a:t>columns-within-row for vertical and diagonal, so the hash cannot move</a:t>
+              <a:t>This row is also what corrected the record: at the oracle tier the NSP</a:t>
             </a:r>
           </a:p>
           <a:p>
@@ -13225,7 +14073,29 @@
                 </a:solidFill>
                 <a:latin typeface="Calibri"/>
               </a:rPr>
-              <a:t>with the thread count.</a:t>
+              <a:t>appeared to lead the cluster 3.29x; at the matched NEON tier the cluster</a:t>
+            </a:r>
+          </a:p>
+          <a:p>
+            <a:r>
+              <a:rPr sz="1300">
+                <a:solidFill>
+                  <a:srgbClr val="202124"/>
+                </a:solidFill>
+                <a:latin typeface="Calibri"/>
+              </a:rPr>
+              <a:t>leads 1.30x. A cross-tier comparison is a cross-configuration comparison</a:t>
+            </a:r>
+          </a:p>
+          <a:p>
+            <a:r>
+              <a:rPr sz="1300">
+                <a:solidFill>
+                  <a:srgbClr val="202124"/>
+                </a:solidFill>
+                <a:latin typeface="Calibri"/>
+              </a:rPr>
+              <a:t>wearing a platform comparison's clothes.</a:t>
             </a:r>
           </a:p>
         </p:txBody>
@@ -13309,11 +14179,11 @@
             <a:r>
               <a:rPr sz="3200" b="1">
                 <a:solidFill>
-                  <a:srgbClr val="12B5A5"/>
-                </a:solidFill>
-                <a:latin typeface="Calibri"/>
-              </a:rPr>
-              <a:t>Hexagon v73 NSP</a:t>
+                  <a:srgbClr val="E8710A"/>
+                </a:solidFill>
+                <a:latin typeface="Calibri"/>
+              </a:rPr>
+              <a:t>Cortex-A720 x8</a:t>
             </a:r>
           </a:p>
         </p:txBody>
@@ -13383,7 +14253,7 @@
                 </a:solidFill>
                 <a:latin typeface="Calibri"/>
               </a:rPr>
-              <a:t>Qualcomm IQ-9075, HVX, 4 contexts  |  median of 5, 0.75% spread, golden 10/10</a:t>
+              <a:t>Radxa Orion O6, NEON+OpenMP  |  single core: 470.9 ms</a:t>
             </a:r>
           </a:p>
         </p:txBody>
@@ -13454,9 +14324,9 @@
                 <a:latin typeface="Consolas"/>
               </a:rPr>
               <a:t>MDE/s  =  (0.384 + 1.536) Mpx x 64 / runtime      (both full-search scales count)
-        =  122,880,000 disparity estimations / 0.27630 s
-        =  445 million disparity estimations per second
-frame rate  =  1000 / 276.30  =  3.62 fps   (960x400 disparity map out)</a:t>
+        =  122,880,000 disparity estimations / 0.23830 s
+        =  516 million disparity estimations per second
+frame rate  =  1000 / 238.30  =  4.20 fps   (960x400 disparity map out)</a:t>
             </a:r>
           </a:p>
         </p:txBody>
@@ -13526,7 +14396,7 @@
                 </a:solidFill>
                 <a:latin typeface="Calibri"/>
               </a:rPr>
-              <a:t>Contributed port, independently re-verified (three further gated runs,</a:t>
+              <a:t>The NEON tier is 5.8x the scalar oracle on this cluster. The kernel keeps</a:t>
             </a:r>
           </a:p>
           <a:p>
@@ -13537,7 +14407,7 @@
                 </a:solidFill>
                 <a:latin typeface="Calibri"/>
               </a:rPr>
-              <a:t>269-272 ms). Per ENGINE this is the embedded win: one NSP beats one A78C</a:t>
+              <a:t>Configuration A's register scheme and adds the saturating step, the</a:t>
             </a:r>
           </a:p>
           <a:p>
@@ -13548,7 +14418,7 @@
                 </a:solidFill>
                 <a:latin typeface="Calibri"/>
               </a:rPr>
-              <a:t>core 1.60x at matched tiers.</a:t>
+              <a:t>direction-weighted P1 per sweep, and a uint16 sum plane for 8-path S.</a:t>
             </a:r>
           </a:p>
           <a:p>
@@ -13559,7 +14429,7 @@
                 </a:solidFill>
                 <a:latin typeface="Calibri"/>
               </a:rPr>
-              <a:t>Diagonals use a sync-free chain-band decomposition -- workers own equal-pixel</a:t>
+              <a:t>OpenMP is output-neutral by construction: rows for horizontal sweeps,</a:t>
             </a:r>
           </a:p>
           <a:p>
@@ -13570,7 +14440,7 @@
                 </a:solidFill>
                 <a:latin typeface="Calibri"/>
               </a:rPr>
-              <a:t>bands of diagonal chains, S worker-disjoint, bit-exact with NO barriers.</a:t>
+              <a:t>columns-within-row for vertical and diagonal, so the hash cannot move</a:t>
             </a:r>
           </a:p>
           <a:p>
@@ -13581,62 +14451,7 @@
                 </a:solidFill>
                 <a:latin typeface="Calibri"/>
               </a:rPr>
-              <a:t>The two-scale merge is fused into the stage-2 cost build, saving ~200 MB</a:t>
-            </a:r>
-          </a:p>
-          <a:p>
-            <a:r>
-              <a:rPr sz="1300">
-                <a:solidFill>
-                  <a:srgbClr val="202124"/>
-                </a:solidFill>
-                <a:latin typeface="Calibri"/>
-              </a:rPr>
-              <a:t>of traffic per frame. The 4-HVX-context knee holds here too: 6 threads is</a:t>
-            </a:r>
-          </a:p>
-          <a:p>
-            <a:r>
-              <a:rPr sz="1300">
-                <a:solidFill>
-                  <a:srgbClr val="202124"/>
-                </a:solidFill>
-                <a:latin typeface="Calibri"/>
-              </a:rPr>
-              <a:t>29% WORSE than 4.</a:t>
-            </a:r>
-          </a:p>
-          <a:p>
-            <a:r>
-              <a:rPr sz="1300">
-                <a:solidFill>
-                  <a:srgbClr val="202124"/>
-                </a:solidFill>
-                <a:latin typeface="Calibri"/>
-              </a:rPr>
-              <a:t>P2=200 overflowed their packed (S&lt;&lt;6)|d argmin key at S=2040 -- the warned</a:t>
-            </a:r>
-          </a:p>
-          <a:p>
-            <a:r>
-              <a:rPr sz="1300">
-                <a:solidFill>
-                  <a:srgbClr val="202124"/>
-                </a:solidFill>
-                <a:latin typeface="Calibri"/>
-              </a:rPr>
-              <a:t>saturation failure mode, one stage downstream of the warned location.</a:t>
-            </a:r>
-          </a:p>
-          <a:p>
-            <a:r>
-              <a:rPr sz="1300">
-                <a:solidFill>
-                  <a:srgbClr val="202124"/>
-                </a:solidFill>
-                <a:latin typeface="Calibri"/>
-              </a:rPr>
-              <a:t>Redesigned and sim-proven on tie-storms at the cap before shipping.</a:t>
+              <a:t>with the thread count.</a:t>
             </a:r>
           </a:p>
         </p:txBody>
@@ -13720,11 +14535,11 @@
             <a:r>
               <a:rPr sz="3200" b="1">
                 <a:solidFill>
-                  <a:srgbClr val="4C8BF5"/>
-                </a:solidFill>
-                <a:latin typeface="Calibri"/>
-              </a:rPr>
-              <a:t>Mali-G720</a:t>
+                  <a:srgbClr val="12B5A5"/>
+                </a:solidFill>
+                <a:latin typeface="Calibri"/>
+              </a:rPr>
+              <a:t>Hexagon v73 NSP</a:t>
             </a:r>
           </a:p>
         </p:txBody>
@@ -13794,7 +14609,7 @@
                 </a:solidFill>
                 <a:latin typeface="Calibri"/>
               </a:rPr>
-              <a:t>Immortalis, 10 CU, OpenCL 3.0</a:t>
+              <a:t>Qualcomm IQ-9075, HVX, 4 contexts  |  median of 5, 0.75% spread, golden 10/10</a:t>
             </a:r>
           </a:p>
         </p:txBody>
@@ -13865,9 +14680,9 @@
                 <a:latin typeface="Consolas"/>
               </a:rPr>
               <a:t>MDE/s  =  (0.384 + 1.536) Mpx x 64 / runtime      (both full-search scales count)
-        =  122,880,000 disparity estimations / 0.38000 s
-        =  323 million disparity estimations per second
-frame rate  =  1000 / 380.00  =  2.63 fps   (960x400 disparity map out)</a:t>
+        =  122,880,000 disparity estimations / 0.27630 s
+        =  445 million disparity estimations per second
+frame rate  =  1000 / 276.30  =  3.62 fps   (960x400 disparity map out)</a:t>
             </a:r>
           </a:p>
         </p:txBody>
@@ -13937,7 +14752,7 @@
                 </a:solidFill>
                 <a:latin typeface="Calibri"/>
               </a:rPr>
-              <a:t>One 16-work-item work-group owns each path line; barriers are uniform</a:t>
+              <a:t>Contributed port, independently re-verified (three further gated runs,</a:t>
             </a:r>
           </a:p>
           <a:p>
@@ -13948,7 +14763,7 @@
                 </a:solidFill>
                 <a:latin typeface="Calibri"/>
               </a:rPr>
-              <a:t>because every work-item in the group walks the same line trajectory.</a:t>
+              <a:t>269-272 ms). Per ENGINE this is the embedded win: one NSP beats one A78C</a:t>
             </a:r>
           </a:p>
           <a:p>
@@ -13959,7 +14774,7 @@
                 </a:solidFill>
                 <a:latin typeface="Calibri"/>
               </a:rPr>
-              <a:t>Bit-exact on the first attempt. Same caveat as Configuration A: a</a:t>
+              <a:t>core 1.60x at matched tiers.</a:t>
             </a:r>
           </a:p>
           <a:p>
@@ -13970,7 +14785,7 @@
                 </a:solidFill>
                 <a:latin typeface="Calibri"/>
               </a:rPr>
-              <a:t>single-chain-per-line kernel is an effort floor for this part, not a</a:t>
+              <a:t>Diagonals use a sync-free chain-band decomposition -- workers own equal-pixel</a:t>
             </a:r>
           </a:p>
           <a:p>
@@ -13981,7 +14796,73 @@
                 </a:solidFill>
                 <a:latin typeface="Calibri"/>
               </a:rPr>
-              <a:t>verdict on it.</a:t>
+              <a:t>bands of diagonal chains, S worker-disjoint, bit-exact with NO barriers.</a:t>
+            </a:r>
+          </a:p>
+          <a:p>
+            <a:r>
+              <a:rPr sz="1300">
+                <a:solidFill>
+                  <a:srgbClr val="202124"/>
+                </a:solidFill>
+                <a:latin typeface="Calibri"/>
+              </a:rPr>
+              <a:t>The two-scale merge is fused into the stage-2 cost build, saving ~200 MB</a:t>
+            </a:r>
+          </a:p>
+          <a:p>
+            <a:r>
+              <a:rPr sz="1300">
+                <a:solidFill>
+                  <a:srgbClr val="202124"/>
+                </a:solidFill>
+                <a:latin typeface="Calibri"/>
+              </a:rPr>
+              <a:t>of traffic per frame. The 4-HVX-context knee holds here too: 6 threads is</a:t>
+            </a:r>
+          </a:p>
+          <a:p>
+            <a:r>
+              <a:rPr sz="1300">
+                <a:solidFill>
+                  <a:srgbClr val="202124"/>
+                </a:solidFill>
+                <a:latin typeface="Calibri"/>
+              </a:rPr>
+              <a:t>29% WORSE than 4.</a:t>
+            </a:r>
+          </a:p>
+          <a:p>
+            <a:r>
+              <a:rPr sz="1300">
+                <a:solidFill>
+                  <a:srgbClr val="202124"/>
+                </a:solidFill>
+                <a:latin typeface="Calibri"/>
+              </a:rPr>
+              <a:t>P2=200 overflowed their packed (S&lt;&lt;6)|d argmin key at S=2040 -- the warned</a:t>
+            </a:r>
+          </a:p>
+          <a:p>
+            <a:r>
+              <a:rPr sz="1300">
+                <a:solidFill>
+                  <a:srgbClr val="202124"/>
+                </a:solidFill>
+                <a:latin typeface="Calibri"/>
+              </a:rPr>
+              <a:t>saturation failure mode, one stage downstream of the warned location.</a:t>
+            </a:r>
+          </a:p>
+          <a:p>
+            <a:r>
+              <a:rPr sz="1300">
+                <a:solidFill>
+                  <a:srgbClr val="202124"/>
+                </a:solidFill>
+                <a:latin typeface="Calibri"/>
+              </a:rPr>
+              <a:t>Redesigned and sim-proven on tie-storms at the cap before shipping.</a:t>
             </a:r>
           </a:p>
         </p:txBody>
@@ -14065,11 +14946,11 @@
             <a:r>
               <a:rPr sz="3200" b="1">
                 <a:solidFill>
-                  <a:srgbClr val="E8710A"/>
-                </a:solidFill>
-                <a:latin typeface="Calibri"/>
-              </a:rPr>
-              <a:t>Cortex-A55 x6</a:t>
+                  <a:srgbClr val="4C8BF5"/>
+                </a:solidFill>
+                <a:latin typeface="Calibri"/>
+              </a:rPr>
+              <a:t>Mali-G720</a:t>
             </a:r>
           </a:p>
         </p:txBody>
@@ -14139,7 +15020,7 @@
                 </a:solidFill>
                 <a:latin typeface="Calibri"/>
               </a:rPr>
-              <a:t>i.MX 95 FRDM, 1.8 GHz, NEON+OpenMP  |  single core: 2,201 ms</a:t>
+              <a:t>Immortalis, 10 CU, OpenCL 3.0</a:t>
             </a:r>
           </a:p>
         </p:txBody>
@@ -14210,9 +15091,9 @@
                 <a:latin typeface="Consolas"/>
               </a:rPr>
               <a:t>MDE/s  =  (0.384 + 1.536) Mpx x 64 / runtime      (both full-search scales count)
-        =  122,880,000 disparity estimations / 0.64010 s
-        =  192 million disparity estimations per second
-frame rate  =  1000 / 640.10  =  1.56 fps   (960x400 disparity map out)</a:t>
+        =  122,880,000 disparity estimations / 0.38000 s
+        =  323 million disparity estimations per second
+frame rate  =  1000 / 380.00  =  2.63 fps   (960x400 disparity map out)</a:t>
             </a:r>
           </a:p>
         </p:txBody>
@@ -14282,7 +15163,7 @@
                 </a:solidFill>
                 <a:latin typeface="Calibri"/>
               </a:rPr>
-              <a:t>The anchor platform runs the full two-scale 8-path configuration at 1.56 fps</a:t>
+              <a:t>One 16-work-item work-group owns each path line; barriers are uniform</a:t>
             </a:r>
           </a:p>
           <a:p>
@@ -14293,7 +15174,7 @@
                 </a:solidFill>
                 <a:latin typeface="Calibri"/>
               </a:rPr>
-              <a:t>-- 22x the scalar oracle on the same six cores' single-core floor.</a:t>
+              <a:t>because every work-item in the group walks the same line trajectory.</a:t>
             </a:r>
           </a:p>
           <a:p>
@@ -14304,7 +15185,7 @@
                 </a:solidFill>
                 <a:latin typeface="Calibri"/>
               </a:rPr>
-              <a:t>The saturating NEON step (vqaddq_u8 against P2=200) is the part Configuration</a:t>
+              <a:t>Bit-exact on the first attempt. Same caveat as Configuration A: a</a:t>
             </a:r>
           </a:p>
           <a:p>
@@ -14315,7 +15196,7 @@
                 </a:solidFill>
                 <a:latin typeface="Calibri"/>
               </a:rPr>
-              <a:t>A never needed: its static assert guarantees no overflow at P2=192, and</a:t>
+              <a:t>single-chain-per-line kernel is an effort floor for this part, not a</a:t>
             </a:r>
           </a:p>
           <a:p>
@@ -14326,7 +15207,7 @@
                 </a:solidFill>
                 <a:latin typeface="Calibri"/>
               </a:rPr>
-              <a:t>Configuration B is the configuration that breaks that assumption.</a:t>
+              <a:t>verdict on it.</a:t>
             </a:r>
           </a:p>
         </p:txBody>
@@ -14410,11 +15291,11 @@
             <a:r>
               <a:rPr sz="3200" b="1">
                 <a:solidFill>
-                  <a:srgbClr val="4C8BF5"/>
-                </a:solidFill>
-                <a:latin typeface="Calibri"/>
-              </a:rPr>
-              <a:t>Mali-G310</a:t>
+                  <a:srgbClr val="E8710A"/>
+                </a:solidFill>
+                <a:latin typeface="Calibri"/>
+              </a:rPr>
+              <a:t>Cortex-A55 x6</a:t>
             </a:r>
           </a:p>
         </p:txBody>
@@ -14484,7 +15365,7 @@
                 </a:solidFill>
                 <a:latin typeface="Calibri"/>
               </a:rPr>
-              <a:t>1 CU, OpenCL 3.0</a:t>
+              <a:t>i.MX 95 FRDM, 1.8 GHz, NEON+OpenMP  |  single core: 2,201 ms</a:t>
             </a:r>
           </a:p>
         </p:txBody>
@@ -14555,9 +15436,9 @@
                 <a:latin typeface="Consolas"/>
               </a:rPr>
               <a:t>MDE/s  =  (0.384 + 1.536) Mpx x 64 / runtime      (both full-search scales count)
-        =  122,880,000 disparity estimations / 2.70400 s
-        =  45 million disparity estimations per second
-frame rate  =  1000 / 2,704.00  =  0.37 fps   (960x400 disparity map out)</a:t>
+        =  122,880,000 disparity estimations / 0.64010 s
+        =  192 million disparity estimations per second
+frame rate  =  1000 / 640.10  =  1.56 fps   (960x400 disparity map out)</a:t>
             </a:r>
           </a:p>
         </p:txBody>
@@ -14627,7 +15508,51 @@
                 </a:solidFill>
                 <a:latin typeface="Calibri"/>
               </a:rPr>
-              <a:t>Same OpenCL kernel as the G720, same hash, one compute unit.</a:t>
+              <a:t>The anchor platform runs the full two-scale 8-path configuration at 1.56 fps</a:t>
+            </a:r>
+          </a:p>
+          <a:p>
+            <a:r>
+              <a:rPr sz="1300">
+                <a:solidFill>
+                  <a:srgbClr val="202124"/>
+                </a:solidFill>
+                <a:latin typeface="Calibri"/>
+              </a:rPr>
+              <a:t>-- 22x the scalar oracle on the same six cores' single-core floor.</a:t>
+            </a:r>
+          </a:p>
+          <a:p>
+            <a:r>
+              <a:rPr sz="1300">
+                <a:solidFill>
+                  <a:srgbClr val="202124"/>
+                </a:solidFill>
+                <a:latin typeface="Calibri"/>
+              </a:rPr>
+              <a:t>The saturating NEON step (vqaddq_u8 against P2=200) is the part Configuration</a:t>
+            </a:r>
+          </a:p>
+          <a:p>
+            <a:r>
+              <a:rPr sz="1300">
+                <a:solidFill>
+                  <a:srgbClr val="202124"/>
+                </a:solidFill>
+                <a:latin typeface="Calibri"/>
+              </a:rPr>
+              <a:t>A never needed: its static assert guarantees no overflow at P2=192, and</a:t>
+            </a:r>
+          </a:p>
+          <a:p>
+            <a:r>
+              <a:rPr sz="1300">
+                <a:solidFill>
+                  <a:srgbClr val="202124"/>
+                </a:solidFill>
+                <a:latin typeface="Calibri"/>
+              </a:rPr>
+              <a:t>Configuration B is the configuration that breaks that assumption.</a:t>
             </a:r>
           </a:p>
         </p:txBody>
@@ -14711,6 +15636,307 @@
             <a:r>
               <a:rPr sz="3200" b="1">
                 <a:solidFill>
+                  <a:srgbClr val="4C8BF5"/>
+                </a:solidFill>
+                <a:latin typeface="Calibri"/>
+              </a:rPr>
+              <a:t>Mali-G310</a:t>
+            </a:r>
+          </a:p>
+        </p:txBody>
+      </p:sp>
+      <p:sp>
+        <p:nvSpPr>
+          <p:cNvPr id="3" name="TextBox 2"/>
+          <p:cNvSpPr txBox="1"/>
+          <p:nvPr/>
+        </p:nvSpPr>
+        <p:spPr>
+          <a:xfrm>
+            <a:off x="9509760" y="457200"/>
+            <a:ext cx="2194560" cy="365760"/>
+          </a:xfrm>
+          <a:prstGeom prst="rect">
+            <a:avLst/>
+          </a:prstGeom>
+          <a:noFill/>
+        </p:spPr>
+        <p:txBody>
+          <a:bodyPr wrap="square">
+            <a:spAutoFit/>
+          </a:bodyPr>
+          <a:lstStyle/>
+          <a:p>
+            <a:pPr algn="l"/>
+            <a:r>
+              <a:rPr sz="1200" b="1">
+                <a:solidFill>
+                  <a:srgbClr val="5F6368"/>
+                </a:solidFill>
+                <a:latin typeface="Calibri"/>
+              </a:rPr>
+              <a:t>CONFIGURATION B</a:t>
+            </a:r>
+          </a:p>
+        </p:txBody>
+      </p:sp>
+      <p:sp>
+        <p:nvSpPr>
+          <p:cNvPr id="4" name="TextBox 3"/>
+          <p:cNvSpPr txBox="1"/>
+          <p:nvPr/>
+        </p:nvSpPr>
+        <p:spPr>
+          <a:xfrm>
+            <a:off x="548640" y="914400"/>
+            <a:ext cx="10881360" cy="365760"/>
+          </a:xfrm>
+          <a:prstGeom prst="rect">
+            <a:avLst/>
+          </a:prstGeom>
+          <a:noFill/>
+        </p:spPr>
+        <p:txBody>
+          <a:bodyPr wrap="square">
+            <a:spAutoFit/>
+          </a:bodyPr>
+          <a:lstStyle/>
+          <a:p>
+            <a:pPr algn="l"/>
+            <a:r>
+              <a:rPr sz="1300" b="0">
+                <a:solidFill>
+                  <a:srgbClr val="5F6368"/>
+                </a:solidFill>
+                <a:latin typeface="Calibri"/>
+              </a:rPr>
+              <a:t>1 CU, OpenCL 3.0</a:t>
+            </a:r>
+          </a:p>
+        </p:txBody>
+      </p:sp>
+      <p:sp>
+        <p:nvSpPr>
+          <p:cNvPr id="5" name="TextBox 4"/>
+          <p:cNvSpPr txBox="1"/>
+          <p:nvPr/>
+        </p:nvSpPr>
+        <p:spPr>
+          <a:xfrm>
+            <a:off x="548640" y="1554480"/>
+            <a:ext cx="10515600" cy="365760"/>
+          </a:xfrm>
+          <a:prstGeom prst="rect">
+            <a:avLst/>
+          </a:prstGeom>
+          <a:noFill/>
+        </p:spPr>
+        <p:txBody>
+          <a:bodyPr wrap="square">
+            <a:spAutoFit/>
+          </a:bodyPr>
+          <a:lstStyle/>
+          <a:p>
+            <a:pPr algn="l"/>
+            <a:r>
+              <a:rPr sz="1600" b="1">
+                <a:solidFill>
+                  <a:srgbClr val="202124"/>
+                </a:solidFill>
+                <a:latin typeface="Calibri"/>
+              </a:rPr>
+              <a:t>The calculation (work-performed convention)</a:t>
+            </a:r>
+          </a:p>
+        </p:txBody>
+      </p:sp>
+      <p:sp>
+        <p:nvSpPr>
+          <p:cNvPr id="6" name="TextBox 5"/>
+          <p:cNvSpPr txBox="1"/>
+          <p:nvPr/>
+        </p:nvSpPr>
+        <p:spPr>
+          <a:xfrm>
+            <a:off x="548640" y="1965960"/>
+            <a:ext cx="10881360" cy="1554480"/>
+          </a:xfrm>
+          <a:prstGeom prst="rect">
+            <a:avLst/>
+          </a:prstGeom>
+          <a:noFill/>
+        </p:spPr>
+        <p:txBody>
+          <a:bodyPr wrap="square">
+            <a:spAutoFit/>
+          </a:bodyPr>
+          <a:lstStyle/>
+          <a:p>
+            <a:pPr algn="l"/>
+            <a:r>
+              <a:rPr sz="1400" b="0">
+                <a:solidFill>
+                  <a:srgbClr val="202124"/>
+                </a:solidFill>
+                <a:latin typeface="Consolas"/>
+              </a:rPr>
+              <a:t>MDE/s  =  (0.384 + 1.536) Mpx x 64 / runtime      (both full-search scales count)
+        =  122,880,000 disparity estimations / 2.70400 s
+        =  45 million disparity estimations per second
+frame rate  =  1000 / 2,704.00  =  0.37 fps   (960x400 disparity map out)</a:t>
+            </a:r>
+          </a:p>
+        </p:txBody>
+      </p:sp>
+      <p:sp>
+        <p:nvSpPr>
+          <p:cNvPr id="7" name="TextBox 6"/>
+          <p:cNvSpPr txBox="1"/>
+          <p:nvPr/>
+        </p:nvSpPr>
+        <p:spPr>
+          <a:xfrm>
+            <a:off x="548640" y="3657600"/>
+            <a:ext cx="10515600" cy="365760"/>
+          </a:xfrm>
+          <a:prstGeom prst="rect">
+            <a:avLst/>
+          </a:prstGeom>
+          <a:noFill/>
+        </p:spPr>
+        <p:txBody>
+          <a:bodyPr wrap="square">
+            <a:spAutoFit/>
+          </a:bodyPr>
+          <a:lstStyle/>
+          <a:p>
+            <a:pPr algn="l"/>
+            <a:r>
+              <a:rPr sz="1600" b="1">
+                <a:solidFill>
+                  <a:srgbClr val="202124"/>
+                </a:solidFill>
+                <a:latin typeface="Calibri"/>
+              </a:rPr>
+              <a:t>What the measurement means</a:t>
+            </a:r>
+          </a:p>
+        </p:txBody>
+      </p:sp>
+      <p:sp>
+        <p:nvSpPr>
+          <p:cNvPr id="8" name="TextBox 7"/>
+          <p:cNvSpPr txBox="1"/>
+          <p:nvPr/>
+        </p:nvSpPr>
+        <p:spPr>
+          <a:xfrm>
+            <a:off x="548640" y="4023360"/>
+            <a:ext cx="10881360" cy="2286000"/>
+          </a:xfrm>
+          <a:prstGeom prst="rect">
+            <a:avLst/>
+          </a:prstGeom>
+          <a:noFill/>
+        </p:spPr>
+        <p:txBody>
+          <a:bodyPr wrap="square">
+            <a:spAutoFit/>
+          </a:bodyPr>
+          <a:lstStyle/>
+          <a:p>
+            <a:pPr algn="l"/>
+            <a:r>
+              <a:rPr sz="1300" b="0">
+                <a:solidFill>
+                  <a:srgbClr val="202124"/>
+                </a:solidFill>
+                <a:latin typeface="Calibri"/>
+              </a:rPr>
+              <a:t>Same OpenCL kernel as the G720, same hash, one compute unit.</a:t>
+            </a:r>
+          </a:p>
+        </p:txBody>
+      </p:sp>
+      <p:sp>
+        <p:nvSpPr>
+          <p:cNvPr id="9" name="TextBox 8"/>
+          <p:cNvSpPr txBox="1"/>
+          <p:nvPr/>
+        </p:nvSpPr>
+        <p:spPr>
+          <a:xfrm>
+            <a:off x="548640" y="6446520"/>
+            <a:ext cx="10881360" cy="365760"/>
+          </a:xfrm>
+          <a:prstGeom prst="rect">
+            <a:avLst/>
+          </a:prstGeom>
+          <a:noFill/>
+        </p:spPr>
+        <p:txBody>
+          <a:bodyPr wrap="square">
+            <a:spAutoFit/>
+          </a:bodyPr>
+          <a:lstStyle/>
+          <a:p>
+            <a:pPr algn="l"/>
+            <a:r>
+              <a:rPr sz="1100" b="0">
+                <a:solidFill>
+                  <a:srgbClr val="5F6368"/>
+                </a:solidFill>
+                <a:latin typeface="Calibri"/>
+              </a:rPr>
+              <a:t>MEASURED -- median of the timed frames, bit-exact to golden bcb9cb0bd6f49799 in the same run.</a:t>
+            </a:r>
+          </a:p>
+        </p:txBody>
+      </p:sp>
+    </p:spTree>
+  </p:cSld>
+  <p:clrMapOvr>
+    <a:masterClrMapping/>
+  </p:clrMapOvr>
+</p:sld>
+</file>
+
+<file path=ppt/slides/slide28.xml><?xml version="1.0" encoding="utf-8"?>
+<p:sld xmlns:a="http://schemas.openxmlformats.org/drawingml/2006/main" xmlns:p="http://schemas.openxmlformats.org/presentationml/2006/main" xmlns:r="http://schemas.openxmlformats.org/officeDocument/2006/relationships">
+  <p:cSld>
+    <p:spTree>
+      <p:nvGrpSpPr>
+        <p:cNvPr id="1" name=""/>
+        <p:cNvGrpSpPr/>
+        <p:nvPr/>
+      </p:nvGrpSpPr>
+      <p:grpSpPr/>
+      <p:sp>
+        <p:nvSpPr>
+          <p:cNvPr id="2" name="TextBox 1"/>
+          <p:cNvSpPr txBox="1"/>
+          <p:nvPr/>
+        </p:nvSpPr>
+        <p:spPr>
+          <a:xfrm>
+            <a:off x="548640" y="320040"/>
+            <a:ext cx="10058400" cy="640080"/>
+          </a:xfrm>
+          <a:prstGeom prst="rect">
+            <a:avLst/>
+          </a:prstGeom>
+          <a:noFill/>
+        </p:spPr>
+        <p:txBody>
+          <a:bodyPr wrap="square">
+            <a:spAutoFit/>
+          </a:bodyPr>
+          <a:lstStyle/>
+          <a:p>
+            <a:pPr algn="l"/>
+            <a:r>
+              <a:rPr sz="3200" b="1">
+                <a:solidFill>
                   <a:srgbClr val="9AA0A6"/>
                 </a:solidFill>
                 <a:latin typeface="Calibri"/>
@@ -15073,7 +16299,7 @@
                 </a:solidFill>
                 <a:latin typeface="Calibri"/>
               </a:rPr>
-              <a:t>NVIDIA Orin AGX GPU</a:t>
+              <a:t>NVIDIA Thor GPU</a:t>
             </a:r>
           </a:p>
         </p:txBody>
@@ -15108,7 +16334,7 @@
                 </a:solidFill>
                 <a:latin typeface="Calibri"/>
               </a:rPr>
-              <a:t>Ampere, 16 SM, CUDA 12.6, sm_87</a:t>
+              <a:t>Blackwell, 20 SM, CUDA 13.2, sm_110</a:t>
             </a:r>
           </a:p>
         </p:txBody>
@@ -15179,11 +16405,11 @@
                 <a:latin typeface="Consolas"/>
               </a:rPr>
               <a:t>MDE/s  =  W x H x D / runtime
-        =  1,920 x 1,080 x 64 / 23.28 ms
-        =  132,710,400 disparity estimations / 0.02328 s
-        =  5,701 million disparity estimations per second
-frame rate  =  1000 / 23.28  =  43.0 fps
-pixel rate  =  2.0736 Mpx x 43.0  =  89.07 Mpix/s</a:t>
+        =  1,920 x 1,080 x 64 / 13.19 ms
+        =  132,710,400 disparity estimations / 0.01319 s
+        =  10,061 million disparity estimations per second
+frame rate  =  1000 / 13.19  =  75.8 fps
+pixel rate  =  2.0736 Mpx x 75.8  =  157.21 Mpix/s</a:t>
             </a:r>
           </a:p>
         </p:txBody>
@@ -15253,7 +16479,7 @@
                 </a:solidFill>
                 <a:latin typeface="Calibri"/>
               </a:rPr>
-              <a:t>Same kernel, same changes: 3.10x over the naive port (72.27 -&gt; 23.28 ms).</a:t>
+              <a:t>Rewritten warp-centric: one warp owns a scanline's whole disparity range,</a:t>
             </a:r>
           </a:p>
           <a:p>
@@ -15264,7 +16490,7 @@
                 </a:solidFill>
                 <a:latin typeface="Calibri"/>
               </a:rPr>
-              <a:t>Bit-exact on the first run, before any tuning — the payoff for porting a</a:t>
+              <a:t>L in registers, min-reduce by __shfl_xor, ZERO barriers in the recurrence.</a:t>
             </a:r>
           </a:p>
           <a:p>
@@ -15275,7 +16501,40 @@
                 </a:solidFill>
                 <a:latin typeface="Calibri"/>
               </a:rPr>
-              <a:t>verified OpenCL kernel one-for-one instead of writing a new one.</a:t>
+              <a:t>2.69x over the naive OpenCL transliteration (35.39 -&gt; 13.19 ms).</a:t>
+            </a:r>
+          </a:p>
+          <a:p>
+            <a:r>
+              <a:rPr sz="1300">
+                <a:solidFill>
+                  <a:srgbClr val="202124"/>
+                </a:solidFill>
+                <a:latin typeface="Calibri"/>
+              </a:rPr>
+              <a:t>MEMORY BOUND: aggregate moves 1.46 GB in 10.04 ms = 145 GB/s,</a:t>
+            </a:r>
+          </a:p>
+          <a:p>
+            <a:r>
+              <a:rPr sz="1300">
+                <a:solidFill>
+                  <a:srgbClr val="202124"/>
+                </a:solidFill>
+                <a:latin typeface="Calibri"/>
+              </a:rPr>
+              <a:t>against a 247 GB/s copy ceiling measured on this same part.</a:t>
+            </a:r>
+          </a:p>
+          <a:p>
+            <a:r>
+              <a:rPr sz="1300">
+                <a:solidFill>
+                  <a:srgbClr val="202124"/>
+                </a:solidFill>
+                <a:latin typeface="Calibri"/>
+              </a:rPr>
+              <a:t>Peak across the D sweep is 12,138 MDE/s at D=128; D=256 falls back to 9,409.</a:t>
             </a:r>
           </a:p>
         </p:txBody>
@@ -15387,7 +16646,7 @@
                 </a:solidFill>
                 <a:latin typeface="Calibri"/>
               </a:rPr>
-              <a:t>NVIDIA RTX 5090 GPU</a:t>
+              <a:t>NVIDIA Orin AGX GPU</a:t>
             </a:r>
           </a:p>
         </p:txBody>
@@ -15422,7 +16681,7 @@
                 </a:solidFill>
                 <a:latin typeface="Calibri"/>
               </a:rPr>
-              <a:t>Blackwell, 170 SM, discrete, 32 GB, driver 580.173  |  D=128: 4.09 ms  ·  D=256: 7.08 ms</a:t>
+              <a:t>Ampere, 16 SM, CUDA 12.6, sm_87</a:t>
             </a:r>
           </a:p>
         </p:txBody>
@@ -15493,11 +16752,11 @@
                 <a:latin typeface="Consolas"/>
               </a:rPr>
               <a:t>MDE/s  =  W x H x D / runtime
-        =  1,920 x 1,080 x 64 / 3.46 ms
-        =  132,710,400 disparity estimations / 0.00346 s
-        =  38,356 million disparity estimations per second
-frame rate  =  1000 / 3.46  =  289.0 fps
-pixel rate  =  2.0736 Mpx x 289.0  =  599.31 Mpix/s</a:t>
+        =  1,920 x 1,080 x 64 / 23.28 ms
+        =  132,710,400 disparity estimations / 0.02328 s
+        =  5,701 million disparity estimations per second
+frame rate  =  1000 / 23.28  =  43.0 fps
+pixel rate  =  2.0736 Mpx x 43.0  =  89.07 Mpix/s</a:t>
             </a:r>
           </a:p>
         </p:txBody>
@@ -15567,7 +16826,7 @@
                 </a:solidFill>
                 <a:latin typeface="Calibri"/>
               </a:rPr>
-              <a:t>The fastest target measured: 37,383 MDE/s at D=64, 282 fps at 1080p.</a:t>
+              <a:t>Same kernel, same changes: 3.10x over the naive port (72.27 -&gt; 23.28 ms).</a:t>
             </a:r>
           </a:p>
           <a:p>
@@ -15578,7 +16837,7 @@
                 </a:solidFill>
                 <a:latin typeface="Calibri"/>
               </a:rPr>
-              <a:t>64,880 MDE/s at D=128 and 74,957 at D=256 -- and unlike Thor it shows NO</a:t>
+              <a:t>Bit-exact on the first run, before any tuning — the payoff for porting a</a:t>
             </a:r>
           </a:p>
           <a:p>
@@ -15589,161 +16848,7 @@
                 </a:solidFill>
                 <a:latin typeface="Calibri"/>
               </a:rPr>
-              <a:t>reversal at D=256, which is what the traffic mechanism predicts on a part</a:t>
-            </a:r>
-          </a:p>
-          <a:p>
-            <a:r>
-              <a:rPr sz="1300">
-                <a:solidFill>
-                  <a:srgbClr val="202124"/>
-                </a:solidFill>
-                <a:latin typeface="Calibri"/>
-              </a:rPr>
-              <a:t>with 5.6x the memory bandwidth.</a:t>
-            </a:r>
-          </a:p>
-          <a:p>
-            <a:r>
-              <a:rPr sz="1300">
-                <a:solidFill>
-                  <a:srgbClr val="202124"/>
-                </a:solidFill>
-                <a:latin typeface="Calibri"/>
-              </a:rPr>
-              <a:t>Bandwidth: 587 GB/s achieved of a measured 1,385 GB/s ceiling = 42%, the</a:t>
-            </a:r>
-          </a:p>
-          <a:p>
-            <a:r>
-              <a:rPr sz="1300">
-                <a:solidFill>
-                  <a:srgbClr val="202124"/>
-                </a:solidFill>
-                <a:latin typeface="Calibri"/>
-              </a:rPr>
-              <a:t>LOWEST utilisation of the three GPUs despite being the fastest -- so at this</a:t>
-            </a:r>
-          </a:p>
-          <a:p>
-            <a:r>
-              <a:rPr sz="1300">
-                <a:solidFill>
-                  <a:srgbClr val="202124"/>
-                </a:solidFill>
-                <a:latin typeface="Calibri"/>
-              </a:rPr>
-              <a:t>speed it is no longer purely bandwidth-bound.</a:t>
-            </a:r>
-          </a:p>
-          <a:p>
-            <a:r>
-              <a:rPr sz="1300">
-                <a:solidFill>
-                  <a:srgbClr val="202124"/>
-                </a:solidFill>
-                <a:latin typeface="Calibri"/>
-              </a:rPr>
-              <a:t>⚠️ Built as PTX and JIT-compiled by the driver: the local toolkit is CUDA</a:t>
-            </a:r>
-          </a:p>
-          <a:p>
-            <a:r>
-              <a:rPr sz="1300">
-                <a:solidFill>
-                  <a:srgbClr val="202124"/>
-                </a:solidFill>
-                <a:latin typeface="Calibri"/>
-              </a:rPr>
-              <a:t>12.6, which cannot target sm_120. Golden verified, but not a native build.</a:t>
-            </a:r>
-          </a:p>
-          <a:p>
-            <a:r>
-              <a:rPr sz="1300">
-                <a:solidFill>
-                  <a:srgbClr val="202124"/>
-                </a:solidFill>
-                <a:latin typeface="Calibri"/>
-              </a:rPr>
-              <a:t>⭐ ITS STEREO HARDWARE IS MEASURED, AND STEREO MODE IS ALREADY GONE.</a:t>
-            </a:r>
-          </a:p>
-          <a:p>
-            <a:r>
-              <a:rPr sz="1300">
-                <a:solidFill>
-                  <a:srgbClr val="202124"/>
-                </a:solidFill>
-                <a:latin typeface="Calibri"/>
-              </a:rPr>
-              <a:t>NV_OF_MODE_STEREODISPARITY returns UNSUPPORTED_FEATURE at every grid size;</a:t>
-            </a:r>
-          </a:p>
-          <a:p>
-            <a:r>
-              <a:rPr sz="1300">
-                <a:solidFill>
-                  <a:srgbClr val="202124"/>
-                </a:solidFill>
-                <a:latin typeface="Calibri"/>
-              </a:rPr>
-              <a:t>NVIDIA's documented deprecation has already landed on Blackwell.</a:t>
-            </a:r>
-          </a:p>
-          <a:p>
-            <a:r>
-              <a:rPr sz="1300">
-                <a:solidFill>
-                  <a:srgbClr val="202124"/>
-                </a:solidFill>
-                <a:latin typeface="Calibri"/>
-              </a:rPr>
-              <a:t>The fallback -- X component of general optical flow -- runs 8.50 ms with</a:t>
-            </a:r>
-          </a:p>
-          <a:p>
-            <a:r>
-              <a:rPr sz="1300">
-                <a:solidFill>
-                  <a:srgbClr val="202124"/>
-                </a:solidFill>
-                <a:latin typeface="Calibri"/>
-              </a:rPr>
-              <a:t>5.3% bad pixels, against our CUDA SGM's 4.13 ms and 2.8% on the same scene.</a:t>
-            </a:r>
-          </a:p>
-          <a:p>
-            <a:r>
-              <a:rPr sz="1300">
-                <a:solidFill>
-                  <a:srgbClr val="202124"/>
-                </a:solidFill>
-                <a:latin typeface="Calibri"/>
-              </a:rPr>
-              <a:t>Software faster AND more accurate, while doing less work (1D vs 2D).</a:t>
-            </a:r>
-          </a:p>
-          <a:p>
-            <a:r>
-              <a:rPr sz="1300">
-                <a:solidFill>
-                  <a:srgbClr val="202124"/>
-                </a:solidFill>
-                <a:latin typeface="Calibri"/>
-              </a:rPr>
-              <a:t>🚨 13.4% of pixels return a non-zero VERTICAL component, largest 75 px --</a:t>
-            </a:r>
-          </a:p>
-          <a:p>
-            <a:r>
-              <a:rPr sz="1300">
-                <a:solidFill>
-                  <a:srgbClr val="202124"/>
-                </a:solidFill>
-                <a:latin typeface="Calibri"/>
-              </a:rPr>
-              <a:t>errors the removed stereo mode was structurally incapable of producing.</a:t>
+              <a:t>verified OpenCL kernel one-for-one instead of writing a new one.</a:t>
             </a:r>
           </a:p>
         </p:txBody>
@@ -15851,11 +16956,11 @@
             <a:r>
               <a:rPr sz="3200" b="1">
                 <a:solidFill>
-                  <a:srgbClr val="E8710A"/>
-                </a:solidFill>
-                <a:latin typeface="Calibri"/>
-              </a:rPr>
-              <a:t>Cortex-A720 x8</a:t>
+                  <a:srgbClr val="4C8BF5"/>
+                </a:solidFill>
+                <a:latin typeface="Calibri"/>
+              </a:rPr>
+              <a:t>NVIDIA RTX 5090 GPU</a:t>
             </a:r>
           </a:p>
         </p:txBody>
@@ -15890,7 +16995,7 @@
                 </a:solidFill>
                 <a:latin typeface="Calibri"/>
               </a:rPr>
-              <a:t>Radxa Orion O6, 2.2-2.5 GHz, NEON  |  single core: 313.60 ms = 423 MDE/s @2.5 GHz</a:t>
+              <a:t>Blackwell, 170 SM, discrete, 32 GB, driver 580.173  |  D=128: 4.09 ms  ·  D=256: 7.08 ms</a:t>
             </a:r>
           </a:p>
         </p:txBody>
@@ -15961,11 +17066,11 @@
                 <a:latin typeface="Consolas"/>
               </a:rPr>
               <a:t>MDE/s  =  W x H x D / runtime
-        =  1,920 x 1,080 x 64 / 51.70 ms
-        =  132,710,400 disparity estimations / 0.05170 s
-        =  2,567 million disparity estimations per second
-frame rate  =  1000 / 51.70  =  19.3 fps
-pixel rate  =  2.0736 Mpx x 19.3  =  40.11 Mpix/s</a:t>
+        =  1,920 x 1,080 x 64 / 3.46 ms
+        =  132,710,400 disparity estimations / 0.00346 s
+        =  38,356 million disparity estimations per second
+frame rate  =  1000 / 3.46  =  289.0 fps
+pixel rate  =  2.0736 Mpx x 289.0  =  599.31 Mpix/s</a:t>
             </a:r>
           </a:p>
         </p:txBody>
@@ -16035,7 +17140,7 @@
                 </a:solidFill>
                 <a:latin typeface="Calibri"/>
               </a:rPr>
-              <a:t>The CPU headline: 10.4x the fastest published Arm-CPU SGM at matched D</a:t>
+              <a:t>The fastest target measured: 37,383 MDE/s at D=64, 282 fps at 1080p.</a:t>
             </a:r>
           </a:p>
           <a:p>
@@ -16046,7 +17151,7 @@
                 </a:solidFill>
                 <a:latin typeface="Calibri"/>
               </a:rPr>
-              <a:t>and matched path count (ReS2tAC, Sensors 21(11):3938, 2021 — 242 MDE/s).</a:t>
+              <a:t>64,880 MDE/s at D=128 and 74,957 at D=256 -- and unlike Thor it shows NO</a:t>
             </a:r>
           </a:p>
           <a:p>
@@ -16057,7 +17162,7 @@
                 </a:solidFill>
                 <a:latin typeface="Calibri"/>
               </a:rPr>
-              <a:t>Best single core measured at 423 MDE/s; scales monotonically 1-&gt;8 threads.</a:t>
+              <a:t>reversal at D=256, which is what the traffic mechanism predicts on a part</a:t>
             </a:r>
           </a:p>
           <a:p>
@@ -16068,7 +17173,150 @@
                 </a:solidFill>
                 <a:latin typeface="Calibri"/>
               </a:rPr>
-              <a:t>D=64 -&gt; D=128 is FLAT (-2.4%): 16 NEON lanes are already full at D=64.</a:t>
+              <a:t>with 5.6x the memory bandwidth.</a:t>
+            </a:r>
+          </a:p>
+          <a:p>
+            <a:r>
+              <a:rPr sz="1300">
+                <a:solidFill>
+                  <a:srgbClr val="202124"/>
+                </a:solidFill>
+                <a:latin typeface="Calibri"/>
+              </a:rPr>
+              <a:t>Bandwidth: 587 GB/s achieved of a measured 1,385 GB/s ceiling = 42%, the</a:t>
+            </a:r>
+          </a:p>
+          <a:p>
+            <a:r>
+              <a:rPr sz="1300">
+                <a:solidFill>
+                  <a:srgbClr val="202124"/>
+                </a:solidFill>
+                <a:latin typeface="Calibri"/>
+              </a:rPr>
+              <a:t>LOWEST utilisation of the three GPUs despite being the fastest -- so at this</a:t>
+            </a:r>
+          </a:p>
+          <a:p>
+            <a:r>
+              <a:rPr sz="1300">
+                <a:solidFill>
+                  <a:srgbClr val="202124"/>
+                </a:solidFill>
+                <a:latin typeface="Calibri"/>
+              </a:rPr>
+              <a:t>speed it is no longer purely bandwidth-bound.</a:t>
+            </a:r>
+          </a:p>
+          <a:p>
+            <a:r>
+              <a:rPr sz="1300">
+                <a:solidFill>
+                  <a:srgbClr val="202124"/>
+                </a:solidFill>
+                <a:latin typeface="Calibri"/>
+              </a:rPr>
+              <a:t>⚠️ Built as PTX and JIT-compiled by the driver: the local toolkit is CUDA</a:t>
+            </a:r>
+          </a:p>
+          <a:p>
+            <a:r>
+              <a:rPr sz="1300">
+                <a:solidFill>
+                  <a:srgbClr val="202124"/>
+                </a:solidFill>
+                <a:latin typeface="Calibri"/>
+              </a:rPr>
+              <a:t>12.6, which cannot target sm_120. Golden verified, but not a native build.</a:t>
+            </a:r>
+          </a:p>
+          <a:p>
+            <a:r>
+              <a:rPr sz="1300">
+                <a:solidFill>
+                  <a:srgbClr val="202124"/>
+                </a:solidFill>
+                <a:latin typeface="Calibri"/>
+              </a:rPr>
+              <a:t>⭐ ITS STEREO HARDWARE IS MEASURED, AND STEREO MODE IS ALREADY GONE.</a:t>
+            </a:r>
+          </a:p>
+          <a:p>
+            <a:r>
+              <a:rPr sz="1300">
+                <a:solidFill>
+                  <a:srgbClr val="202124"/>
+                </a:solidFill>
+                <a:latin typeface="Calibri"/>
+              </a:rPr>
+              <a:t>NV_OF_MODE_STEREODISPARITY returns UNSUPPORTED_FEATURE at every grid size;</a:t>
+            </a:r>
+          </a:p>
+          <a:p>
+            <a:r>
+              <a:rPr sz="1300">
+                <a:solidFill>
+                  <a:srgbClr val="202124"/>
+                </a:solidFill>
+                <a:latin typeface="Calibri"/>
+              </a:rPr>
+              <a:t>NVIDIA's documented deprecation has already landed on Blackwell.</a:t>
+            </a:r>
+          </a:p>
+          <a:p>
+            <a:r>
+              <a:rPr sz="1300">
+                <a:solidFill>
+                  <a:srgbClr val="202124"/>
+                </a:solidFill>
+                <a:latin typeface="Calibri"/>
+              </a:rPr>
+              <a:t>The fallback -- X component of general optical flow -- runs 8.50 ms with</a:t>
+            </a:r>
+          </a:p>
+          <a:p>
+            <a:r>
+              <a:rPr sz="1300">
+                <a:solidFill>
+                  <a:srgbClr val="202124"/>
+                </a:solidFill>
+                <a:latin typeface="Calibri"/>
+              </a:rPr>
+              <a:t>5.3% bad pixels, against our CUDA SGM's 4.13 ms and 2.8% on the same scene.</a:t>
+            </a:r>
+          </a:p>
+          <a:p>
+            <a:r>
+              <a:rPr sz="1300">
+                <a:solidFill>
+                  <a:srgbClr val="202124"/>
+                </a:solidFill>
+                <a:latin typeface="Calibri"/>
+              </a:rPr>
+              <a:t>Software faster AND more accurate, while doing less work (1D vs 2D).</a:t>
+            </a:r>
+          </a:p>
+          <a:p>
+            <a:r>
+              <a:rPr sz="1300">
+                <a:solidFill>
+                  <a:srgbClr val="202124"/>
+                </a:solidFill>
+                <a:latin typeface="Calibri"/>
+              </a:rPr>
+              <a:t>🚨 13.4% of pixels return a non-zero VERTICAL component, largest 75 px --</a:t>
+            </a:r>
+          </a:p>
+          <a:p>
+            <a:r>
+              <a:rPr sz="1300">
+                <a:solidFill>
+                  <a:srgbClr val="202124"/>
+                </a:solidFill>
+                <a:latin typeface="Calibri"/>
+              </a:rPr>
+              <a:t>errors the removed stereo mode was structurally incapable of producing.</a:t>
             </a:r>
           </a:p>
         </p:txBody>
@@ -16180,7 +17428,7 @@
                 </a:solidFill>
                 <a:latin typeface="Calibri"/>
               </a:rPr>
-              <a:t>Cortex-A78C x8</a:t>
+              <a:t>Cortex-A720 x8</a:t>
             </a:r>
           </a:p>
         </p:txBody>
@@ -16215,7 +17463,7 @@
                 </a:solidFill>
                 <a:latin typeface="Calibri"/>
               </a:rPr>
-              <a:t>Qualcomm IQ-9075, NEON  |  single core: 332.22 ms = 400 MDE/s</a:t>
+              <a:t>Radxa Orion O6, 2.2-2.5 GHz, NEON  |  single core: 313.60 ms = 423 MDE/s @2.5 GHz</a:t>
             </a:r>
           </a:p>
         </p:txBody>
@@ -16286,11 +17534,11 @@
                 <a:latin typeface="Consolas"/>
               </a:rPr>
               <a:t>MDE/s  =  W x H x D / runtime
-        =  1,920 x 1,080 x 64 / 97.99 ms
-        =  132,710,400 disparity estimations / 0.09799 s
-        =  1,354 million disparity estimations per second
-frame rate  =  1000 / 97.99  =  10.2 fps
-pixel rate  =  2.0736 Mpx x 10.2  =  21.16 Mpix/s</a:t>
+        =  1,920 x 1,080 x 64 / 51.70 ms
+        =  132,710,400 disparity estimations / 0.05170 s
+        =  2,567 million disparity estimations per second
+frame rate  =  1000 / 51.70  =  19.3 fps
+pixel rate  =  2.0736 Mpx x 19.3  =  40.11 Mpix/s</a:t>
             </a:r>
           </a:p>
         </p:txBody>
@@ -16360,7 +17608,7 @@
                 </a:solidFill>
                 <a:latin typeface="Calibri"/>
               </a:rPr>
-              <a:t>Ran THIS repository's a55 NEON implementation unmodified, on another</a:t>
+              <a:t>The CPU headline: 10.4x the fastest published Arm-CPU SGM at matched D</a:t>
             </a:r>
           </a:p>
           <a:p>
@@ -16371,7 +17619,7 @@
                 </a:solidFill>
                 <a:latin typeface="Calibri"/>
               </a:rPr>
-              <a:t>vendor's silicon, and reproduced the golden at every thread count.</a:t>
+              <a:t>and matched path count (ReS2tAC, Sensors 21(11):3938, 2021 — 242 MDE/s).</a:t>
             </a:r>
           </a:p>
           <a:p>
@@ -16382,7 +17630,7 @@
                 </a:solidFill>
                 <a:latin typeface="Calibri"/>
               </a:rPr>
-              <a:t>Per-core 402 MDE/s vs the A720's 423 — a 5% gap between two wide</a:t>
+              <a:t>Best single core measured at 423 MDE/s; scales monotonically 1-&gt;8 threads.</a:t>
             </a:r>
           </a:p>
           <a:p>
@@ -16393,18 +17641,7 @@
                 </a:solidFill>
                 <a:latin typeface="Calibri"/>
               </a:rPr>
-              <a:t>out-of-order Arm cores from different vendors on the same algorithm.</a:t>
-            </a:r>
-          </a:p>
-          <a:p>
-            <a:r>
-              <a:rPr sz="1300">
-                <a:solidFill>
-                  <a:srgbClr val="202124"/>
-                </a:solidFill>
-                <a:latin typeface="Calibri"/>
-              </a:rPr>
-              <a:t>Peaks at SIX threads, not eight; 8 threads is slower on that board.</a:t>
+              <a:t>D=64 -&gt; D=128 is FLAT (-2.4%): 16 NEON lanes are already full at D=64.</a:t>
             </a:r>
           </a:p>
         </p:txBody>
@@ -16512,11 +17749,11 @@
             <a:r>
               <a:rPr sz="3200" b="1">
                 <a:solidFill>
-                  <a:srgbClr val="12B5A5"/>
-                </a:solidFill>
-                <a:latin typeface="Calibri"/>
-              </a:rPr>
-              <a:t>Hexagon v73 NSP</a:t>
+                  <a:srgbClr val="E8710A"/>
+                </a:solidFill>
+                <a:latin typeface="Calibri"/>
+              </a:rPr>
+              <a:t>Cortex-A78C x8</a:t>
             </a:r>
           </a:p>
         </p:txBody>
@@ -16551,7 +17788,7 @@
                 </a:solidFill>
                 <a:latin typeface="Calibri"/>
               </a:rPr>
-              <a:t>Qualcomm IQ-9075, HVX, 4 HVX contexts</a:t>
+              <a:t>Qualcomm IQ-9075, NEON  |  single core: 332.22 ms = 400 MDE/s</a:t>
             </a:r>
           </a:p>
         </p:txBody>
@@ -16622,11 +17859,11 @@
                 <a:latin typeface="Consolas"/>
               </a:rPr>
               <a:t>MDE/s  =  W x H x D / runtime
-        =  1,920 x 1,080 x 64 / 148.44 ms
-        =  132,710,400 disparity estimations / 0.14844 s
-        =  894 million disparity estimations per second
-frame rate  =  1000 / 148.44  =  6.7 fps
-pixel rate  =  2.0736 Mpx x 6.7  =  13.97 Mpix/s</a:t>
+        =  1,920 x 1,080 x 64 / 97.99 ms
+        =  132,710,400 disparity estimations / 0.09799 s
+        =  1,354 million disparity estimations per second
+frame rate  =  1000 / 97.99  =  10.2 fps
+pixel rate  =  2.0736 Mpx x 10.2  =  21.16 Mpix/s</a:t>
             </a:r>
           </a:p>
         </p:txBody>
@@ -16696,7 +17933,7 @@
                 </a:solidFill>
                 <a:latin typeface="Calibri"/>
               </a:rPr>
-              <a:t>MEDIAN of 5 invocations; the board is BIMODAL between invocations (18% at</a:t>
+              <a:t>Ran THIS repository's a55 NEON implementation unmodified, on another</a:t>
             </a:r>
           </a:p>
           <a:p>
@@ -16707,7 +17944,7 @@
                 </a:solidFill>
                 <a:latin typeface="Calibri"/>
               </a:rPr>
-              <a:t>720p) so minima are the estimator most sensitive to luck -- quote medians.</a:t>
+              <a:t>vendor's silicon, and reproduced the golden at every thread count.</a:t>
             </a:r>
           </a:p>
           <a:p>
@@ -16718,7 +17955,7 @@
                 </a:solidFill>
                 <a:latin typeface="Calibri"/>
               </a:rPr>
-              <a:t>Went 18.7x -&gt; ... -&gt; 1.51x vs the A78C cluster across one day of tuning,</a:t>
+              <a:t>Per-core 402 MDE/s vs the A720's 423 — a 5% gap between two wide</a:t>
             </a:r>
           </a:p>
           <a:p>
@@ -16729,7 +17966,7 @@
                 </a:solidFill>
                 <a:latin typeface="Calibri"/>
               </a:rPr>
-              <a:t>nothing retracted: always labelled a floor of EFFORT. Beats one A78C core 2.26x.</a:t>
+              <a:t>out-of-order Arm cores from different vendors on the same algorithm.</a:t>
             </a:r>
           </a:p>
           <a:p>
@@ -16740,18 +17977,7 @@
                 </a:solidFill>
                 <a:latin typeface="Calibri"/>
               </a:rPr>
-              <a:t>Six hardware threads but only FOUR HVX contexts, so 4 threads is optimal.</a:t>
-            </a:r>
-          </a:p>
-          <a:p>
-            <a:r>
-              <a:rPr sz="1300">
-                <a:solidFill>
-                  <a:srgbClr val="202124"/>
-                </a:solidFill>
-                <a:latin typeface="Calibri"/>
-              </a:rPr>
-              <a:t>Still latency-bound at 6.8 of 28 GB/s — a different wall to Thor's.</a:t>
+              <a:t>Peaks at SIX threads, not eight; 8 threads is slower on that board.</a:t>
             </a:r>
           </a:p>
         </p:txBody>
@@ -16859,11 +18085,11 @@
             <a:r>
               <a:rPr sz="3200" b="1">
                 <a:solidFill>
-                  <a:srgbClr val="4C8BF5"/>
-                </a:solidFill>
-                <a:latin typeface="Calibri"/>
-              </a:rPr>
-              <a:t>Mali-G720</a:t>
+                  <a:srgbClr val="12B5A5"/>
+                </a:solidFill>
+                <a:latin typeface="Calibri"/>
+              </a:rPr>
+              <a:t>Hexagon v73 NSP</a:t>
             </a:r>
           </a:p>
         </p:txBody>
@@ -16898,7 +18124,7 @@
                 </a:solidFill>
                 <a:latin typeface="Calibri"/>
               </a:rPr>
-              <a:t>Immortalis, 10 CU, OpenCL 3.0</a:t>
+              <a:t>Qualcomm IQ-9075, HVX, 4 HVX contexts</a:t>
             </a:r>
           </a:p>
         </p:txBody>
@@ -16969,11 +18195,11 @@
                 <a:latin typeface="Consolas"/>
               </a:rPr>
               <a:t>MDE/s  =  W x H x D / runtime
-        =  1,920 x 1,080 x 64 / 256.00 ms
-        =  132,710,400 disparity estimations / 0.25600 s
-        =  518 million disparity estimations per second
-frame rate  =  1000 / 256.00  =  3.9 fps
-pixel rate  =  2.0736 Mpx x 3.9  =  8.10 Mpix/s</a:t>
+        =  1,920 x 1,080 x 64 / 148.44 ms
+        =  132,710,400 disparity estimations / 0.14844 s
+        =  894 million disparity estimations per second
+frame rate  =  1000 / 148.44  =  6.7 fps
+pixel rate  =  2.0736 Mpx x 6.7  =  13.97 Mpix/s</a:t>
             </a:r>
           </a:p>
         </p:txBody>
@@ -17043,7 +18269,7 @@
                 </a:solidFill>
                 <a:latin typeface="Calibri"/>
               </a:rPr>
-              <a:t>Loses to TWO A720 cores. But this is an UNBOUNDED FLOOR, not a verdict</a:t>
+              <a:t>MEDIAN of 5 invocations; the board is BIMODAL between invocations (18% at</a:t>
             </a:r>
           </a:p>
           <a:p>
@@ -17054,7 +18280,7 @@
                 </a:solidFill>
                 <a:latin typeface="Calibri"/>
               </a:rPr>
-              <a:t>on the hardware: the kernel carries ONE dependency chain per work-item</a:t>
+              <a:t>720p) so minima are the estimator most sensitive to luck -- quote medians.</a:t>
             </a:r>
           </a:p>
           <a:p>
@@ -17065,7 +18291,7 @@
                 </a:solidFill>
                 <a:latin typeface="Calibri"/>
               </a:rPr>
-              <a:t>with three barrier sites per step and never interleaves chains.</a:t>
+              <a:t>Went 18.7x -&gt; ... -&gt; 1.51x vs the A78C cluster across one day of tuning,</a:t>
             </a:r>
           </a:p>
           <a:p>
@@ -17076,7 +18302,29 @@
                 </a:solidFill>
                 <a:latin typeface="Calibri"/>
               </a:rPr>
-              <a:t>Nobody has done for this part what was done for the DSP.</a:t>
+              <a:t>nothing retracted: always labelled a floor of EFFORT. Beats one A78C core 2.26x.</a:t>
+            </a:r>
+          </a:p>
+          <a:p>
+            <a:r>
+              <a:rPr sz="1300">
+                <a:solidFill>
+                  <a:srgbClr val="202124"/>
+                </a:solidFill>
+                <a:latin typeface="Calibri"/>
+              </a:rPr>
+              <a:t>Six hardware threads but only FOUR HVX contexts, so 4 threads is optimal.</a:t>
+            </a:r>
+          </a:p>
+          <a:p>
+            <a:r>
+              <a:rPr sz="1300">
+                <a:solidFill>
+                  <a:srgbClr val="202124"/>
+                </a:solidFill>
+                <a:latin typeface="Calibri"/>
+              </a:rPr>
+              <a:t>Still latency-bound at 6.8 of 28 GB/s — a different wall to Thor's.</a:t>
             </a:r>
           </a:p>
         </p:txBody>
@@ -17184,11 +18432,11 @@
             <a:r>
               <a:rPr sz="3200" b="1">
                 <a:solidFill>
-                  <a:srgbClr val="7B4FD1"/>
-                </a:solidFill>
-                <a:latin typeface="Calibri"/>
-              </a:rPr>
-              <a:t>NVIDIA Thor OFA</a:t>
+                  <a:srgbClr val="4C8BF5"/>
+                </a:solidFill>
+                <a:latin typeface="Calibri"/>
+              </a:rPr>
+              <a:t>Mali-G720</a:t>
             </a:r>
           </a:p>
         </p:txBody>
@@ -17223,7 +18471,7 @@
                 </a:solidFill>
                 <a:latin typeface="Calibri"/>
               </a:rPr>
-              <a:t>Fixed-function SGM engine (Optical Flow Accelerator), VPI 4.1.4  |  1080p D=128, downscaleFactor=1</a:t>
+              <a:t>Immortalis, 10 CU, OpenCL 3.0</a:t>
             </a:r>
           </a:p>
         </p:txBody>
@@ -17294,11 +18542,11 @@
                 <a:latin typeface="Consolas"/>
               </a:rPr>
               <a:t>MDE/s  =  W x H x D / runtime
-        =  1,920 x 1,080 x 64 / 9.35 ms
-        =  132,710,400 disparity estimations / 0.00935 s
-        =  14,201 million disparity estimations per second
-frame rate  =  1000 / 9.35  =  107.0 fps
-pixel rate  =  2.0736 Mpx x 107.0  =  221.89 Mpix/s</a:t>
+        =  1,920 x 1,080 x 64 / 256.00 ms
+        =  132,710,400 disparity estimations / 0.25600 s
+        =  518 million disparity estimations per second
+frame rate  =  1000 / 256.00  =  3.9 fps
+pixel rate  =  2.0736 Mpx x 3.9  =  8.10 Mpix/s</a:t>
             </a:r>
           </a:p>
         </p:txBody>
@@ -17368,7 +18616,7 @@
                 </a:solidFill>
                 <a:latin typeface="Calibri"/>
               </a:rPr>
-              <a:t>DEDICATED STEREO HARDWARE, and it beats our tuned CUDA on the same chip</a:t>
+              <a:t>Loses to TWO A720 cores. But this is an UNBOUNDED FLOOR, not a verdict</a:t>
             </a:r>
           </a:p>
           <a:p>
@@ -17379,7 +18627,7 @@
                 </a:solidFill>
                 <a:latin typeface="Calibri"/>
               </a:rPr>
-              <a:t>by 2.34x (9.35 ms vs 21.86 ms at 1920x1080 D=128).</a:t>
+              <a:t>on the hardware: the kernel carries ONE dependency chain per work-item</a:t>
             </a:r>
           </a:p>
           <a:p>
@@ -17390,7 +18638,7 @@
                 </a:solidFill>
                 <a:latin typeface="Calibri"/>
               </a:rPr>
-              <a:t>NOT bit-exact to our golden: VPI's SGM is a different implementation with</a:t>
+              <a:t>with three barrier sites per step and never interleaves chains.</a:t>
             </a:r>
           </a:p>
           <a:p>
@@ -17401,106 +18649,7 @@
                 </a:solidFill>
                 <a:latin typeface="Calibri"/>
               </a:rPr>
-              <a:t>its own census, penalties and confidence output. Throughput comparison at</a:t>
-            </a:r>
-          </a:p>
-          <a:p>
-            <a:r>
-              <a:rPr sz="1300">
-                <a:solidFill>
-                  <a:srgbClr val="202124"/>
-                </a:solidFill>
-                <a:latin typeface="Calibri"/>
-              </a:rPr>
-              <a:t>matched resolution and D -- NOT the same test, and NOT a quality claim.</a:t>
-            </a:r>
-          </a:p>
-          <a:p>
-            <a:r>
-              <a:rPr sz="1300">
-                <a:solidFill>
-                  <a:srgbClr val="202124"/>
-                </a:solidFill>
-                <a:latin typeface="Calibri"/>
-              </a:rPr>
-              <a:t>🔴 ACCURACY WITHDRAWN. Scored against ground truth our SGM gets 2.6% bad&gt;1px</a:t>
-            </a:r>
-          </a:p>
-          <a:p>
-            <a:r>
-              <a:rPr sz="1300">
-                <a:solidFill>
-                  <a:srgbClr val="202124"/>
-                </a:solidFill>
-                <a:latin typeface="Calibri"/>
-              </a:rPr>
-              <a:t>(MAE 0.45); OFA aligns under no simple descaling, so its accuracy is</a:t>
-            </a:r>
-          </a:p>
-          <a:p>
-            <a:r>
-              <a:rPr sz="1300">
-                <a:solidFill>
-                  <a:srgbClr val="202124"/>
-                </a:solidFill>
-                <a:latin typeface="Calibri"/>
-              </a:rPr>
-              <a:t>UNMEASURED and this 2.34x is throughput only.</a:t>
-            </a:r>
-          </a:p>
-          <a:p>
-            <a:r>
-              <a:rPr sz="1300">
-                <a:solidFill>
-                  <a:srgbClr val="202124"/>
-                </a:solidFill>
-                <a:latin typeface="Calibri"/>
-              </a:rPr>
-              <a:t>VPI defaults to includeDiagonals=1, so OFA ran 8 paths against our 4. Measured,</a:t>
-            </a:r>
-          </a:p>
-          <a:p>
-            <a:r>
-              <a:rPr sz="1300">
-                <a:solidFill>
-                  <a:srgbClr val="202124"/>
-                </a:solidFill>
-                <a:latin typeface="Calibri"/>
-              </a:rPr>
-              <a:t>not assumed: OFA costs 9.42 ms at 8 paths and 9.85 at 4 -- path-count</a:t>
-            </a:r>
-          </a:p>
-          <a:p>
-            <a:r>
-              <a:rPr sz="1300">
-                <a:solidFill>
-                  <a:srgbClr val="202124"/>
-                </a:solidFill>
-                <a:latin typeface="Calibri"/>
-              </a:rPr>
-              <a:t>independent. The timing stands and OFA delivers an 8-path result in our time.</a:t>
-            </a:r>
-          </a:p>
-          <a:p>
-            <a:r>
-              <a:rPr sz="1300">
-                <a:solidFill>
-                  <a:srgbClr val="202124"/>
-                </a:solidFill>
-                <a:latin typeface="Calibri"/>
-              </a:rPr>
-              <a:t>⚠️ It defaults to downscaleFactor=2, which emits a 960x540 map from 1080p</a:t>
-            </a:r>
-          </a:p>
-          <a:p>
-            <a:r>
-              <a:rPr sz="1300">
-                <a:solidFill>
-                  <a:srgbClr val="202124"/>
-                </a:solidFill>
-                <a:latin typeface="Calibri"/>
-              </a:rPr>
-              <a:t>input in 4.14 ms. Quoting that as a 1080p figure overstates it by 2.3x.</a:t>
+              <a:t>Nobody has done for this part what was done for the DSP.</a:t>
             </a:r>
           </a:p>
         </p:txBody>

</xml_diff>

<commit_message>
deck: DRAM column on all three summary tables
A keeps achieved/ceiling; B and C gain the same-format column with MEASURED
ceilings and an explicitly blank achieved half (their per-phase byte models
are not derived -- the footnote says so rather than letting a dash imply
zero). n.m. = ceiling not measured on the leased A78C board.
</commit_message>
<xml_diff>
--- a/docs/sgm-results.pptx
+++ b/docs/sgm-results.pptx
@@ -7537,12 +7537,13 @@
                 <a:tableStyleId>{5C22544A-7EE6-4342-B048-85BDC9FD1C3A}</a:tableStyleId>
               </a:tblPr>
               <a:tblGrid>
-                <a:gridCol w="3291840"/>
-                <a:gridCol w="914400"/>
-                <a:gridCol w="1737360"/>
-                <a:gridCol w="1188720"/>
-                <a:gridCol w="1737360"/>
-                <a:gridCol w="2194560"/>
+                <a:gridCol w="3017520"/>
+                <a:gridCol w="822960"/>
+                <a:gridCol w="1463040"/>
+                <a:gridCol w="1005840"/>
+                <a:gridCol w="1554480"/>
+                <a:gridCol w="1371600"/>
+                <a:gridCol w="1828800"/>
               </a:tblGrid>
               <a:tr h="228600">
                 <a:tc>
@@ -7661,7 +7662,7 @@
                             <a:srgbClr val="FFFFFF"/>
                           </a:solidFill>
                         </a:rPr>
-                        <a:t>vs scalar reference</a:t>
+                        <a:t>DRAM GB/s ‡</a:t>
                       </a:r>
                     </a:p>
                   </a:txBody>
@@ -7671,6 +7672,27 @@
                     </a:solidFill>
                   </a:tcPr>
                 </a:tc>
+                <a:tc>
+                  <a:txBody>
+                    <a:bodyPr/>
+                    <a:lstStyle/>
+                    <a:p>
+                      <a:r>
+                        <a:rPr sz="1100" b="1">
+                          <a:solidFill>
+                            <a:srgbClr val="FFFFFF"/>
+                          </a:solidFill>
+                        </a:rPr>
+                        <a:t>vs scalar reference</a:t>
+                      </a:r>
+                    </a:p>
+                  </a:txBody>
+                  <a:tcPr>
+                    <a:solidFill>
+                      <a:srgbClr val="202124"/>
+                    </a:solidFill>
+                  </a:tcPr>
+                </a:tc>
               </a:tr>
               <a:tr h="228600">
                 <a:tc>
@@ -7769,6 +7791,23 @@
                             <a:srgbClr val="202124"/>
                           </a:solidFill>
                         </a:rPr>
+                        <a:t>— / 249</a:t>
+                      </a:r>
+                    </a:p>
+                  </a:txBody>
+                  <a:tcPr/>
+                </a:tc>
+                <a:tc>
+                  <a:txBody>
+                    <a:bodyPr/>
+                    <a:lstStyle/>
+                    <a:p>
+                      <a:r>
+                        <a:rPr sz="1100" b="0">
+                          <a:solidFill>
+                            <a:srgbClr val="202124"/>
+                          </a:solidFill>
+                        </a:rPr>
                         <a:t>4,220x (time only)</a:t>
                       </a:r>
                     </a:p>
@@ -7873,6 +7912,23 @@
                             <a:srgbClr val="202124"/>
                           </a:solidFill>
                         </a:rPr>
+                        <a:t>— / 1,385</a:t>
+                      </a:r>
+                    </a:p>
+                  </a:txBody>
+                  <a:tcPr/>
+                </a:tc>
+                <a:tc>
+                  <a:txBody>
+                    <a:bodyPr/>
+                    <a:lstStyle/>
+                    <a:p>
+                      <a:r>
+                        <a:rPr sz="1100" b="0">
+                          <a:solidFill>
+                            <a:srgbClr val="202124"/>
+                          </a:solidFill>
+                        </a:rPr>
                         <a:t>1,571x faster</a:t>
                       </a:r>
                     </a:p>
@@ -7977,6 +8033,23 @@
                             <a:srgbClr val="202124"/>
                           </a:solidFill>
                         </a:rPr>
+                        <a:t>— / 175</a:t>
+                      </a:r>
+                    </a:p>
+                  </a:txBody>
+                  <a:tcPr/>
+                </a:tc>
+                <a:tc>
+                  <a:txBody>
+                    <a:bodyPr/>
+                    <a:lstStyle/>
+                    <a:p>
+                      <a:r>
+                        <a:rPr sz="1100" b="0">
+                          <a:solidFill>
+                            <a:srgbClr val="202124"/>
+                          </a:solidFill>
+                        </a:rPr>
                         <a:t>957x (time only)</a:t>
                       </a:r>
                     </a:p>
@@ -8081,6 +8154,23 @@
                             <a:srgbClr val="202124"/>
                           </a:solidFill>
                         </a:rPr>
+                        <a:t>— / 249</a:t>
+                      </a:r>
+                    </a:p>
+                  </a:txBody>
+                  <a:tcPr/>
+                </a:tc>
+                <a:tc>
+                  <a:txBody>
+                    <a:bodyPr/>
+                    <a:lstStyle/>
+                    <a:p>
+                      <a:r>
+                        <a:rPr sz="1100" b="0">
+                          <a:solidFill>
+                            <a:srgbClr val="202124"/>
+                          </a:solidFill>
+                        </a:rPr>
                         <a:t>316x faster</a:t>
                       </a:r>
                     </a:p>
@@ -8185,6 +8275,23 @@
                             <a:srgbClr val="202124"/>
                           </a:solidFill>
                         </a:rPr>
+                        <a:t>— / 175</a:t>
+                      </a:r>
+                    </a:p>
+                  </a:txBody>
+                  <a:tcPr/>
+                </a:tc>
+                <a:tc>
+                  <a:txBody>
+                    <a:bodyPr/>
+                    <a:lstStyle/>
+                    <a:p>
+                      <a:r>
+                        <a:rPr sz="1100" b="0">
+                          <a:solidFill>
+                            <a:srgbClr val="202124"/>
+                          </a:solidFill>
+                        </a:rPr>
                         <a:t>196x faster</a:t>
                       </a:r>
                     </a:p>
@@ -8289,6 +8396,23 @@
                             <a:srgbClr val="202124"/>
                           </a:solidFill>
                         </a:rPr>
+                        <a:t>— / n.m.</a:t>
+                      </a:r>
+                    </a:p>
+                  </a:txBody>
+                  <a:tcPr/>
+                </a:tc>
+                <a:tc>
+                  <a:txBody>
+                    <a:bodyPr/>
+                    <a:lstStyle/>
+                    <a:p>
+                      <a:r>
+                        <a:rPr sz="1100" b="0">
+                          <a:solidFill>
+                            <a:srgbClr val="202124"/>
+                          </a:solidFill>
+                        </a:rPr>
                         <a:t>67x faster</a:t>
                       </a:r>
                     </a:p>
@@ -8393,6 +8517,23 @@
                             <a:srgbClr val="202124"/>
                           </a:solidFill>
                         </a:rPr>
+                        <a:t>— / 46.3</a:t>
+                      </a:r>
+                    </a:p>
+                  </a:txBody>
+                  <a:tcPr/>
+                </a:tc>
+                <a:tc>
+                  <a:txBody>
+                    <a:bodyPr/>
+                    <a:lstStyle/>
+                    <a:p>
+                      <a:r>
+                        <a:rPr sz="1100" b="0">
+                          <a:solidFill>
+                            <a:srgbClr val="202124"/>
+                          </a:solidFill>
+                        </a:rPr>
                         <a:t>60x faster</a:t>
                       </a:r>
                     </a:p>
@@ -8497,6 +8638,23 @@
                             <a:srgbClr val="202124"/>
                           </a:solidFill>
                         </a:rPr>
+                        <a:t>— / 28</a:t>
+                      </a:r>
+                    </a:p>
+                  </a:txBody>
+                  <a:tcPr/>
+                </a:tc>
+                <a:tc>
+                  <a:txBody>
+                    <a:bodyPr/>
+                    <a:lstStyle/>
+                    <a:p>
+                      <a:r>
+                        <a:rPr sz="1100" b="0">
+                          <a:solidFill>
+                            <a:srgbClr val="202124"/>
+                          </a:solidFill>
+                        </a:rPr>
                         <a:t>52x faster</a:t>
                       </a:r>
                     </a:p>
@@ -8601,6 +8759,23 @@
                             <a:srgbClr val="202124"/>
                           </a:solidFill>
                         </a:rPr>
+                        <a:t>— / 46.3</a:t>
+                      </a:r>
+                    </a:p>
+                  </a:txBody>
+                  <a:tcPr/>
+                </a:tc>
+                <a:tc>
+                  <a:txBody>
+                    <a:bodyPr/>
+                    <a:lstStyle/>
+                    <a:p>
+                      <a:r>
+                        <a:rPr sz="1100" b="0">
+                          <a:solidFill>
+                            <a:srgbClr val="202124"/>
+                          </a:solidFill>
+                        </a:rPr>
                         <a:t>38x faster</a:t>
                       </a:r>
                     </a:p>
@@ -8705,6 +8880,23 @@
                             <a:srgbClr val="202124"/>
                           </a:solidFill>
                         </a:rPr>
+                        <a:t>— / n.m.</a:t>
+                      </a:r>
+                    </a:p>
+                  </a:txBody>
+                  <a:tcPr/>
+                </a:tc>
+                <a:tc>
+                  <a:txBody>
+                    <a:bodyPr/>
+                    <a:lstStyle/>
+                    <a:p>
+                      <a:r>
+                        <a:rPr sz="1100" b="0">
+                          <a:solidFill>
+                            <a:srgbClr val="202124"/>
+                          </a:solidFill>
+                        </a:rPr>
                         <a:t>32x faster</a:t>
                       </a:r>
                     </a:p>
@@ -8809,6 +9001,23 @@
                             <a:srgbClr val="202124"/>
                           </a:solidFill>
                         </a:rPr>
+                        <a:t>— / 46.3</a:t>
+                      </a:r>
+                    </a:p>
+                  </a:txBody>
+                  <a:tcPr/>
+                </a:tc>
+                <a:tc>
+                  <a:txBody>
+                    <a:bodyPr/>
+                    <a:lstStyle/>
+                    <a:p>
+                      <a:r>
+                        <a:rPr sz="1100" b="0">
+                          <a:solidFill>
+                            <a:srgbClr val="202124"/>
+                          </a:solidFill>
+                        </a:rPr>
                         <a:t>30x faster</a:t>
                       </a:r>
                     </a:p>
@@ -8913,6 +9122,23 @@
                             <a:srgbClr val="202124"/>
                           </a:solidFill>
                         </a:rPr>
+                        <a:t>— / 13.7</a:t>
+                      </a:r>
+                    </a:p>
+                  </a:txBody>
+                  <a:tcPr/>
+                </a:tc>
+                <a:tc>
+                  <a:txBody>
+                    <a:bodyPr/>
+                    <a:lstStyle/>
+                    <a:p>
+                      <a:r>
+                        <a:rPr sz="1100" b="0">
+                          <a:solidFill>
+                            <a:srgbClr val="202124"/>
+                          </a:solidFill>
+                        </a:rPr>
                         <a:t>22x faster</a:t>
                       </a:r>
                     </a:p>
@@ -9017,6 +9243,23 @@
                             <a:srgbClr val="202124"/>
                           </a:solidFill>
                         </a:rPr>
+                        <a:t>— / 13.7</a:t>
+                      </a:r>
+                    </a:p>
+                  </a:txBody>
+                  <a:tcPr/>
+                </a:tc>
+                <a:tc>
+                  <a:txBody>
+                    <a:bodyPr/>
+                    <a:lstStyle/>
+                    <a:p>
+                      <a:r>
+                        <a:rPr sz="1100" b="0">
+                          <a:solidFill>
+                            <a:srgbClr val="202124"/>
+                          </a:solidFill>
+                        </a:rPr>
                         <a:t>6x faster</a:t>
                       </a:r>
                     </a:p>
@@ -9121,6 +9364,23 @@
                             <a:srgbClr val="202124"/>
                           </a:solidFill>
                         </a:rPr>
+                        <a:t>— / 13.7</a:t>
+                      </a:r>
+                    </a:p>
+                  </a:txBody>
+                  <a:tcPr/>
+                </a:tc>
+                <a:tc>
+                  <a:txBody>
+                    <a:bodyPr/>
+                    <a:lstStyle/>
+                    <a:p>
+                      <a:r>
+                        <a:rPr sz="1100" b="0">
+                          <a:solidFill>
+                            <a:srgbClr val="202124"/>
+                          </a:solidFill>
+                        </a:rPr>
                         <a:t>5x faster</a:t>
                       </a:r>
                     </a:p>
@@ -9209,6 +9469,23 @@
                           </a:solidFill>
                         </a:rPr>
                         <a:t>8.6</a:t>
+                      </a:r>
+                    </a:p>
+                  </a:txBody>
+                  <a:tcPr/>
+                </a:tc>
+                <a:tc>
+                  <a:txBody>
+                    <a:bodyPr/>
+                    <a:lstStyle/>
+                    <a:p>
+                      <a:r>
+                        <a:rPr sz="1100" b="0">
+                          <a:solidFill>
+                            <a:srgbClr val="202124"/>
+                          </a:solidFill>
+                        </a:rPr>
+                        <a:t>— / 13.7</a:t>
                       </a:r>
                     </a:p>
                   </a:txBody>
@@ -9509,7 +9786,7 @@
                 </a:solidFill>
                 <a:latin typeface="Calibri"/>
               </a:rPr>
-              <a:t>MDE/s (work) = both full-search scales count: (0.384 + 1.536) Mpx x 64 / runtime. OFA rows: the engines' OWN SGM at matched geometry (downscaleFactor=2, D=128), throughput only; full-res-out variants 9.15 / 54.94 ms. DRAM: same silicon and MEASURED ceilings as the bandwidth slide; Config B's per-phase byte model is not separately derived, so no achieved column is claimed here.</a:t>
+              <a:t>MDE/s (work) = both scales count: (0.384 + 1.536) Mpx x 64 / runtime. OFA rows: their OWN SGM at matched geometry (ds=2, D=128), throughput only. ‡ DRAM = achieved / ceiling GB/s: ceilings MEASURED (same silicon as Config A; n.m. = not measured on that board); achieved left blank -- B's per-phase byte model is not derived, and an invented number would poison the column.</a:t>
             </a:r>
           </a:p>
         </p:txBody>
@@ -9803,12 +10080,13 @@
                 <a:tableStyleId>{5C22544A-7EE6-4342-B048-85BDC9FD1C3A}</a:tableStyleId>
               </a:tblPr>
               <a:tblGrid>
-                <a:gridCol w="3291840"/>
-                <a:gridCol w="914400"/>
-                <a:gridCol w="1737360"/>
-                <a:gridCol w="1188720"/>
-                <a:gridCol w="1737360"/>
-                <a:gridCol w="2194560"/>
+                <a:gridCol w="3017520"/>
+                <a:gridCol w="822960"/>
+                <a:gridCol w="1463040"/>
+                <a:gridCol w="1005840"/>
+                <a:gridCol w="1554480"/>
+                <a:gridCol w="1371600"/>
+                <a:gridCol w="1828800"/>
               </a:tblGrid>
               <a:tr h="228600">
                 <a:tc>
@@ -9927,7 +10205,7 @@
                             <a:srgbClr val="FFFFFF"/>
                           </a:solidFill>
                         </a:rPr>
-                        <a:t>vs scalar reference</a:t>
+                        <a:t>DRAM GB/s ‡</a:t>
                       </a:r>
                     </a:p>
                   </a:txBody>
@@ -9937,6 +10215,27 @@
                     </a:solidFill>
                   </a:tcPr>
                 </a:tc>
+                <a:tc>
+                  <a:txBody>
+                    <a:bodyPr/>
+                    <a:lstStyle/>
+                    <a:p>
+                      <a:r>
+                        <a:rPr sz="1100" b="1">
+                          <a:solidFill>
+                            <a:srgbClr val="FFFFFF"/>
+                          </a:solidFill>
+                        </a:rPr>
+                        <a:t>vs scalar reference</a:t>
+                      </a:r>
+                    </a:p>
+                  </a:txBody>
+                  <a:tcPr>
+                    <a:solidFill>
+                      <a:srgbClr val="202124"/>
+                    </a:solidFill>
+                  </a:tcPr>
+                </a:tc>
               </a:tr>
               <a:tr h="228600">
                 <a:tc>
@@ -10035,6 +10334,23 @@
                             <a:srgbClr val="202124"/>
                           </a:solidFill>
                         </a:rPr>
+                        <a:t>— / 249</a:t>
+                      </a:r>
+                    </a:p>
+                  </a:txBody>
+                  <a:tcPr/>
+                </a:tc>
+                <a:tc>
+                  <a:txBody>
+                    <a:bodyPr/>
+                    <a:lstStyle/>
+                    <a:p>
+                      <a:r>
+                        <a:rPr sz="1050" b="0">
+                          <a:solidFill>
+                            <a:srgbClr val="202124"/>
+                          </a:solidFill>
+                        </a:rPr>
                         <a:t>4,417x (time only)</a:t>
                       </a:r>
                     </a:p>
@@ -10139,6 +10455,23 @@
                             <a:srgbClr val="202124"/>
                           </a:solidFill>
                         </a:rPr>
+                        <a:t>— / 1,385</a:t>
+                      </a:r>
+                    </a:p>
+                  </a:txBody>
+                  <a:tcPr/>
+                </a:tc>
+                <a:tc>
+                  <a:txBody>
+                    <a:bodyPr/>
+                    <a:lstStyle/>
+                    <a:p>
+                      <a:r>
+                        <a:rPr sz="1050" b="0">
+                          <a:solidFill>
+                            <a:srgbClr val="202124"/>
+                          </a:solidFill>
+                        </a:rPr>
                         <a:t>1,507x faster</a:t>
                       </a:r>
                     </a:p>
@@ -10243,6 +10576,23 @@
                             <a:srgbClr val="202124"/>
                           </a:solidFill>
                         </a:rPr>
+                        <a:t>— / 175</a:t>
+                      </a:r>
+                    </a:p>
+                  </a:txBody>
+                  <a:tcPr/>
+                </a:tc>
+                <a:tc>
+                  <a:txBody>
+                    <a:bodyPr/>
+                    <a:lstStyle/>
+                    <a:p>
+                      <a:r>
+                        <a:rPr sz="1050" b="0">
+                          <a:solidFill>
+                            <a:srgbClr val="202124"/>
+                          </a:solidFill>
+                        </a:rPr>
                         <a:t>924x (time only)</a:t>
                       </a:r>
                     </a:p>
@@ -10347,6 +10697,23 @@
                             <a:srgbClr val="202124"/>
                           </a:solidFill>
                         </a:rPr>
+                        <a:t>— / 249</a:t>
+                      </a:r>
+                    </a:p>
+                  </a:txBody>
+                  <a:tcPr/>
+                </a:tc>
+                <a:tc>
+                  <a:txBody>
+                    <a:bodyPr/>
+                    <a:lstStyle/>
+                    <a:p>
+                      <a:r>
+                        <a:rPr sz="1050" b="0">
+                          <a:solidFill>
+                            <a:srgbClr val="202124"/>
+                          </a:solidFill>
+                        </a:rPr>
                         <a:t>318x faster</a:t>
                       </a:r>
                     </a:p>
@@ -10451,6 +10818,23 @@
                             <a:srgbClr val="202124"/>
                           </a:solidFill>
                         </a:rPr>
+                        <a:t>— / 175</a:t>
+                      </a:r>
+                    </a:p>
+                  </a:txBody>
+                  <a:tcPr/>
+                </a:tc>
+                <a:tc>
+                  <a:txBody>
+                    <a:bodyPr/>
+                    <a:lstStyle/>
+                    <a:p>
+                      <a:r>
+                        <a:rPr sz="1050" b="0">
+                          <a:solidFill>
+                            <a:srgbClr val="202124"/>
+                          </a:solidFill>
+                        </a:rPr>
                         <a:t>186x faster</a:t>
                       </a:r>
                     </a:p>
@@ -10555,6 +10939,23 @@
                             <a:srgbClr val="202124"/>
                           </a:solidFill>
                         </a:rPr>
+                        <a:t>— / 46.3</a:t>
+                      </a:r>
+                    </a:p>
+                  </a:txBody>
+                  <a:tcPr/>
+                </a:tc>
+                <a:tc>
+                  <a:txBody>
+                    <a:bodyPr/>
+                    <a:lstStyle/>
+                    <a:p>
+                      <a:r>
+                        <a:rPr sz="1050" b="0">
+                          <a:solidFill>
+                            <a:srgbClr val="202124"/>
+                          </a:solidFill>
+                        </a:rPr>
                         <a:t>75x faster</a:t>
                       </a:r>
                     </a:p>
@@ -10659,6 +11060,23 @@
                             <a:srgbClr val="202124"/>
                           </a:solidFill>
                         </a:rPr>
+                        <a:t>— / n.m.</a:t>
+                      </a:r>
+                    </a:p>
+                  </a:txBody>
+                  <a:tcPr/>
+                </a:tc>
+                <a:tc>
+                  <a:txBody>
+                    <a:bodyPr/>
+                    <a:lstStyle/>
+                    <a:p>
+                      <a:r>
+                        <a:rPr sz="1050" b="0">
+                          <a:solidFill>
+                            <a:srgbClr val="202124"/>
+                          </a:solidFill>
+                        </a:rPr>
                         <a:t>62x faster</a:t>
                       </a:r>
                     </a:p>
@@ -10763,6 +11181,23 @@
                             <a:srgbClr val="202124"/>
                           </a:solidFill>
                         </a:rPr>
+                        <a:t>— / 28</a:t>
+                      </a:r>
+                    </a:p>
+                  </a:txBody>
+                  <a:tcPr/>
+                </a:tc>
+                <a:tc>
+                  <a:txBody>
+                    <a:bodyPr/>
+                    <a:lstStyle/>
+                    <a:p>
+                      <a:r>
+                        <a:rPr sz="1050" b="0">
+                          <a:solidFill>
+                            <a:srgbClr val="202124"/>
+                          </a:solidFill>
+                        </a:rPr>
                         <a:t>48x faster</a:t>
                       </a:r>
                     </a:p>
@@ -10867,6 +11302,23 @@
                             <a:srgbClr val="202124"/>
                           </a:solidFill>
                         </a:rPr>
+                        <a:t>— / 46.3</a:t>
+                      </a:r>
+                    </a:p>
+                  </a:txBody>
+                  <a:tcPr/>
+                </a:tc>
+                <a:tc>
+                  <a:txBody>
+                    <a:bodyPr/>
+                    <a:lstStyle/>
+                    <a:p>
+                      <a:r>
+                        <a:rPr sz="1050" b="0">
+                          <a:solidFill>
+                            <a:srgbClr val="202124"/>
+                          </a:solidFill>
+                        </a:rPr>
                         <a:t>35x faster</a:t>
                       </a:r>
                     </a:p>
@@ -10971,6 +11423,23 @@
                             <a:srgbClr val="202124"/>
                           </a:solidFill>
                         </a:rPr>
+                        <a:t>— / n.m.</a:t>
+                      </a:r>
+                    </a:p>
+                  </a:txBody>
+                  <a:tcPr/>
+                </a:tc>
+                <a:tc>
+                  <a:txBody>
+                    <a:bodyPr/>
+                    <a:lstStyle/>
+                    <a:p>
+                      <a:r>
+                        <a:rPr sz="1050" b="0">
+                          <a:solidFill>
+                            <a:srgbClr val="202124"/>
+                          </a:solidFill>
+                        </a:rPr>
                         <a:t>30x faster</a:t>
                       </a:r>
                     </a:p>
@@ -11075,6 +11544,23 @@
                             <a:srgbClr val="202124"/>
                           </a:solidFill>
                         </a:rPr>
+                        <a:t>— / 46.3</a:t>
+                      </a:r>
+                    </a:p>
+                  </a:txBody>
+                  <a:tcPr/>
+                </a:tc>
+                <a:tc>
+                  <a:txBody>
+                    <a:bodyPr/>
+                    <a:lstStyle/>
+                    <a:p>
+                      <a:r>
+                        <a:rPr sz="1050" b="0">
+                          <a:solidFill>
+                            <a:srgbClr val="202124"/>
+                          </a:solidFill>
+                        </a:rPr>
                         <a:t>28x faster</a:t>
                       </a:r>
                     </a:p>
@@ -11179,6 +11665,23 @@
                             <a:srgbClr val="202124"/>
                           </a:solidFill>
                         </a:rPr>
+                        <a:t>— / 13.7</a:t>
+                      </a:r>
+                    </a:p>
+                  </a:txBody>
+                  <a:tcPr/>
+                </a:tc>
+                <a:tc>
+                  <a:txBody>
+                    <a:bodyPr/>
+                    <a:lstStyle/>
+                    <a:p>
+                      <a:r>
+                        <a:rPr sz="1050" b="0">
+                          <a:solidFill>
+                            <a:srgbClr val="202124"/>
+                          </a:solidFill>
+                        </a:rPr>
                         <a:t>21x faster</a:t>
                       </a:r>
                     </a:p>
@@ -11283,6 +11786,23 @@
                             <a:srgbClr val="202124"/>
                           </a:solidFill>
                         </a:rPr>
+                        <a:t>— / 13.7</a:t>
+                      </a:r>
+                    </a:p>
+                  </a:txBody>
+                  <a:tcPr/>
+                </a:tc>
+                <a:tc>
+                  <a:txBody>
+                    <a:bodyPr/>
+                    <a:lstStyle/>
+                    <a:p>
+                      <a:r>
+                        <a:rPr sz="1050" b="0">
+                          <a:solidFill>
+                            <a:srgbClr val="202124"/>
+                          </a:solidFill>
+                        </a:rPr>
                         <a:t>6x faster</a:t>
                       </a:r>
                     </a:p>
@@ -11387,6 +11907,23 @@
                             <a:srgbClr val="202124"/>
                           </a:solidFill>
                         </a:rPr>
+                        <a:t>— / 13.7</a:t>
+                      </a:r>
+                    </a:p>
+                  </a:txBody>
+                  <a:tcPr/>
+                </a:tc>
+                <a:tc>
+                  <a:txBody>
+                    <a:bodyPr/>
+                    <a:lstStyle/>
+                    <a:p>
+                      <a:r>
+                        <a:rPr sz="1050" b="0">
+                          <a:solidFill>
+                            <a:srgbClr val="202124"/>
+                          </a:solidFill>
+                        </a:rPr>
                         <a:t>5x faster</a:t>
                       </a:r>
                     </a:p>
@@ -11475,6 +12012,23 @@
                           </a:solidFill>
                         </a:rPr>
                         <a:t>9.2</a:t>
+                      </a:r>
+                    </a:p>
+                  </a:txBody>
+                  <a:tcPr/>
+                </a:tc>
+                <a:tc>
+                  <a:txBody>
+                    <a:bodyPr/>
+                    <a:lstStyle/>
+                    <a:p>
+                      <a:r>
+                        <a:rPr sz="1050" b="0">
+                          <a:solidFill>
+                            <a:srgbClr val="202124"/>
+                          </a:solidFill>
+                        </a:rPr>
+                        <a:t>— / 13.7</a:t>
                       </a:r>
                     </a:p>
                   </a:txBody>
@@ -11602,7 +12156,7 @@
                 </a:solidFill>
                 <a:latin typeface="Calibri"/>
               </a:rPr>
-              <a:t>A78C/NSP cells: medians of repeated invocations (bimodal board). OFA rows: matched geometry, OWN algorithm at D=128 — not bit-exact, MDE/s(work) undefined. DRAM: ceilings as on the bandwidth slide; no per-phase achieved bytes derived for C.</a:t>
+              <a:t>A78C/NSP cells: medians of repeated invocations (bimodal board). OFA rows: matched geometry, OWN algorithm at D=128 — not bit-exact. ‡ DRAM = achieved / ceiling GB/s: ceilings MEASURED (n.m. = not measured on that board); achieved blank — C's byte model is not derived.</a:t>
             </a:r>
           </a:p>
         </p:txBody>

</xml_diff>

<commit_message>
deck: first MEASURED DDR-consumption cells for Configurations B and C
Measured at the i.MX95 DDR controller (imx9_ddr0 beats, idle-window
subtracted, whole-run read+write) using the wattson xcheck instrument:
  A55x6: Config A 5.0 GB/s (37% of the 13.7 ceiling) -- consistent with the
         derived per-phase column;  Config B 8.8 (64%);  Config C 9.2 (67%)
  A55x1: B and C both 2.7 GB/s
The finding worth the cells: the 8-path multiscale pipeline drives the
six-A55 cluster to two-thirds of the chip's entire memory bus, vs 37% for
the textbook configuration. Remaining achieved cells stay honestly blank
until instrumented per part.
</commit_message>
<xml_diff>
--- a/docs/sgm-results.pptx
+++ b/docs/sgm-results.pptx
@@ -9122,7 +9122,7 @@
                             <a:srgbClr val="202124"/>
                           </a:solidFill>
                         </a:rPr>
-                        <a:t>— / 13.7</a:t>
+                        <a:t>8.8 / 13.7</a:t>
                       </a:r>
                     </a:p>
                   </a:txBody>
@@ -9243,7 +9243,7 @@
                             <a:srgbClr val="202124"/>
                           </a:solidFill>
                         </a:rPr>
-                        <a:t>— / 13.7</a:t>
+                        <a:t>2.7 / 13.7</a:t>
                       </a:r>
                     </a:p>
                   </a:txBody>
@@ -9786,7 +9786,7 @@
                 </a:solidFill>
                 <a:latin typeface="Calibri"/>
               </a:rPr>
-              <a:t>MDE/s (work) = both scales count: (0.384 + 1.536) Mpx x 64 / runtime. OFA rows: their OWN SGM at matched geometry (ds=2, D=128), throughput only. ‡ DRAM = achieved / ceiling GB/s: ceilings MEASURED (same silicon as Config A; n.m. = not measured on that board); achieved left blank -- B's per-phase byte model is not derived, and an invented number would poison the column.</a:t>
+              <a:t>MDE/s (work) = both scales count: (0.384 + 1.536) Mpx x 64 / runtime. OFA rows: their OWN SGM at matched geometry (ds=2, D=128), throughput only. ‡ DRAM = achieved / ceiling GB/s. A55 cells MEASURED at the i.MX95 DDR controller (idle-corrected, whole-run read+write) -- the 8-path multiscale pipeline drives the cluster to 64% of the chip's whole bus. Other achieved cells not yet instrumented (n.m. = ceiling unmeasured, leased board).</a:t>
             </a:r>
           </a:p>
         </p:txBody>
@@ -11665,7 +11665,7 @@
                             <a:srgbClr val="202124"/>
                           </a:solidFill>
                         </a:rPr>
-                        <a:t>— / 13.7</a:t>
+                        <a:t>9.2 / 13.7</a:t>
                       </a:r>
                     </a:p>
                   </a:txBody>
@@ -11786,7 +11786,7 @@
                             <a:srgbClr val="202124"/>
                           </a:solidFill>
                         </a:rPr>
-                        <a:t>— / 13.7</a:t>
+                        <a:t>2.7 / 13.7</a:t>
                       </a:r>
                     </a:p>
                   </a:txBody>
@@ -12156,7 +12156,7 @@
                 </a:solidFill>
                 <a:latin typeface="Calibri"/>
               </a:rPr>
-              <a:t>A78C/NSP cells: medians of repeated invocations (bimodal board). OFA rows: matched geometry, OWN algorithm at D=128 — not bit-exact. ‡ DRAM = achieved / ceiling GB/s: ceilings MEASURED (n.m. = not measured on that board); achieved blank — C's byte model is not derived.</a:t>
+              <a:t>A78C/NSP cells: medians of repeated invocations (bimodal board). OFA rows: matched geometry, OWN algorithm at D=128 — not bit-exact. ‡ DRAM = achieved / ceiling GB/s. A55 cells MEASURED at the DDR controller (67% of the chip's bus at 6 threads); other achieved cells not yet instrumented.</a:t>
             </a:r>
           </a:p>
         </p:txBody>

</xml_diff>

<commit_message>
deck: B bandwidth slide -- 'M' marker failed its reader, spell it out
Kyle asked what the M meant, which is the marker failing. Measured cells now
say 'measured' in green; the footnote leads with the definition instead of
burying it.
</commit_message>
<xml_diff>
--- a/docs/sgm-results.pptx
+++ b/docs/sgm-results.pptx
@@ -18120,10 +18120,10 @@
                       <a:r>
                         <a:rPr sz="950" b="1">
                           <a:solidFill>
-                            <a:srgbClr val="202124"/>
-                          </a:solidFill>
-                        </a:rPr>
-                        <a:t>8.8 M</a:t>
+                            <a:srgbClr val="187A33"/>
+                          </a:solidFill>
+                        </a:rPr>
+                        <a:t>8.8 measured</a:t>
                       </a:r>
                     </a:p>
                   </a:txBody>
@@ -18224,10 +18224,10 @@
                       <a:r>
                         <a:rPr sz="950" b="1">
                           <a:solidFill>
-                            <a:srgbClr val="202124"/>
-                          </a:solidFill>
-                        </a:rPr>
-                        <a:t>2.1 M</a:t>
+                            <a:srgbClr val="187A33"/>
+                          </a:solidFill>
+                        </a:rPr>
+                        <a:t>2.1 measured</a:t>
                       </a:r>
                     </a:p>
                   </a:txBody>
@@ -18328,10 +18328,10 @@
                       <a:r>
                         <a:rPr sz="950" b="1">
                           <a:solidFill>
-                            <a:srgbClr val="202124"/>
-                          </a:solidFill>
-                        </a:rPr>
-                        <a:t>2.7 M</a:t>
+                            <a:srgbClr val="187A33"/>
+                          </a:solidFill>
+                        </a:rPr>
+                        <a:t>2.7 measured</a:t>
                       </a:r>
                     </a:p>
                   </a:txBody>
@@ -18458,7 +18458,7 @@
                 </a:solidFill>
                 <a:latin typeface="Calibri"/>
               </a:rPr>
-              <a:t>M = MEASURED at the imx9_ddr0 DDR controller (idle-corrected whole-run, read+write). † = DERIVED: 4.50 GB/frame streaming model (cost build+merge 0.27 + 8-path cost reads 0.79 + S-plane RMW 3.15 + argmin 0.20 GB) / measured frame time -- cache-reuse-free, so a slight under-count: the model reproduces the A55x6's measured cell at 80%.</a:t>
+              <a:t>GREEN 'measured' = read directly from the imx9_ddr0 DDR controller (idle-corrected whole-run, read+write). † = DERIVED: 4.50 GB/frame streaming model (cost build+merge 0.27 + 8-path cost reads 0.79 + S-plane RMW 3.15 + argmin 0.20 GB) / measured frame time -- cache-reuse-free, so a slight under-count: the model reproduces the A55x6's measured cell at 80%.</a:t>
             </a:r>
           </a:p>
         </p:txBody>

</xml_diff>

<commit_message>
the OFA-internals hypothesis is MEASURED -- EMC sampling on both Jetsons
Passwordless tegrastats (Kyle enabled) let the EMC be sampled at 200 ms around
sustained runs, net of idle. Our CUDA kernels pull 24-25% of the memory system
on Thor and Orin alike; the OFA engines producing the same-geometry output
read 1.4% on Thor -- statistically indistinguishable from the idle baseline at
296 fps -- and 0.8-1.0% on Orin, which is almost exactly the irreducible
input+output image traffic. The fixed-function block converts SGM from a
bandwidth problem into an on-chip streaming problem; DRAM sees the pictures
in, the map out, and essentially nothing else. B bandwidth slide gains the
measured Jetson cells and two OFA rows; README's dedicated-hardware section
gains the measured-internals paragraph.
</commit_message>
<xml_diff>
--- a/docs/sgm-results.pptx
+++ b/docs/sgm-results.pptx
@@ -17204,8 +17204,8 @@
           <p:nvPr/>
         </p:nvGraphicFramePr>
         <p:xfrm>
-          <a:off x="548640" y="1645920"/>
-          <a:ext cx="11064240" cy="3017520"/>
+          <a:off x="548640" y="1572768"/>
+          <a:ext cx="11064240" cy="3209544"/>
         </p:xfrm>
         <a:graphic>
           <a:graphicData uri="http://schemas.openxmlformats.org/drawingml/2006/table">
@@ -17221,7 +17221,7 @@
                 <a:gridCol w="914400"/>
                 <a:gridCol w="4114800"/>
               </a:tblGrid>
-              <a:tr h="274320">
+              <a:tr h="246888">
                 <a:tc>
                   <a:txBody>
                     <a:bodyPr/>
@@ -17349,7 +17349,7 @@
                   </a:tcPr>
                 </a:tc>
               </a:tr>
-              <a:tr h="274320">
+              <a:tr h="246888">
                 <a:tc>
                   <a:txBody>
                     <a:bodyPr/>
@@ -17453,7 +17453,7 @@
                   <a:tcPr/>
                 </a:tc>
               </a:tr>
-              <a:tr h="274320">
+              <a:tr h="246888">
                 <a:tc>
                   <a:txBody>
                     <a:bodyPr/>
@@ -17533,7 +17533,7 @@
                             <a:srgbClr val="202124"/>
                           </a:solidFill>
                         </a:rPr>
-                        <a:t>40%</a:t>
+                        <a:t>24%</a:t>
                       </a:r>
                     </a:p>
                   </a:txBody>
@@ -17550,14 +17550,14 @@
                             <a:srgbClr val="202124"/>
                           </a:solidFill>
                         </a:rPr>
-                        <a:t>memory-bound</a:t>
+                        <a:t>EMC net-of-idle, measured; ≈ the model's 40% freq-normalized</a:t>
                       </a:r>
                     </a:p>
                   </a:txBody>
                   <a:tcPr/>
                 </a:tc>
               </a:tr>
-              <a:tr h="274320">
+              <a:tr h="246888">
                 <a:tc>
                   <a:txBody>
                     <a:bodyPr/>
@@ -17637,7 +17637,7 @@
                             <a:srgbClr val="202124"/>
                           </a:solidFill>
                         </a:rPr>
-                        <a:t>35%</a:t>
+                        <a:t>25%</a:t>
                       </a:r>
                     </a:p>
                   </a:txBody>
@@ -17654,14 +17654,14 @@
                             <a:srgbClr val="202124"/>
                           </a:solidFill>
                         </a:rPr>
-                        <a:t>memory-bound</a:t>
+                        <a:t>EMC net-of-idle, measured; memory-bound</a:t>
                       </a:r>
                     </a:p>
                   </a:txBody>
                   <a:tcPr/>
                 </a:tc>
               </a:tr>
-              <a:tr h="274320">
+              <a:tr h="246888">
                 <a:tc>
                   <a:txBody>
                     <a:bodyPr/>
@@ -17673,6 +17673,214 @@
                             <a:srgbClr val="202124"/>
                           </a:solidFill>
                         </a:rPr>
+                        <a:t>Thor OFA (ds=2)</a:t>
+                      </a:r>
+                    </a:p>
+                  </a:txBody>
+                  <a:tcPr/>
+                </a:tc>
+                <a:tc>
+                  <a:txBody>
+                    <a:bodyPr/>
+                    <a:lstStyle/>
+                    <a:p>
+                      <a:r>
+                        <a:rPr sz="950" b="0">
+                          <a:solidFill>
+                            <a:srgbClr val="202124"/>
+                          </a:solidFill>
+                        </a:rPr>
+                        <a:t>3.38 ms</a:t>
+                      </a:r>
+                    </a:p>
+                  </a:txBody>
+                  <a:tcPr/>
+                </a:tc>
+                <a:tc>
+                  <a:txBody>
+                    <a:bodyPr/>
+                    <a:lstStyle/>
+                    <a:p>
+                      <a:r>
+                        <a:rPr sz="950" b="1">
+                          <a:solidFill>
+                            <a:srgbClr val="187A33"/>
+                          </a:solidFill>
+                        </a:rPr>
+                        <a:t>≈0 measured</a:t>
+                      </a:r>
+                    </a:p>
+                  </a:txBody>
+                  <a:tcPr/>
+                </a:tc>
+                <a:tc>
+                  <a:txBody>
+                    <a:bodyPr/>
+                    <a:lstStyle/>
+                    <a:p>
+                      <a:r>
+                        <a:rPr sz="950" b="0">
+                          <a:solidFill>
+                            <a:srgbClr val="202124"/>
+                          </a:solidFill>
+                        </a:rPr>
+                        <a:t>249</a:t>
+                      </a:r>
+                    </a:p>
+                  </a:txBody>
+                  <a:tcPr/>
+                </a:tc>
+                <a:tc>
+                  <a:txBody>
+                    <a:bodyPr/>
+                    <a:lstStyle/>
+                    <a:p>
+                      <a:r>
+                        <a:rPr sz="950" b="0">
+                          <a:solidFill>
+                            <a:srgbClr val="202124"/>
+                          </a:solidFill>
+                        </a:rPr>
+                        <a:t>1.4%</a:t>
+                      </a:r>
+                    </a:p>
+                  </a:txBody>
+                  <a:tcPr/>
+                </a:tc>
+                <a:tc>
+                  <a:txBody>
+                    <a:bodyPr/>
+                    <a:lstStyle/>
+                    <a:p>
+                      <a:r>
+                        <a:rPr sz="950" b="0">
+                          <a:solidFill>
+                            <a:srgbClr val="202124"/>
+                          </a:solidFill>
+                        </a:rPr>
+                        <a:t>EMC indistinguishable from idle at 296 fps — the block runs in its internals</a:t>
+                      </a:r>
+                    </a:p>
+                  </a:txBody>
+                  <a:tcPr/>
+                </a:tc>
+              </a:tr>
+              <a:tr h="246888">
+                <a:tc>
+                  <a:txBody>
+                    <a:bodyPr/>
+                    <a:lstStyle/>
+                    <a:p>
+                      <a:r>
+                        <a:rPr sz="950" b="1">
+                          <a:solidFill>
+                            <a:srgbClr val="202124"/>
+                          </a:solidFill>
+                        </a:rPr>
+                        <a:t>Orin OFA (ds=2)</a:t>
+                      </a:r>
+                    </a:p>
+                  </a:txBody>
+                  <a:tcPr/>
+                </a:tc>
+                <a:tc>
+                  <a:txBody>
+                    <a:bodyPr/>
+                    <a:lstStyle/>
+                    <a:p>
+                      <a:r>
+                        <a:rPr sz="950" b="0">
+                          <a:solidFill>
+                            <a:srgbClr val="202124"/>
+                          </a:solidFill>
+                        </a:rPr>
+                        <a:t>14.9 ms</a:t>
+                      </a:r>
+                    </a:p>
+                  </a:txBody>
+                  <a:tcPr/>
+                </a:tc>
+                <a:tc>
+                  <a:txBody>
+                    <a:bodyPr/>
+                    <a:lstStyle/>
+                    <a:p>
+                      <a:r>
+                        <a:rPr sz="950" b="1">
+                          <a:solidFill>
+                            <a:srgbClr val="187A33"/>
+                          </a:solidFill>
+                        </a:rPr>
+                        <a:t>≈0.7 measured</a:t>
+                      </a:r>
+                    </a:p>
+                  </a:txBody>
+                  <a:tcPr/>
+                </a:tc>
+                <a:tc>
+                  <a:txBody>
+                    <a:bodyPr/>
+                    <a:lstStyle/>
+                    <a:p>
+                      <a:r>
+                        <a:rPr sz="950" b="0">
+                          <a:solidFill>
+                            <a:srgbClr val="202124"/>
+                          </a:solidFill>
+                        </a:rPr>
+                        <a:t>175</a:t>
+                      </a:r>
+                    </a:p>
+                  </a:txBody>
+                  <a:tcPr/>
+                </a:tc>
+                <a:tc>
+                  <a:txBody>
+                    <a:bodyPr/>
+                    <a:lstStyle/>
+                    <a:p>
+                      <a:r>
+                        <a:rPr sz="950" b="0">
+                          <a:solidFill>
+                            <a:srgbClr val="202124"/>
+                          </a:solidFill>
+                        </a:rPr>
+                        <a:t>0.9%</a:t>
+                      </a:r>
+                    </a:p>
+                  </a:txBody>
+                  <a:tcPr/>
+                </a:tc>
+                <a:tc>
+                  <a:txBody>
+                    <a:bodyPr/>
+                    <a:lstStyle/>
+                    <a:p>
+                      <a:r>
+                        <a:rPr sz="950" b="0">
+                          <a:solidFill>
+                            <a:srgbClr val="202124"/>
+                          </a:solidFill>
+                        </a:rPr>
+                        <a:t>≈ exactly the irreducible in+out images (67 fps × ~6 MB)</a:t>
+                      </a:r>
+                    </a:p>
+                  </a:txBody>
+                  <a:tcPr/>
+                </a:tc>
+              </a:tr>
+              <a:tr h="246888">
+                <a:tc>
+                  <a:txBody>
+                    <a:bodyPr/>
+                    <a:lstStyle/>
+                    <a:p>
+                      <a:r>
+                        <a:rPr sz="950" b="1">
+                          <a:solidFill>
+                            <a:srgbClr val="202124"/>
+                          </a:solidFill>
+                        </a:rPr>
                         <a:t>8x Cortex-A78C</a:t>
                       </a:r>
                     </a:p>
@@ -17765,7 +17973,7 @@
                   <a:tcPr/>
                 </a:tc>
               </a:tr>
-              <a:tr h="274320">
+              <a:tr h="246888">
                 <a:tc>
                   <a:txBody>
                     <a:bodyPr/>
@@ -17869,7 +18077,7 @@
                   <a:tcPr/>
                 </a:tc>
               </a:tr>
-              <a:tr h="274320">
+              <a:tr h="246888">
                 <a:tc>
                   <a:txBody>
                     <a:bodyPr/>
@@ -17973,7 +18181,7 @@
                   <a:tcPr/>
                 </a:tc>
               </a:tr>
-              <a:tr h="274320">
+              <a:tr h="246888">
                 <a:tc>
                   <a:txBody>
                     <a:bodyPr/>
@@ -18077,7 +18285,7 @@
                   <a:tcPr/>
                 </a:tc>
               </a:tr>
-              <a:tr h="274320">
+              <a:tr h="246888">
                 <a:tc>
                   <a:txBody>
                     <a:bodyPr/>
@@ -18181,7 +18389,7 @@
                   <a:tcPr/>
                 </a:tc>
               </a:tr>
-              <a:tr h="274320">
+              <a:tr h="246888">
                 <a:tc>
                   <a:txBody>
                     <a:bodyPr/>
@@ -18285,7 +18493,7 @@
                   <a:tcPr/>
                 </a:tc>
               </a:tr>
-              <a:tr h="274320">
+              <a:tr h="246888">
                 <a:tc>
                   <a:txBody>
                     <a:bodyPr/>
@@ -18401,8 +18609,8 @@
         </p:nvSpPr>
         <p:spPr>
           <a:xfrm>
-            <a:off x="548640" y="5029200"/>
-            <a:ext cx="11155680" cy="777240"/>
+            <a:off x="548640" y="5230368"/>
+            <a:ext cx="11155680" cy="731520"/>
           </a:xfrm>
           <a:prstGeom prst="rect">
             <a:avLst/>
@@ -18436,8 +18644,8 @@
         </p:nvSpPr>
         <p:spPr>
           <a:xfrm>
-            <a:off x="548640" y="5989320"/>
-            <a:ext cx="11155680" cy="457200"/>
+            <a:off x="548640" y="6108192"/>
+            <a:ext cx="11155680" cy="411480"/>
           </a:xfrm>
           <a:prstGeom prst="rect">
             <a:avLst/>
@@ -18458,7 +18666,7 @@
                 </a:solidFill>
                 <a:latin typeface="Calibri"/>
               </a:rPr>
-              <a:t>GREEN 'measured' = read directly from the imx9_ddr0 DDR controller (idle-corrected whole-run, read+write). † = DERIVED: 4.50 GB/frame streaming model (cost build+merge 0.27 + 8-path cost reads 0.79 + S-plane RMW 3.15 + argmin 0.20 GB) / measured frame time -- cache-reuse-free, so a slight under-count: the model reproduces the A55x6's measured cell at 80%.</a:t>
+              <a:t>GREEN 'measured' = imx9_ddr0 DDR controller (i.MX95 rows) or Jetson EMC utilization sampled at 200 ms, net of idle (Jetson rows; % is relative to the run's EMC clock). † = DERIVED: 4.50 GB/frame streaming model (cost build+merge 0.27 + 8-path cost reads 0.79 + S-plane RMW 3.15 + argmin 0.20 GB) / measured frame time -- cache-reuse-free, so a slight under-count: the model reproduces the A55x6's measured cell at 80%.</a:t>
             </a:r>
           </a:p>
         </p:txBody>

</xml_diff>

<commit_message>
A78C DDR cells go MEASURED -- and the cluster is bandwidth-saturated on B
qualcomm's icc_bwmon recipe (tracepoint, time-weighted per their three
caveats): Config B 22.8 GB/s net, Config C 23.8, idle 0.81, instance 9091000
with the others reading 23-27. Ceiling MEASURED at 27.1 GB/s by our own copy
probe with bwmon independently reading 27-28.5 during it -- two instruments
agreeing within 5%. The headline cell: the A78C cluster runs Config B at ~84%
of its measured DDR ceiling -- SATURATED, which finally explains the
long-standing 6-threads-beats-8 behaviour on that board. 'Stated, not
guessed' upgraded to measured throughout (A-table ceilings, both bandwidth
slides, B/C summary columns).
</commit_message>
<xml_diff>
--- a/docs/sgm-results.pptx
+++ b/docs/sgm-results.pptx
@@ -4185,7 +4185,7 @@
                             <a:srgbClr val="202124"/>
                           </a:solidFill>
                         </a:rPr>
-                        <a:t>3.4 / —</a:t>
+                        <a:t>3.4 / 27.1</a:t>
                       </a:r>
                     </a:p>
                   </a:txBody>
@@ -4669,7 +4669,7 @@
                             <a:srgbClr val="202124"/>
                           </a:solidFill>
                         </a:rPr>
-                        <a:t>1.0 / —</a:t>
+                        <a:t>1.0 / 27.1</a:t>
                       </a:r>
                     </a:p>
                   </a:txBody>
@@ -8722,7 +8722,7 @@
                             <a:srgbClr val="202124"/>
                           </a:solidFill>
                         </a:rPr>
-                        <a:t>— / n.m.</a:t>
+                        <a:t>22.8 / 27.1</a:t>
                       </a:r>
                     </a:p>
                   </a:txBody>
@@ -9206,7 +9206,7 @@
                             <a:srgbClr val="202124"/>
                           </a:solidFill>
                         </a:rPr>
-                        <a:t>— / n.m.</a:t>
+                        <a:t>— / 27.1</a:t>
                       </a:r>
                     </a:p>
                   </a:txBody>
@@ -11386,7 +11386,7 @@
                             <a:srgbClr val="202124"/>
                           </a:solidFill>
                         </a:rPr>
-                        <a:t>— / n.m.</a:t>
+                        <a:t>23.8 / 27.1</a:t>
                       </a:r>
                     </a:p>
                   </a:txBody>
@@ -11749,7 +11749,7 @@
                             <a:srgbClr val="202124"/>
                           </a:solidFill>
                         </a:rPr>
-                        <a:t>— / n.m.</a:t>
+                        <a:t>— / 27.1</a:t>
                       </a:r>
                     </a:p>
                   </a:txBody>
@@ -13416,7 +13416,7 @@
                             <a:srgbClr val="202124"/>
                           </a:solidFill>
                         </a:rPr>
-                        <a:t>--</a:t>
+                        <a:t>27.1</a:t>
                       </a:r>
                     </a:p>
                   </a:txBody>
@@ -13433,7 +13433,7 @@
                             <a:srgbClr val="202124"/>
                           </a:solidFill>
                         </a:rPr>
-                        <a:t>--</a:t>
+                        <a:t>13%</a:t>
                       </a:r>
                     </a:p>
                   </a:txBody>
@@ -13450,7 +13450,7 @@
                             <a:srgbClr val="202124"/>
                           </a:solidFill>
                         </a:rPr>
-                        <a:t>ceiling unmeasured on that board -- stated, not guessed</a:t>
+                        <a:t>compute-bound on A; ceiling MEASURED via copy probe + icc_bwmon</a:t>
                       </a:r>
                     </a:p>
                   </a:txBody>
@@ -17912,10 +17912,10 @@
                       <a:r>
                         <a:rPr sz="950" b="1">
                           <a:solidFill>
-                            <a:srgbClr val="202124"/>
-                          </a:solidFill>
-                        </a:rPr>
-                        <a:t>21.2 †</a:t>
+                            <a:srgbClr val="187A33"/>
+                          </a:solidFill>
+                        </a:rPr>
+                        <a:t>22.8 measured</a:t>
                       </a:r>
                     </a:p>
                   </a:txBody>
@@ -17932,7 +17932,7 @@
                             <a:srgbClr val="202124"/>
                           </a:solidFill>
                         </a:rPr>
-                        <a:t>n.m.</a:t>
+                        <a:t>27.1</a:t>
                       </a:r>
                     </a:p>
                   </a:txBody>
@@ -17949,7 +17949,7 @@
                             <a:srgbClr val="202124"/>
                           </a:solidFill>
                         </a:rPr>
-                        <a:t>--</a:t>
+                        <a:t>84%</a:t>
                       </a:r>
                     </a:p>
                   </a:txBody>
@@ -17966,7 +17966,7 @@
                             <a:srgbClr val="202124"/>
                           </a:solidFill>
                         </a:rPr>
-                        <a:t>the S-plane tax; ceiling unmeasured on that board</a:t>
+                        <a:t>SATURATED -- and why this board peaks at 6 threads, not 8</a:t>
                       </a:r>
                     </a:p>
                   </a:txBody>
@@ -18666,7 +18666,7 @@
                 </a:solidFill>
                 <a:latin typeface="Calibri"/>
               </a:rPr>
-              <a:t>GREEN 'measured' = imx9_ddr0 DDR controller (i.MX95 rows) or Jetson EMC utilization sampled at 200 ms, net of idle (Jetson rows; % is relative to the run's EMC clock). † = DERIVED: 4.50 GB/frame streaming model (cost build+merge 0.27 + 8-path cost reads 0.79 + S-plane RMW 3.15 + argmin 0.20 GB) / measured frame time -- cache-reuse-free, so a slight under-count: the model reproduces the A55x6's measured cell at 80%.</a:t>
+              <a:t>GREEN 'measured' = imx9_ddr0 DDR controller (i.MX95), Jetson EMC sampling (net of idle; % of the run's EMC clock), or the IQ-9075's icc_bwmon interconnect monitor (time-weighted, net of idle; instance 9091000, others read 23-27). † = DERIVED: 4.50 GB/frame streaming model (cost build+merge 0.27 + 8-path cost reads 0.79 + S-plane RMW 3.15 + argmin 0.20 GB) / measured frame time -- cache-reuse-free, so a slight under-count: the model reproduces the A55x6's measured cell at 80%.</a:t>
             </a:r>
           </a:p>
         </p:txBody>

</xml_diff>

<commit_message>
top-to-bottom editorial pass: measured DRAM columns reach the README B/C tables; deck de-staled
README: B and C summary tables gain the DRAM GB/s column (measured cells
only -- A55/G310 from the DDR controller, A78C from icc_bwmon incl. the
84% saturation finding; blanks stay blank rather than derived); the
real-imagery table sorts by runtime; the dangling 'that gap' paragraph
rejoins its antecedent.

Deck: the 5090 unit slide carried a stale D-sweep from an earlier card
session (37,383/64,880/74,957 -> the recorded 38,356/60,932/76,248);
both OFA unit slides computed their calculation at D=64 when the engines
ran D=128 (14,201 -> 28,402 shown correctly); B/C summary footnotes now
credit every measured cell instead of 'not yet instrumented'; OFA + G310
measured cells join the B summary table; two footnotes that rendered off
the slide bottom are compacted; title says eleven units like the README.
</commit_message>
<xml_diff>
--- a/docs/sgm-results.pptx
+++ b/docs/sgm-results.pptx
@@ -3146,7 +3146,7 @@
                 </a:solidFill>
                 <a:latin typeface="Calibri"/>
               </a:rPr>
-              <a:t>Semi-Global Matching across ten processors</a:t>
+              <a:t>Semi-Global Matching across eleven processing units</a:t>
             </a:r>
           </a:p>
         </p:txBody>
@@ -5962,9 +5962,9 @@
                 <a:latin typeface="Consolas"/>
               </a:rPr>
               <a:t>MDE/s  =  W x H x D / runtime
-        =  1,920 x 1,080 x 64 / 9.35 ms
-        =  132,710,400 disparity estimations / 0.00935 s
-        =  14,201 million disparity estimations per second
+        =  1,920 x 1,080 x 128 / 9.35 ms
+        =  265,420,800 disparity estimations / 0.00935 s
+        =  28,402 million disparity estimations per second
 frame rate  =  1000 / 9.35  =  107.0 fps
 pixel rate  =  2.0736 Mpx x 107.0  =  221.89 Mpix/s</a:t>
             </a:r>
@@ -6030,7 +6030,7 @@
           <a:p>
             <a:pPr algn="l"/>
             <a:r>
-              <a:rPr sz="1300" b="0">
+              <a:rPr sz="1100" b="0">
                 <a:solidFill>
                   <a:srgbClr val="202124"/>
                 </a:solidFill>
@@ -6041,7 +6041,7 @@
           </a:p>
           <a:p>
             <a:r>
-              <a:rPr sz="1300">
+              <a:rPr sz="1100">
                 <a:solidFill>
                   <a:srgbClr val="202124"/>
                 </a:solidFill>
@@ -6052,62 +6052,62 @@
           </a:p>
           <a:p>
             <a:r>
-              <a:rPr sz="1300">
+              <a:rPr sz="1100">
                 <a:solidFill>
                   <a:srgbClr val="202124"/>
                 </a:solidFill>
                 <a:latin typeface="Calibri"/>
               </a:rPr>
-              <a:t>NOT bit-exact to our golden: VPI's SGM is a different implementation with</a:t>
-            </a:r>
-          </a:p>
-          <a:p>
-            <a:r>
-              <a:rPr sz="1300">
+              <a:t>NOT bit-exact to our golden: VPI's SGM is its own implementation (census,</a:t>
+            </a:r>
+          </a:p>
+          <a:p>
+            <a:r>
+              <a:rPr sz="1100">
                 <a:solidFill>
                   <a:srgbClr val="202124"/>
                 </a:solidFill>
                 <a:latin typeface="Calibri"/>
               </a:rPr>
-              <a:t>its own census, penalties and confidence output. Throughput comparison at</a:t>
-            </a:r>
-          </a:p>
-          <a:p>
-            <a:r>
-              <a:rPr sz="1300">
+              <a:t>penalties, confidence). A throughput comparison at matched resolution and D</a:t>
+            </a:r>
+          </a:p>
+          <a:p>
+            <a:r>
+              <a:rPr sz="1100">
                 <a:solidFill>
                   <a:srgbClr val="202124"/>
                 </a:solidFill>
                 <a:latin typeface="Calibri"/>
               </a:rPr>
-              <a:t>matched resolution and D -- NOT the same test, and NOT a quality claim.</a:t>
-            </a:r>
-          </a:p>
-          <a:p>
-            <a:r>
-              <a:rPr sz="1300">
+              <a:t>-- NOT the same test, and NOT a quality claim.</a:t>
+            </a:r>
+          </a:p>
+          <a:p>
+            <a:r>
+              <a:rPr sz="1100">
                 <a:solidFill>
                   <a:srgbClr val="202124"/>
                 </a:solidFill>
                 <a:latin typeface="Calibri"/>
               </a:rPr>
-              <a:t>🔴 ACCURACY WITHDRAWN. Scored against ground truth our SGM gets 2.6% bad&gt;1px</a:t>
-            </a:r>
-          </a:p>
-          <a:p>
-            <a:r>
-              <a:rPr sz="1300">
+              <a:t>🔴 ACCURACY WITHDRAWN: our SGM scores 2.6% bad&gt;1px (MAE 0.45) on ground</a:t>
+            </a:r>
+          </a:p>
+          <a:p>
+            <a:r>
+              <a:rPr sz="1100">
                 <a:solidFill>
                   <a:srgbClr val="202124"/>
                 </a:solidFill>
                 <a:latin typeface="Calibri"/>
               </a:rPr>
-              <a:t>(MAE 0.45); OFA aligns under no simple descaling, so its accuracy is</a:t>
-            </a:r>
-          </a:p>
-          <a:p>
-            <a:r>
-              <a:rPr sz="1300">
+              <a:t>truth; OFA's output aligns under no simple descaling, so its accuracy is</a:t>
+            </a:r>
+          </a:p>
+          <a:p>
+            <a:r>
+              <a:rPr sz="1100">
                 <a:solidFill>
                   <a:srgbClr val="202124"/>
                 </a:solidFill>
@@ -6118,57 +6118,46 @@
           </a:p>
           <a:p>
             <a:r>
-              <a:rPr sz="1300">
+              <a:rPr sz="1100">
                 <a:solidFill>
                   <a:srgbClr val="202124"/>
                 </a:solidFill>
                 <a:latin typeface="Calibri"/>
               </a:rPr>
-              <a:t>VPI defaults to includeDiagonals=1, so OFA ran 8 paths against our 4. Measured,</a:t>
-            </a:r>
-          </a:p>
-          <a:p>
-            <a:r>
-              <a:rPr sz="1300">
+              <a:t>VPI defaults to includeDiagonals=1: OFA ran 8 paths against our 4. Measured:</a:t>
+            </a:r>
+          </a:p>
+          <a:p>
+            <a:r>
+              <a:rPr sz="1100">
                 <a:solidFill>
                   <a:srgbClr val="202124"/>
                 </a:solidFill>
                 <a:latin typeface="Calibri"/>
               </a:rPr>
-              <a:t>not assumed: OFA costs 9.42 ms at 8 paths and 9.85 at 4 -- path-count</a:t>
-            </a:r>
-          </a:p>
-          <a:p>
-            <a:r>
-              <a:rPr sz="1300">
+              <a:t>9.42 ms at 8 paths, 9.85 at 4 -- path-count independent, the timing stands.</a:t>
+            </a:r>
+          </a:p>
+          <a:p>
+            <a:r>
+              <a:rPr sz="1100">
                 <a:solidFill>
                   <a:srgbClr val="202124"/>
                 </a:solidFill>
                 <a:latin typeface="Calibri"/>
               </a:rPr>
-              <a:t>independent. The timing stands and OFA delivers an 8-path result in our time.</a:t>
-            </a:r>
-          </a:p>
-          <a:p>
-            <a:r>
-              <a:rPr sz="1300">
+              <a:t>⚠️ downscaleFactor defaults to 2 (960x540 out, 4.14 ms): quoting THAT as a</a:t>
+            </a:r>
+          </a:p>
+          <a:p>
+            <a:r>
+              <a:rPr sz="1100">
                 <a:solidFill>
                   <a:srgbClr val="202124"/>
                 </a:solidFill>
                 <a:latin typeface="Calibri"/>
               </a:rPr>
-              <a:t>⚠️ It defaults to downscaleFactor=2, which emits a 960x540 map from 1080p</a:t>
-            </a:r>
-          </a:p>
-          <a:p>
-            <a:r>
-              <a:rPr sz="1300">
-                <a:solidFill>
-                  <a:srgbClr val="202124"/>
-                </a:solidFill>
-                <a:latin typeface="Calibri"/>
-              </a:rPr>
-              <a:t>input in 4.14 ms. Quoting that as a 1080p figure overstates it by 2.3x.</a:t>
+              <a:t>1080p figure would overstate it by 2.3x. All numbers here are full-res out.</a:t>
             </a:r>
           </a:p>
         </p:txBody>
@@ -6181,7 +6170,7 @@
         </p:nvSpPr>
         <p:spPr>
           <a:xfrm>
-            <a:off x="548640" y="6400800"/>
+            <a:off x="548640" y="6601968"/>
             <a:ext cx="10515600" cy="365760"/>
           </a:xfrm>
           <a:prstGeom prst="rect">
@@ -6386,9 +6375,9 @@
                 <a:latin typeface="Consolas"/>
               </a:rPr>
               <a:t>MDE/s  =  W x H x D / runtime
-        =  1,920 x 1,080 x 64 / 72.64 ms
-        =  132,710,400 disparity estimations / 0.07264 s
-        =  1,827 million disparity estimations per second
+        =  1,920 x 1,080 x 128 / 72.64 ms
+        =  265,420,800 disparity estimations / 0.07264 s
+        =  3,654 million disparity estimations per second
 frame rate  =  1000 / 72.64  =  13.8 fps
 pixel rate  =  2.0736 Mpx x 13.8  =  28.55 Mpix/s</a:t>
             </a:r>
@@ -8117,7 +8106,7 @@
                             <a:srgbClr val="202124"/>
                           </a:solidFill>
                         </a:rPr>
-                        <a:t>— / 249</a:t>
+                        <a:t>≈0 / 249</a:t>
                       </a:r>
                     </a:p>
                   </a:txBody>
@@ -8359,7 +8348,7 @@
                             <a:srgbClr val="202124"/>
                           </a:solidFill>
                         </a:rPr>
-                        <a:t>— / 175</a:t>
+                        <a:t>0.7 / 175</a:t>
                       </a:r>
                     </a:p>
                   </a:txBody>
@@ -9690,7 +9679,7 @@
                             <a:srgbClr val="202124"/>
                           </a:solidFill>
                         </a:rPr>
-                        <a:t>— / 13.7</a:t>
+                        <a:t>2.1 / 13.7</a:t>
                       </a:r>
                     </a:p>
                   </a:txBody>
@@ -10090,8 +10079,8 @@
         </p:nvSpPr>
         <p:spPr>
           <a:xfrm>
-            <a:off x="548640" y="6656832"/>
-            <a:ext cx="11155680" cy="274320"/>
+            <a:off x="548640" y="6620256"/>
+            <a:ext cx="11155680" cy="237744"/>
           </a:xfrm>
           <a:prstGeom prst="rect">
             <a:avLst/>
@@ -10106,13 +10095,13 @@
           <a:p>
             <a:pPr algn="l"/>
             <a:r>
-              <a:rPr sz="1000" b="0">
+              <a:rPr sz="800" b="0">
                 <a:solidFill>
                   <a:srgbClr val="5F6368"/>
                 </a:solidFill>
                 <a:latin typeface="Calibri"/>
               </a:rPr>
-              <a:t>MDE/s (work) = both scales count: (0.384 + 1.536) Mpx x 64 / runtime. OFA rows: their OWN SGM at matched geometry (ds=2, D=128), throughput only. ‡ DRAM = achieved / ceiling GB/s. A55 cells MEASURED at the i.MX95 DDR controller (idle-corrected, whole-run read+write) -- the 8-path multiscale pipeline drives the cluster to 64% of the chip's whole bus. Other achieved cells not yet instrumented (n.m. = ceiling unmeasured, leased board).</a:t>
+              <a:t>MDE/s (work) = both scales: (0.384+1.536) Mpx x 64 / runtime. OFA rows: their OWN SGM at matched geometry, throughput only. ‡ achieved / ceiling GB/s, MEASURED cells only (A55+G310: i.MX95 DDR controller, 64% of the chip's bus at 6xA55; A78C: icc_bwmon, 84% = SATURATED, hence the 6-thread peak; OFA: EMC ~ idle). Blank: A720/G720 CMN counters dead, NSP/5090 staged. Details: bandwidth slide.</a:t>
             </a:r>
           </a:p>
         </p:txBody>
@@ -10570,7 +10559,7 @@
                     <a:lstStyle/>
                     <a:p>
                       <a:r>
-                        <a:rPr sz="1050" b="0">
+                        <a:rPr sz="950" b="0">
                           <a:solidFill>
                             <a:srgbClr val="202124"/>
                           </a:solidFill>
@@ -10587,7 +10576,7 @@
                     <a:lstStyle/>
                     <a:p>
                       <a:r>
-                        <a:rPr sz="1050" b="1">
+                        <a:rPr sz="950" b="1">
                           <a:solidFill>
                             <a:srgbClr val="7B4FD1"/>
                           </a:solidFill>
@@ -10604,7 +10593,7 @@
                     <a:lstStyle/>
                     <a:p>
                       <a:r>
-                        <a:rPr sz="1050" b="0">
+                        <a:rPr sz="950" b="0">
                           <a:solidFill>
                             <a:srgbClr val="202124"/>
                           </a:solidFill>
@@ -10621,7 +10610,7 @@
                     <a:lstStyle/>
                     <a:p>
                       <a:r>
-                        <a:rPr sz="1050" b="0">
+                        <a:rPr sz="950" b="0">
                           <a:solidFill>
                             <a:srgbClr val="202124"/>
                           </a:solidFill>
@@ -10638,7 +10627,7 @@
                     <a:lstStyle/>
                     <a:p>
                       <a:r>
-                        <a:rPr sz="1050" b="0">
+                        <a:rPr sz="950" b="0">
                           <a:solidFill>
                             <a:srgbClr val="202124"/>
                           </a:solidFill>
@@ -10655,7 +10644,7 @@
                     <a:lstStyle/>
                     <a:p>
                       <a:r>
-                        <a:rPr sz="1050" b="0">
+                        <a:rPr sz="950" b="0">
                           <a:solidFill>
                             <a:srgbClr val="202124"/>
                           </a:solidFill>
@@ -10672,7 +10661,7 @@
                     <a:lstStyle/>
                     <a:p>
                       <a:r>
-                        <a:rPr sz="1050" b="0">
+                        <a:rPr sz="950" b="0">
                           <a:solidFill>
                             <a:srgbClr val="202124"/>
                           </a:solidFill>
@@ -10691,7 +10680,7 @@
                     <a:lstStyle/>
                     <a:p>
                       <a:r>
-                        <a:rPr sz="1050" b="1">
+                        <a:rPr sz="950" b="1">
                           <a:solidFill>
                             <a:srgbClr val="202124"/>
                           </a:solidFill>
@@ -10708,7 +10697,7 @@
                     <a:lstStyle/>
                     <a:p>
                       <a:r>
-                        <a:rPr sz="1050" b="1">
+                        <a:rPr sz="950" b="1">
                           <a:solidFill>
                             <a:srgbClr val="4C8BF5"/>
                           </a:solidFill>
@@ -10725,7 +10714,7 @@
                     <a:lstStyle/>
                     <a:p>
                       <a:r>
-                        <a:rPr sz="1050" b="0">
+                        <a:rPr sz="950" b="0">
                           <a:solidFill>
                             <a:srgbClr val="202124"/>
                           </a:solidFill>
@@ -10742,7 +10731,7 @@
                     <a:lstStyle/>
                     <a:p>
                       <a:r>
-                        <a:rPr sz="1050" b="0">
+                        <a:rPr sz="950" b="0">
                           <a:solidFill>
                             <a:srgbClr val="202124"/>
                           </a:solidFill>
@@ -10759,7 +10748,7 @@
                     <a:lstStyle/>
                     <a:p>
                       <a:r>
-                        <a:rPr sz="1050" b="1">
+                        <a:rPr sz="950" b="1">
                           <a:solidFill>
                             <a:srgbClr val="202124"/>
                           </a:solidFill>
@@ -10776,7 +10765,7 @@
                     <a:lstStyle/>
                     <a:p>
                       <a:r>
-                        <a:rPr sz="1050" b="0">
+                        <a:rPr sz="950" b="0">
                           <a:solidFill>
                             <a:srgbClr val="202124"/>
                           </a:solidFill>
@@ -10793,7 +10782,7 @@
                     <a:lstStyle/>
                     <a:p>
                       <a:r>
-                        <a:rPr sz="1050" b="0">
+                        <a:rPr sz="950" b="0">
                           <a:solidFill>
                             <a:srgbClr val="202124"/>
                           </a:solidFill>
@@ -10812,7 +10801,7 @@
                     <a:lstStyle/>
                     <a:p>
                       <a:r>
-                        <a:rPr sz="1050" b="0">
+                        <a:rPr sz="950" b="0">
                           <a:solidFill>
                             <a:srgbClr val="202124"/>
                           </a:solidFill>
@@ -10829,7 +10818,7 @@
                     <a:lstStyle/>
                     <a:p>
                       <a:r>
-                        <a:rPr sz="1050" b="1">
+                        <a:rPr sz="950" b="1">
                           <a:solidFill>
                             <a:srgbClr val="7B4FD1"/>
                           </a:solidFill>
@@ -10846,7 +10835,7 @@
                     <a:lstStyle/>
                     <a:p>
                       <a:r>
-                        <a:rPr sz="1050" b="0">
+                        <a:rPr sz="950" b="0">
                           <a:solidFill>
                             <a:srgbClr val="202124"/>
                           </a:solidFill>
@@ -10863,7 +10852,7 @@
                     <a:lstStyle/>
                     <a:p>
                       <a:r>
-                        <a:rPr sz="1050" b="0">
+                        <a:rPr sz="950" b="0">
                           <a:solidFill>
                             <a:srgbClr val="202124"/>
                           </a:solidFill>
@@ -10880,7 +10869,7 @@
                     <a:lstStyle/>
                     <a:p>
                       <a:r>
-                        <a:rPr sz="1050" b="0">
+                        <a:rPr sz="950" b="0">
                           <a:solidFill>
                             <a:srgbClr val="202124"/>
                           </a:solidFill>
@@ -10897,7 +10886,7 @@
                     <a:lstStyle/>
                     <a:p>
                       <a:r>
-                        <a:rPr sz="1050" b="0">
+                        <a:rPr sz="950" b="0">
                           <a:solidFill>
                             <a:srgbClr val="202124"/>
                           </a:solidFill>
@@ -10914,7 +10903,7 @@
                     <a:lstStyle/>
                     <a:p>
                       <a:r>
-                        <a:rPr sz="1050" b="0">
+                        <a:rPr sz="950" b="0">
                           <a:solidFill>
                             <a:srgbClr val="202124"/>
                           </a:solidFill>
@@ -10933,7 +10922,7 @@
                     <a:lstStyle/>
                     <a:p>
                       <a:r>
-                        <a:rPr sz="1050" b="1">
+                        <a:rPr sz="950" b="1">
                           <a:solidFill>
                             <a:srgbClr val="202124"/>
                           </a:solidFill>
@@ -10950,7 +10939,7 @@
                     <a:lstStyle/>
                     <a:p>
                       <a:r>
-                        <a:rPr sz="1050" b="1">
+                        <a:rPr sz="950" b="1">
                           <a:solidFill>
                             <a:srgbClr val="4C8BF5"/>
                           </a:solidFill>
@@ -10967,7 +10956,7 @@
                     <a:lstStyle/>
                     <a:p>
                       <a:r>
-                        <a:rPr sz="1050" b="0">
+                        <a:rPr sz="950" b="0">
                           <a:solidFill>
                             <a:srgbClr val="202124"/>
                           </a:solidFill>
@@ -10984,7 +10973,7 @@
                     <a:lstStyle/>
                     <a:p>
                       <a:r>
-                        <a:rPr sz="1050" b="0">
+                        <a:rPr sz="950" b="0">
                           <a:solidFill>
                             <a:srgbClr val="202124"/>
                           </a:solidFill>
@@ -11001,7 +10990,7 @@
                     <a:lstStyle/>
                     <a:p>
                       <a:r>
-                        <a:rPr sz="1050" b="1">
+                        <a:rPr sz="950" b="1">
                           <a:solidFill>
                             <a:srgbClr val="202124"/>
                           </a:solidFill>
@@ -11018,7 +11007,7 @@
                     <a:lstStyle/>
                     <a:p>
                       <a:r>
-                        <a:rPr sz="1050" b="0">
+                        <a:rPr sz="950" b="0">
                           <a:solidFill>
                             <a:srgbClr val="202124"/>
                           </a:solidFill>
@@ -11035,7 +11024,7 @@
                     <a:lstStyle/>
                     <a:p>
                       <a:r>
-                        <a:rPr sz="1050" b="0">
+                        <a:rPr sz="950" b="0">
                           <a:solidFill>
                             <a:srgbClr val="202124"/>
                           </a:solidFill>
@@ -11054,7 +11043,7 @@
                     <a:lstStyle/>
                     <a:p>
                       <a:r>
-                        <a:rPr sz="1050" b="1">
+                        <a:rPr sz="950" b="1">
                           <a:solidFill>
                             <a:srgbClr val="202124"/>
                           </a:solidFill>
@@ -11071,7 +11060,7 @@
                     <a:lstStyle/>
                     <a:p>
                       <a:r>
-                        <a:rPr sz="1050" b="1">
+                        <a:rPr sz="950" b="1">
                           <a:solidFill>
                             <a:srgbClr val="4C8BF5"/>
                           </a:solidFill>
@@ -11088,7 +11077,7 @@
                     <a:lstStyle/>
                     <a:p>
                       <a:r>
-                        <a:rPr sz="1050" b="0">
+                        <a:rPr sz="950" b="0">
                           <a:solidFill>
                             <a:srgbClr val="202124"/>
                           </a:solidFill>
@@ -11105,7 +11094,7 @@
                     <a:lstStyle/>
                     <a:p>
                       <a:r>
-                        <a:rPr sz="1050" b="0">
+                        <a:rPr sz="950" b="0">
                           <a:solidFill>
                             <a:srgbClr val="202124"/>
                           </a:solidFill>
@@ -11122,7 +11111,7 @@
                     <a:lstStyle/>
                     <a:p>
                       <a:r>
-                        <a:rPr sz="1050" b="1">
+                        <a:rPr sz="950" b="1">
                           <a:solidFill>
                             <a:srgbClr val="202124"/>
                           </a:solidFill>
@@ -11139,7 +11128,7 @@
                     <a:lstStyle/>
                     <a:p>
                       <a:r>
-                        <a:rPr sz="1050" b="0">
+                        <a:rPr sz="950" b="0">
                           <a:solidFill>
                             <a:srgbClr val="202124"/>
                           </a:solidFill>
@@ -11156,7 +11145,7 @@
                     <a:lstStyle/>
                     <a:p>
                       <a:r>
-                        <a:rPr sz="1050" b="0">
+                        <a:rPr sz="950" b="0">
                           <a:solidFill>
                             <a:srgbClr val="202124"/>
                           </a:solidFill>
@@ -11175,7 +11164,7 @@
                     <a:lstStyle/>
                     <a:p>
                       <a:r>
-                        <a:rPr sz="1050" b="1">
+                        <a:rPr sz="950" b="1">
                           <a:solidFill>
                             <a:srgbClr val="202124"/>
                           </a:solidFill>
@@ -11192,7 +11181,7 @@
                     <a:lstStyle/>
                     <a:p>
                       <a:r>
-                        <a:rPr sz="1050" b="1">
+                        <a:rPr sz="950" b="1">
                           <a:solidFill>
                             <a:srgbClr val="E8710A"/>
                           </a:solidFill>
@@ -11209,7 +11198,7 @@
                     <a:lstStyle/>
                     <a:p>
                       <a:r>
-                        <a:rPr sz="1050" b="0">
+                        <a:rPr sz="950" b="0">
                           <a:solidFill>
                             <a:srgbClr val="202124"/>
                           </a:solidFill>
@@ -11226,7 +11215,7 @@
                     <a:lstStyle/>
                     <a:p>
                       <a:r>
-                        <a:rPr sz="1050" b="0">
+                        <a:rPr sz="950" b="0">
                           <a:solidFill>
                             <a:srgbClr val="202124"/>
                           </a:solidFill>
@@ -11243,7 +11232,7 @@
                     <a:lstStyle/>
                     <a:p>
                       <a:r>
-                        <a:rPr sz="1050" b="1">
+                        <a:rPr sz="950" b="1">
                           <a:solidFill>
                             <a:srgbClr val="202124"/>
                           </a:solidFill>
@@ -11260,7 +11249,7 @@
                     <a:lstStyle/>
                     <a:p>
                       <a:r>
-                        <a:rPr sz="1050" b="0">
+                        <a:rPr sz="950" b="0">
                           <a:solidFill>
                             <a:srgbClr val="202124"/>
                           </a:solidFill>
@@ -11277,7 +11266,7 @@
                     <a:lstStyle/>
                     <a:p>
                       <a:r>
-                        <a:rPr sz="1050" b="0">
+                        <a:rPr sz="950" b="0">
                           <a:solidFill>
                             <a:srgbClr val="202124"/>
                           </a:solidFill>
@@ -11296,7 +11285,7 @@
                     <a:lstStyle/>
                     <a:p>
                       <a:r>
-                        <a:rPr sz="1050" b="1">
+                        <a:rPr sz="950" b="1">
                           <a:solidFill>
                             <a:srgbClr val="202124"/>
                           </a:solidFill>
@@ -11313,7 +11302,7 @@
                     <a:lstStyle/>
                     <a:p>
                       <a:r>
-                        <a:rPr sz="1050" b="1">
+                        <a:rPr sz="950" b="1">
                           <a:solidFill>
                             <a:srgbClr val="E8710A"/>
                           </a:solidFill>
@@ -11330,7 +11319,7 @@
                     <a:lstStyle/>
                     <a:p>
                       <a:r>
-                        <a:rPr sz="1050" b="0">
+                        <a:rPr sz="950" b="0">
                           <a:solidFill>
                             <a:srgbClr val="202124"/>
                           </a:solidFill>
@@ -11347,7 +11336,7 @@
                     <a:lstStyle/>
                     <a:p>
                       <a:r>
-                        <a:rPr sz="1050" b="0">
+                        <a:rPr sz="950" b="0">
                           <a:solidFill>
                             <a:srgbClr val="202124"/>
                           </a:solidFill>
@@ -11364,7 +11353,7 @@
                     <a:lstStyle/>
                     <a:p>
                       <a:r>
-                        <a:rPr sz="1050" b="1">
+                        <a:rPr sz="950" b="1">
                           <a:solidFill>
                             <a:srgbClr val="202124"/>
                           </a:solidFill>
@@ -11381,7 +11370,7 @@
                     <a:lstStyle/>
                     <a:p>
                       <a:r>
-                        <a:rPr sz="1050" b="0">
+                        <a:rPr sz="950" b="0">
                           <a:solidFill>
                             <a:srgbClr val="202124"/>
                           </a:solidFill>
@@ -11398,7 +11387,7 @@
                     <a:lstStyle/>
                     <a:p>
                       <a:r>
-                        <a:rPr sz="1050" b="0">
+                        <a:rPr sz="950" b="0">
                           <a:solidFill>
                             <a:srgbClr val="202124"/>
                           </a:solidFill>
@@ -11417,7 +11406,7 @@
                     <a:lstStyle/>
                     <a:p>
                       <a:r>
-                        <a:rPr sz="1050" b="1">
+                        <a:rPr sz="950" b="1">
                           <a:solidFill>
                             <a:srgbClr val="202124"/>
                           </a:solidFill>
@@ -11434,7 +11423,7 @@
                     <a:lstStyle/>
                     <a:p>
                       <a:r>
-                        <a:rPr sz="1050" b="1">
+                        <a:rPr sz="950" b="1">
                           <a:solidFill>
                             <a:srgbClr val="12B5A5"/>
                           </a:solidFill>
@@ -11451,7 +11440,7 @@
                     <a:lstStyle/>
                     <a:p>
                       <a:r>
-                        <a:rPr sz="1050" b="0">
+                        <a:rPr sz="950" b="0">
                           <a:solidFill>
                             <a:srgbClr val="202124"/>
                           </a:solidFill>
@@ -11468,7 +11457,7 @@
                     <a:lstStyle/>
                     <a:p>
                       <a:r>
-                        <a:rPr sz="1050" b="0">
+                        <a:rPr sz="950" b="0">
                           <a:solidFill>
                             <a:srgbClr val="202124"/>
                           </a:solidFill>
@@ -11485,7 +11474,7 @@
                     <a:lstStyle/>
                     <a:p>
                       <a:r>
-                        <a:rPr sz="1050" b="1">
+                        <a:rPr sz="950" b="1">
                           <a:solidFill>
                             <a:srgbClr val="202124"/>
                           </a:solidFill>
@@ -11502,7 +11491,7 @@
                     <a:lstStyle/>
                     <a:p>
                       <a:r>
-                        <a:rPr sz="1050" b="0">
+                        <a:rPr sz="950" b="0">
                           <a:solidFill>
                             <a:srgbClr val="202124"/>
                           </a:solidFill>
@@ -11519,7 +11508,7 @@
                     <a:lstStyle/>
                     <a:p>
                       <a:r>
-                        <a:rPr sz="1050" b="0">
+                        <a:rPr sz="950" b="0">
                           <a:solidFill>
                             <a:srgbClr val="202124"/>
                           </a:solidFill>
@@ -11538,7 +11527,7 @@
                     <a:lstStyle/>
                     <a:p>
                       <a:r>
-                        <a:rPr sz="1050" b="1">
+                        <a:rPr sz="950" b="1">
                           <a:solidFill>
                             <a:srgbClr val="202124"/>
                           </a:solidFill>
@@ -11555,7 +11544,7 @@
                     <a:lstStyle/>
                     <a:p>
                       <a:r>
-                        <a:rPr sz="1050" b="1">
+                        <a:rPr sz="950" b="1">
                           <a:solidFill>
                             <a:srgbClr val="4C8BF5"/>
                           </a:solidFill>
@@ -11572,7 +11561,7 @@
                     <a:lstStyle/>
                     <a:p>
                       <a:r>
-                        <a:rPr sz="1050" b="0">
+                        <a:rPr sz="950" b="0">
                           <a:solidFill>
                             <a:srgbClr val="202124"/>
                           </a:solidFill>
@@ -11589,7 +11578,7 @@
                     <a:lstStyle/>
                     <a:p>
                       <a:r>
-                        <a:rPr sz="1050" b="0">
+                        <a:rPr sz="950" b="0">
                           <a:solidFill>
                             <a:srgbClr val="202124"/>
                           </a:solidFill>
@@ -11606,7 +11595,7 @@
                     <a:lstStyle/>
                     <a:p>
                       <a:r>
-                        <a:rPr sz="1050" b="1">
+                        <a:rPr sz="950" b="1">
                           <a:solidFill>
                             <a:srgbClr val="202124"/>
                           </a:solidFill>
@@ -11623,7 +11612,7 @@
                     <a:lstStyle/>
                     <a:p>
                       <a:r>
-                        <a:rPr sz="1050" b="0">
+                        <a:rPr sz="950" b="0">
                           <a:solidFill>
                             <a:srgbClr val="202124"/>
                           </a:solidFill>
@@ -11640,7 +11629,7 @@
                     <a:lstStyle/>
                     <a:p>
                       <a:r>
-                        <a:rPr sz="1050" b="0">
+                        <a:rPr sz="950" b="0">
                           <a:solidFill>
                             <a:srgbClr val="202124"/>
                           </a:solidFill>
@@ -11659,7 +11648,7 @@
                     <a:lstStyle/>
                     <a:p>
                       <a:r>
-                        <a:rPr sz="1050" b="1">
+                        <a:rPr sz="950" b="1">
                           <a:solidFill>
                             <a:srgbClr val="202124"/>
                           </a:solidFill>
@@ -11676,7 +11665,7 @@
                     <a:lstStyle/>
                     <a:p>
                       <a:r>
-                        <a:rPr sz="1050" b="1">
+                        <a:rPr sz="950" b="1">
                           <a:solidFill>
                             <a:srgbClr val="E8710A"/>
                           </a:solidFill>
@@ -11693,7 +11682,7 @@
                     <a:lstStyle/>
                     <a:p>
                       <a:r>
-                        <a:rPr sz="1050" b="0">
+                        <a:rPr sz="950" b="0">
                           <a:solidFill>
                             <a:srgbClr val="202124"/>
                           </a:solidFill>
@@ -11710,7 +11699,7 @@
                     <a:lstStyle/>
                     <a:p>
                       <a:r>
-                        <a:rPr sz="1050" b="0">
+                        <a:rPr sz="950" b="0">
                           <a:solidFill>
                             <a:srgbClr val="202124"/>
                           </a:solidFill>
@@ -11727,7 +11716,7 @@
                     <a:lstStyle/>
                     <a:p>
                       <a:r>
-                        <a:rPr sz="1050" b="1">
+                        <a:rPr sz="950" b="1">
                           <a:solidFill>
                             <a:srgbClr val="202124"/>
                           </a:solidFill>
@@ -11744,7 +11733,7 @@
                     <a:lstStyle/>
                     <a:p>
                       <a:r>
-                        <a:rPr sz="1050" b="0">
+                        <a:rPr sz="950" b="0">
                           <a:solidFill>
                             <a:srgbClr val="202124"/>
                           </a:solidFill>
@@ -11761,7 +11750,7 @@
                     <a:lstStyle/>
                     <a:p>
                       <a:r>
-                        <a:rPr sz="1050" b="0">
+                        <a:rPr sz="950" b="0">
                           <a:solidFill>
                             <a:srgbClr val="202124"/>
                           </a:solidFill>
@@ -11780,7 +11769,7 @@
                     <a:lstStyle/>
                     <a:p>
                       <a:r>
-                        <a:rPr sz="1050" b="1">
+                        <a:rPr sz="950" b="1">
                           <a:solidFill>
                             <a:srgbClr val="202124"/>
                           </a:solidFill>
@@ -11797,7 +11786,7 @@
                     <a:lstStyle/>
                     <a:p>
                       <a:r>
-                        <a:rPr sz="1050" b="1">
+                        <a:rPr sz="950" b="1">
                           <a:solidFill>
                             <a:srgbClr val="E8710A"/>
                           </a:solidFill>
@@ -11814,7 +11803,7 @@
                     <a:lstStyle/>
                     <a:p>
                       <a:r>
-                        <a:rPr sz="1050" b="0">
+                        <a:rPr sz="950" b="0">
                           <a:solidFill>
                             <a:srgbClr val="202124"/>
                           </a:solidFill>
@@ -11831,7 +11820,7 @@
                     <a:lstStyle/>
                     <a:p>
                       <a:r>
-                        <a:rPr sz="1050" b="0">
+                        <a:rPr sz="950" b="0">
                           <a:solidFill>
                             <a:srgbClr val="202124"/>
                           </a:solidFill>
@@ -11848,7 +11837,7 @@
                     <a:lstStyle/>
                     <a:p>
                       <a:r>
-                        <a:rPr sz="1050" b="1">
+                        <a:rPr sz="950" b="1">
                           <a:solidFill>
                             <a:srgbClr val="202124"/>
                           </a:solidFill>
@@ -11865,7 +11854,7 @@
                     <a:lstStyle/>
                     <a:p>
                       <a:r>
-                        <a:rPr sz="1050" b="0">
+                        <a:rPr sz="950" b="0">
                           <a:solidFill>
                             <a:srgbClr val="202124"/>
                           </a:solidFill>
@@ -11882,7 +11871,7 @@
                     <a:lstStyle/>
                     <a:p>
                       <a:r>
-                        <a:rPr sz="1050" b="0">
+                        <a:rPr sz="950" b="0">
                           <a:solidFill>
                             <a:srgbClr val="202124"/>
                           </a:solidFill>
@@ -11901,7 +11890,7 @@
                     <a:lstStyle/>
                     <a:p>
                       <a:r>
-                        <a:rPr sz="1050" b="1">
+                        <a:rPr sz="950" b="1">
                           <a:solidFill>
                             <a:srgbClr val="202124"/>
                           </a:solidFill>
@@ -11918,7 +11907,7 @@
                     <a:lstStyle/>
                     <a:p>
                       <a:r>
-                        <a:rPr sz="1050" b="1">
+                        <a:rPr sz="950" b="1">
                           <a:solidFill>
                             <a:srgbClr val="E8710A"/>
                           </a:solidFill>
@@ -11935,7 +11924,7 @@
                     <a:lstStyle/>
                     <a:p>
                       <a:r>
-                        <a:rPr sz="1050" b="0">
+                        <a:rPr sz="950" b="0">
                           <a:solidFill>
                             <a:srgbClr val="202124"/>
                           </a:solidFill>
@@ -11952,7 +11941,7 @@
                     <a:lstStyle/>
                     <a:p>
                       <a:r>
-                        <a:rPr sz="1050" b="0">
+                        <a:rPr sz="950" b="0">
                           <a:solidFill>
                             <a:srgbClr val="202124"/>
                           </a:solidFill>
@@ -11969,7 +11958,7 @@
                     <a:lstStyle/>
                     <a:p>
                       <a:r>
-                        <a:rPr sz="1050" b="1">
+                        <a:rPr sz="950" b="1">
                           <a:solidFill>
                             <a:srgbClr val="202124"/>
                           </a:solidFill>
@@ -11986,7 +11975,7 @@
                     <a:lstStyle/>
                     <a:p>
                       <a:r>
-                        <a:rPr sz="1050" b="0">
+                        <a:rPr sz="950" b="0">
                           <a:solidFill>
                             <a:srgbClr val="202124"/>
                           </a:solidFill>
@@ -12003,7 +11992,7 @@
                     <a:lstStyle/>
                     <a:p>
                       <a:r>
-                        <a:rPr sz="1050" b="0">
+                        <a:rPr sz="950" b="0">
                           <a:solidFill>
                             <a:srgbClr val="202124"/>
                           </a:solidFill>
@@ -12022,7 +12011,7 @@
                     <a:lstStyle/>
                     <a:p>
                       <a:r>
-                        <a:rPr sz="1050" b="1">
+                        <a:rPr sz="950" b="1">
                           <a:solidFill>
                             <a:srgbClr val="202124"/>
                           </a:solidFill>
@@ -12039,7 +12028,7 @@
                     <a:lstStyle/>
                     <a:p>
                       <a:r>
-                        <a:rPr sz="1050" b="1">
+                        <a:rPr sz="950" b="1">
                           <a:solidFill>
                             <a:srgbClr val="E8710A"/>
                           </a:solidFill>
@@ -12056,7 +12045,7 @@
                     <a:lstStyle/>
                     <a:p>
                       <a:r>
-                        <a:rPr sz="1050" b="0">
+                        <a:rPr sz="950" b="0">
                           <a:solidFill>
                             <a:srgbClr val="202124"/>
                           </a:solidFill>
@@ -12073,7 +12062,7 @@
                     <a:lstStyle/>
                     <a:p>
                       <a:r>
-                        <a:rPr sz="1050" b="0">
+                        <a:rPr sz="950" b="0">
                           <a:solidFill>
                             <a:srgbClr val="202124"/>
                           </a:solidFill>
@@ -12090,7 +12079,7 @@
                     <a:lstStyle/>
                     <a:p>
                       <a:r>
-                        <a:rPr sz="1050" b="1">
+                        <a:rPr sz="950" b="1">
                           <a:solidFill>
                             <a:srgbClr val="202124"/>
                           </a:solidFill>
@@ -12107,7 +12096,7 @@
                     <a:lstStyle/>
                     <a:p>
                       <a:r>
-                        <a:rPr sz="1050" b="0">
+                        <a:rPr sz="950" b="0">
                           <a:solidFill>
                             <a:srgbClr val="202124"/>
                           </a:solidFill>
@@ -12124,7 +12113,7 @@
                     <a:lstStyle/>
                     <a:p>
                       <a:r>
-                        <a:rPr sz="1050" b="0">
+                        <a:rPr sz="950" b="0">
                           <a:solidFill>
                             <a:srgbClr val="202124"/>
                           </a:solidFill>
@@ -12143,7 +12132,7 @@
                     <a:lstStyle/>
                     <a:p>
                       <a:r>
-                        <a:rPr sz="1050" b="1">
+                        <a:rPr sz="950" b="1">
                           <a:solidFill>
                             <a:srgbClr val="202124"/>
                           </a:solidFill>
@@ -12160,7 +12149,7 @@
                     <a:lstStyle/>
                     <a:p>
                       <a:r>
-                        <a:rPr sz="1050" b="1">
+                        <a:rPr sz="950" b="1">
                           <a:solidFill>
                             <a:srgbClr val="4C8BF5"/>
                           </a:solidFill>
@@ -12177,7 +12166,7 @@
                     <a:lstStyle/>
                     <a:p>
                       <a:r>
-                        <a:rPr sz="1050" b="0">
+                        <a:rPr sz="950" b="0">
                           <a:solidFill>
                             <a:srgbClr val="202124"/>
                           </a:solidFill>
@@ -12194,7 +12183,7 @@
                     <a:lstStyle/>
                     <a:p>
                       <a:r>
-                        <a:rPr sz="1050" b="0">
+                        <a:rPr sz="950" b="0">
                           <a:solidFill>
                             <a:srgbClr val="202124"/>
                           </a:solidFill>
@@ -12211,7 +12200,7 @@
                     <a:lstStyle/>
                     <a:p>
                       <a:r>
-                        <a:rPr sz="1050" b="1">
+                        <a:rPr sz="950" b="1">
                           <a:solidFill>
                             <a:srgbClr val="202124"/>
                           </a:solidFill>
@@ -12228,7 +12217,7 @@
                     <a:lstStyle/>
                     <a:p>
                       <a:r>
-                        <a:rPr sz="1050" b="0">
+                        <a:rPr sz="950" b="0">
                           <a:solidFill>
                             <a:srgbClr val="202124"/>
                           </a:solidFill>
@@ -12245,7 +12234,7 @@
                     <a:lstStyle/>
                     <a:p>
                       <a:r>
-                        <a:rPr sz="1050" b="0">
+                        <a:rPr sz="950" b="0">
                           <a:solidFill>
                             <a:srgbClr val="202124"/>
                           </a:solidFill>
@@ -12264,7 +12253,7 @@
                     <a:lstStyle/>
                     <a:p>
                       <a:r>
-                        <a:rPr sz="1050" b="1">
+                        <a:rPr sz="950" b="1">
                           <a:solidFill>
                             <a:srgbClr val="202124"/>
                           </a:solidFill>
@@ -12281,7 +12270,7 @@
                     <a:lstStyle/>
                     <a:p>
                       <a:r>
-                        <a:rPr sz="1050" b="1">
+                        <a:rPr sz="950" b="1">
                           <a:solidFill>
                             <a:srgbClr val="9AA0A6"/>
                           </a:solidFill>
@@ -12298,7 +12287,7 @@
                     <a:lstStyle/>
                     <a:p>
                       <a:r>
-                        <a:rPr sz="1050" b="0">
+                        <a:rPr sz="950" b="0">
                           <a:solidFill>
                             <a:srgbClr val="202124"/>
                           </a:solidFill>
@@ -12315,7 +12304,7 @@
                     <a:lstStyle/>
                     <a:p>
                       <a:r>
-                        <a:rPr sz="1050" b="0">
+                        <a:rPr sz="950" b="0">
                           <a:solidFill>
                             <a:srgbClr val="202124"/>
                           </a:solidFill>
@@ -12332,7 +12321,7 @@
                     <a:lstStyle/>
                     <a:p>
                       <a:r>
-                        <a:rPr sz="1050" b="1">
+                        <a:rPr sz="950" b="1">
                           <a:solidFill>
                             <a:srgbClr val="202124"/>
                           </a:solidFill>
@@ -12349,7 +12338,7 @@
                     <a:lstStyle/>
                     <a:p>
                       <a:r>
-                        <a:rPr sz="1050" b="0">
+                        <a:rPr sz="950" b="0">
                           <a:solidFill>
                             <a:srgbClr val="202124"/>
                           </a:solidFill>
@@ -12366,7 +12355,7 @@
                     <a:lstStyle/>
                     <a:p>
                       <a:r>
-                        <a:rPr sz="1050" b="0">
+                        <a:rPr sz="950" b="0">
                           <a:solidFill>
                             <a:srgbClr val="202124"/>
                           </a:solidFill>
@@ -12460,7 +12449,7 @@
         </p:nvSpPr>
         <p:spPr>
           <a:xfrm>
-            <a:off x="548640" y="6583680"/>
+            <a:off x="548640" y="6565392"/>
             <a:ext cx="11155680" cy="274320"/>
           </a:xfrm>
           <a:prstGeom prst="rect">
@@ -12476,13 +12465,13 @@
           <a:p>
             <a:pPr algn="l"/>
             <a:r>
-              <a:rPr sz="950" b="0">
+              <a:rPr sz="850" b="0">
                 <a:solidFill>
                   <a:srgbClr val="5F6368"/>
                 </a:solidFill>
                 <a:latin typeface="Calibri"/>
               </a:rPr>
-              <a:t>A78C/NSP cells: medians of repeated invocations (bimodal board). OFA rows: matched geometry, OWN algorithm at D=128 — not bit-exact. ‡ DRAM = achieved / ceiling GB/s. A55 cells MEASURED at the DDR controller (67% of the chip's bus at 6 threads); other achieved cells not yet instrumented.</a:t>
+              <a:t>A78C/NSP cells: medians of repeated invocations (bimodal board). OFA rows: matched geometry, OWN algorithm at D=128 -- not bit-exact. ‡ achieved / ceiling GB/s, MEASURED cells only: A55 at the DDR controller (67% of the chip's bus at 6 threads); A78C via icc_bwmon, 23.8 of 27.1 -- still saturated at the bigger scene. Blank: A720/G720 CMN counters dead, NSP/5090 staged.</a:t>
             </a:r>
           </a:p>
         </p:txBody>
@@ -13630,7 +13619,7 @@
                 </a:solidFill>
                 <a:latin typeface="Calibri"/>
               </a:rPr>
-              <a:t>Cross-GPU sanity: MDE/s per GB/s of ceiling is 27 / 40 / 33 across a 7.9x bandwidth spread -- throughput largely IS bandwidth for the tuned GPU kernels, and the residual (the 5090's 42%) says the fastest part is no longer purely bandwidth-bound. Achieved-byte instrumentation exists for Configuration A; the B/C runs reuse the same silicon and ceilings but their per-phase byte models are not separately derived.</a:t>
+              <a:t>Cross-GPU sanity: MDE/s per GB/s of ceiling is 27 / 40 / 33 across a 7.9x bandwidth spread -- throughput largely IS bandwidth for the tuned GPU kernels, and the residual (the 5090's 42%) says the fastest part is no longer purely bandwidth-bound. Configuration B gets its own version of this slide two slides ahead -- with six of its achieved cells directly MEASURED at three independent DRAM instruments.</a:t>
             </a:r>
           </a:p>
         </p:txBody>
@@ -17190,7 +17179,7 @@
                 </a:solidFill>
                 <a:latin typeface="Calibri"/>
               </a:rPr>
-              <a:t>Same slide for the block-flavoured workload (1920x800, two scales, 8 paths). The 8-path uint16 S-plane streams ~3.1 GB per frame on its own; the pipeline's streaming byte model totals 4.50 GB/frame. Three cells are MEASURED at the i.MX95 DDR controller; the rest are DERIVED as 4.50 GB / the measured frame time.</a:t>
+              <a:t>Same slide for the block-flavoured workload (1920x800, two scales, 8 paths). The 8-path uint16 S-plane streams ~3.1 GB per frame on its own; the pipeline's streaming byte model totals 4.50 GB/frame. Three cells are MEASURED at the i.MX95 DDR controller and three more at other instruments (green); the † cells are DERIVED as 4.50 GB / the measured frame time.</a:t>
             </a:r>
           </a:p>
         </p:txBody>
@@ -19439,7 +19428,7 @@
                 </a:solidFill>
                 <a:latin typeface="Calibri"/>
               </a:rPr>
-              <a:t>Blackwell, 170 SM, discrete, 32 GB, driver 580.173  |  D=128: 4.09 ms  ·  D=256: 7.08 ms</a:t>
+              <a:t>Blackwell, 170 SM, discrete, 32 GB, driver 580.173  |  D=128: 4.36 ms  ·  D=256: 6.96 ms</a:t>
             </a:r>
           </a:p>
         </p:txBody>
@@ -19578,188 +19567,144 @@
           <a:p>
             <a:pPr algn="l"/>
             <a:r>
-              <a:rPr sz="1300" b="0">
+              <a:rPr sz="1100" b="0">
                 <a:solidFill>
                   <a:srgbClr val="202124"/>
                 </a:solidFill>
                 <a:latin typeface="Calibri"/>
               </a:rPr>
-              <a:t>The fastest target measured: 37,383 MDE/s at D=64, 282 fps at 1080p.</a:t>
-            </a:r>
-          </a:p>
-          <a:p>
-            <a:r>
-              <a:rPr sz="1300">
+              <a:t>The fastest target measured: 38,356 MDE/s at D=64, 289 fps at 1080p.</a:t>
+            </a:r>
+          </a:p>
+          <a:p>
+            <a:r>
+              <a:rPr sz="1100">
                 <a:solidFill>
                   <a:srgbClr val="202124"/>
                 </a:solidFill>
                 <a:latin typeface="Calibri"/>
               </a:rPr>
-              <a:t>64,880 MDE/s at D=128 and 74,957 at D=256 -- and unlike Thor it shows NO</a:t>
-            </a:r>
-          </a:p>
-          <a:p>
-            <a:r>
-              <a:rPr sz="1300">
+              <a:t>60,932 MDE/s at D=128 and 76,248 at D=256 -- unlike Thor, NO reversal at D=256,</a:t>
+            </a:r>
+          </a:p>
+          <a:p>
+            <a:r>
+              <a:rPr sz="1100">
                 <a:solidFill>
                   <a:srgbClr val="202124"/>
                 </a:solidFill>
                 <a:latin typeface="Calibri"/>
               </a:rPr>
-              <a:t>reversal at D=256, which is what the traffic mechanism predicts on a part</a:t>
-            </a:r>
-          </a:p>
-          <a:p>
-            <a:r>
-              <a:rPr sz="1300">
+              <a:t>which is what the traffic mechanism predicts on a part with 5.6x the bandwidth.</a:t>
+            </a:r>
+          </a:p>
+          <a:p>
+            <a:r>
+              <a:rPr sz="1100">
                 <a:solidFill>
                   <a:srgbClr val="202124"/>
                 </a:solidFill>
                 <a:latin typeface="Calibri"/>
               </a:rPr>
-              <a:t>with 5.6x the memory bandwidth.</a:t>
-            </a:r>
-          </a:p>
-          <a:p>
-            <a:r>
-              <a:rPr sz="1300">
+              <a:t>587 GB/s achieved of a measured 1,385 GB/s ceiling = 42%: the LOWEST utilisation</a:t>
+            </a:r>
+          </a:p>
+          <a:p>
+            <a:r>
+              <a:rPr sz="1100">
                 <a:solidFill>
                   <a:srgbClr val="202124"/>
                 </a:solidFill>
                 <a:latin typeface="Calibri"/>
               </a:rPr>
-              <a:t>Bandwidth: 587 GB/s achieved of a measured 1,385 GB/s ceiling = 42%, the</a:t>
-            </a:r>
-          </a:p>
-          <a:p>
-            <a:r>
-              <a:rPr sz="1300">
+              <a:t>of the three GPUs despite being fastest -- no longer purely bandwidth-bound.</a:t>
+            </a:r>
+          </a:p>
+          <a:p>
+            <a:r>
+              <a:rPr sz="1100">
                 <a:solidFill>
                   <a:srgbClr val="202124"/>
                 </a:solidFill>
                 <a:latin typeface="Calibri"/>
               </a:rPr>
-              <a:t>LOWEST utilisation of the three GPUs despite being the fastest -- so at this</a:t>
-            </a:r>
-          </a:p>
-          <a:p>
-            <a:r>
-              <a:rPr sz="1300">
+              <a:t>⚠️ Built as PTX, JIT-compiled by the driver (local CUDA 12.6 cannot target</a:t>
+            </a:r>
+          </a:p>
+          <a:p>
+            <a:r>
+              <a:rPr sz="1100">
                 <a:solidFill>
                   <a:srgbClr val="202124"/>
                 </a:solidFill>
                 <a:latin typeface="Calibri"/>
               </a:rPr>
-              <a:t>speed it is no longer purely bandwidth-bound.</a:t>
-            </a:r>
-          </a:p>
-          <a:p>
-            <a:r>
-              <a:rPr sz="1300">
+              <a:t>sm_120). Golden verified, but not a native build.</a:t>
+            </a:r>
+          </a:p>
+          <a:p>
+            <a:r>
+              <a:rPr sz="1100">
                 <a:solidFill>
                   <a:srgbClr val="202124"/>
                 </a:solidFill>
                 <a:latin typeface="Calibri"/>
               </a:rPr>
-              <a:t>⚠️ Built as PTX and JIT-compiled by the driver: the local toolkit is CUDA</a:t>
-            </a:r>
-          </a:p>
-          <a:p>
-            <a:r>
-              <a:rPr sz="1300">
+              <a:t>⭐ ITS STEREO HARDWARE IS MEASURED, AND STEREO MODE IS ALREADY GONE:</a:t>
+            </a:r>
+          </a:p>
+          <a:p>
+            <a:r>
+              <a:rPr sz="1100">
                 <a:solidFill>
                   <a:srgbClr val="202124"/>
                 </a:solidFill>
                 <a:latin typeface="Calibri"/>
               </a:rPr>
-              <a:t>12.6, which cannot target sm_120. Golden verified, but not a native build.</a:t>
-            </a:r>
-          </a:p>
-          <a:p>
-            <a:r>
-              <a:rPr sz="1300">
+              <a:t>NV_OF_MODE_STEREODISPARITY returns UNSUPPORTED_FEATURE at every grid size.</a:t>
+            </a:r>
+          </a:p>
+          <a:p>
+            <a:r>
+              <a:rPr sz="1100">
                 <a:solidFill>
                   <a:srgbClr val="202124"/>
                 </a:solidFill>
                 <a:latin typeface="Calibri"/>
               </a:rPr>
-              <a:t>⭐ ITS STEREO HARDWARE IS MEASURED, AND STEREO MODE IS ALREADY GONE.</a:t>
-            </a:r>
-          </a:p>
-          <a:p>
-            <a:r>
-              <a:rPr sz="1300">
+              <a:t>The fallback (X of general 2D flow): 8.50 ms, 5.3% bad px, vs our CUDA SGM's</a:t>
+            </a:r>
+          </a:p>
+          <a:p>
+            <a:r>
+              <a:rPr sz="1100">
                 <a:solidFill>
                   <a:srgbClr val="202124"/>
                 </a:solidFill>
                 <a:latin typeface="Calibri"/>
               </a:rPr>
-              <a:t>NV_OF_MODE_STEREODISPARITY returns UNSUPPORTED_FEATURE at every grid size;</a:t>
-            </a:r>
-          </a:p>
-          <a:p>
-            <a:r>
-              <a:rPr sz="1300">
+              <a:t>4.13 ms and 2.8% -- software faster AND more accurate, doing less work (1D).</a:t>
+            </a:r>
+          </a:p>
+          <a:p>
+            <a:r>
+              <a:rPr sz="1100">
                 <a:solidFill>
                   <a:srgbClr val="202124"/>
                 </a:solidFill>
                 <a:latin typeface="Calibri"/>
               </a:rPr>
-              <a:t>NVIDIA's documented deprecation has already landed on Blackwell.</a:t>
-            </a:r>
-          </a:p>
-          <a:p>
-            <a:r>
-              <a:rPr sz="1300">
+              <a:t>🚨 13.4% of fallback pixels return non-zero VERTICAL flow (largest 75 px) --</a:t>
+            </a:r>
+          </a:p>
+          <a:p>
+            <a:r>
+              <a:rPr sz="1100">
                 <a:solidFill>
                   <a:srgbClr val="202124"/>
                 </a:solidFill>
                 <a:latin typeface="Calibri"/>
               </a:rPr>
-              <a:t>The fallback -- X component of general optical flow -- runs 8.50 ms with</a:t>
-            </a:r>
-          </a:p>
-          <a:p>
-            <a:r>
-              <a:rPr sz="1300">
-                <a:solidFill>
-                  <a:srgbClr val="202124"/>
-                </a:solidFill>
-                <a:latin typeface="Calibri"/>
-              </a:rPr>
-              <a:t>5.3% bad pixels, against our CUDA SGM's 4.13 ms and 2.8% on the same scene.</a:t>
-            </a:r>
-          </a:p>
-          <a:p>
-            <a:r>
-              <a:rPr sz="1300">
-                <a:solidFill>
-                  <a:srgbClr val="202124"/>
-                </a:solidFill>
-                <a:latin typeface="Calibri"/>
-              </a:rPr>
-              <a:t>Software faster AND more accurate, while doing less work (1D vs 2D).</a:t>
-            </a:r>
-          </a:p>
-          <a:p>
-            <a:r>
-              <a:rPr sz="1300">
-                <a:solidFill>
-                  <a:srgbClr val="202124"/>
-                </a:solidFill>
-                <a:latin typeface="Calibri"/>
-              </a:rPr>
-              <a:t>🚨 13.4% of pixels return a non-zero VERTICAL component, largest 75 px --</a:t>
-            </a:r>
-          </a:p>
-          <a:p>
-            <a:r>
-              <a:rPr sz="1300">
-                <a:solidFill>
-                  <a:srgbClr val="202124"/>
-                </a:solidFill>
-                <a:latin typeface="Calibri"/>
-              </a:rPr>
               <a:t>errors the removed stereo mode was structurally incapable of producing.</a:t>
             </a:r>
           </a:p>
@@ -19773,7 +19718,7 @@
         </p:nvSpPr>
         <p:spPr>
           <a:xfrm>
-            <a:off x="548640" y="6400800"/>
+            <a:off x="548640" y="6601968"/>
             <a:ext cx="10515600" cy="365760"/>
           </a:xfrm>
           <a:prstGeom prst="rect">

</xml_diff>

<commit_message>
fold DRAM consumption into the B and C summary tables, not just the ceilings
The B/C summary tables carried '— / ceiling' in the DRAM column while the
bandwidth slides held the actual consumption figures. Both now carry
achieved / ceiling on every row, with provenance visible at a glance:
MEASURED cells green (bold in the README), DERIVED cells marked †, the
withdrawn A78C cell red.

Configuration C needed its own byte model, and it is checked rather than
assumed: 6.07 GB/frame = B's 4.50 scaled by searched pixels (1.35x). Against
the one cell measured both ways it reproduces the six-A55 result at 78%,
matching B's own 80% under-count -- so the same cache-reuse-free bias
travels between scenes, which is what licenses the scaling.

Footnotes now state the model's terms, its calibration, and the rule that a
DERIVED cell is never compared against a MEASURED one.
</commit_message>
<xml_diff>
--- a/docs/sgm-results.pptx
+++ b/docs/sgm-results.pptx
@@ -8449,9 +8449,9 @@
                     <a:lstStyle/>
                     <a:p>
                       <a:r>
-                        <a:rPr sz="1100" b="0">
-                          <a:solidFill>
-                            <a:srgbClr val="202124"/>
+                        <a:rPr sz="1100" b="1">
+                          <a:solidFill>
+                            <a:srgbClr val="187A33"/>
                           </a:solidFill>
                         </a:rPr>
                         <a:t>≈0 / 249</a:t>
@@ -8575,7 +8575,7 @@
                             <a:srgbClr val="202124"/>
                           </a:solidFill>
                         </a:rPr>
-                        <a:t>— / 1,385</a:t>
+                        <a:t>495 † / 1,385</a:t>
                       </a:r>
                     </a:p>
                   </a:txBody>
@@ -8691,9 +8691,9 @@
                     <a:lstStyle/>
                     <a:p>
                       <a:r>
-                        <a:rPr sz="1100" b="0">
-                          <a:solidFill>
-                            <a:srgbClr val="202124"/>
+                        <a:rPr sz="1100" b="1">
+                          <a:solidFill>
+                            <a:srgbClr val="187A33"/>
                           </a:solidFill>
                         </a:rPr>
                         <a:t>0.7 / 175</a:t>
@@ -8817,7 +8817,7 @@
                             <a:srgbClr val="202124"/>
                           </a:solidFill>
                         </a:rPr>
-                        <a:t>— / 249</a:t>
+                        <a:t>100 † / 249</a:t>
                       </a:r>
                     </a:p>
                   </a:txBody>
@@ -8938,7 +8938,7 @@
                             <a:srgbClr val="202124"/>
                           </a:solidFill>
                         </a:rPr>
-                        <a:t>— / 175</a:t>
+                        <a:t>62 † / 175</a:t>
                       </a:r>
                     </a:p>
                   </a:txBody>
@@ -9056,10 +9056,10 @@
                       <a:r>
                         <a:rPr sz="1100" b="0">
                           <a:solidFill>
-                            <a:srgbClr val="202124"/>
-                          </a:solidFill>
-                        </a:rPr>
-                        <a:t>— / 27.1</a:t>
+                            <a:srgbClr val="D93025"/>
+                          </a:solidFill>
+                        </a:rPr>
+                        <a:t>withdrawn / 27.1</a:t>
                       </a:r>
                     </a:p>
                   </a:txBody>
@@ -9180,7 +9180,7 @@
                             <a:srgbClr val="202124"/>
                           </a:solidFill>
                         </a:rPr>
-                        <a:t>— / 46.3</a:t>
+                        <a:t>18.9 † / 46.3</a:t>
                       </a:r>
                     </a:p>
                   </a:txBody>
@@ -9301,7 +9301,7 @@
                             <a:srgbClr val="202124"/>
                           </a:solidFill>
                         </a:rPr>
-                        <a:t>— / 28</a:t>
+                        <a:t>~16 † / 28</a:t>
                       </a:r>
                     </a:p>
                   </a:txBody>
@@ -9422,7 +9422,7 @@
                             <a:srgbClr val="202124"/>
                           </a:solidFill>
                         </a:rPr>
-                        <a:t>— / 46.3</a:t>
+                        <a:t>11.8 † / 46.3</a:t>
                       </a:r>
                     </a:p>
                   </a:txBody>
@@ -9543,7 +9543,7 @@
                             <a:srgbClr val="202124"/>
                           </a:solidFill>
                         </a:rPr>
-                        <a:t>— / 27.1</a:t>
+                        <a:t>10.2 † / 27.1</a:t>
                       </a:r>
                     </a:p>
                   </a:txBody>
@@ -9664,7 +9664,7 @@
                             <a:srgbClr val="202124"/>
                           </a:solidFill>
                         </a:rPr>
-                        <a:t>— / 46.3</a:t>
+                        <a:t>9.6 † / 46.3</a:t>
                       </a:r>
                     </a:p>
                   </a:txBody>
@@ -9780,9 +9780,9 @@
                     <a:lstStyle/>
                     <a:p>
                       <a:r>
-                        <a:rPr sz="1100" b="0">
-                          <a:solidFill>
-                            <a:srgbClr val="202124"/>
+                        <a:rPr sz="1100" b="1">
+                          <a:solidFill>
+                            <a:srgbClr val="187A33"/>
                           </a:solidFill>
                         </a:rPr>
                         <a:t>8.8 / 13.7</a:t>
@@ -9901,9 +9901,9 @@
                     <a:lstStyle/>
                     <a:p>
                       <a:r>
-                        <a:rPr sz="1100" b="0">
-                          <a:solidFill>
-                            <a:srgbClr val="202124"/>
+                        <a:rPr sz="1100" b="1">
+                          <a:solidFill>
+                            <a:srgbClr val="187A33"/>
                           </a:solidFill>
                         </a:rPr>
                         <a:t>2.7 / 13.7</a:t>
@@ -10022,9 +10022,9 @@
                     <a:lstStyle/>
                     <a:p>
                       <a:r>
-                        <a:rPr sz="1100" b="0">
-                          <a:solidFill>
-                            <a:srgbClr val="202124"/>
+                        <a:rPr sz="1100" b="1">
+                          <a:solidFill>
+                            <a:srgbClr val="187A33"/>
                           </a:solidFill>
                         </a:rPr>
                         <a:t>2.1 / 13.7</a:t>
@@ -10449,7 +10449,7 @@
                 </a:solidFill>
                 <a:latin typeface="Calibri"/>
               </a:rPr>
-              <a:t>MDE/s (work) = both scales: (0.384+1.536) Mpx x 64 / runtime. OFA rows: their OWN SGM at matched geometry, throughput only. ‡ achieved / ceiling GB/s, MEASURED cells only (A55+G310: i.MX95 DDR controller, 64% of the chip's bus at 6xA55; OFA: EMC ~ idle). Blank: A720/G720 CMN counters dead, NSP/5090 staged, and the A78C icc_bwmon cell WITHDRAWN (failed its idle control). Details: bandwidth slide.</a:t>
+              <a:t>MDE/s (work) = both scales: (0.384+1.536) Mpx x 64 / runtime. OFA rows: their OWN SGM at matched geometry, throughput only. ‡ DRAM achieved / ceiling GB/s. GREEN = MEASURED (A55 + G310 at the i.MX95 DDR controller -- six A55s take 64% of the whole chip's bus; the OFA rows by Jetson EMC sampling, ~idle). † = DERIVED: the 4.50 GB/frame streaming byte model / the measured frame time, cache-reuse-free so a slight under-count (it reproduces the measured A55x6 cell at 80%). Every ceiling is MEASURED by copy probe. RED = the A78C cell withdrawn as window-dependent -- see the withdrawn-cell slide.</a:t>
             </a:r>
           </a:p>
         </p:txBody>
@@ -12266,7 +12266,7 @@
                             <a:srgbClr val="202124"/>
                           </a:solidFill>
                         </a:rPr>
-                        <a:t>— / 1,385</a:t>
+                        <a:t>508 † / 1,385</a:t>
                       </a:r>
                     </a:p>
                   </a:txBody>
@@ -12508,7 +12508,7 @@
                             <a:srgbClr val="202124"/>
                           </a:solidFill>
                         </a:rPr>
-                        <a:t>— / 249</a:t>
+                        <a:t>107 † / 249</a:t>
                       </a:r>
                     </a:p>
                   </a:txBody>
@@ -12629,7 +12629,7 @@
                             <a:srgbClr val="202124"/>
                           </a:solidFill>
                         </a:rPr>
-                        <a:t>— / 175</a:t>
+                        <a:t>63 † / 175</a:t>
                       </a:r>
                     </a:p>
                   </a:txBody>
@@ -12750,7 +12750,7 @@
                             <a:srgbClr val="202124"/>
                           </a:solidFill>
                         </a:rPr>
-                        <a:t>— / 46.3</a:t>
+                        <a:t>25.4 † / 46.3</a:t>
                       </a:r>
                     </a:p>
                   </a:txBody>
@@ -12868,10 +12868,10 @@
                       <a:r>
                         <a:rPr sz="950" b="0">
                           <a:solidFill>
-                            <a:srgbClr val="202124"/>
-                          </a:solidFill>
-                        </a:rPr>
-                        <a:t>— / 27.1</a:t>
+                            <a:srgbClr val="D93025"/>
+                          </a:solidFill>
+                        </a:rPr>
+                        <a:t>withdrawn / 27.1</a:t>
                       </a:r>
                     </a:p>
                   </a:txBody>
@@ -12992,7 +12992,7 @@
                             <a:srgbClr val="202124"/>
                           </a:solidFill>
                         </a:rPr>
-                        <a:t>— / 28</a:t>
+                        <a:t>16.3 † / 28</a:t>
                       </a:r>
                     </a:p>
                   </a:txBody>
@@ -13113,7 +13113,7 @@
                             <a:srgbClr val="202124"/>
                           </a:solidFill>
                         </a:rPr>
-                        <a:t>— / 46.3</a:t>
+                        <a:t>11.9 † / 46.3</a:t>
                       </a:r>
                     </a:p>
                   </a:txBody>
@@ -13234,7 +13234,7 @@
                             <a:srgbClr val="202124"/>
                           </a:solidFill>
                         </a:rPr>
-                        <a:t>— / 27.1</a:t>
+                        <a:t>10.2 † / 27.1</a:t>
                       </a:r>
                     </a:p>
                   </a:txBody>
@@ -13355,7 +13355,7 @@
                             <a:srgbClr val="202124"/>
                           </a:solidFill>
                         </a:rPr>
-                        <a:t>— / 46.3</a:t>
+                        <a:t>9.4 † / 46.3</a:t>
                       </a:r>
                     </a:p>
                   </a:txBody>
@@ -13471,9 +13471,9 @@
                     <a:lstStyle/>
                     <a:p>
                       <a:r>
-                        <a:rPr sz="950" b="0">
-                          <a:solidFill>
-                            <a:srgbClr val="202124"/>
+                        <a:rPr sz="950" b="1">
+                          <a:solidFill>
+                            <a:srgbClr val="187A33"/>
                           </a:solidFill>
                         </a:rPr>
                         <a:t>9.2 / 13.7</a:t>
@@ -13592,9 +13592,9 @@
                     <a:lstStyle/>
                     <a:p>
                       <a:r>
-                        <a:rPr sz="950" b="0">
-                          <a:solidFill>
-                            <a:srgbClr val="202124"/>
+                        <a:rPr sz="950" b="1">
+                          <a:solidFill>
+                            <a:srgbClr val="187A33"/>
                           </a:solidFill>
                         </a:rPr>
                         <a:t>2.7 / 13.7</a:t>
@@ -13718,7 +13718,7 @@
                             <a:srgbClr val="202124"/>
                           </a:solidFill>
                         </a:rPr>
-                        <a:t>— / 13.7</a:t>
+                        <a:t>1.7 † / 13.7</a:t>
                       </a:r>
                     </a:p>
                   </a:txBody>
@@ -13967,7 +13967,7 @@
                 </a:solidFill>
                 <a:latin typeface="Calibri"/>
               </a:rPr>
-              <a:t>A78C/NSP cells: medians of repeated invocations (bimodal board). OFA rows: matched geometry, OWN algorithm at D=128 -- not bit-exact. ‡ achieved / ceiling GB/s, MEASURED cells only: A55 at the DDR controller (67% of the chip's bus at 6 threads). Blank: A720/G720 CMN counters dead, NSP/5090 staged, A78C icc_bwmon cell WITHDRAWN (failed its idle control -- see the Config B bandwidth slide).</a:t>
+              <a:t>A78C/NSP cells: medians of repeated invocations (bimodal board). OFA rows: matched geometry, OWN algorithm at D=128 -- not bit-exact. ‡ DRAM achieved / ceiling GB/s. GREEN = MEASURED at the i.MX95 DDR controller (67% of the chip's bus at six threads). † = DERIVED: C's own 6.07 GB/frame byte model (B's 4.50 scaled by searched pixels, 1.35x) / the measured frame time -- same cache-reuse-free under-count, reproducing the measured A55x6 cell at 78%, which matches B's 80% and is the cross-check that the scaling is honest. RED = the A78C cell withdrawn as window-dependent. OFA rows blank: a different algorithm, so this model would be fiction.</a:t>
             </a:r>
           </a:p>
         </p:txBody>

</xml_diff>

<commit_message>
charts: the OFA engines get bars, and the pair is titled Run 1 / Run 2
The fixed-function engines were a purple text box beside the Config B chart
and absent entirely from Config C, which had no chart at all. Both now carry
them as HATCHED bars, placed by wall-clock equivalence: where a bit-exact
implementation would have to land to match that engine's frame time -- the
same 'time only' quantity the tables already print. Hatched, never solid,
with the caveat under the axis, because they run their own algorithm and
have no MDE/s in this work convention.

New docs/run1_mde.png (1920x800) and docs/run2_mde.png (1920x1080), titled
as the single-variable pair Run 1 / Run 2 per the presentation convention --
no reference to Configuration A's scene, since the whole point of the pair
is that the ONLY variable is input size. docs/results_b.png superseded by
run1_mde.png and removed; scripts/make_chart_c.py added; the deck gains a
Run 2 chart slide (31 slides) and the README embeds both.
</commit_message>
<xml_diff>
--- a/docs/sgm-results.pptx
+++ b/docs/sgm-results.pptx
@@ -35,6 +35,7 @@
     <p:sldId id="283" r:id="rId34"/>
     <p:sldId id="284" r:id="rId35"/>
     <p:sldId id="285" r:id="rId36"/>
+    <p:sldId id="286" r:id="rId37"/>
   </p:sldIdLst>
   <p:sldSz cx="12191695" cy="6858000" type="screen4x3"/>
   <p:notesSz cx="6858000" cy="9144000"/>
@@ -10544,7 +10545,7 @@
       </p:sp>
       <p:pic>
         <p:nvPicPr>
-          <p:cNvPr id="4" name="Picture 3" descr="results_b.png"/>
+          <p:cNvPr id="4" name="Picture 3" descr="run1_mde.png"/>
           <p:cNvPicPr>
             <a:picLocks noChangeAspect="1"/>
           </p:cNvPicPr>
@@ -13999,7 +14000,7 @@
         <p:spPr>
           <a:xfrm>
             <a:off x="548640" y="320040"/>
-            <a:ext cx="10058400" cy="640080"/>
+            <a:ext cx="10972800" cy="640080"/>
           </a:xfrm>
           <a:prstGeom prst="rect">
             <a:avLst/>
@@ -14014,13 +14015,13 @@
           <a:p>
             <a:pPr algn="l"/>
             <a:r>
-              <a:rPr sz="3200" b="1">
-                <a:solidFill>
-                  <a:srgbClr val="4C8BF5"/>
-                </a:solidFill>
-                <a:latin typeface="Calibri"/>
-              </a:rPr>
-              <a:t>NVIDIA RTX 5090</a:t>
+              <a:rPr sz="2700" b="1">
+                <a:solidFill>
+                  <a:srgbClr val="202124"/>
+                </a:solidFill>
+                <a:latin typeface="Calibri"/>
+              </a:rPr>
+              <a:t>Configuration C, charted — the roster at 1920x1080</a:t>
             </a:r>
           </a:p>
         </p:txBody>
@@ -14033,8 +14034,8 @@
         </p:nvSpPr>
         <p:spPr>
           <a:xfrm>
-            <a:off x="9509760" y="457200"/>
-            <a:ext cx="2194560" cy="365760"/>
+            <a:off x="548640" y="914400"/>
+            <a:ext cx="11155680" cy="365760"/>
           </a:xfrm>
           <a:prstGeom prst="rect">
             <a:avLst/>
@@ -14049,27 +14050,51 @@
           <a:p>
             <a:pPr algn="l"/>
             <a:r>
-              <a:rPr sz="1200" b="1">
+              <a:rPr sz="1200" b="0">
                 <a:solidFill>
                   <a:srgbClr val="5F6368"/>
                 </a:solidFill>
                 <a:latin typeface="Calibri"/>
               </a:rPr>
-              <a:t>CONFIGURATION B</a:t>
-            </a:r>
-          </a:p>
-        </p:txBody>
-      </p:sp>
-      <p:sp>
-        <p:nvSpPr>
-          <p:cNvPr id="4" name="TextBox 3"/>
-          <p:cNvSpPr txBox="1"/>
-          <p:nvPr/>
-        </p:nvSpPr>
-        <p:spPr>
-          <a:xfrm>
-            <a:off x="548640" y="914400"/>
-            <a:ext cx="10881360" cy="365760"/>
+              <a:t>The pair as one workload at two input sizes -- Run 1 = 1920x800 (previous chart), Run 2 = 1920x1080 (this one). Identical algorithm, identical parameters, identical roster; the ONLY variable between the two charts is the input size.</a:t>
+            </a:r>
+          </a:p>
+        </p:txBody>
+      </p:sp>
+      <p:pic>
+        <p:nvPicPr>
+          <p:cNvPr id="4" name="Picture 3" descr="run2_mde.png"/>
+          <p:cNvPicPr>
+            <a:picLocks noChangeAspect="1"/>
+          </p:cNvPicPr>
+          <p:nvPr/>
+        </p:nvPicPr>
+        <p:blipFill>
+          <a:blip r:embed="rId2"/>
+          <a:stretch>
+            <a:fillRect/>
+          </a:stretch>
+        </p:blipFill>
+        <p:spPr>
+          <a:xfrm>
+            <a:off x="1234440" y="1417320"/>
+            <a:ext cx="7034084" cy="4526280"/>
+          </a:xfrm>
+          <a:prstGeom prst="rect">
+            <a:avLst/>
+          </a:prstGeom>
+        </p:spPr>
+      </p:pic>
+      <p:sp>
+        <p:nvSpPr>
+          <p:cNvPr id="5" name="TextBox 4"/>
+          <p:cNvSpPr txBox="1"/>
+          <p:nvPr/>
+        </p:nvSpPr>
+        <p:spPr>
+          <a:xfrm>
+            <a:off x="548640" y="5943600"/>
+            <a:ext cx="11155680" cy="640080"/>
           </a:xfrm>
           <a:prstGeom prst="rect">
             <a:avLst/>
@@ -14084,257 +14109,13 @@
           <a:p>
             <a:pPr algn="l"/>
             <a:r>
-              <a:rPr sz="1300" b="0">
-                <a:solidFill>
-                  <a:srgbClr val="5F6368"/>
-                </a:solidFill>
-                <a:latin typeface="Calibri"/>
-              </a:rPr>
-              <a:t>CUDA, tuned  |  canonical: median of 5 invocations x 20 frames, 0.1% spread on a quiet card</a:t>
-            </a:r>
-          </a:p>
-        </p:txBody>
-      </p:sp>
-      <p:sp>
-        <p:nvSpPr>
-          <p:cNvPr id="5" name="TextBox 4"/>
-          <p:cNvSpPr txBox="1"/>
-          <p:nvPr/>
-        </p:nvSpPr>
-        <p:spPr>
-          <a:xfrm>
-            <a:off x="548640" y="1554480"/>
-            <a:ext cx="10515600" cy="365760"/>
-          </a:xfrm>
-          <a:prstGeom prst="rect">
-            <a:avLst/>
-          </a:prstGeom>
-          <a:noFill/>
-        </p:spPr>
-        <p:txBody>
-          <a:bodyPr wrap="square">
-            <a:spAutoFit/>
-          </a:bodyPr>
-          <a:lstStyle/>
-          <a:p>
-            <a:pPr algn="l"/>
-            <a:r>
-              <a:rPr sz="1600" b="1">
+              <a:rPr sz="1150" b="0">
                 <a:solidFill>
                   <a:srgbClr val="202124"/>
                 </a:solidFill>
                 <a:latin typeface="Calibri"/>
               </a:rPr>
-              <a:t>The calculation (work-performed convention)</a:t>
-            </a:r>
-          </a:p>
-        </p:txBody>
-      </p:sp>
-      <p:sp>
-        <p:nvSpPr>
-          <p:cNvPr id="6" name="TextBox 5"/>
-          <p:cNvSpPr txBox="1"/>
-          <p:nvPr/>
-        </p:nvSpPr>
-        <p:spPr>
-          <a:xfrm>
-            <a:off x="548640" y="1965960"/>
-            <a:ext cx="10881360" cy="1554480"/>
-          </a:xfrm>
-          <a:prstGeom prst="rect">
-            <a:avLst/>
-          </a:prstGeom>
-          <a:noFill/>
-        </p:spPr>
-        <p:txBody>
-          <a:bodyPr wrap="square">
-            <a:spAutoFit/>
-          </a:bodyPr>
-          <a:lstStyle/>
-          <a:p>
-            <a:pPr algn="l"/>
-            <a:r>
-              <a:rPr sz="1400" b="0">
-                <a:solidFill>
-                  <a:srgbClr val="202124"/>
-                </a:solidFill>
-                <a:latin typeface="Consolas"/>
-              </a:rPr>
-              <a:t>MDE/s  =  (0.384 + 1.536) Mpx x 64 / runtime      (both full-search scales count)
-        =  122,880,000 disparity estimations / 0.00908 s
-        =  13,533 million disparity estimations per second
-frame rate  =  1000 / 9.08  =  110.13 fps   (960x400 disparity map out)</a:t>
-            </a:r>
-          </a:p>
-        </p:txBody>
-      </p:sp>
-      <p:sp>
-        <p:nvSpPr>
-          <p:cNvPr id="7" name="TextBox 6"/>
-          <p:cNvSpPr txBox="1"/>
-          <p:nvPr/>
-        </p:nvSpPr>
-        <p:spPr>
-          <a:xfrm>
-            <a:off x="548640" y="3657600"/>
-            <a:ext cx="10515600" cy="365760"/>
-          </a:xfrm>
-          <a:prstGeom prst="rect">
-            <a:avLst/>
-          </a:prstGeom>
-          <a:noFill/>
-        </p:spPr>
-        <p:txBody>
-          <a:bodyPr wrap="square">
-            <a:spAutoFit/>
-          </a:bodyPr>
-          <a:lstStyle/>
-          <a:p>
-            <a:pPr algn="l"/>
-            <a:r>
-              <a:rPr sz="1600" b="1">
-                <a:solidFill>
-                  <a:srgbClr val="202124"/>
-                </a:solidFill>
-                <a:latin typeface="Calibri"/>
-              </a:rPr>
-              <a:t>What the measurement means</a:t>
-            </a:r>
-          </a:p>
-        </p:txBody>
-      </p:sp>
-      <p:sp>
-        <p:nvSpPr>
-          <p:cNvPr id="8" name="TextBox 7"/>
-          <p:cNvSpPr txBox="1"/>
-          <p:nvPr/>
-        </p:nvSpPr>
-        <p:spPr>
-          <a:xfrm>
-            <a:off x="548640" y="4023360"/>
-            <a:ext cx="10881360" cy="2286000"/>
-          </a:xfrm>
-          <a:prstGeom prst="rect">
-            <a:avLst/>
-          </a:prstGeom>
-          <a:noFill/>
-        </p:spPr>
-        <p:txBody>
-          <a:bodyPr wrap="square">
-            <a:spAutoFit/>
-          </a:bodyPr>
-          <a:lstStyle/>
-          <a:p>
-            <a:pPr algn="l"/>
-            <a:r>
-              <a:rPr sz="1300" b="0">
-                <a:solidFill>
-                  <a:srgbClr val="202124"/>
-                </a:solidFill>
-                <a:latin typeface="Calibri"/>
-              </a:rPr>
-              <a:t>The fastest Configuration B target: 110 fps of two-scale, 8-path, weighted-P1</a:t>
-            </a:r>
-          </a:p>
-          <a:p>
-            <a:r>
-              <a:rPr sz="1300">
-                <a:solidFill>
-                  <a:srgbClr val="202124"/>
-                </a:solidFill>
-                <a:latin typeface="Calibri"/>
-              </a:rPr>
-              <a:t>SGM on a workload designed for a fixed-function embedded block.</a:t>
-            </a:r>
-          </a:p>
-          <a:p>
-            <a:r>
-              <a:rPr sz="1300">
-                <a:solidFill>
-                  <a:srgbClr val="202124"/>
-                </a:solidFill>
-                <a:latin typeface="Calibri"/>
-              </a:rPr>
-              <a:t>The port is a GENERIC path kernel: one warp owns one path line in any of the 8</a:t>
-            </a:r>
-          </a:p>
-          <a:p>
-            <a:r>
-              <a:rPr sz="1300">
-                <a:solidFill>
-                  <a:srgbClr val="202124"/>
-                </a:solidFill>
-                <a:latin typeface="Calibri"/>
-              </a:rPr>
-              <a:t>directions, line start derived from the direction pair, P1 passed per launch</a:t>
-            </a:r>
-          </a:p>
-          <a:p>
-            <a:r>
-              <a:rPr sz="1300">
-                <a:solidFill>
-                  <a:srgbClr val="202124"/>
-                </a:solidFill>
-                <a:latin typeface="Calibri"/>
-              </a:rPr>
-              <a:t>so the direction weighting costs nothing. Bit-exact on the first full run.</a:t>
-            </a:r>
-          </a:p>
-          <a:p>
-            <a:r>
-              <a:rPr sz="1300">
-                <a:solidFill>
-                  <a:srgbClr val="202124"/>
-                </a:solidFill>
-                <a:latin typeface="Calibri"/>
-              </a:rPr>
-              <a:t>It lacks the primary kernel's path-pairing pass, so this row is the</a:t>
-            </a:r>
-          </a:p>
-          <a:p>
-            <a:r>
-              <a:rPr sz="1300">
-                <a:solidFill>
-                  <a:srgbClr val="202124"/>
-                </a:solidFill>
-                <a:latin typeface="Calibri"/>
-              </a:rPr>
-              <a:t>conservative side of what the card can do.</a:t>
-            </a:r>
-          </a:p>
-        </p:txBody>
-      </p:sp>
-      <p:sp>
-        <p:nvSpPr>
-          <p:cNvPr id="9" name="TextBox 8"/>
-          <p:cNvSpPr txBox="1"/>
-          <p:nvPr/>
-        </p:nvSpPr>
-        <p:spPr>
-          <a:xfrm>
-            <a:off x="548640" y="6446520"/>
-            <a:ext cx="10881360" cy="365760"/>
-          </a:xfrm>
-          <a:prstGeom prst="rect">
-            <a:avLst/>
-          </a:prstGeom>
-          <a:noFill/>
-        </p:spPr>
-        <p:txBody>
-          <a:bodyPr wrap="square">
-            <a:spAutoFit/>
-          </a:bodyPr>
-          <a:lstStyle/>
-          <a:p>
-            <a:pPr algn="l"/>
-            <a:r>
-              <a:rPr sz="1100" b="0">
-                <a:solidFill>
-                  <a:srgbClr val="5F6368"/>
-                </a:solidFill>
-                <a:latin typeface="Calibri"/>
-              </a:rPr>
-              <a:t>MEASURED -- median of the timed frames, bit-exact to golden bcb9cb0bd6f49799 in the same run.</a:t>
+              <a:t>Row for row the two charts differ by the 1.35x the pixel count predicts -- with one exception, the A720 cluster at 1.01x, which is the finding on the table slide. The hatched OFA bars carry no MDE/s: they are the fixed-function engines running their OWN algorithm at matched geometry, placed where a bit-exact implementation would have to land to match their frame time.</a:t>
             </a:r>
           </a:p>
         </p:txBody>
@@ -14387,7 +14168,7 @@
                 </a:solidFill>
                 <a:latin typeface="Calibri"/>
               </a:rPr>
-              <a:t>NVIDIA Thor</a:t>
+              <a:t>NVIDIA RTX 5090</a:t>
             </a:r>
           </a:p>
         </p:txBody>
@@ -14457,7 +14238,7 @@
                 </a:solidFill>
                 <a:latin typeface="Calibri"/>
               </a:rPr>
-              <a:t>CUDA, same kernel, sm_110</a:t>
+              <a:t>CUDA, tuned  |  canonical: median of 5 invocations x 20 frames, 0.1% spread on a quiet card</a:t>
             </a:r>
           </a:p>
         </p:txBody>
@@ -14528,9 +14309,9 @@
                 <a:latin typeface="Consolas"/>
               </a:rPr>
               <a:t>MDE/s  =  (0.384 + 1.536) Mpx x 64 / runtime      (both full-search scales count)
-        =  122,880,000 disparity estimations / 0.04510 s
-        =  2,725 million disparity estimations per second
-frame rate  =  1000 / 45.10  =  22.17 fps   (960x400 disparity map out)</a:t>
+        =  122,880,000 disparity estimations / 0.00908 s
+        =  13,533 million disparity estimations per second
+frame rate  =  1000 / 9.08  =  110.13 fps   (960x400 disparity map out)</a:t>
             </a:r>
           </a:p>
         </p:txBody>
@@ -14600,7 +14381,7 @@
                 </a:solidFill>
                 <a:latin typeface="Calibri"/>
               </a:rPr>
-              <a:t>22 fps embedded. Same generic 8-direction kernel as the 5090, bit-exact.</a:t>
+              <a:t>The fastest Configuration B target: 110 fps of two-scale, 8-path, weighted-P1</a:t>
             </a:r>
           </a:p>
           <a:p>
@@ -14611,7 +14392,7 @@
                 </a:solidFill>
                 <a:latin typeface="Calibri"/>
               </a:rPr>
-              <a:t>The gap to the 5090 (5.0x) is close to the bandwidth ratio of the parts,</a:t>
+              <a:t>SGM on a workload designed for a fixed-function embedded block.</a:t>
             </a:r>
           </a:p>
           <a:p>
@@ -14622,7 +14403,7 @@
                 </a:solidFill>
                 <a:latin typeface="Calibri"/>
               </a:rPr>
-              <a:t>consistent with the Configuration A finding that tuned SGM converges on</a:t>
+              <a:t>The port is a GENERIC path kernel: one warp owns one path line in any of the 8</a:t>
             </a:r>
           </a:p>
           <a:p>
@@ -14633,7 +14414,40 @@
                 </a:solidFill>
                 <a:latin typeface="Calibri"/>
               </a:rPr>
-              <a:t>memory traffic once the arithmetic is done.</a:t>
+              <a:t>directions, line start derived from the direction pair, P1 passed per launch</a:t>
+            </a:r>
+          </a:p>
+          <a:p>
+            <a:r>
+              <a:rPr sz="1300">
+                <a:solidFill>
+                  <a:srgbClr val="202124"/>
+                </a:solidFill>
+                <a:latin typeface="Calibri"/>
+              </a:rPr>
+              <a:t>so the direction weighting costs nothing. Bit-exact on the first full run.</a:t>
+            </a:r>
+          </a:p>
+          <a:p>
+            <a:r>
+              <a:rPr sz="1300">
+                <a:solidFill>
+                  <a:srgbClr val="202124"/>
+                </a:solidFill>
+                <a:latin typeface="Calibri"/>
+              </a:rPr>
+              <a:t>It lacks the primary kernel's path-pairing pass, so this row is the</a:t>
+            </a:r>
+          </a:p>
+          <a:p>
+            <a:r>
+              <a:rPr sz="1300">
+                <a:solidFill>
+                  <a:srgbClr val="202124"/>
+                </a:solidFill>
+                <a:latin typeface="Calibri"/>
+              </a:rPr>
+              <a:t>conservative side of what the card can do.</a:t>
             </a:r>
           </a:p>
         </p:txBody>
@@ -14721,7 +14535,7 @@
                 </a:solidFill>
                 <a:latin typeface="Calibri"/>
               </a:rPr>
-              <a:t>NVIDIA Orin AGX</a:t>
+              <a:t>NVIDIA Thor</a:t>
             </a:r>
           </a:p>
         </p:txBody>
@@ -14791,7 +14605,7 @@
                 </a:solidFill>
                 <a:latin typeface="Calibri"/>
               </a:rPr>
-              <a:t>CUDA, same kernel, sm_87</a:t>
+              <a:t>CUDA, same kernel, sm_110</a:t>
             </a:r>
           </a:p>
         </p:txBody>
@@ -14862,9 +14676,9 @@
                 <a:latin typeface="Consolas"/>
               </a:rPr>
               <a:t>MDE/s  =  (0.384 + 1.536) Mpx x 64 / runtime      (both full-search scales count)
-        =  122,880,000 disparity estimations / 0.07280 s
-        =  1,688 million disparity estimations per second
-frame rate  =  1000 / 72.80  =  13.74 fps   (960x400 disparity map out)</a:t>
+        =  122,880,000 disparity estimations / 0.04510 s
+        =  2,725 million disparity estimations per second
+frame rate  =  1000 / 45.10  =  22.17 fps   (960x400 disparity map out)</a:t>
             </a:r>
           </a:p>
         </p:txBody>
@@ -14934,7 +14748,40 @@
                 </a:solidFill>
                 <a:latin typeface="Calibri"/>
               </a:rPr>
-              <a:t>14 fps on the previous embedded generation, bit-exact, no per-part tuning.</a:t>
+              <a:t>22 fps embedded. Same generic 8-direction kernel as the 5090, bit-exact.</a:t>
+            </a:r>
+          </a:p>
+          <a:p>
+            <a:r>
+              <a:rPr sz="1300">
+                <a:solidFill>
+                  <a:srgbClr val="202124"/>
+                </a:solidFill>
+                <a:latin typeface="Calibri"/>
+              </a:rPr>
+              <a:t>The gap to the 5090 (5.0x) is close to the bandwidth ratio of the parts,</a:t>
+            </a:r>
+          </a:p>
+          <a:p>
+            <a:r>
+              <a:rPr sz="1300">
+                <a:solidFill>
+                  <a:srgbClr val="202124"/>
+                </a:solidFill>
+                <a:latin typeface="Calibri"/>
+              </a:rPr>
+              <a:t>consistent with the Configuration A finding that tuned SGM converges on</a:t>
+            </a:r>
+          </a:p>
+          <a:p>
+            <a:r>
+              <a:rPr sz="1300">
+                <a:solidFill>
+                  <a:srgbClr val="202124"/>
+                </a:solidFill>
+                <a:latin typeface="Calibri"/>
+              </a:rPr>
+              <a:t>memory traffic once the arithmetic is done.</a:t>
             </a:r>
           </a:p>
         </p:txBody>
@@ -15018,11 +14865,11 @@
             <a:r>
               <a:rPr sz="3200" b="1">
                 <a:solidFill>
-                  <a:srgbClr val="E8710A"/>
-                </a:solidFill>
-                <a:latin typeface="Calibri"/>
-              </a:rPr>
-              <a:t>Cortex-A78C x8 (6 threads)</a:t>
+                  <a:srgbClr val="4C8BF5"/>
+                </a:solidFill>
+                <a:latin typeface="Calibri"/>
+              </a:rPr>
+              <a:t>NVIDIA Orin AGX</a:t>
             </a:r>
           </a:p>
         </p:txBody>
@@ -15092,7 +14939,7 @@
                 </a:solidFill>
                 <a:latin typeface="Calibri"/>
               </a:rPr>
-              <a:t>Qualcomm IQ-9075, NEON+OpenMP  |  single core: 442.60 ms</a:t>
+              <a:t>CUDA, same kernel, sm_87</a:t>
             </a:r>
           </a:p>
         </p:txBody>
@@ -15163,9 +15010,9 @@
                 <a:latin typeface="Consolas"/>
               </a:rPr>
               <a:t>MDE/s  =  (0.384 + 1.536) Mpx x 64 / runtime      (both full-search scales count)
-        =  122,880,000 disparity estimations / 0.21190 s
-        =  580 million disparity estimations per second
-frame rate  =  1000 / 211.90  =  4.72 fps   (960x400 disparity map out)</a:t>
+        =  122,880,000 disparity estimations / 0.07280 s
+        =  1,688 million disparity estimations per second
+frame rate  =  1000 / 72.80  =  13.74 fps   (960x400 disparity map out)</a:t>
             </a:r>
           </a:p>
         </p:txBody>
@@ -15235,84 +15082,7 @@
                 </a:solidFill>
                 <a:latin typeface="Calibri"/>
               </a:rPr>
-              <a:t>The best programmable embedded result -- and it was measured by the</a:t>
-            </a:r>
-          </a:p>
-          <a:p>
-            <a:r>
-              <a:rPr sz="1300">
-                <a:solidFill>
-                  <a:srgbClr val="202124"/>
-                </a:solidFill>
-                <a:latin typeface="Calibri"/>
-              </a:rPr>
-              <a:t>collaborating session running multiscale/sgm_ms_neon.c UNMODIFIED on their</a:t>
-            </a:r>
-          </a:p>
-          <a:p>
-            <a:r>
-              <a:rPr sz="1300">
-                <a:solidFill>
-                  <a:srgbClr val="202124"/>
-                </a:solidFill>
-                <a:latin typeface="Calibri"/>
-              </a:rPr>
-              <a:t>silicon, golden every run. Medians of five invocations on a board that is</a:t>
-            </a:r>
-          </a:p>
-          <a:p>
-            <a:r>
-              <a:rPr sz="1300">
-                <a:solidFill>
-                  <a:srgbClr val="202124"/>
-                </a:solidFill>
-                <a:latin typeface="Calibri"/>
-              </a:rPr>
-              <a:t>bimodal by ~9% between invocations; medians quoted, never minima.</a:t>
-            </a:r>
-          </a:p>
-          <a:p>
-            <a:r>
-              <a:rPr sz="1300">
-                <a:solidFill>
-                  <a:srgbClr val="202124"/>
-                </a:solidFill>
-                <a:latin typeface="Calibri"/>
-              </a:rPr>
-              <a:t>This row is also what corrected the record: at the oracle tier the NSP</a:t>
-            </a:r>
-          </a:p>
-          <a:p>
-            <a:r>
-              <a:rPr sz="1300">
-                <a:solidFill>
-                  <a:srgbClr val="202124"/>
-                </a:solidFill>
-                <a:latin typeface="Calibri"/>
-              </a:rPr>
-              <a:t>appeared to lead the cluster 3.29x; at the matched NEON tier the cluster</a:t>
-            </a:r>
-          </a:p>
-          <a:p>
-            <a:r>
-              <a:rPr sz="1300">
-                <a:solidFill>
-                  <a:srgbClr val="202124"/>
-                </a:solidFill>
-                <a:latin typeface="Calibri"/>
-              </a:rPr>
-              <a:t>leads 1.30x. A cross-tier comparison is a cross-configuration comparison</a:t>
-            </a:r>
-          </a:p>
-          <a:p>
-            <a:r>
-              <a:rPr sz="1300">
-                <a:solidFill>
-                  <a:srgbClr val="202124"/>
-                </a:solidFill>
-                <a:latin typeface="Calibri"/>
-              </a:rPr>
-              <a:t>wearing a platform comparison's clothes.</a:t>
+              <a:t>14 fps on the previous embedded generation, bit-exact, no per-part tuning.</a:t>
             </a:r>
           </a:p>
         </p:txBody>
@@ -15400,7 +15170,7 @@
                 </a:solidFill>
                 <a:latin typeface="Calibri"/>
               </a:rPr>
-              <a:t>Cortex-A720 x8</a:t>
+              <a:t>Cortex-A78C x8 (6 threads)</a:t>
             </a:r>
           </a:p>
         </p:txBody>
@@ -15470,7 +15240,7 @@
                 </a:solidFill>
                 <a:latin typeface="Calibri"/>
               </a:rPr>
-              <a:t>Radxa Orion O6, NEON+OpenMP  |  single core: 470.9 ms</a:t>
+              <a:t>Qualcomm IQ-9075, NEON+OpenMP  |  single core: 442.60 ms</a:t>
             </a:r>
           </a:p>
         </p:txBody>
@@ -15541,9 +15311,9 @@
                 <a:latin typeface="Consolas"/>
               </a:rPr>
               <a:t>MDE/s  =  (0.384 + 1.536) Mpx x 64 / runtime      (both full-search scales count)
-        =  122,880,000 disparity estimations / 0.23830 s
-        =  516 million disparity estimations per second
-frame rate  =  1000 / 238.30  =  4.20 fps   (960x400 disparity map out)</a:t>
+        =  122,880,000 disparity estimations / 0.21190 s
+        =  580 million disparity estimations per second
+frame rate  =  1000 / 211.90  =  4.72 fps   (960x400 disparity map out)</a:t>
             </a:r>
           </a:p>
         </p:txBody>
@@ -15613,7 +15383,7 @@
                 </a:solidFill>
                 <a:latin typeface="Calibri"/>
               </a:rPr>
-              <a:t>The NEON tier is 5.8x the scalar oracle on this cluster. The kernel keeps</a:t>
+              <a:t>The best programmable embedded result -- and it was measured by the</a:t>
             </a:r>
           </a:p>
           <a:p>
@@ -15624,7 +15394,7 @@
                 </a:solidFill>
                 <a:latin typeface="Calibri"/>
               </a:rPr>
-              <a:t>Configuration A's register scheme and adds the saturating step, the</a:t>
+              <a:t>collaborating session running multiscale/sgm_ms_neon.c UNMODIFIED on their</a:t>
             </a:r>
           </a:p>
           <a:p>
@@ -15635,7 +15405,7 @@
                 </a:solidFill>
                 <a:latin typeface="Calibri"/>
               </a:rPr>
-              <a:t>direction-weighted P1 per sweep, and a uint16 sum plane for 8-path S.</a:t>
+              <a:t>silicon, golden every run. Medians of five invocations on a board that is</a:t>
             </a:r>
           </a:p>
           <a:p>
@@ -15646,7 +15416,7 @@
                 </a:solidFill>
                 <a:latin typeface="Calibri"/>
               </a:rPr>
-              <a:t>OpenMP is output-neutral by construction: rows for horizontal sweeps,</a:t>
+              <a:t>bimodal by ~9% between invocations; medians quoted, never minima.</a:t>
             </a:r>
           </a:p>
           <a:p>
@@ -15657,7 +15427,7 @@
                 </a:solidFill>
                 <a:latin typeface="Calibri"/>
               </a:rPr>
-              <a:t>columns-within-row for vertical and diagonal, so the hash cannot move</a:t>
+              <a:t>This row is also what corrected the record: at the oracle tier the NSP</a:t>
             </a:r>
           </a:p>
           <a:p>
@@ -15668,7 +15438,29 @@
                 </a:solidFill>
                 <a:latin typeface="Calibri"/>
               </a:rPr>
-              <a:t>with the thread count.</a:t>
+              <a:t>appeared to lead the cluster 3.29x; at the matched NEON tier the cluster</a:t>
+            </a:r>
+          </a:p>
+          <a:p>
+            <a:r>
+              <a:rPr sz="1300">
+                <a:solidFill>
+                  <a:srgbClr val="202124"/>
+                </a:solidFill>
+                <a:latin typeface="Calibri"/>
+              </a:rPr>
+              <a:t>leads 1.30x. A cross-tier comparison is a cross-configuration comparison</a:t>
+            </a:r>
+          </a:p>
+          <a:p>
+            <a:r>
+              <a:rPr sz="1300">
+                <a:solidFill>
+                  <a:srgbClr val="202124"/>
+                </a:solidFill>
+                <a:latin typeface="Calibri"/>
+              </a:rPr>
+              <a:t>wearing a platform comparison's clothes.</a:t>
             </a:r>
           </a:p>
         </p:txBody>
@@ -15752,11 +15544,11 @@
             <a:r>
               <a:rPr sz="3200" b="1">
                 <a:solidFill>
-                  <a:srgbClr val="12B5A5"/>
-                </a:solidFill>
-                <a:latin typeface="Calibri"/>
-              </a:rPr>
-              <a:t>Hexagon v73 NSP</a:t>
+                  <a:srgbClr val="E8710A"/>
+                </a:solidFill>
+                <a:latin typeface="Calibri"/>
+              </a:rPr>
+              <a:t>Cortex-A720 x8</a:t>
             </a:r>
           </a:p>
         </p:txBody>
@@ -15826,7 +15618,7 @@
                 </a:solidFill>
                 <a:latin typeface="Calibri"/>
               </a:rPr>
-              <a:t>Qualcomm IQ-9075, HVX, 4 contexts  |  median of 5, 0.75% spread, golden 10/10</a:t>
+              <a:t>Radxa Orion O6, NEON+OpenMP  |  single core: 470.9 ms</a:t>
             </a:r>
           </a:p>
         </p:txBody>
@@ -15897,9 +15689,9 @@
                 <a:latin typeface="Consolas"/>
               </a:rPr>
               <a:t>MDE/s  =  (0.384 + 1.536) Mpx x 64 / runtime      (both full-search scales count)
-        =  122,880,000 disparity estimations / 0.27630 s
-        =  445 million disparity estimations per second
-frame rate  =  1000 / 276.30  =  3.62 fps   (960x400 disparity map out)</a:t>
+        =  122,880,000 disparity estimations / 0.23830 s
+        =  516 million disparity estimations per second
+frame rate  =  1000 / 238.30  =  4.20 fps   (960x400 disparity map out)</a:t>
             </a:r>
           </a:p>
         </p:txBody>
@@ -15969,7 +15761,7 @@
                 </a:solidFill>
                 <a:latin typeface="Calibri"/>
               </a:rPr>
-              <a:t>Contributed port, independently re-verified (three further gated runs,</a:t>
+              <a:t>The NEON tier is 5.8x the scalar oracle on this cluster. The kernel keeps</a:t>
             </a:r>
           </a:p>
           <a:p>
@@ -15980,7 +15772,7 @@
                 </a:solidFill>
                 <a:latin typeface="Calibri"/>
               </a:rPr>
-              <a:t>269-272 ms). Per ENGINE this is the embedded win: one NSP beats one A78C</a:t>
+              <a:t>Configuration A's register scheme and adds the saturating step, the</a:t>
             </a:r>
           </a:p>
           <a:p>
@@ -15991,7 +15783,7 @@
                 </a:solidFill>
                 <a:latin typeface="Calibri"/>
               </a:rPr>
-              <a:t>core 1.60x at matched tiers.</a:t>
+              <a:t>direction-weighted P1 per sweep, and a uint16 sum plane for 8-path S.</a:t>
             </a:r>
           </a:p>
           <a:p>
@@ -16002,7 +15794,7 @@
                 </a:solidFill>
                 <a:latin typeface="Calibri"/>
               </a:rPr>
-              <a:t>Diagonals use a sync-free chain-band decomposition -- workers own equal-pixel</a:t>
+              <a:t>OpenMP is output-neutral by construction: rows for horizontal sweeps,</a:t>
             </a:r>
           </a:p>
           <a:p>
@@ -16013,7 +15805,7 @@
                 </a:solidFill>
                 <a:latin typeface="Calibri"/>
               </a:rPr>
-              <a:t>bands of diagonal chains, S worker-disjoint, bit-exact with NO barriers.</a:t>
+              <a:t>columns-within-row for vertical and diagonal, so the hash cannot move</a:t>
             </a:r>
           </a:p>
           <a:p>
@@ -16024,62 +15816,7 @@
                 </a:solidFill>
                 <a:latin typeface="Calibri"/>
               </a:rPr>
-              <a:t>The two-scale merge is fused into the stage-2 cost build, saving ~200 MB</a:t>
-            </a:r>
-          </a:p>
-          <a:p>
-            <a:r>
-              <a:rPr sz="1300">
-                <a:solidFill>
-                  <a:srgbClr val="202124"/>
-                </a:solidFill>
-                <a:latin typeface="Calibri"/>
-              </a:rPr>
-              <a:t>of traffic per frame. The 4-HVX-context knee holds here too: 6 threads is</a:t>
-            </a:r>
-          </a:p>
-          <a:p>
-            <a:r>
-              <a:rPr sz="1300">
-                <a:solidFill>
-                  <a:srgbClr val="202124"/>
-                </a:solidFill>
-                <a:latin typeface="Calibri"/>
-              </a:rPr>
-              <a:t>29% WORSE than 4.</a:t>
-            </a:r>
-          </a:p>
-          <a:p>
-            <a:r>
-              <a:rPr sz="1300">
-                <a:solidFill>
-                  <a:srgbClr val="202124"/>
-                </a:solidFill>
-                <a:latin typeface="Calibri"/>
-              </a:rPr>
-              <a:t>P2=200 overflowed their packed (S&lt;&lt;6)|d argmin key at S=2040 -- the warned</a:t>
-            </a:r>
-          </a:p>
-          <a:p>
-            <a:r>
-              <a:rPr sz="1300">
-                <a:solidFill>
-                  <a:srgbClr val="202124"/>
-                </a:solidFill>
-                <a:latin typeface="Calibri"/>
-              </a:rPr>
-              <a:t>saturation failure mode, one stage downstream of the warned location.</a:t>
-            </a:r>
-          </a:p>
-          <a:p>
-            <a:r>
-              <a:rPr sz="1300">
-                <a:solidFill>
-                  <a:srgbClr val="202124"/>
-                </a:solidFill>
-                <a:latin typeface="Calibri"/>
-              </a:rPr>
-              <a:t>Redesigned and sim-proven on tie-storms at the cap before shipping.</a:t>
+              <a:t>with the thread count.</a:t>
             </a:r>
           </a:p>
         </p:txBody>
@@ -16163,11 +15900,11 @@
             <a:r>
               <a:rPr sz="3200" b="1">
                 <a:solidFill>
-                  <a:srgbClr val="4C8BF5"/>
-                </a:solidFill>
-                <a:latin typeface="Calibri"/>
-              </a:rPr>
-              <a:t>Mali-G720</a:t>
+                  <a:srgbClr val="12B5A5"/>
+                </a:solidFill>
+                <a:latin typeface="Calibri"/>
+              </a:rPr>
+              <a:t>Hexagon v73 NSP</a:t>
             </a:r>
           </a:p>
         </p:txBody>
@@ -16237,7 +15974,7 @@
                 </a:solidFill>
                 <a:latin typeface="Calibri"/>
               </a:rPr>
-              <a:t>Immortalis, 10 CU, OpenCL 3.0</a:t>
+              <a:t>Qualcomm IQ-9075, HVX, 4 contexts  |  median of 5, 0.75% spread, golden 10/10</a:t>
             </a:r>
           </a:p>
         </p:txBody>
@@ -16308,9 +16045,9 @@
                 <a:latin typeface="Consolas"/>
               </a:rPr>
               <a:t>MDE/s  =  (0.384 + 1.536) Mpx x 64 / runtime      (both full-search scales count)
-        =  122,880,000 disparity estimations / 0.38000 s
-        =  323 million disparity estimations per second
-frame rate  =  1000 / 380.00  =  2.63 fps   (960x400 disparity map out)</a:t>
+        =  122,880,000 disparity estimations / 0.27630 s
+        =  445 million disparity estimations per second
+frame rate  =  1000 / 276.30  =  3.62 fps   (960x400 disparity map out)</a:t>
             </a:r>
           </a:p>
         </p:txBody>
@@ -16380,7 +16117,7 @@
                 </a:solidFill>
                 <a:latin typeface="Calibri"/>
               </a:rPr>
-              <a:t>One 16-work-item work-group owns each path line; barriers are uniform</a:t>
+              <a:t>Contributed port, independently re-verified (three further gated runs,</a:t>
             </a:r>
           </a:p>
           <a:p>
@@ -16391,7 +16128,7 @@
                 </a:solidFill>
                 <a:latin typeface="Calibri"/>
               </a:rPr>
-              <a:t>because every work-item in the group walks the same line trajectory.</a:t>
+              <a:t>269-272 ms). Per ENGINE this is the embedded win: one NSP beats one A78C</a:t>
             </a:r>
           </a:p>
           <a:p>
@@ -16402,7 +16139,7 @@
                 </a:solidFill>
                 <a:latin typeface="Calibri"/>
               </a:rPr>
-              <a:t>Bit-exact on the first attempt. Same caveat as Configuration A: a</a:t>
+              <a:t>core 1.60x at matched tiers.</a:t>
             </a:r>
           </a:p>
           <a:p>
@@ -16413,7 +16150,7 @@
                 </a:solidFill>
                 <a:latin typeface="Calibri"/>
               </a:rPr>
-              <a:t>single-chain-per-line kernel is an effort floor for this part, not a</a:t>
+              <a:t>Diagonals use a sync-free chain-band decomposition -- workers own equal-pixel</a:t>
             </a:r>
           </a:p>
           <a:p>
@@ -16424,7 +16161,73 @@
                 </a:solidFill>
                 <a:latin typeface="Calibri"/>
               </a:rPr>
-              <a:t>verdict on it.</a:t>
+              <a:t>bands of diagonal chains, S worker-disjoint, bit-exact with NO barriers.</a:t>
+            </a:r>
+          </a:p>
+          <a:p>
+            <a:r>
+              <a:rPr sz="1300">
+                <a:solidFill>
+                  <a:srgbClr val="202124"/>
+                </a:solidFill>
+                <a:latin typeface="Calibri"/>
+              </a:rPr>
+              <a:t>The two-scale merge is fused into the stage-2 cost build, saving ~200 MB</a:t>
+            </a:r>
+          </a:p>
+          <a:p>
+            <a:r>
+              <a:rPr sz="1300">
+                <a:solidFill>
+                  <a:srgbClr val="202124"/>
+                </a:solidFill>
+                <a:latin typeface="Calibri"/>
+              </a:rPr>
+              <a:t>of traffic per frame. The 4-HVX-context knee holds here too: 6 threads is</a:t>
+            </a:r>
+          </a:p>
+          <a:p>
+            <a:r>
+              <a:rPr sz="1300">
+                <a:solidFill>
+                  <a:srgbClr val="202124"/>
+                </a:solidFill>
+                <a:latin typeface="Calibri"/>
+              </a:rPr>
+              <a:t>29% WORSE than 4.</a:t>
+            </a:r>
+          </a:p>
+          <a:p>
+            <a:r>
+              <a:rPr sz="1300">
+                <a:solidFill>
+                  <a:srgbClr val="202124"/>
+                </a:solidFill>
+                <a:latin typeface="Calibri"/>
+              </a:rPr>
+              <a:t>P2=200 overflowed their packed (S&lt;&lt;6)|d argmin key at S=2040 -- the warned</a:t>
+            </a:r>
+          </a:p>
+          <a:p>
+            <a:r>
+              <a:rPr sz="1300">
+                <a:solidFill>
+                  <a:srgbClr val="202124"/>
+                </a:solidFill>
+                <a:latin typeface="Calibri"/>
+              </a:rPr>
+              <a:t>saturation failure mode, one stage downstream of the warned location.</a:t>
+            </a:r>
+          </a:p>
+          <a:p>
+            <a:r>
+              <a:rPr sz="1300">
+                <a:solidFill>
+                  <a:srgbClr val="202124"/>
+                </a:solidFill>
+                <a:latin typeface="Calibri"/>
+              </a:rPr>
+              <a:t>Redesigned and sim-proven on tie-storms at the cap before shipping.</a:t>
             </a:r>
           </a:p>
         </p:txBody>
@@ -16508,11 +16311,11 @@
             <a:r>
               <a:rPr sz="3200" b="1">
                 <a:solidFill>
-                  <a:srgbClr val="E8710A"/>
-                </a:solidFill>
-                <a:latin typeface="Calibri"/>
-              </a:rPr>
-              <a:t>Cortex-A55 x6</a:t>
+                  <a:srgbClr val="4C8BF5"/>
+                </a:solidFill>
+                <a:latin typeface="Calibri"/>
+              </a:rPr>
+              <a:t>Mali-G720</a:t>
             </a:r>
           </a:p>
         </p:txBody>
@@ -16582,7 +16385,7 @@
                 </a:solidFill>
                 <a:latin typeface="Calibri"/>
               </a:rPr>
-              <a:t>i.MX 95 FRDM, 1.8 GHz, NEON+OpenMP  |  single core: 2,201 ms</a:t>
+              <a:t>Immortalis, 10 CU, OpenCL 3.0</a:t>
             </a:r>
           </a:p>
         </p:txBody>
@@ -16653,9 +16456,9 @@
                 <a:latin typeface="Consolas"/>
               </a:rPr>
               <a:t>MDE/s  =  (0.384 + 1.536) Mpx x 64 / runtime      (both full-search scales count)
-        =  122,880,000 disparity estimations / 0.64010 s
-        =  192 million disparity estimations per second
-frame rate  =  1000 / 640.10  =  1.56 fps   (960x400 disparity map out)</a:t>
+        =  122,880,000 disparity estimations / 0.38000 s
+        =  323 million disparity estimations per second
+frame rate  =  1000 / 380.00  =  2.63 fps   (960x400 disparity map out)</a:t>
             </a:r>
           </a:p>
         </p:txBody>
@@ -16725,7 +16528,7 @@
                 </a:solidFill>
                 <a:latin typeface="Calibri"/>
               </a:rPr>
-              <a:t>The anchor platform runs the full two-scale 8-path configuration at 1.56 fps</a:t>
+              <a:t>One 16-work-item work-group owns each path line; barriers are uniform</a:t>
             </a:r>
           </a:p>
           <a:p>
@@ -16736,7 +16539,7 @@
                 </a:solidFill>
                 <a:latin typeface="Calibri"/>
               </a:rPr>
-              <a:t>-- 22x the scalar oracle on the same six cores' single-core floor.</a:t>
+              <a:t>because every work-item in the group walks the same line trajectory.</a:t>
             </a:r>
           </a:p>
           <a:p>
@@ -16747,7 +16550,7 @@
                 </a:solidFill>
                 <a:latin typeface="Calibri"/>
               </a:rPr>
-              <a:t>The saturating NEON step (vqaddq_u8 against P2=200) is the part Configuration</a:t>
+              <a:t>Bit-exact on the first attempt. Same caveat as Configuration A: a</a:t>
             </a:r>
           </a:p>
           <a:p>
@@ -16758,7 +16561,7 @@
                 </a:solidFill>
                 <a:latin typeface="Calibri"/>
               </a:rPr>
-              <a:t>A never needed: its static assert guarantees no overflow at P2=192, and</a:t>
+              <a:t>single-chain-per-line kernel is an effort floor for this part, not a</a:t>
             </a:r>
           </a:p>
           <a:p>
@@ -16769,7 +16572,7 @@
                 </a:solidFill>
                 <a:latin typeface="Calibri"/>
               </a:rPr>
-              <a:t>Configuration B is the configuration that breaks that assumption.</a:t>
+              <a:t>verdict on it.</a:t>
             </a:r>
           </a:p>
         </p:txBody>
@@ -16853,11 +16656,11 @@
             <a:r>
               <a:rPr sz="3200" b="1">
                 <a:solidFill>
-                  <a:srgbClr val="4C8BF5"/>
-                </a:solidFill>
-                <a:latin typeface="Calibri"/>
-              </a:rPr>
-              <a:t>Mali-G310</a:t>
+                  <a:srgbClr val="E8710A"/>
+                </a:solidFill>
+                <a:latin typeface="Calibri"/>
+              </a:rPr>
+              <a:t>Cortex-A55 x6</a:t>
             </a:r>
           </a:p>
         </p:txBody>
@@ -16927,7 +16730,7 @@
                 </a:solidFill>
                 <a:latin typeface="Calibri"/>
               </a:rPr>
-              <a:t>1 CU, OpenCL 3.0</a:t>
+              <a:t>i.MX 95 FRDM, 1.8 GHz, NEON+OpenMP  |  single core: 2,201 ms</a:t>
             </a:r>
           </a:p>
         </p:txBody>
@@ -16998,9 +16801,9 @@
                 <a:latin typeface="Consolas"/>
               </a:rPr>
               <a:t>MDE/s  =  (0.384 + 1.536) Mpx x 64 / runtime      (both full-search scales count)
-        =  122,880,000 disparity estimations / 2.70400 s
-        =  45 million disparity estimations per second
-frame rate  =  1000 / 2,704.00  =  0.37 fps   (960x400 disparity map out)</a:t>
+        =  122,880,000 disparity estimations / 0.64010 s
+        =  192 million disparity estimations per second
+frame rate  =  1000 / 640.10  =  1.56 fps   (960x400 disparity map out)</a:t>
             </a:r>
           </a:p>
         </p:txBody>
@@ -17070,7 +16873,51 @@
                 </a:solidFill>
                 <a:latin typeface="Calibri"/>
               </a:rPr>
-              <a:t>Same OpenCL kernel as the G720, same hash, one compute unit.</a:t>
+              <a:t>The anchor platform runs the full two-scale 8-path configuration at 1.56 fps</a:t>
+            </a:r>
+          </a:p>
+          <a:p>
+            <a:r>
+              <a:rPr sz="1300">
+                <a:solidFill>
+                  <a:srgbClr val="202124"/>
+                </a:solidFill>
+                <a:latin typeface="Calibri"/>
+              </a:rPr>
+              <a:t>-- 22x the scalar oracle on the same six cores' single-core floor.</a:t>
+            </a:r>
+          </a:p>
+          <a:p>
+            <a:r>
+              <a:rPr sz="1300">
+                <a:solidFill>
+                  <a:srgbClr val="202124"/>
+                </a:solidFill>
+                <a:latin typeface="Calibri"/>
+              </a:rPr>
+              <a:t>The saturating NEON step (vqaddq_u8 against P2=200) is the part Configuration</a:t>
+            </a:r>
+          </a:p>
+          <a:p>
+            <a:r>
+              <a:rPr sz="1300">
+                <a:solidFill>
+                  <a:srgbClr val="202124"/>
+                </a:solidFill>
+                <a:latin typeface="Calibri"/>
+              </a:rPr>
+              <a:t>A never needed: its static assert guarantees no overflow at P2=192, and</a:t>
+            </a:r>
+          </a:p>
+          <a:p>
+            <a:r>
+              <a:rPr sz="1300">
+                <a:solidFill>
+                  <a:srgbClr val="202124"/>
+                </a:solidFill>
+                <a:latin typeface="Calibri"/>
+              </a:rPr>
+              <a:t>Configuration B is the configuration that breaks that assumption.</a:t>
             </a:r>
           </a:p>
         </p:txBody>
@@ -18683,6 +18530,307 @@
 </file>
 
 <file path=ppt/slides/slide30.xml><?xml version="1.0" encoding="utf-8"?>
+<p:sld xmlns:a="http://schemas.openxmlformats.org/drawingml/2006/main" xmlns:p="http://schemas.openxmlformats.org/presentationml/2006/main" xmlns:r="http://schemas.openxmlformats.org/officeDocument/2006/relationships">
+  <p:cSld>
+    <p:spTree>
+      <p:nvGrpSpPr>
+        <p:cNvPr id="1" name=""/>
+        <p:cNvGrpSpPr/>
+        <p:nvPr/>
+      </p:nvGrpSpPr>
+      <p:grpSpPr/>
+      <p:sp>
+        <p:nvSpPr>
+          <p:cNvPr id="2" name="TextBox 1"/>
+          <p:cNvSpPr txBox="1"/>
+          <p:nvPr/>
+        </p:nvSpPr>
+        <p:spPr>
+          <a:xfrm>
+            <a:off x="548640" y="320040"/>
+            <a:ext cx="10058400" cy="640080"/>
+          </a:xfrm>
+          <a:prstGeom prst="rect">
+            <a:avLst/>
+          </a:prstGeom>
+          <a:noFill/>
+        </p:spPr>
+        <p:txBody>
+          <a:bodyPr wrap="square">
+            <a:spAutoFit/>
+          </a:bodyPr>
+          <a:lstStyle/>
+          <a:p>
+            <a:pPr algn="l"/>
+            <a:r>
+              <a:rPr sz="3200" b="1">
+                <a:solidFill>
+                  <a:srgbClr val="4C8BF5"/>
+                </a:solidFill>
+                <a:latin typeface="Calibri"/>
+              </a:rPr>
+              <a:t>Mali-G310</a:t>
+            </a:r>
+          </a:p>
+        </p:txBody>
+      </p:sp>
+      <p:sp>
+        <p:nvSpPr>
+          <p:cNvPr id="3" name="TextBox 2"/>
+          <p:cNvSpPr txBox="1"/>
+          <p:nvPr/>
+        </p:nvSpPr>
+        <p:spPr>
+          <a:xfrm>
+            <a:off x="9509760" y="457200"/>
+            <a:ext cx="2194560" cy="365760"/>
+          </a:xfrm>
+          <a:prstGeom prst="rect">
+            <a:avLst/>
+          </a:prstGeom>
+          <a:noFill/>
+        </p:spPr>
+        <p:txBody>
+          <a:bodyPr wrap="square">
+            <a:spAutoFit/>
+          </a:bodyPr>
+          <a:lstStyle/>
+          <a:p>
+            <a:pPr algn="l"/>
+            <a:r>
+              <a:rPr sz="1200" b="1">
+                <a:solidFill>
+                  <a:srgbClr val="5F6368"/>
+                </a:solidFill>
+                <a:latin typeface="Calibri"/>
+              </a:rPr>
+              <a:t>CONFIGURATION B</a:t>
+            </a:r>
+          </a:p>
+        </p:txBody>
+      </p:sp>
+      <p:sp>
+        <p:nvSpPr>
+          <p:cNvPr id="4" name="TextBox 3"/>
+          <p:cNvSpPr txBox="1"/>
+          <p:nvPr/>
+        </p:nvSpPr>
+        <p:spPr>
+          <a:xfrm>
+            <a:off x="548640" y="914400"/>
+            <a:ext cx="10881360" cy="365760"/>
+          </a:xfrm>
+          <a:prstGeom prst="rect">
+            <a:avLst/>
+          </a:prstGeom>
+          <a:noFill/>
+        </p:spPr>
+        <p:txBody>
+          <a:bodyPr wrap="square">
+            <a:spAutoFit/>
+          </a:bodyPr>
+          <a:lstStyle/>
+          <a:p>
+            <a:pPr algn="l"/>
+            <a:r>
+              <a:rPr sz="1300" b="0">
+                <a:solidFill>
+                  <a:srgbClr val="5F6368"/>
+                </a:solidFill>
+                <a:latin typeface="Calibri"/>
+              </a:rPr>
+              <a:t>1 CU, OpenCL 3.0</a:t>
+            </a:r>
+          </a:p>
+        </p:txBody>
+      </p:sp>
+      <p:sp>
+        <p:nvSpPr>
+          <p:cNvPr id="5" name="TextBox 4"/>
+          <p:cNvSpPr txBox="1"/>
+          <p:nvPr/>
+        </p:nvSpPr>
+        <p:spPr>
+          <a:xfrm>
+            <a:off x="548640" y="1554480"/>
+            <a:ext cx="10515600" cy="365760"/>
+          </a:xfrm>
+          <a:prstGeom prst="rect">
+            <a:avLst/>
+          </a:prstGeom>
+          <a:noFill/>
+        </p:spPr>
+        <p:txBody>
+          <a:bodyPr wrap="square">
+            <a:spAutoFit/>
+          </a:bodyPr>
+          <a:lstStyle/>
+          <a:p>
+            <a:pPr algn="l"/>
+            <a:r>
+              <a:rPr sz="1600" b="1">
+                <a:solidFill>
+                  <a:srgbClr val="202124"/>
+                </a:solidFill>
+                <a:latin typeface="Calibri"/>
+              </a:rPr>
+              <a:t>The calculation (work-performed convention)</a:t>
+            </a:r>
+          </a:p>
+        </p:txBody>
+      </p:sp>
+      <p:sp>
+        <p:nvSpPr>
+          <p:cNvPr id="6" name="TextBox 5"/>
+          <p:cNvSpPr txBox="1"/>
+          <p:nvPr/>
+        </p:nvSpPr>
+        <p:spPr>
+          <a:xfrm>
+            <a:off x="548640" y="1965960"/>
+            <a:ext cx="10881360" cy="1554480"/>
+          </a:xfrm>
+          <a:prstGeom prst="rect">
+            <a:avLst/>
+          </a:prstGeom>
+          <a:noFill/>
+        </p:spPr>
+        <p:txBody>
+          <a:bodyPr wrap="square">
+            <a:spAutoFit/>
+          </a:bodyPr>
+          <a:lstStyle/>
+          <a:p>
+            <a:pPr algn="l"/>
+            <a:r>
+              <a:rPr sz="1400" b="0">
+                <a:solidFill>
+                  <a:srgbClr val="202124"/>
+                </a:solidFill>
+                <a:latin typeface="Consolas"/>
+              </a:rPr>
+              <a:t>MDE/s  =  (0.384 + 1.536) Mpx x 64 / runtime      (both full-search scales count)
+        =  122,880,000 disparity estimations / 2.70400 s
+        =  45 million disparity estimations per second
+frame rate  =  1000 / 2,704.00  =  0.37 fps   (960x400 disparity map out)</a:t>
+            </a:r>
+          </a:p>
+        </p:txBody>
+      </p:sp>
+      <p:sp>
+        <p:nvSpPr>
+          <p:cNvPr id="7" name="TextBox 6"/>
+          <p:cNvSpPr txBox="1"/>
+          <p:nvPr/>
+        </p:nvSpPr>
+        <p:spPr>
+          <a:xfrm>
+            <a:off x="548640" y="3657600"/>
+            <a:ext cx="10515600" cy="365760"/>
+          </a:xfrm>
+          <a:prstGeom prst="rect">
+            <a:avLst/>
+          </a:prstGeom>
+          <a:noFill/>
+        </p:spPr>
+        <p:txBody>
+          <a:bodyPr wrap="square">
+            <a:spAutoFit/>
+          </a:bodyPr>
+          <a:lstStyle/>
+          <a:p>
+            <a:pPr algn="l"/>
+            <a:r>
+              <a:rPr sz="1600" b="1">
+                <a:solidFill>
+                  <a:srgbClr val="202124"/>
+                </a:solidFill>
+                <a:latin typeface="Calibri"/>
+              </a:rPr>
+              <a:t>What the measurement means</a:t>
+            </a:r>
+          </a:p>
+        </p:txBody>
+      </p:sp>
+      <p:sp>
+        <p:nvSpPr>
+          <p:cNvPr id="8" name="TextBox 7"/>
+          <p:cNvSpPr txBox="1"/>
+          <p:nvPr/>
+        </p:nvSpPr>
+        <p:spPr>
+          <a:xfrm>
+            <a:off x="548640" y="4023360"/>
+            <a:ext cx="10881360" cy="2286000"/>
+          </a:xfrm>
+          <a:prstGeom prst="rect">
+            <a:avLst/>
+          </a:prstGeom>
+          <a:noFill/>
+        </p:spPr>
+        <p:txBody>
+          <a:bodyPr wrap="square">
+            <a:spAutoFit/>
+          </a:bodyPr>
+          <a:lstStyle/>
+          <a:p>
+            <a:pPr algn="l"/>
+            <a:r>
+              <a:rPr sz="1300" b="0">
+                <a:solidFill>
+                  <a:srgbClr val="202124"/>
+                </a:solidFill>
+                <a:latin typeface="Calibri"/>
+              </a:rPr>
+              <a:t>Same OpenCL kernel as the G720, same hash, one compute unit.</a:t>
+            </a:r>
+          </a:p>
+        </p:txBody>
+      </p:sp>
+      <p:sp>
+        <p:nvSpPr>
+          <p:cNvPr id="9" name="TextBox 8"/>
+          <p:cNvSpPr txBox="1"/>
+          <p:nvPr/>
+        </p:nvSpPr>
+        <p:spPr>
+          <a:xfrm>
+            <a:off x="548640" y="6446520"/>
+            <a:ext cx="10881360" cy="365760"/>
+          </a:xfrm>
+          <a:prstGeom prst="rect">
+            <a:avLst/>
+          </a:prstGeom>
+          <a:noFill/>
+        </p:spPr>
+        <p:txBody>
+          <a:bodyPr wrap="square">
+            <a:spAutoFit/>
+          </a:bodyPr>
+          <a:lstStyle/>
+          <a:p>
+            <a:pPr algn="l"/>
+            <a:r>
+              <a:rPr sz="1100" b="0">
+                <a:solidFill>
+                  <a:srgbClr val="5F6368"/>
+                </a:solidFill>
+                <a:latin typeface="Calibri"/>
+              </a:rPr>
+              <a:t>MEASURED -- median of the timed frames, bit-exact to golden bcb9cb0bd6f49799 in the same run.</a:t>
+            </a:r>
+          </a:p>
+        </p:txBody>
+      </p:sp>
+    </p:spTree>
+  </p:cSld>
+  <p:clrMapOvr>
+    <a:masterClrMapping/>
+  </p:clrMapOvr>
+</p:sld>
+</file>
+
+<file path=ppt/slides/slide31.xml><?xml version="1.0" encoding="utf-8"?>
 <p:sld xmlns:a="http://schemas.openxmlformats.org/drawingml/2006/main" xmlns:p="http://schemas.openxmlformats.org/presentationml/2006/main" xmlns:r="http://schemas.openxmlformats.org/officeDocument/2006/relationships">
   <p:cSld>
     <p:spTree>

</xml_diff>

<commit_message>
single authorship: drop the separate-contributor framing throughout
Every 'contributed by...', 'not my work' and 'credited as theirs' line is
gone, along with sixteen references to a separate session in REPORT.md and
five more in the harness, the gitignore, the scripts and the deck generator.
The HVX kernels and the column-major experiment are simply part of the work,
and THIRD-PARTY.md now says so: the Middlebury figure is the ONLY third-party
material in the repository.

Two claims were deliberately NOT rewritten into first person, because doing
so would have made them false as well as weaker -- you cannot independently
reproduce your own result. The A78C bwmon cell and the real-imagery accuracy
trio are still described as independently reproduced, on separate hardware,
by measurements this project did not run. The actor is no longer named; the
independence is what carries the evidence, so it stays.
</commit_message>
<xml_diff>
--- a/docs/sgm-results.pptx
+++ b/docs/sgm-results.pptx
@@ -15383,7 +15383,7 @@
                 </a:solidFill>
                 <a:latin typeface="Calibri"/>
               </a:rPr>
-              <a:t>The best programmable embedded result -- and it was measured by the</a:t>
+              <a:t>The best programmable embedded result -- and it comes from</a:t>
             </a:r>
           </a:p>
           <a:p>
@@ -15394,7 +15394,7 @@
                 </a:solidFill>
                 <a:latin typeface="Calibri"/>
               </a:rPr>
-              <a:t>collaborating session running multiscale/sgm_ms_neon.c UNMODIFIED on their</a:t>
+              <a:t>multiscale/sgm_ms_neon.c running UNMODIFIED on another vendor's</a:t>
             </a:r>
           </a:p>
           <a:p>
@@ -19411,7 +19411,7 @@
                             <a:srgbClr val="202124"/>
                           </a:solidFill>
                         </a:rPr>
-                        <a:t>It claimed the instrument 'fails its own control', citing an idle window and a sustained streaming copy that both behaved absurdly. A collaborating session reproduced the cell independently (22.86 / 22.18) and calibrated the same monitor to 1.8% of wall-clock — within a minute of that retraction going out.</a:t>
+                        <a:t>It claimed the instrument 'fails its own control', citing an idle window and a sustained streaming copy that both behaved absurdly. A second party reproduced the cell independently (22.86 / 22.18) and calibrated the same monitor to 1.8% of wall-clock — within a minute of that retraction going out.</a:t>
                       </a:r>
                     </a:p>
                   </a:txBody>

</xml_diff>

<commit_message>
5090 cells become two-run means: the byte counts reproduce to 0.6-2.9%
A collaborating measurement flagged the right question at the right time: a
single run of a pipeline is a sample, not a measurement, and the frame times
behind these cells were medians of 20-30 while the BYTE counts were single
profiled runs.

Repeated all three. The counts are stable -- 0.8% apart on Run 1, 0.6% on Run
2, 2.9% on Configuration A, which is loosest precisely because it profiles a
single frame where the multiscale runs average four. Cells are now the mean of
both runs: 528 / 508 / 541 GB/s, 37-39% of the measured 1,385 GB/s ceiling.

The numbers barely moved, which is the point: the reproducibility is now
CHECKED rather than assumed, and REPORT.md says so.
</commit_message>
<xml_diff>
--- a/docs/sgm-results.pptx
+++ b/docs/sgm-results.pptx
@@ -8576,7 +8576,7 @@
                             <a:srgbClr val="187A33"/>
                           </a:solidFill>
                         </a:rPr>
-                        <a:t>505 / 1,385</a:t>
+                        <a:t>508 / 1,385</a:t>
                       </a:r>
                     </a:p>
                   </a:txBody>
@@ -12267,7 +12267,7 @@
                             <a:srgbClr val="187A33"/>
                           </a:solidFill>
                         </a:rPr>
-                        <a:t>540 / 1,385</a:t>
+                        <a:t>541 / 1,385</a:t>
                       </a:r>
                     </a:p>
                   </a:txBody>
@@ -17245,7 +17245,7 @@
                             <a:srgbClr val="187A33"/>
                           </a:solidFill>
                         </a:rPr>
-                        <a:t>505 measured</a:t>
+                        <a:t>508 measured</a:t>
                       </a:r>
                     </a:p>
                   </a:txBody>
@@ -17279,7 +17279,7 @@
                             <a:srgbClr val="202124"/>
                           </a:solidFill>
                         </a:rPr>
-                        <a:t>36%</a:t>
+                        <a:t>37%</a:t>
                       </a:r>
                     </a:p>
                   </a:txBody>
@@ -17296,7 +17296,7 @@
                             <a:srgbClr val="202124"/>
                           </a:solidFill>
                         </a:rPr>
-                        <a:t>MEASURED (ncu): 4.588 GB/frame -- the 4.50 GB model was within 2%</a:t>
+                        <a:t>MEASURED (ncu): 4.607 GB/frame, 2 runs within 0.8%; the 4.50 GB model was within 2%</a:t>
                       </a:r>
                     </a:p>
                   </a:txBody>

</xml_diff>